<commit_message>
Declutter portrait one-pager footer; centre arrows; pillars naming
Replaces the solid delivery ribbon with a plain text line using
vertically-centred arrow glyphs, adds air around the governance and
programme panels, removes the key-point box, and runs Harder to Kill
as a single full-width strip. Renames capability strands to
capability pillars on the slide.

Co-Authored-By: Claude Fable 5 <noreply@anthropic.com>
Claude-Session: https://claude.ai/code/session_01YLo1WfwUDkbwfJEF3ZNVbB
</commit_message>
<xml_diff>
--- a/output/combat-mindset-onepager-portrait.pptx
+++ b/output/combat-mindset-onepager-portrait.pptx
@@ -2413,7 +2413,7 @@
                 <a:ea typeface="Arial" pitchFamily="34" charset="-122"/>
                 <a:cs typeface="Arial" pitchFamily="34" charset="-120"/>
               </a:rPr>
-              <a:t>·  Capability strands</a:t>
+              <a:t>·  Capability pillars</a:t>
             </a:r>
             <a:endParaRPr lang="en-US" sz="720" dirty="0"/>
           </a:p>
@@ -2679,7 +2679,7 @@
                 <a:ea typeface="Arial" pitchFamily="34" charset="-122"/>
                 <a:cs typeface="Arial" pitchFamily="34" charset="-120"/>
               </a:rPr>
-              <a:t>CAPABILITY STRANDS</a:t>
+              <a:t>CAPABILITY PILLARS</a:t>
             </a:r>
             <a:endParaRPr lang="en-US" sz="1050" dirty="0"/>
           </a:p>
@@ -3354,7 +3354,7 @@
                 <a:ea typeface="Arial" pitchFamily="34" charset="-122"/>
                 <a:cs typeface="Arial" pitchFamily="34" charset="-120"/>
               </a:rPr>
-              <a:t>each product contributes across multiple strands</a:t>
+              <a:t>each product contributes across multiple pillars</a:t>
             </a:r>
             <a:endParaRPr lang="en-US" sz="750" dirty="0"/>
           </a:p>
@@ -3883,34 +3883,14 @@
       </p:sp>
       <p:sp>
         <p:nvSpPr>
-          <p:cNvPr id="90" name="Shape 76"/>
-          <p:cNvSpPr/>
-          <p:nvPr/>
-        </p:nvSpPr>
-        <p:spPr>
-          <a:xfrm>
-            <a:off x="457200" y="8650224"/>
-            <a:ext cx="6647688" cy="237744"/>
-          </a:xfrm>
-          <a:prstGeom prst="rect">
-            <a:avLst/>
-          </a:prstGeom>
-          <a:solidFill>
-            <a:srgbClr val="CDD2B7"/>
-          </a:solidFill>
-          <a:ln/>
-        </p:spPr>
-      </p:sp>
-      <p:sp>
-        <p:nvSpPr>
-          <p:cNvPr id="91" name="Text 77"/>
-          <p:cNvSpPr/>
-          <p:nvPr/>
-        </p:nvSpPr>
-        <p:spPr>
-          <a:xfrm>
-            <a:off x="457200" y="8650224"/>
-            <a:ext cx="6647688" cy="237744"/>
+          <p:cNvPr id="90" name="Text 76"/>
+          <p:cNvSpPr/>
+          <p:nvPr/>
+        </p:nvSpPr>
+        <p:spPr>
+          <a:xfrm>
+            <a:off x="457200" y="8631936"/>
+            <a:ext cx="6647688" cy="182880"/>
           </a:xfrm>
           <a:prstGeom prst="rect">
             <a:avLst/>
@@ -3926,7 +3906,7 @@
               <a:buNone/>
             </a:pPr>
             <a:r>
-              <a:rPr lang="en-US" sz="780" b="1" dirty="0">
+              <a:rPr lang="en-US" sz="800" b="1" dirty="0">
                 <a:solidFill>
                   <a:srgbClr val="002516"/>
                 </a:solidFill>
@@ -3934,22 +3914,106 @@
                 <a:ea typeface="Arial" pitchFamily="34" charset="-122"/>
                 <a:cs typeface="Arial" pitchFamily="34" charset="-120"/>
               </a:rPr>
-              <a:t>Delivered across the Prepare – Perform – Recover cycle and the Lead Self → Lead Teams → Lead Leaders → Lead Systems progression</a:t>
-            </a:r>
-            <a:endParaRPr lang="en-US" sz="780" dirty="0"/>
-          </a:p>
-        </p:txBody>
-      </p:sp>
-      <p:sp>
-        <p:nvSpPr>
-          <p:cNvPr id="92" name="Shape 78"/>
-          <p:cNvSpPr/>
-          <p:nvPr/>
-        </p:nvSpPr>
-        <p:spPr>
-          <a:xfrm>
-            <a:off x="457200" y="9034272"/>
-            <a:ext cx="3246120" cy="1042416"/>
+              <a:t>Delivered across the Prepare – Perform – Recover cycle   ·   Lead Self</a:t>
+            </a:r>
+            <a:pPr algn="ctr" indent="0" marL="0">
+              <a:buNone/>
+            </a:pPr>
+            <a:r>
+              <a:rPr lang="en-US" sz="620" b="1" dirty="0">
+                <a:solidFill>
+                  <a:srgbClr val="C62026"/>
+                </a:solidFill>
+                <a:latin typeface="Arial" pitchFamily="34" charset="0"/>
+                <a:ea typeface="Arial" pitchFamily="34" charset="-122"/>
+                <a:cs typeface="Arial" pitchFamily="34" charset="-120"/>
+              </a:rPr>
+              <a:t>  ►  </a:t>
+            </a:r>
+            <a:pPr algn="ctr" indent="0" marL="0">
+              <a:buNone/>
+            </a:pPr>
+            <a:r>
+              <a:rPr lang="en-US" sz="800" b="1" dirty="0">
+                <a:solidFill>
+                  <a:srgbClr val="002516"/>
+                </a:solidFill>
+                <a:latin typeface="Arial" pitchFamily="34" charset="0"/>
+                <a:ea typeface="Arial" pitchFamily="34" charset="-122"/>
+                <a:cs typeface="Arial" pitchFamily="34" charset="-120"/>
+              </a:rPr>
+              <a:t>Lead Teams</a:t>
+            </a:r>
+            <a:pPr algn="ctr" indent="0" marL="0">
+              <a:buNone/>
+            </a:pPr>
+            <a:r>
+              <a:rPr lang="en-US" sz="620" b="1" dirty="0">
+                <a:solidFill>
+                  <a:srgbClr val="C62026"/>
+                </a:solidFill>
+                <a:latin typeface="Arial" pitchFamily="34" charset="0"/>
+                <a:ea typeface="Arial" pitchFamily="34" charset="-122"/>
+                <a:cs typeface="Arial" pitchFamily="34" charset="-120"/>
+              </a:rPr>
+              <a:t>  ►  </a:t>
+            </a:r>
+            <a:pPr algn="ctr" indent="0" marL="0">
+              <a:buNone/>
+            </a:pPr>
+            <a:r>
+              <a:rPr lang="en-US" sz="800" b="1" dirty="0">
+                <a:solidFill>
+                  <a:srgbClr val="002516"/>
+                </a:solidFill>
+                <a:latin typeface="Arial" pitchFamily="34" charset="0"/>
+                <a:ea typeface="Arial" pitchFamily="34" charset="-122"/>
+                <a:cs typeface="Arial" pitchFamily="34" charset="-120"/>
+              </a:rPr>
+              <a:t>Lead Leaders</a:t>
+            </a:r>
+            <a:pPr algn="ctr" indent="0" marL="0">
+              <a:buNone/>
+            </a:pPr>
+            <a:r>
+              <a:rPr lang="en-US" sz="620" b="1" dirty="0">
+                <a:solidFill>
+                  <a:srgbClr val="C62026"/>
+                </a:solidFill>
+                <a:latin typeface="Arial" pitchFamily="34" charset="0"/>
+                <a:ea typeface="Arial" pitchFamily="34" charset="-122"/>
+                <a:cs typeface="Arial" pitchFamily="34" charset="-120"/>
+              </a:rPr>
+              <a:t>  ►  </a:t>
+            </a:r>
+            <a:pPr algn="ctr" indent="0" marL="0">
+              <a:buNone/>
+            </a:pPr>
+            <a:r>
+              <a:rPr lang="en-US" sz="800" b="1" dirty="0">
+                <a:solidFill>
+                  <a:srgbClr val="002516"/>
+                </a:solidFill>
+                <a:latin typeface="Arial" pitchFamily="34" charset="0"/>
+                <a:ea typeface="Arial" pitchFamily="34" charset="-122"/>
+                <a:cs typeface="Arial" pitchFamily="34" charset="-120"/>
+              </a:rPr>
+              <a:t>Lead Systems</a:t>
+            </a:r>
+            <a:endParaRPr lang="en-US" sz="800" dirty="0"/>
+          </a:p>
+        </p:txBody>
+      </p:sp>
+      <p:sp>
+        <p:nvSpPr>
+          <p:cNvPr id="91" name="Shape 77"/>
+          <p:cNvSpPr/>
+          <p:nvPr/>
+        </p:nvSpPr>
+        <p:spPr>
+          <a:xfrm>
+            <a:off x="457200" y="8997696"/>
+            <a:ext cx="3246120" cy="1078992"/>
           </a:xfrm>
           <a:prstGeom prst="rect">
             <a:avLst/>
@@ -3964,7 +4028,7 @@
       </p:sp>
       <p:pic>
         <p:nvPicPr>
-          <p:cNvPr id="93" name="Image 12" descr="preencoded.png">    </p:cNvPr>
+          <p:cNvPr id="92" name="Image 12" descr="preencoded.png">    </p:cNvPr>
           <p:cNvPicPr>
             <a:picLocks noChangeAspect="1"/>
           </p:cNvPicPr>
@@ -3978,7 +4042,7 @@
         </p:blipFill>
         <p:spPr>
           <a:xfrm>
-            <a:off x="566928" y="9116568"/>
+            <a:off x="585216" y="9089136"/>
             <a:ext cx="201168" cy="201168"/>
           </a:xfrm>
           <a:prstGeom prst="rect">
@@ -3988,46 +4052,46 @@
       </p:pic>
       <p:sp>
         <p:nvSpPr>
+          <p:cNvPr id="93" name="Text 78"/>
+          <p:cNvSpPr/>
+          <p:nvPr/>
+        </p:nvSpPr>
+        <p:spPr>
+          <a:xfrm>
+            <a:off x="859536" y="9079992"/>
+            <a:ext cx="2770632" cy="201168"/>
+          </a:xfrm>
+          <a:prstGeom prst="rect">
+            <a:avLst/>
+          </a:prstGeom>
+          <a:noFill/>
+          <a:ln/>
+        </p:spPr>
+        <p:txBody>
+          <a:bodyPr wrap="square" lIns="0" tIns="0" rIns="0" bIns="0" rtlCol="0" anchor="ctr"/>
+          <a:lstStyle/>
+          <a:p>
+            <a:pPr algn="l" indent="0" marL="0">
+              <a:buNone/>
+            </a:pPr>
+            <a:r>
+              <a:rPr lang="en-US" sz="880" b="1" dirty="0">
+                <a:solidFill>
+                  <a:srgbClr val="002516"/>
+                </a:solidFill>
+                <a:latin typeface="Arial" pitchFamily="34" charset="0"/>
+                <a:ea typeface="Arial" pitchFamily="34" charset="-122"/>
+                <a:cs typeface="Arial" pitchFamily="34" charset="-120"/>
+              </a:rPr>
+              <a:t>GOVERNANCE AND ASSURANCE</a:t>
+            </a:r>
+            <a:endParaRPr lang="en-US" sz="880" dirty="0"/>
+          </a:p>
+        </p:txBody>
+      </p:sp>
+      <p:sp>
+        <p:nvSpPr>
           <p:cNvPr id="94" name="Text 79"/>
-          <p:cNvSpPr/>
-          <p:nvPr/>
-        </p:nvSpPr>
-        <p:spPr>
-          <a:xfrm>
-            <a:off x="841248" y="9107424"/>
-            <a:ext cx="2788920" cy="201168"/>
-          </a:xfrm>
-          <a:prstGeom prst="rect">
-            <a:avLst/>
-          </a:prstGeom>
-          <a:noFill/>
-          <a:ln/>
-        </p:spPr>
-        <p:txBody>
-          <a:bodyPr wrap="square" lIns="0" tIns="0" rIns="0" bIns="0" rtlCol="0" anchor="ctr"/>
-          <a:lstStyle/>
-          <a:p>
-            <a:pPr algn="l" indent="0" marL="0">
-              <a:buNone/>
-            </a:pPr>
-            <a:r>
-              <a:rPr lang="en-US" sz="880" b="1" dirty="0">
-                <a:solidFill>
-                  <a:srgbClr val="002516"/>
-                </a:solidFill>
-                <a:latin typeface="Arial" pitchFamily="34" charset="0"/>
-                <a:ea typeface="Arial" pitchFamily="34" charset="-122"/>
-                <a:cs typeface="Arial" pitchFamily="34" charset="-120"/>
-              </a:rPr>
-              <a:t>GOVERNANCE AND ASSURANCE</a:t>
-            </a:r>
-            <a:endParaRPr lang="en-US" sz="880" dirty="0"/>
-          </a:p>
-        </p:txBody>
-      </p:sp>
-      <p:sp>
-        <p:nvSpPr>
-          <p:cNvPr id="95" name="Text 80"/>
           <p:cNvSpPr/>
           <p:nvPr/>
         </p:nvSpPr>
@@ -4154,14 +4218,14 @@
       </p:sp>
       <p:sp>
         <p:nvSpPr>
-          <p:cNvPr id="96" name="Shape 81"/>
-          <p:cNvSpPr/>
-          <p:nvPr/>
-        </p:nvSpPr>
-        <p:spPr>
-          <a:xfrm>
-            <a:off x="3858768" y="9034272"/>
-            <a:ext cx="3246120" cy="1042416"/>
+          <p:cNvPr id="95" name="Shape 80"/>
+          <p:cNvSpPr/>
+          <p:nvPr/>
+        </p:nvSpPr>
+        <p:spPr>
+          <a:xfrm>
+            <a:off x="3858768" y="8997696"/>
+            <a:ext cx="3246120" cy="1078992"/>
           </a:xfrm>
           <a:prstGeom prst="rect">
             <a:avLst/>
@@ -4176,7 +4240,7 @@
       </p:sp>
       <p:pic>
         <p:nvPicPr>
-          <p:cNvPr id="97" name="Image 13" descr="preencoded.png">    </p:cNvPr>
+          <p:cNvPr id="96" name="Image 13" descr="preencoded.png">    </p:cNvPr>
           <p:cNvPicPr>
             <a:picLocks noChangeAspect="1"/>
           </p:cNvPicPr>
@@ -4190,7 +4254,7 @@
         </p:blipFill>
         <p:spPr>
           <a:xfrm>
-            <a:off x="3968496" y="9116568"/>
+            <a:off x="3986784" y="9089136"/>
             <a:ext cx="201168" cy="201168"/>
           </a:xfrm>
           <a:prstGeom prst="rect">
@@ -4200,46 +4264,46 @@
       </p:pic>
       <p:sp>
         <p:nvSpPr>
+          <p:cNvPr id="97" name="Text 81"/>
+          <p:cNvSpPr/>
+          <p:nvPr/>
+        </p:nvSpPr>
+        <p:spPr>
+          <a:xfrm>
+            <a:off x="4261104" y="9079992"/>
+            <a:ext cx="2770632" cy="201168"/>
+          </a:xfrm>
+          <a:prstGeom prst="rect">
+            <a:avLst/>
+          </a:prstGeom>
+          <a:noFill/>
+          <a:ln/>
+        </p:spPr>
+        <p:txBody>
+          <a:bodyPr wrap="square" lIns="0" tIns="0" rIns="0" bIns="0" rtlCol="0" anchor="ctr"/>
+          <a:lstStyle/>
+          <a:p>
+            <a:pPr algn="l" indent="0" marL="0">
+              <a:buNone/>
+            </a:pPr>
+            <a:r>
+              <a:rPr lang="en-US" sz="880" b="1" dirty="0">
+                <a:solidFill>
+                  <a:srgbClr val="002516"/>
+                </a:solidFill>
+                <a:latin typeface="Arial" pitchFamily="34" charset="0"/>
+                <a:ea typeface="Arial" pitchFamily="34" charset="-122"/>
+                <a:cs typeface="Arial" pitchFamily="34" charset="-120"/>
+              </a:rPr>
+              <a:t>PROGRAMME OF WORK — PHASES 0–5</a:t>
+            </a:r>
+            <a:endParaRPr lang="en-US" sz="880" dirty="0"/>
+          </a:p>
+        </p:txBody>
+      </p:sp>
+      <p:sp>
+        <p:nvSpPr>
           <p:cNvPr id="98" name="Text 82"/>
-          <p:cNvSpPr/>
-          <p:nvPr/>
-        </p:nvSpPr>
-        <p:spPr>
-          <a:xfrm>
-            <a:off x="4242816" y="9107424"/>
-            <a:ext cx="2788920" cy="201168"/>
-          </a:xfrm>
-          <a:prstGeom prst="rect">
-            <a:avLst/>
-          </a:prstGeom>
-          <a:noFill/>
-          <a:ln/>
-        </p:spPr>
-        <p:txBody>
-          <a:bodyPr wrap="square" lIns="0" tIns="0" rIns="0" bIns="0" rtlCol="0" anchor="ctr"/>
-          <a:lstStyle/>
-          <a:p>
-            <a:pPr algn="l" indent="0" marL="0">
-              <a:buNone/>
-            </a:pPr>
-            <a:r>
-              <a:rPr lang="en-US" sz="880" b="1" dirty="0">
-                <a:solidFill>
-                  <a:srgbClr val="002516"/>
-                </a:solidFill>
-                <a:latin typeface="Arial" pitchFamily="34" charset="0"/>
-                <a:ea typeface="Arial" pitchFamily="34" charset="-122"/>
-                <a:cs typeface="Arial" pitchFamily="34" charset="-120"/>
-              </a:rPr>
-              <a:t>PROGRAMME OF WORK — PHASES 0–5</a:t>
-            </a:r>
-            <a:endParaRPr lang="en-US" sz="880" dirty="0"/>
-          </a:p>
-        </p:txBody>
-      </p:sp>
-      <p:sp>
-        <p:nvSpPr>
-          <p:cNvPr id="99" name="Text 83"/>
           <p:cNvSpPr/>
           <p:nvPr/>
         </p:nvSpPr>
@@ -4381,14 +4445,14 @@
       </p:sp>
       <p:sp>
         <p:nvSpPr>
-          <p:cNvPr id="100" name="Shape 84"/>
-          <p:cNvSpPr/>
-          <p:nvPr/>
-        </p:nvSpPr>
-        <p:spPr>
-          <a:xfrm>
-            <a:off x="457200" y="10131552"/>
-            <a:ext cx="3246120" cy="347472"/>
+          <p:cNvPr id="99" name="Shape 83"/>
+          <p:cNvSpPr/>
+          <p:nvPr/>
+        </p:nvSpPr>
+        <p:spPr>
+          <a:xfrm>
+            <a:off x="457200" y="10204704"/>
+            <a:ext cx="6647688" cy="274320"/>
           </a:xfrm>
           <a:prstGeom prst="rect">
             <a:avLst/>
@@ -4401,7 +4465,7 @@
       </p:sp>
       <p:pic>
         <p:nvPicPr>
-          <p:cNvPr id="101" name="Image 14" descr="preencoded.png">    </p:cNvPr>
+          <p:cNvPr id="100" name="Image 14" descr="preencoded.png">    </p:cNvPr>
           <p:cNvPicPr>
             <a:picLocks noChangeAspect="1"/>
           </p:cNvPicPr>
@@ -4415,7 +4479,7 @@
         </p:blipFill>
         <p:spPr>
           <a:xfrm>
-            <a:off x="566928" y="10213848"/>
+            <a:off x="585216" y="10250424"/>
             <a:ext cx="182880" cy="182880"/>
           </a:xfrm>
           <a:prstGeom prst="rect">
@@ -4425,14 +4489,14 @@
       </p:pic>
       <p:sp>
         <p:nvSpPr>
-          <p:cNvPr id="102" name="Text 85"/>
-          <p:cNvSpPr/>
-          <p:nvPr/>
-        </p:nvSpPr>
-        <p:spPr>
-          <a:xfrm>
-            <a:off x="841248" y="10168128"/>
-            <a:ext cx="2788920" cy="146304"/>
+          <p:cNvPr id="101" name="Text 84"/>
+          <p:cNvSpPr/>
+          <p:nvPr/>
+        </p:nvSpPr>
+        <p:spPr>
+          <a:xfrm>
+            <a:off x="877824" y="10204704"/>
+            <a:ext cx="6135624" cy="274320"/>
           </a:xfrm>
           <a:prstGeom prst="rect">
             <a:avLst/>
@@ -4448,7 +4512,7 @@
               <a:buNone/>
             </a:pPr>
             <a:r>
-              <a:rPr lang="en-US" sz="950" b="1" spc="200" kern="0" dirty="0">
+              <a:rPr lang="en-US" sz="1000" b="1" spc="250" kern="0" dirty="0">
                 <a:solidFill>
                   <a:srgbClr val="C62026"/>
                 </a:solidFill>
@@ -4458,36 +4522,11 @@
               </a:rPr>
               <a:t>HARDER TO KILL</a:t>
             </a:r>
-            <a:endParaRPr lang="en-US" sz="950" dirty="0"/>
-          </a:p>
-        </p:txBody>
-      </p:sp>
-      <p:sp>
-        <p:nvSpPr>
-          <p:cNvPr id="103" name="Text 86"/>
-          <p:cNvSpPr/>
-          <p:nvPr/>
-        </p:nvSpPr>
-        <p:spPr>
-          <a:xfrm>
-            <a:off x="841248" y="10314432"/>
-            <a:ext cx="2788920" cy="128016"/>
-          </a:xfrm>
-          <a:prstGeom prst="rect">
-            <a:avLst/>
-          </a:prstGeom>
-          <a:noFill/>
-          <a:ln/>
-        </p:spPr>
-        <p:txBody>
-          <a:bodyPr wrap="square" lIns="0" tIns="0" rIns="0" bIns="0" rtlCol="0" anchor="ctr"/>
-          <a:lstStyle/>
-          <a:p>
             <a:pPr algn="l" indent="0" marL="0">
               <a:buNone/>
             </a:pPr>
             <a:r>
-              <a:rPr lang="en-US" sz="620" dirty="0">
+              <a:rPr lang="en-US" sz="700" dirty="0">
                 <a:solidFill>
                   <a:srgbClr val="FFFFFF"/>
                 </a:solidFill>
@@ -4495,84 +4534,9 @@
                 <a:ea typeface="Arial" pitchFamily="34" charset="-122"/>
                 <a:cs typeface="Arial" pitchFamily="34" charset="-120"/>
               </a:rPr>
-              <a:t>Proposed Warfighter Focus line — subject to sponsor endorsement</a:t>
-            </a:r>
-            <a:endParaRPr lang="en-US" sz="620" dirty="0"/>
-          </a:p>
-        </p:txBody>
-      </p:sp>
-      <p:sp>
-        <p:nvSpPr>
-          <p:cNvPr id="104" name="Shape 87"/>
-          <p:cNvSpPr/>
-          <p:nvPr/>
-        </p:nvSpPr>
-        <p:spPr>
-          <a:xfrm>
-            <a:off x="3858768" y="10131552"/>
-            <a:ext cx="3246120" cy="347472"/>
-          </a:xfrm>
-          <a:prstGeom prst="rect">
-            <a:avLst/>
-          </a:prstGeom>
-          <a:solidFill>
-            <a:srgbClr val="CDD2B7">
-              <a:alpha val="45000"/>
-            </a:srgbClr>
-          </a:solidFill>
-          <a:ln/>
-        </p:spPr>
-      </p:sp>
-      <p:sp>
-        <p:nvSpPr>
-          <p:cNvPr id="105" name="Text 88"/>
-          <p:cNvSpPr/>
-          <p:nvPr/>
-        </p:nvSpPr>
-        <p:spPr>
-          <a:xfrm>
-            <a:off x="3931920" y="10131552"/>
-            <a:ext cx="3099816" cy="347472"/>
-          </a:xfrm>
-          <a:prstGeom prst="rect">
-            <a:avLst/>
-          </a:prstGeom>
-          <a:noFill/>
-          <a:ln/>
-        </p:spPr>
-        <p:txBody>
-          <a:bodyPr wrap="square" lIns="0" tIns="0" rIns="0" bIns="0" rtlCol="0" anchor="ctr"/>
-          <a:lstStyle/>
-          <a:p>
-            <a:pPr algn="l" indent="0" marL="0">
-              <a:buNone/>
-            </a:pPr>
-            <a:r>
-              <a:rPr lang="en-US" sz="740" b="1" dirty="0">
-                <a:solidFill>
-                  <a:srgbClr val="002516"/>
-                </a:solidFill>
-                <a:latin typeface="Arial" pitchFamily="34" charset="0"/>
-                <a:ea typeface="Arial" pitchFamily="34" charset="-122"/>
-                <a:cs typeface="Arial" pitchFamily="34" charset="-120"/>
-              </a:rPr>
-              <a:t>KEY POINT  </a:t>
-            </a:r>
-            <a:pPr algn="l" indent="0" marL="0">
-              <a:buNone/>
-            </a:pPr>
-            <a:r>
-              <a:rPr lang="en-US" sz="680" dirty="0">
-                <a:solidFill>
-                  <a:srgbClr val="000000"/>
-                </a:solidFill>
-                <a:latin typeface="Arial" pitchFamily="34" charset="0"/>
-                <a:ea typeface="Arial" pitchFamily="34" charset="-122"/>
-                <a:cs typeface="Arial" pitchFamily="34" charset="-120"/>
-              </a:rPr>
-              <a:t>Performance Under Pressure is developed across relevant settings. When expressed in combat and aligned with purpose, identity, values, leadership and the willingness to act, it contributes to Combat Mindset.</a:t>
-            </a:r>
-            <a:endParaRPr lang="en-US" sz="740" dirty="0"/>
+              <a:t>      Proposed Warfighter Focus line — subject to sponsor endorsement</a:t>
+            </a:r>
+            <a:endParaRPr lang="en-US" sz="1000" dirty="0"/>
           </a:p>
         </p:txBody>
       </p:sp>

</xml_diff>

<commit_message>
Collapse programme to phases 0-4; separate development from delivery
Removes the standalone MVP integration trial phase (COGCON has already
been trialled in live training; integration evidence folds into
mapping and validation) so report back becomes Phase 4. Rewords the
developmental-models line from "Delivered" to "Developed" and adds an
explicit delivery attribution to training establishments, units and
existing instructor workforces, so the Lead Self-Systems progression
no longer reads as NZALC-only delivery.

Co-Authored-By: Claude Fable 5 <noreply@anthropic.com>
Claude-Session: https://claude.ai/code/session_01YLo1WfwUDkbwfJEF3ZNVbB
</commit_message>
<xml_diff>
--- a/output/combat-mindset-onepager-portrait.pptx
+++ b/output/combat-mindset-onepager-portrait.pptx
@@ -3889,8 +3889,8 @@
         </p:nvSpPr>
         <p:spPr>
           <a:xfrm>
-            <a:off x="457200" y="8631936"/>
-            <a:ext cx="6647688" cy="182880"/>
+            <a:off x="457200" y="8595360"/>
+            <a:ext cx="6647688" cy="164592"/>
           </a:xfrm>
           <a:prstGeom prst="rect">
             <a:avLst/>
@@ -3914,7 +3914,7 @@
                 <a:ea typeface="Arial" pitchFamily="34" charset="-122"/>
                 <a:cs typeface="Arial" pitchFamily="34" charset="-120"/>
               </a:rPr>
-              <a:t>Delivered across the Prepare – Perform – Recover cycle   ·   Lead Self</a:t>
+              <a:t>Developed across the Prepare – Perform – Recover cycle   ·   Lead Self</a:t>
             </a:r>
             <a:pPr algn="ctr" indent="0" marL="0">
               <a:buNone/>
@@ -4006,7 +4006,46 @@
       </p:sp>
       <p:sp>
         <p:nvSpPr>
-          <p:cNvPr id="91" name="Shape 77"/>
+          <p:cNvPr id="91" name="Text 77"/>
+          <p:cNvSpPr/>
+          <p:nvPr/>
+        </p:nvSpPr>
+        <p:spPr>
+          <a:xfrm>
+            <a:off x="457200" y="8769096"/>
+            <a:ext cx="6647688" cy="137160"/>
+          </a:xfrm>
+          <a:prstGeom prst="rect">
+            <a:avLst/>
+          </a:prstGeom>
+          <a:noFill/>
+          <a:ln/>
+        </p:spPr>
+        <p:txBody>
+          <a:bodyPr wrap="square" lIns="0" tIns="0" rIns="0" bIns="0" rtlCol="0" anchor="ctr"/>
+          <a:lstStyle/>
+          <a:p>
+            <a:pPr algn="ctr" indent="0" marL="0">
+              <a:buNone/>
+            </a:pPr>
+            <a:r>
+              <a:rPr lang="en-US" sz="700" i="1" dirty="0">
+                <a:solidFill>
+                  <a:srgbClr val="000000"/>
+                </a:solidFill>
+                <a:latin typeface="Arial" pitchFamily="34" charset="0"/>
+                <a:ea typeface="Arial" pitchFamily="34" charset="-122"/>
+                <a:cs typeface="Arial" pitchFamily="34" charset="-120"/>
+              </a:rPr>
+              <a:t>Delivered by approved training establishments, units and existing instructor workforces across Army</a:t>
+            </a:r>
+            <a:endParaRPr lang="en-US" sz="700" dirty="0"/>
+          </a:p>
+        </p:txBody>
+      </p:sp>
+      <p:sp>
+        <p:nvSpPr>
+          <p:cNvPr id="92" name="Shape 78"/>
           <p:cNvSpPr/>
           <p:nvPr/>
         </p:nvSpPr>
@@ -4028,7 +4067,7 @@
       </p:sp>
       <p:pic>
         <p:nvPicPr>
-          <p:cNvPr id="92" name="Image 12" descr="preencoded.png">    </p:cNvPr>
+          <p:cNvPr id="93" name="Image 12" descr="preencoded.png">    </p:cNvPr>
           <p:cNvPicPr>
             <a:picLocks noChangeAspect="1"/>
           </p:cNvPicPr>
@@ -4052,7 +4091,7 @@
       </p:pic>
       <p:sp>
         <p:nvSpPr>
-          <p:cNvPr id="93" name="Text 78"/>
+          <p:cNvPr id="94" name="Text 79"/>
           <p:cNvSpPr/>
           <p:nvPr/>
         </p:nvSpPr>
@@ -4091,7 +4130,7 @@
       </p:sp>
       <p:sp>
         <p:nvSpPr>
-          <p:cNvPr id="94" name="Text 79"/>
+          <p:cNvPr id="95" name="Text 80"/>
           <p:cNvSpPr/>
           <p:nvPr/>
         </p:nvSpPr>
@@ -4218,7 +4257,7 @@
       </p:sp>
       <p:sp>
         <p:nvSpPr>
-          <p:cNvPr id="95" name="Shape 80"/>
+          <p:cNvPr id="96" name="Shape 81"/>
           <p:cNvSpPr/>
           <p:nvPr/>
         </p:nvSpPr>
@@ -4240,7 +4279,7 @@
       </p:sp>
       <p:pic>
         <p:nvPicPr>
-          <p:cNvPr id="96" name="Image 13" descr="preencoded.png">    </p:cNvPr>
+          <p:cNvPr id="97" name="Image 13" descr="preencoded.png">    </p:cNvPr>
           <p:cNvPicPr>
             <a:picLocks noChangeAspect="1"/>
           </p:cNvPicPr>
@@ -4264,7 +4303,7 @@
       </p:pic>
       <p:sp>
         <p:nvSpPr>
-          <p:cNvPr id="97" name="Text 81"/>
+          <p:cNvPr id="98" name="Text 82"/>
           <p:cNvSpPr/>
           <p:nvPr/>
         </p:nvSpPr>
@@ -4295,7 +4334,7 @@
                 <a:ea typeface="Arial" pitchFamily="34" charset="-122"/>
                 <a:cs typeface="Arial" pitchFamily="34" charset="-120"/>
               </a:rPr>
-              <a:t>PROGRAMME OF WORK — PHASES 0–5</a:t>
+              <a:t>PROGRAMME OF WORK — PHASES 0–4</a:t>
             </a:r>
             <a:endParaRPr lang="en-US" sz="880" dirty="0"/>
           </a:p>
@@ -4303,7 +4342,7 @@
       </p:sp>
       <p:sp>
         <p:nvSpPr>
-          <p:cNvPr id="98" name="Text 82"/>
+          <p:cNvPr id="99" name="Text 83"/>
           <p:cNvSpPr/>
           <p:nvPr/>
         </p:nvSpPr>
@@ -4357,7 +4396,7 @@
                 <a:ea typeface="Arial" pitchFamily="34" charset="-122"/>
                 <a:cs typeface="Arial" pitchFamily="34" charset="-120"/>
               </a:rPr>
-              <a:t>1.  Map current capabilities and products</a:t>
+              <a:t>1.  Map current capabilities, products and evidence</a:t>
             </a:r>
             <a:endParaRPr lang="en-US" sz="700" dirty="0"/>
           </a:p>
@@ -4417,35 +4456,15 @@
                 <a:ea typeface="Arial" pitchFamily="34" charset="-122"/>
                 <a:cs typeface="Arial" pitchFamily="34" charset="-120"/>
               </a:rPr>
-              <a:t>4.  Limited COGCON MVP integration trial (subject to capacity)</a:t>
+              <a:t>4.  Report back — Framework v1.0, November 2026</a:t>
             </a:r>
             <a:endParaRPr lang="en-US" sz="700" dirty="0"/>
           </a:p>
-          <a:p>
-            <a:pPr algn="l" indent="0" marL="0">
-              <a:spcAft>
-                <a:spcPts val="200"/>
-              </a:spcAft>
-              <a:buNone/>
-            </a:pPr>
-            <a:r>
-              <a:rPr lang="en-US" sz="700" dirty="0">
-                <a:solidFill>
-                  <a:srgbClr val="000000"/>
-                </a:solidFill>
-                <a:latin typeface="Arial" pitchFamily="34" charset="0"/>
-                <a:ea typeface="Arial" pitchFamily="34" charset="-122"/>
-                <a:cs typeface="Arial" pitchFamily="34" charset="-120"/>
-              </a:rPr>
-              <a:t>5.  Report back — Framework v1.0, November 2026</a:t>
-            </a:r>
-            <a:endParaRPr lang="en-US" sz="700" dirty="0"/>
-          </a:p>
-        </p:txBody>
-      </p:sp>
-      <p:sp>
-        <p:nvSpPr>
-          <p:cNvPr id="99" name="Shape 83"/>
+        </p:txBody>
+      </p:sp>
+      <p:sp>
+        <p:nvSpPr>
+          <p:cNvPr id="100" name="Shape 84"/>
           <p:cNvSpPr/>
           <p:nvPr/>
         </p:nvSpPr>
@@ -4465,7 +4484,7 @@
       </p:sp>
       <p:pic>
         <p:nvPicPr>
-          <p:cNvPr id="100" name="Image 14" descr="preencoded.png">    </p:cNvPr>
+          <p:cNvPr id="101" name="Image 14" descr="preencoded.png">    </p:cNvPr>
           <p:cNvPicPr>
             <a:picLocks noChangeAspect="1"/>
           </p:cNvPicPr>
@@ -4489,7 +4508,7 @@
       </p:pic>
       <p:sp>
         <p:nvSpPr>
-          <p:cNvPr id="101" name="Text 84"/>
+          <p:cNvPr id="102" name="Text 85"/>
           <p:cNvSpPr/>
           <p:nvPr/>
         </p:nvSpPr>

</xml_diff>

<commit_message>
Combine one-pager into the paper; re-attribute as ACS product (v0.5)
The paper now opens cover > hyperlinked contents > The Model on a Page
(the portrait one-pager embedded at 300dpi as the first section, in
the TOC) > body. Cover re-attributed: Army Command School originator,
ACS 2026 reference, joint NZALC/HPC subtitle replaced with the mission
line, named originators and distribution row removed. Both one-pagers
carry the same ACS document control. Version to Draft v0.5.

Co-Authored-By: Claude Fable 5 <noreply@anthropic.com>
Claude-Session: https://claude.ai/code/session_01YLo1WfwUDkbwfJEF3ZNVbB
</commit_message>
<xml_diff>
--- a/output/combat-mindset-onepager-portrait.pptx
+++ b/output/combat-mindset-onepager-portrait.pptx
@@ -1026,7 +1026,7 @@
                 <a:ea typeface="Arial" pitchFamily="34" charset="-122"/>
                 <a:cs typeface="Arial" pitchFamily="34" charset="-120"/>
               </a:rPr>
-              <a:t>NZALC / HPC  ·  Draft v0.4  ·  July 2026</a:t>
+              <a:t>Army Command School  ·  ACS 2026</a:t>
             </a:r>
             <a:endParaRPr lang="en-US" sz="600" dirty="0"/>
           </a:p>
@@ -1065,7 +1065,7 @@
                 <a:ea typeface="Arial" pitchFamily="34" charset="-122"/>
                 <a:cs typeface="Arial" pitchFamily="34" charset="-120"/>
               </a:rPr>
-              <a:t>Distribution: COMDT ACS</a:t>
+              <a:t>Draft v0.5  ·  July 2026</a:t>
             </a:r>
             <a:endParaRPr lang="en-US" sz="600" dirty="0"/>
           </a:p>
@@ -1167,7 +1167,7 @@
                 <a:ea typeface="Arial" pitchFamily="34" charset="-122"/>
                 <a:cs typeface="Arial" pitchFamily="34" charset="-120"/>
               </a:rPr>
-              <a:t>Joint NZALC and Human Performance Cell response to COMDT ACS</a:t>
+              <a:t>Defining, developing and assuring the human-performance capability Army requires to remain effective in combat.</a:t>
             </a:r>
             <a:endParaRPr lang="en-US" sz="800" dirty="0"/>
           </a:p>

</xml_diff>

<commit_message>
Model on a Page declutter: banners, rules and qualifier removed
Removed UNCLASSIFIED banners and black bars, header subtitle and rule,
connector side-rules, tagline qualifier and all rendered em dashes
(phase titles use colons; PUP products use parentheses). Three feature
cards now centre their headings and supporting text with icons kept
left; crosshair moved to the left of the Combat Mindset card; PUP
supporting line simplified to Prepare - Perform - Recover. Paper embed
regenerated.

Co-Authored-By: Claude Fable 5 <noreply@anthropic.com>
Claude-Session: https://claude.ai/code/session_01YLo1WfwUDkbwfJEF3ZNVbB
</commit_message>
<xml_diff>
--- a/output/combat-mindset-onepager-portrait.pptx
+++ b/output/combat-mindset-onepager-portrait.pptx
@@ -877,131 +877,13 @@
       </p:grpSpPr>
       <p:sp>
         <p:nvSpPr>
-          <p:cNvPr id="2" name="Shape 0"/>
-          <p:cNvSpPr/>
-          <p:nvPr/>
-        </p:nvSpPr>
-        <p:spPr>
-          <a:xfrm>
-            <a:off x="0" y="0"/>
-            <a:ext cx="7562088" cy="164592"/>
-          </a:xfrm>
-          <a:prstGeom prst="rect">
-            <a:avLst/>
-          </a:prstGeom>
-          <a:solidFill>
-            <a:srgbClr val="000000"/>
-          </a:solidFill>
-          <a:ln/>
-        </p:spPr>
-      </p:sp>
-      <p:sp>
-        <p:nvSpPr>
-          <p:cNvPr id="3" name="Text 1"/>
-          <p:cNvSpPr/>
-          <p:nvPr/>
-        </p:nvSpPr>
-        <p:spPr>
-          <a:xfrm>
-            <a:off x="0" y="0"/>
-            <a:ext cx="7562088" cy="164592"/>
-          </a:xfrm>
-          <a:prstGeom prst="rect">
-            <a:avLst/>
-          </a:prstGeom>
-          <a:noFill/>
-          <a:ln/>
-        </p:spPr>
-        <p:txBody>
-          <a:bodyPr wrap="square" lIns="0" tIns="0" rIns="0" bIns="0" rtlCol="0" anchor="ctr"/>
-          <a:lstStyle/>
-          <a:p>
-            <a:pPr algn="ctr" indent="0" marL="0">
-              <a:buNone/>
-            </a:pPr>
-            <a:r>
-              <a:rPr lang="en-US" sz="750" b="1" spc="400" kern="0" dirty="0">
-                <a:solidFill>
-                  <a:srgbClr val="FFFFFF"/>
-                </a:solidFill>
-                <a:latin typeface="Arial" pitchFamily="34" charset="0"/>
-                <a:ea typeface="Arial" pitchFamily="34" charset="-122"/>
-                <a:cs typeface="Arial" pitchFamily="34" charset="-120"/>
-              </a:rPr>
-              <a:t>UNCLASSIFIED</a:t>
-            </a:r>
-            <a:endParaRPr lang="en-US" sz="750" dirty="0"/>
-          </a:p>
-        </p:txBody>
-      </p:sp>
-      <p:sp>
-        <p:nvSpPr>
-          <p:cNvPr id="4" name="Shape 2"/>
-          <p:cNvSpPr/>
-          <p:nvPr/>
-        </p:nvSpPr>
-        <p:spPr>
-          <a:xfrm>
-            <a:off x="0" y="10524744"/>
-            <a:ext cx="7562088" cy="164592"/>
-          </a:xfrm>
-          <a:prstGeom prst="rect">
-            <a:avLst/>
-          </a:prstGeom>
-          <a:solidFill>
-            <a:srgbClr val="000000"/>
-          </a:solidFill>
-          <a:ln/>
-        </p:spPr>
-      </p:sp>
-      <p:sp>
-        <p:nvSpPr>
-          <p:cNvPr id="5" name="Text 3"/>
-          <p:cNvSpPr/>
-          <p:nvPr/>
-        </p:nvSpPr>
-        <p:spPr>
-          <a:xfrm>
-            <a:off x="0" y="10524744"/>
-            <a:ext cx="7562088" cy="164592"/>
-          </a:xfrm>
-          <a:prstGeom prst="rect">
-            <a:avLst/>
-          </a:prstGeom>
-          <a:noFill/>
-          <a:ln/>
-        </p:spPr>
-        <p:txBody>
-          <a:bodyPr wrap="square" lIns="0" tIns="0" rIns="0" bIns="0" rtlCol="0" anchor="ctr"/>
-          <a:lstStyle/>
-          <a:p>
-            <a:pPr algn="ctr" indent="0" marL="0">
-              <a:buNone/>
-            </a:pPr>
-            <a:r>
-              <a:rPr lang="en-US" sz="750" b="1" spc="400" kern="0" dirty="0">
-                <a:solidFill>
-                  <a:srgbClr val="FFFFFF"/>
-                </a:solidFill>
-                <a:latin typeface="Arial" pitchFamily="34" charset="0"/>
-                <a:ea typeface="Arial" pitchFamily="34" charset="-122"/>
-                <a:cs typeface="Arial" pitchFamily="34" charset="-120"/>
-              </a:rPr>
-              <a:t>UNCLASSIFIED</a:t>
-            </a:r>
-            <a:endParaRPr lang="en-US" sz="750" dirty="0"/>
-          </a:p>
-        </p:txBody>
-      </p:sp>
-      <p:sp>
-        <p:nvSpPr>
-          <p:cNvPr id="6" name="Text 4"/>
-          <p:cNvSpPr/>
-          <p:nvPr/>
-        </p:nvSpPr>
-        <p:spPr>
-          <a:xfrm>
-            <a:off x="457200" y="10524744"/>
+          <p:cNvPr id="2" name="Text 0"/>
+          <p:cNvSpPr/>
+          <p:nvPr/>
+        </p:nvSpPr>
+        <p:spPr>
+          <a:xfrm>
+            <a:off x="457200" y="10469880"/>
             <a:ext cx="2377440" cy="164592"/>
           </a:xfrm>
           <a:prstGeom prst="rect">
@@ -1020,7 +902,7 @@
             <a:r>
               <a:rPr lang="en-US" sz="600" dirty="0">
                 <a:solidFill>
-                  <a:srgbClr val="CDD2B7"/>
+                  <a:srgbClr val="000000"/>
                 </a:solidFill>
                 <a:latin typeface="Arial" pitchFamily="34" charset="0"/>
                 <a:ea typeface="Arial" pitchFamily="34" charset="-122"/>
@@ -1034,13 +916,13 @@
       </p:sp>
       <p:sp>
         <p:nvSpPr>
-          <p:cNvPr id="7" name="Text 5"/>
-          <p:cNvSpPr/>
-          <p:nvPr/>
-        </p:nvSpPr>
-        <p:spPr>
-          <a:xfrm>
-            <a:off x="5212080" y="10524744"/>
+          <p:cNvPr id="3" name="Text 1"/>
+          <p:cNvSpPr/>
+          <p:nvPr/>
+        </p:nvSpPr>
+        <p:spPr>
+          <a:xfrm>
+            <a:off x="5212080" y="10469880"/>
             <a:ext cx="1892808" cy="164592"/>
           </a:xfrm>
           <a:prstGeom prst="rect">
@@ -1059,7 +941,7 @@
             <a:r>
               <a:rPr lang="en-US" sz="600" dirty="0">
                 <a:solidFill>
-                  <a:srgbClr val="CDD2B7"/>
+                  <a:srgbClr val="000000"/>
                 </a:solidFill>
                 <a:latin typeface="Arial" pitchFamily="34" charset="0"/>
                 <a:ea typeface="Arial" pitchFamily="34" charset="-122"/>
@@ -1073,7 +955,7 @@
       </p:sp>
       <p:pic>
         <p:nvPicPr>
-          <p:cNvPr id="8" name="Image 0" descr="/tmp/claude-0/-home-user-PUP/2d4cec0e-a52e-5368-bb54-803c6f37698d/scratchpad/logo-trimmed.png">    </p:cNvPr>
+          <p:cNvPr id="4" name="Image 0" descr="/tmp/claude-0/-home-user-PUP/2d4cec0e-a52e-5368-bb54-803c6f37698d/scratchpad/logo-trimmed.png">    </p:cNvPr>
           <p:cNvPicPr>
             <a:picLocks noChangeAspect="1"/>
           </p:cNvPicPr>
@@ -1087,7 +969,7 @@
         </p:blipFill>
         <p:spPr>
           <a:xfrm>
-            <a:off x="457200" y="310896"/>
+            <a:off x="457200" y="457200"/>
             <a:ext cx="1005840" cy="243230"/>
           </a:xfrm>
           <a:prstGeom prst="rect">
@@ -1097,14 +979,14 @@
       </p:pic>
       <p:sp>
         <p:nvSpPr>
-          <p:cNvPr id="9" name="Text 6"/>
-          <p:cNvSpPr/>
-          <p:nvPr/>
-        </p:nvSpPr>
-        <p:spPr>
-          <a:xfrm>
-            <a:off x="1691640" y="274320"/>
-            <a:ext cx="5413248" cy="256032"/>
+          <p:cNvPr id="5" name="Text 2"/>
+          <p:cNvSpPr/>
+          <p:nvPr/>
+        </p:nvSpPr>
+        <p:spPr>
+          <a:xfrm>
+            <a:off x="1691640" y="429768"/>
+            <a:ext cx="5413248" cy="292608"/>
           </a:xfrm>
           <a:prstGeom prst="rect">
             <a:avLst/>
@@ -1128,7 +1010,7 @@
                 <a:ea typeface="Arial" pitchFamily="34" charset="-122"/>
                 <a:cs typeface="Arial" pitchFamily="34" charset="-120"/>
               </a:rPr>
-              <a:t>COMBAT MINDSET — THE WAY FORWARD</a:t>
+              <a:t>COMBAT MINDSET THE WAY FORWARD</a:t>
             </a:r>
             <a:endParaRPr lang="en-US" sz="1550" dirty="0"/>
           </a:p>
@@ -1136,69 +1018,7 @@
       </p:sp>
       <p:sp>
         <p:nvSpPr>
-          <p:cNvPr id="10" name="Text 7"/>
-          <p:cNvSpPr/>
-          <p:nvPr/>
-        </p:nvSpPr>
-        <p:spPr>
-          <a:xfrm>
-            <a:off x="1691640" y="530352"/>
-            <a:ext cx="5413248" cy="164592"/>
-          </a:xfrm>
-          <a:prstGeom prst="rect">
-            <a:avLst/>
-          </a:prstGeom>
-          <a:noFill/>
-          <a:ln/>
-        </p:spPr>
-        <p:txBody>
-          <a:bodyPr wrap="square" lIns="0" tIns="0" rIns="0" bIns="0" rtlCol="0" anchor="ctr"/>
-          <a:lstStyle/>
-          <a:p>
-            <a:pPr algn="l" indent="0" marL="0">
-              <a:buNone/>
-            </a:pPr>
-            <a:r>
-              <a:rPr lang="en-US" sz="800" i="1" dirty="0">
-                <a:solidFill>
-                  <a:srgbClr val="000000"/>
-                </a:solidFill>
-                <a:latin typeface="Arial" pitchFamily="34" charset="0"/>
-                <a:ea typeface="Arial" pitchFamily="34" charset="-122"/>
-                <a:cs typeface="Arial" pitchFamily="34" charset="-120"/>
-              </a:rPr>
-              <a:t>Defining, developing and assuring the human-performance capability Army requires to remain effective in combat.</a:t>
-            </a:r>
-            <a:endParaRPr lang="en-US" sz="800" dirty="0"/>
-          </a:p>
-        </p:txBody>
-      </p:sp>
-      <p:sp>
-        <p:nvSpPr>
-          <p:cNvPr id="11" name="Shape 8"/>
-          <p:cNvSpPr/>
-          <p:nvPr/>
-        </p:nvSpPr>
-        <p:spPr>
-          <a:xfrm>
-            <a:off x="457200" y="822960"/>
-            <a:ext cx="6647688" cy="0"/>
-          </a:xfrm>
-          <a:prstGeom prst="line">
-            <a:avLst/>
-          </a:prstGeom>
-          <a:noFill/>
-          <a:ln w="12700">
-            <a:solidFill>
-              <a:srgbClr val="000000"/>
-            </a:solidFill>
-            <a:prstDash val="solid"/>
-          </a:ln>
-        </p:spPr>
-      </p:sp>
-      <p:sp>
-        <p:nvSpPr>
-          <p:cNvPr id="12" name="Shape 9"/>
+          <p:cNvPr id="6" name="Shape 3"/>
           <p:cNvSpPr/>
           <p:nvPr/>
         </p:nvSpPr>
@@ -1218,7 +1038,7 @@
       </p:sp>
       <p:sp>
         <p:nvSpPr>
-          <p:cNvPr id="13" name="Shape 10"/>
+          <p:cNvPr id="7" name="Shape 4"/>
           <p:cNvSpPr/>
           <p:nvPr/>
         </p:nvSpPr>
@@ -1245,7 +1065,7 @@
       </p:sp>
       <p:sp>
         <p:nvSpPr>
-          <p:cNvPr id="14" name="Text 11"/>
+          <p:cNvPr id="8" name="Text 5"/>
           <p:cNvSpPr/>
           <p:nvPr/>
         </p:nvSpPr>
@@ -1284,7 +1104,7 @@
       </p:sp>
       <p:pic>
         <p:nvPicPr>
-          <p:cNvPr id="15" name="Image 1" descr="preencoded.png">    </p:cNvPr>
+          <p:cNvPr id="9" name="Image 1" descr="preencoded.png">    </p:cNvPr>
           <p:cNvPicPr>
             <a:picLocks noChangeAspect="1"/>
           </p:cNvPicPr>
@@ -1300,8 +1120,8 @@
         </p:blipFill>
         <p:spPr>
           <a:xfrm>
-            <a:off x="5943600" y="1298448"/>
-            <a:ext cx="713232" cy="713232"/>
+            <a:off x="713232" y="1335024"/>
+            <a:ext cx="603504" cy="603504"/>
           </a:xfrm>
           <a:prstGeom prst="rect">
             <a:avLst/>
@@ -1310,14 +1130,14 @@
       </p:pic>
       <p:sp>
         <p:nvSpPr>
-          <p:cNvPr id="16" name="Text 12"/>
-          <p:cNvSpPr/>
-          <p:nvPr/>
-        </p:nvSpPr>
-        <p:spPr>
-          <a:xfrm>
-            <a:off x="731520" y="1298448"/>
-            <a:ext cx="5257800" cy="502920"/>
+          <p:cNvPr id="10" name="Text 6"/>
+          <p:cNvSpPr/>
+          <p:nvPr/>
+        </p:nvSpPr>
+        <p:spPr>
+          <a:xfrm>
+            <a:off x="457200" y="1316736"/>
+            <a:ext cx="6647688" cy="502920"/>
           </a:xfrm>
           <a:prstGeom prst="rect">
             <a:avLst/>
@@ -1329,7 +1149,7 @@
           <a:bodyPr wrap="square" lIns="0" tIns="0" rIns="0" bIns="0" rtlCol="0" anchor="ctr"/>
           <a:lstStyle/>
           <a:p>
-            <a:pPr algn="l" indent="0" marL="0">
+            <a:pPr algn="ctr" indent="0" marL="0">
               <a:buNone/>
             </a:pPr>
             <a:r>
@@ -1349,14 +1169,14 @@
       </p:sp>
       <p:sp>
         <p:nvSpPr>
-          <p:cNvPr id="17" name="Text 13"/>
-          <p:cNvSpPr/>
-          <p:nvPr/>
-        </p:nvSpPr>
-        <p:spPr>
-          <a:xfrm>
-            <a:off x="749808" y="1828800"/>
-            <a:ext cx="5257800" cy="237744"/>
+          <p:cNvPr id="11" name="Text 7"/>
+          <p:cNvSpPr/>
+          <p:nvPr/>
+        </p:nvSpPr>
+        <p:spPr>
+          <a:xfrm>
+            <a:off x="457200" y="1847088"/>
+            <a:ext cx="6647688" cy="237744"/>
           </a:xfrm>
           <a:prstGeom prst="rect">
             <a:avLst/>
@@ -1368,7 +1188,7 @@
           <a:bodyPr wrap="square" lIns="0" tIns="0" rIns="0" bIns="0" rtlCol="0" anchor="ctr"/>
           <a:lstStyle/>
           <a:p>
-            <a:pPr algn="l" indent="0" marL="0">
+            <a:pPr algn="ctr" indent="0" marL="0">
               <a:buNone/>
             </a:pPr>
             <a:r>
@@ -1388,46 +1208,7 @@
       </p:sp>
       <p:sp>
         <p:nvSpPr>
-          <p:cNvPr id="18" name="Text 14"/>
-          <p:cNvSpPr/>
-          <p:nvPr/>
-        </p:nvSpPr>
-        <p:spPr>
-          <a:xfrm>
-            <a:off x="4023360" y="2048256"/>
-            <a:ext cx="2926080" cy="109728"/>
-          </a:xfrm>
-          <a:prstGeom prst="rect">
-            <a:avLst/>
-          </a:prstGeom>
-          <a:noFill/>
-          <a:ln/>
-        </p:spPr>
-        <p:txBody>
-          <a:bodyPr wrap="square" lIns="0" tIns="0" rIns="0" bIns="0" rtlCol="0" anchor="ctr"/>
-          <a:lstStyle/>
-          <a:p>
-            <a:pPr algn="r" indent="0" marL="0">
-              <a:buNone/>
-            </a:pPr>
-            <a:r>
-              <a:rPr lang="en-US" sz="580" i="1" dirty="0">
-                <a:solidFill>
-                  <a:srgbClr val="CDD2B7"/>
-                </a:solidFill>
-                <a:latin typeface="Arial" pitchFamily="34" charset="0"/>
-                <a:ea typeface="Arial" pitchFamily="34" charset="-122"/>
-                <a:cs typeface="Arial" pitchFamily="34" charset="-120"/>
-              </a:rPr>
-              <a:t>Tagline subject to sponsor endorsement</a:t>
-            </a:r>
-            <a:endParaRPr lang="en-US" sz="580" dirty="0"/>
-          </a:p>
-        </p:txBody>
-      </p:sp>
-      <p:sp>
-        <p:nvSpPr>
-          <p:cNvPr id="19" name="Shape 15"/>
+          <p:cNvPr id="12" name="Shape 8"/>
           <p:cNvSpPr/>
           <p:nvPr/>
         </p:nvSpPr>
@@ -1447,7 +1228,7 @@
       </p:sp>
       <p:sp>
         <p:nvSpPr>
-          <p:cNvPr id="20" name="Text 16"/>
+          <p:cNvPr id="13" name="Text 9"/>
           <p:cNvSpPr/>
           <p:nvPr/>
         </p:nvSpPr>
@@ -1486,53 +1267,7 @@
       </p:sp>
       <p:sp>
         <p:nvSpPr>
-          <p:cNvPr id="21" name="Shape 17"/>
-          <p:cNvSpPr/>
-          <p:nvPr/>
-        </p:nvSpPr>
-        <p:spPr>
-          <a:xfrm>
-            <a:off x="960120" y="2478024"/>
-            <a:ext cx="1037844" cy="0"/>
-          </a:xfrm>
-          <a:prstGeom prst="line">
-            <a:avLst/>
-          </a:prstGeom>
-          <a:noFill/>
-          <a:ln w="9525">
-            <a:solidFill>
-              <a:srgbClr val="A89662"/>
-            </a:solidFill>
-            <a:prstDash val="solid"/>
-          </a:ln>
-        </p:spPr>
-      </p:sp>
-      <p:sp>
-        <p:nvSpPr>
-          <p:cNvPr id="22" name="Shape 18"/>
-          <p:cNvSpPr/>
-          <p:nvPr/>
-        </p:nvSpPr>
-        <p:spPr>
-          <a:xfrm>
-            <a:off x="5564124" y="2478024"/>
-            <a:ext cx="1037844" cy="0"/>
-          </a:xfrm>
-          <a:prstGeom prst="line">
-            <a:avLst/>
-          </a:prstGeom>
-          <a:noFill/>
-          <a:ln w="9525">
-            <a:solidFill>
-              <a:srgbClr val="A89662"/>
-            </a:solidFill>
-            <a:prstDash val="solid"/>
-          </a:ln>
-        </p:spPr>
-      </p:sp>
-      <p:sp>
-        <p:nvSpPr>
-          <p:cNvPr id="23" name="Shape 19"/>
+          <p:cNvPr id="14" name="Shape 10"/>
           <p:cNvSpPr/>
           <p:nvPr/>
         </p:nvSpPr>
@@ -1552,7 +1287,7 @@
       </p:sp>
       <p:sp>
         <p:nvSpPr>
-          <p:cNvPr id="24" name="Shape 20"/>
+          <p:cNvPr id="15" name="Shape 11"/>
           <p:cNvSpPr/>
           <p:nvPr/>
         </p:nvSpPr>
@@ -1579,7 +1314,7 @@
       </p:sp>
       <p:sp>
         <p:nvSpPr>
-          <p:cNvPr id="25" name="Text 21"/>
+          <p:cNvPr id="16" name="Text 12"/>
           <p:cNvSpPr/>
           <p:nvPr/>
         </p:nvSpPr>
@@ -1618,7 +1353,7 @@
       </p:sp>
       <p:pic>
         <p:nvPicPr>
-          <p:cNvPr id="26" name="Image 2" descr="preencoded.png">    </p:cNvPr>
+          <p:cNvPr id="17" name="Image 2" descr="preencoded.png">    </p:cNvPr>
           <p:cNvPicPr>
             <a:picLocks noChangeAspect="1"/>
           </p:cNvPicPr>
@@ -1642,14 +1377,14 @@
       </p:pic>
       <p:sp>
         <p:nvSpPr>
-          <p:cNvPr id="27" name="Text 22"/>
-          <p:cNvSpPr/>
-          <p:nvPr/>
-        </p:nvSpPr>
-        <p:spPr>
-          <a:xfrm>
-            <a:off x="1280160" y="3035808"/>
-            <a:ext cx="5596128" cy="384048"/>
+          <p:cNvPr id="18" name="Text 13"/>
+          <p:cNvSpPr/>
+          <p:nvPr/>
+        </p:nvSpPr>
+        <p:spPr>
+          <a:xfrm>
+            <a:off x="457200" y="3035808"/>
+            <a:ext cx="6647688" cy="384048"/>
           </a:xfrm>
           <a:prstGeom prst="rect">
             <a:avLst/>
@@ -1681,14 +1416,14 @@
       </p:sp>
       <p:sp>
         <p:nvSpPr>
-          <p:cNvPr id="28" name="Text 23"/>
-          <p:cNvSpPr/>
-          <p:nvPr/>
-        </p:nvSpPr>
-        <p:spPr>
-          <a:xfrm>
-            <a:off x="594360" y="3465576"/>
-            <a:ext cx="6373368" cy="182880"/>
+          <p:cNvPr id="19" name="Text 14"/>
+          <p:cNvSpPr/>
+          <p:nvPr/>
+        </p:nvSpPr>
+        <p:spPr>
+          <a:xfrm>
+            <a:off x="457200" y="3465576"/>
+            <a:ext cx="6647688" cy="182880"/>
           </a:xfrm>
           <a:prstGeom prst="rect">
             <a:avLst/>
@@ -1704,7 +1439,7 @@
               <a:buNone/>
             </a:pPr>
             <a:r>
-              <a:rPr lang="en-US" sz="860" b="1" dirty="0">
+              <a:rPr lang="en-US" sz="1050" b="1" dirty="0">
                 <a:solidFill>
                   <a:srgbClr val="FFFFFF"/>
                 </a:solidFill>
@@ -1712,15 +1447,15 @@
                 <a:ea typeface="Arial" pitchFamily="34" charset="-122"/>
                 <a:cs typeface="Arial" pitchFamily="34" charset="-120"/>
               </a:rPr>
-              <a:t>Prepare for pressure   ·   Perform through pressure   ·   Adapt within pressure   ·   Recover from pressure</a:t>
-            </a:r>
-            <a:endParaRPr lang="en-US" sz="860" dirty="0"/>
-          </a:p>
-        </p:txBody>
-      </p:sp>
-      <p:sp>
-        <p:nvSpPr>
-          <p:cNvPr id="29" name="Shape 24"/>
+              <a:t>Prepare   •   Perform   •   Recover</a:t>
+            </a:r>
+            <a:endParaRPr lang="en-US" sz="1050" dirty="0"/>
+          </a:p>
+        </p:txBody>
+      </p:sp>
+      <p:sp>
+        <p:nvSpPr>
+          <p:cNvPr id="20" name="Shape 15"/>
           <p:cNvSpPr/>
           <p:nvPr/>
         </p:nvSpPr>
@@ -1740,7 +1475,7 @@
       </p:sp>
       <p:sp>
         <p:nvSpPr>
-          <p:cNvPr id="30" name="Text 25"/>
+          <p:cNvPr id="21" name="Text 16"/>
           <p:cNvSpPr/>
           <p:nvPr/>
         </p:nvSpPr>
@@ -1779,53 +1514,7 @@
       </p:sp>
       <p:sp>
         <p:nvSpPr>
-          <p:cNvPr id="31" name="Shape 26"/>
-          <p:cNvSpPr/>
-          <p:nvPr/>
-        </p:nvSpPr>
-        <p:spPr>
-          <a:xfrm>
-            <a:off x="960120" y="4069080"/>
-            <a:ext cx="1037844" cy="0"/>
-          </a:xfrm>
-          <a:prstGeom prst="line">
-            <a:avLst/>
-          </a:prstGeom>
-          <a:noFill/>
-          <a:ln w="9525">
-            <a:solidFill>
-              <a:srgbClr val="A89662"/>
-            </a:solidFill>
-            <a:prstDash val="solid"/>
-          </a:ln>
-        </p:spPr>
-      </p:sp>
-      <p:sp>
-        <p:nvSpPr>
-          <p:cNvPr id="32" name="Shape 27"/>
-          <p:cNvSpPr/>
-          <p:nvPr/>
-        </p:nvSpPr>
-        <p:spPr>
-          <a:xfrm>
-            <a:off x="5564124" y="4069080"/>
-            <a:ext cx="1037844" cy="0"/>
-          </a:xfrm>
-          <a:prstGeom prst="line">
-            <a:avLst/>
-          </a:prstGeom>
-          <a:noFill/>
-          <a:ln w="9525">
-            <a:solidFill>
-              <a:srgbClr val="A89662"/>
-            </a:solidFill>
-            <a:prstDash val="solid"/>
-          </a:ln>
-        </p:spPr>
-      </p:sp>
-      <p:sp>
-        <p:nvSpPr>
-          <p:cNvPr id="33" name="Shape 28"/>
+          <p:cNvPr id="22" name="Shape 17"/>
           <p:cNvSpPr/>
           <p:nvPr/>
         </p:nvSpPr>
@@ -1845,7 +1534,7 @@
       </p:sp>
       <p:sp>
         <p:nvSpPr>
-          <p:cNvPr id="34" name="Shape 29"/>
+          <p:cNvPr id="23" name="Shape 18"/>
           <p:cNvSpPr/>
           <p:nvPr/>
         </p:nvSpPr>
@@ -1872,7 +1561,7 @@
       </p:sp>
       <p:sp>
         <p:nvSpPr>
-          <p:cNvPr id="35" name="Text 30"/>
+          <p:cNvPr id="24" name="Text 19"/>
           <p:cNvSpPr/>
           <p:nvPr/>
         </p:nvSpPr>
@@ -1911,7 +1600,7 @@
       </p:sp>
       <p:pic>
         <p:nvPicPr>
-          <p:cNvPr id="36" name="Image 3" descr="preencoded.png">    </p:cNvPr>
+          <p:cNvPr id="25" name="Image 3" descr="preencoded.png">    </p:cNvPr>
           <p:cNvPicPr>
             <a:picLocks noChangeAspect="1"/>
           </p:cNvPicPr>
@@ -1935,14 +1624,14 @@
       </p:pic>
       <p:sp>
         <p:nvSpPr>
-          <p:cNvPr id="37" name="Text 31"/>
-          <p:cNvSpPr/>
-          <p:nvPr/>
-        </p:nvSpPr>
-        <p:spPr>
-          <a:xfrm>
-            <a:off x="1234440" y="4553712"/>
-            <a:ext cx="5687568" cy="329184"/>
+          <p:cNvPr id="26" name="Text 20"/>
+          <p:cNvSpPr/>
+          <p:nvPr/>
+        </p:nvSpPr>
+        <p:spPr>
+          <a:xfrm>
+            <a:off x="457200" y="4553712"/>
+            <a:ext cx="6647688" cy="329184"/>
           </a:xfrm>
           <a:prstGeom prst="rect">
             <a:avLst/>
@@ -1974,14 +1663,14 @@
       </p:sp>
       <p:sp>
         <p:nvSpPr>
-          <p:cNvPr id="38" name="Text 32"/>
-          <p:cNvSpPr/>
-          <p:nvPr/>
-        </p:nvSpPr>
-        <p:spPr>
-          <a:xfrm>
-            <a:off x="1234440" y="4910328"/>
-            <a:ext cx="5687568" cy="182880"/>
+          <p:cNvPr id="27" name="Text 21"/>
+          <p:cNvSpPr/>
+          <p:nvPr/>
+        </p:nvSpPr>
+        <p:spPr>
+          <a:xfrm>
+            <a:off x="457200" y="4910328"/>
+            <a:ext cx="6647688" cy="182880"/>
           </a:xfrm>
           <a:prstGeom prst="rect">
             <a:avLst/>
@@ -2013,7 +1702,7 @@
       </p:sp>
       <p:sp>
         <p:nvSpPr>
-          <p:cNvPr id="39" name="Shape 33"/>
+          <p:cNvPr id="28" name="Shape 22"/>
           <p:cNvSpPr/>
           <p:nvPr/>
         </p:nvSpPr>
@@ -2033,7 +1722,7 @@
       </p:sp>
       <p:pic>
         <p:nvPicPr>
-          <p:cNvPr id="40" name="Image 4" descr="preencoded.png">    </p:cNvPr>
+          <p:cNvPr id="29" name="Image 4" descr="preencoded.png">    </p:cNvPr>
           <p:cNvPicPr>
             <a:picLocks noChangeAspect="1"/>
           </p:cNvPicPr>
@@ -2057,7 +1746,7 @@
       </p:pic>
       <p:sp>
         <p:nvSpPr>
-          <p:cNvPr id="41" name="Text 34"/>
+          <p:cNvPr id="30" name="Text 23"/>
           <p:cNvSpPr/>
           <p:nvPr/>
         </p:nvSpPr>
@@ -2096,7 +1785,7 @@
       </p:sp>
       <p:sp>
         <p:nvSpPr>
-          <p:cNvPr id="42" name="Shape 35"/>
+          <p:cNvPr id="31" name="Shape 24"/>
           <p:cNvSpPr/>
           <p:nvPr/>
         </p:nvSpPr>
@@ -2121,7 +1810,7 @@
       </p:sp>
       <p:sp>
         <p:nvSpPr>
-          <p:cNvPr id="43" name="Shape 36"/>
+          <p:cNvPr id="32" name="Shape 25"/>
           <p:cNvSpPr/>
           <p:nvPr/>
         </p:nvSpPr>
@@ -2141,7 +1830,7 @@
       </p:sp>
       <p:pic>
         <p:nvPicPr>
-          <p:cNvPr id="44" name="Image 5" descr="preencoded.png">    </p:cNvPr>
+          <p:cNvPr id="33" name="Image 5" descr="preencoded.png">    </p:cNvPr>
           <p:cNvPicPr>
             <a:picLocks noChangeAspect="1"/>
           </p:cNvPicPr>
@@ -2165,7 +1854,7 @@
       </p:pic>
       <p:sp>
         <p:nvSpPr>
-          <p:cNvPr id="45" name="Text 37"/>
+          <p:cNvPr id="34" name="Text 26"/>
           <p:cNvSpPr/>
           <p:nvPr/>
         </p:nvSpPr>
@@ -2204,7 +1893,7 @@
       </p:sp>
       <p:sp>
         <p:nvSpPr>
-          <p:cNvPr id="46" name="Shape 38"/>
+          <p:cNvPr id="35" name="Shape 27"/>
           <p:cNvSpPr/>
           <p:nvPr/>
         </p:nvSpPr>
@@ -2229,7 +1918,7 @@
       </p:sp>
       <p:sp>
         <p:nvSpPr>
-          <p:cNvPr id="47" name="Shape 39"/>
+          <p:cNvPr id="36" name="Shape 28"/>
           <p:cNvSpPr/>
           <p:nvPr/>
         </p:nvSpPr>
@@ -2249,7 +1938,7 @@
       </p:sp>
       <p:pic>
         <p:nvPicPr>
-          <p:cNvPr id="48" name="Image 6" descr="preencoded.png">    </p:cNvPr>
+          <p:cNvPr id="37" name="Image 6" descr="preencoded.png">    </p:cNvPr>
           <p:cNvPicPr>
             <a:picLocks noChangeAspect="1"/>
           </p:cNvPicPr>
@@ -2273,7 +1962,7 @@
       </p:pic>
       <p:sp>
         <p:nvSpPr>
-          <p:cNvPr id="49" name="Text 40"/>
+          <p:cNvPr id="38" name="Text 29"/>
           <p:cNvSpPr/>
           <p:nvPr/>
         </p:nvSpPr>
@@ -2312,7 +2001,7 @@
       </p:sp>
       <p:sp>
         <p:nvSpPr>
-          <p:cNvPr id="50" name="Shape 41"/>
+          <p:cNvPr id="39" name="Shape 30"/>
           <p:cNvSpPr/>
           <p:nvPr/>
         </p:nvSpPr>
@@ -2337,7 +2026,7 @@
       </p:sp>
       <p:sp>
         <p:nvSpPr>
-          <p:cNvPr id="51" name="Text 42"/>
+          <p:cNvPr id="40" name="Text 31"/>
           <p:cNvSpPr/>
           <p:nvPr/>
         </p:nvSpPr>
@@ -2485,7 +2174,7 @@
       </p:sp>
       <p:pic>
         <p:nvPicPr>
-          <p:cNvPr id="52" name="Image 7" descr="preencoded.png">    </p:cNvPr>
+          <p:cNvPr id="41" name="Image 7" descr="preencoded.png">    </p:cNvPr>
           <p:cNvPicPr>
             <a:picLocks noChangeAspect="1"/>
           </p:cNvPicPr>
@@ -2509,7 +2198,7 @@
       </p:pic>
       <p:sp>
         <p:nvSpPr>
-          <p:cNvPr id="53" name="Text 43"/>
+          <p:cNvPr id="42" name="Text 32"/>
           <p:cNvSpPr/>
           <p:nvPr/>
         </p:nvSpPr>
@@ -2548,7 +2237,7 @@
       </p:sp>
       <p:sp>
         <p:nvSpPr>
-          <p:cNvPr id="54" name="Text 44"/>
+          <p:cNvPr id="43" name="Text 33"/>
           <p:cNvSpPr/>
           <p:nvPr/>
         </p:nvSpPr>
@@ -2646,7 +2335,7 @@
                 <a:ea typeface="Arial" pitchFamily="34" charset="-122"/>
                 <a:cs typeface="Arial" pitchFamily="34" charset="-120"/>
               </a:rPr>
-              <a:t>Performance Under Pressure — Lead Self</a:t>
+              <a:t>Performance Under Pressure (Lead Self)</a:t>
             </a:r>
             <a:endParaRPr lang="en-US" sz="730" dirty="0"/>
           </a:p>
@@ -2667,7 +2356,7 @@
                 <a:ea typeface="Arial" pitchFamily="34" charset="-122"/>
                 <a:cs typeface="Arial" pitchFamily="34" charset="-120"/>
               </a:rPr>
-              <a:t>Performance Under Pressure — Lead Teams</a:t>
+              <a:t>Performance Under Pressure (Lead Teams)</a:t>
             </a:r>
             <a:endParaRPr lang="en-US" sz="730" dirty="0"/>
           </a:p>
@@ -2675,7 +2364,7 @@
       </p:sp>
       <p:sp>
         <p:nvSpPr>
-          <p:cNvPr id="55" name="Shape 45"/>
+          <p:cNvPr id="44" name="Shape 34"/>
           <p:cNvSpPr/>
           <p:nvPr/>
         </p:nvSpPr>
@@ -2698,7 +2387,7 @@
       </p:sp>
       <p:pic>
         <p:nvPicPr>
-          <p:cNvPr id="56" name="Image 8" descr="preencoded.png">    </p:cNvPr>
+          <p:cNvPr id="45" name="Image 8" descr="preencoded.png">    </p:cNvPr>
           <p:cNvPicPr>
             <a:picLocks noChangeAspect="1"/>
           </p:cNvPicPr>
@@ -2722,7 +2411,7 @@
       </p:pic>
       <p:sp>
         <p:nvSpPr>
-          <p:cNvPr id="57" name="Text 46"/>
+          <p:cNvPr id="46" name="Text 35"/>
           <p:cNvSpPr/>
           <p:nvPr/>
         </p:nvSpPr>
@@ -2761,7 +2450,7 @@
       </p:sp>
       <p:sp>
         <p:nvSpPr>
-          <p:cNvPr id="58" name="Text 47"/>
+          <p:cNvPr id="47" name="Text 36"/>
           <p:cNvSpPr/>
           <p:nvPr/>
         </p:nvSpPr>
@@ -2825,7 +2514,7 @@
       </p:sp>
       <p:sp>
         <p:nvSpPr>
-          <p:cNvPr id="59" name="Shape 48"/>
+          <p:cNvPr id="48" name="Shape 37"/>
           <p:cNvSpPr/>
           <p:nvPr/>
         </p:nvSpPr>
@@ -2848,7 +2537,7 @@
       </p:sp>
       <p:pic>
         <p:nvPicPr>
-          <p:cNvPr id="60" name="Image 9" descr="preencoded.png">    </p:cNvPr>
+          <p:cNvPr id="49" name="Image 9" descr="preencoded.png">    </p:cNvPr>
           <p:cNvPicPr>
             <a:picLocks noChangeAspect="1"/>
           </p:cNvPicPr>
@@ -2872,7 +2561,7 @@
       </p:pic>
       <p:sp>
         <p:nvSpPr>
-          <p:cNvPr id="61" name="Text 49"/>
+          <p:cNvPr id="50" name="Text 38"/>
           <p:cNvSpPr/>
           <p:nvPr/>
         </p:nvSpPr>
@@ -2911,7 +2600,7 @@
       </p:sp>
       <p:sp>
         <p:nvSpPr>
-          <p:cNvPr id="62" name="Text 50"/>
+          <p:cNvPr id="51" name="Text 39"/>
           <p:cNvSpPr/>
           <p:nvPr/>
         </p:nvSpPr>
@@ -3017,7 +2706,7 @@
       </p:sp>
       <p:sp>
         <p:nvSpPr>
-          <p:cNvPr id="63" name="Shape 51"/>
+          <p:cNvPr id="52" name="Shape 40"/>
           <p:cNvSpPr/>
           <p:nvPr/>
         </p:nvSpPr>
@@ -3042,7 +2731,7 @@
       </p:sp>
       <p:pic>
         <p:nvPicPr>
-          <p:cNvPr id="64" name="Image 10" descr="preencoded.png">    </p:cNvPr>
+          <p:cNvPr id="53" name="Image 10" descr="preencoded.png">    </p:cNvPr>
           <p:cNvPicPr>
             <a:picLocks noChangeAspect="1"/>
           </p:cNvPicPr>
@@ -3066,7 +2755,7 @@
       </p:pic>
       <p:sp>
         <p:nvSpPr>
-          <p:cNvPr id="65" name="Text 52"/>
+          <p:cNvPr id="54" name="Text 41"/>
           <p:cNvSpPr/>
           <p:nvPr/>
         </p:nvSpPr>
@@ -3105,7 +2794,7 @@
       </p:sp>
       <p:sp>
         <p:nvSpPr>
-          <p:cNvPr id="66" name="Shape 53"/>
+          <p:cNvPr id="55" name="Shape 42"/>
           <p:cNvSpPr/>
           <p:nvPr/>
         </p:nvSpPr>
@@ -3128,7 +2817,7 @@
       </p:sp>
       <p:sp>
         <p:nvSpPr>
-          <p:cNvPr id="67" name="Shape 54"/>
+          <p:cNvPr id="56" name="Shape 43"/>
           <p:cNvSpPr/>
           <p:nvPr/>
         </p:nvSpPr>
@@ -3153,7 +2842,7 @@
       </p:sp>
       <p:sp>
         <p:nvSpPr>
-          <p:cNvPr id="68" name="Text 55"/>
+          <p:cNvPr id="57" name="Text 44"/>
           <p:cNvSpPr/>
           <p:nvPr/>
         </p:nvSpPr>
@@ -3192,7 +2881,7 @@
       </p:sp>
       <p:sp>
         <p:nvSpPr>
-          <p:cNvPr id="69" name="Text 56"/>
+          <p:cNvPr id="58" name="Text 45"/>
           <p:cNvSpPr/>
           <p:nvPr/>
         </p:nvSpPr>
@@ -3223,7 +2912,7 @@
                 <a:ea typeface="Arial" pitchFamily="34" charset="-122"/>
                 <a:cs typeface="Arial" pitchFamily="34" charset="-120"/>
               </a:rPr>
-              <a:t>Phase 0 — Define and govern</a:t>
+              <a:t>Phase 0: Define and govern</a:t>
             </a:r>
             <a:endParaRPr lang="en-US" sz="820" dirty="0"/>
           </a:p>
@@ -3231,7 +2920,7 @@
       </p:sp>
       <p:sp>
         <p:nvSpPr>
-          <p:cNvPr id="70" name="Text 57"/>
+          <p:cNvPr id="59" name="Text 46"/>
           <p:cNvSpPr/>
           <p:nvPr/>
         </p:nvSpPr>
@@ -3270,7 +2959,7 @@
       </p:sp>
       <p:sp>
         <p:nvSpPr>
-          <p:cNvPr id="71" name="Shape 58"/>
+          <p:cNvPr id="60" name="Shape 47"/>
           <p:cNvSpPr/>
           <p:nvPr/>
         </p:nvSpPr>
@@ -3295,7 +2984,7 @@
       </p:sp>
       <p:sp>
         <p:nvSpPr>
-          <p:cNvPr id="72" name="Text 59"/>
+          <p:cNvPr id="61" name="Text 48"/>
           <p:cNvSpPr/>
           <p:nvPr/>
         </p:nvSpPr>
@@ -3334,7 +3023,7 @@
       </p:sp>
       <p:sp>
         <p:nvSpPr>
-          <p:cNvPr id="73" name="Text 60"/>
+          <p:cNvPr id="62" name="Text 49"/>
           <p:cNvSpPr/>
           <p:nvPr/>
         </p:nvSpPr>
@@ -3365,7 +3054,7 @@
                 <a:ea typeface="Arial" pitchFamily="34" charset="-122"/>
                 <a:cs typeface="Arial" pitchFamily="34" charset="-120"/>
               </a:rPr>
-              <a:t>Phase 1 — Understand</a:t>
+              <a:t>Phase 1: Understand</a:t>
             </a:r>
             <a:endParaRPr lang="en-US" sz="820" dirty="0"/>
           </a:p>
@@ -3373,7 +3062,7 @@
       </p:sp>
       <p:sp>
         <p:nvSpPr>
-          <p:cNvPr id="74" name="Text 61"/>
+          <p:cNvPr id="63" name="Text 50"/>
           <p:cNvSpPr/>
           <p:nvPr/>
         </p:nvSpPr>
@@ -3412,7 +3101,7 @@
       </p:sp>
       <p:sp>
         <p:nvSpPr>
-          <p:cNvPr id="75" name="Shape 62"/>
+          <p:cNvPr id="64" name="Shape 51"/>
           <p:cNvSpPr/>
           <p:nvPr/>
         </p:nvSpPr>
@@ -3437,7 +3126,7 @@
       </p:sp>
       <p:sp>
         <p:nvSpPr>
-          <p:cNvPr id="76" name="Text 63"/>
+          <p:cNvPr id="65" name="Text 52"/>
           <p:cNvSpPr/>
           <p:nvPr/>
         </p:nvSpPr>
@@ -3476,7 +3165,7 @@
       </p:sp>
       <p:sp>
         <p:nvSpPr>
-          <p:cNvPr id="77" name="Text 64"/>
+          <p:cNvPr id="66" name="Text 53"/>
           <p:cNvSpPr/>
           <p:nvPr/>
         </p:nvSpPr>
@@ -3507,7 +3196,7 @@
                 <a:ea typeface="Arial" pitchFamily="34" charset="-122"/>
                 <a:cs typeface="Arial" pitchFamily="34" charset="-120"/>
               </a:rPr>
-              <a:t>Phase 2 — Design</a:t>
+              <a:t>Phase 2: Design</a:t>
             </a:r>
             <a:endParaRPr lang="en-US" sz="820" dirty="0"/>
           </a:p>
@@ -3515,7 +3204,7 @@
       </p:sp>
       <p:sp>
         <p:nvSpPr>
-          <p:cNvPr id="78" name="Text 65"/>
+          <p:cNvPr id="67" name="Text 54"/>
           <p:cNvSpPr/>
           <p:nvPr/>
         </p:nvSpPr>
@@ -3554,7 +3243,7 @@
       </p:sp>
       <p:sp>
         <p:nvSpPr>
-          <p:cNvPr id="79" name="Shape 66"/>
+          <p:cNvPr id="68" name="Shape 55"/>
           <p:cNvSpPr/>
           <p:nvPr/>
         </p:nvSpPr>
@@ -3579,7 +3268,7 @@
       </p:sp>
       <p:sp>
         <p:nvSpPr>
-          <p:cNvPr id="80" name="Text 67"/>
+          <p:cNvPr id="69" name="Text 56"/>
           <p:cNvSpPr/>
           <p:nvPr/>
         </p:nvSpPr>
@@ -3618,7 +3307,7 @@
       </p:sp>
       <p:sp>
         <p:nvSpPr>
-          <p:cNvPr id="81" name="Text 68"/>
+          <p:cNvPr id="70" name="Text 57"/>
           <p:cNvSpPr/>
           <p:nvPr/>
         </p:nvSpPr>
@@ -3649,7 +3338,7 @@
                 <a:ea typeface="Arial" pitchFamily="34" charset="-122"/>
                 <a:cs typeface="Arial" pitchFamily="34" charset="-120"/>
               </a:rPr>
-              <a:t>Phase 3 — Validate</a:t>
+              <a:t>Phase 3: Validate</a:t>
             </a:r>
             <a:endParaRPr lang="en-US" sz="820" dirty="0"/>
           </a:p>
@@ -3657,7 +3346,7 @@
       </p:sp>
       <p:sp>
         <p:nvSpPr>
-          <p:cNvPr id="82" name="Text 69"/>
+          <p:cNvPr id="71" name="Text 58"/>
           <p:cNvSpPr/>
           <p:nvPr/>
         </p:nvSpPr>
@@ -3696,7 +3385,7 @@
       </p:sp>
       <p:sp>
         <p:nvSpPr>
-          <p:cNvPr id="83" name="Shape 70"/>
+          <p:cNvPr id="72" name="Shape 59"/>
           <p:cNvSpPr/>
           <p:nvPr/>
         </p:nvSpPr>
@@ -3721,7 +3410,7 @@
       </p:sp>
       <p:sp>
         <p:nvSpPr>
-          <p:cNvPr id="84" name="Text 71"/>
+          <p:cNvPr id="73" name="Text 60"/>
           <p:cNvSpPr/>
           <p:nvPr/>
         </p:nvSpPr>
@@ -3760,7 +3449,7 @@
       </p:sp>
       <p:sp>
         <p:nvSpPr>
-          <p:cNvPr id="85" name="Text 72"/>
+          <p:cNvPr id="74" name="Text 61"/>
           <p:cNvSpPr/>
           <p:nvPr/>
         </p:nvSpPr>
@@ -3791,7 +3480,7 @@
                 <a:ea typeface="Arial" pitchFamily="34" charset="-122"/>
                 <a:cs typeface="Arial" pitchFamily="34" charset="-120"/>
               </a:rPr>
-              <a:t>Phase 4 — Endorse and implement</a:t>
+              <a:t>Phase 4: Endorse and implement</a:t>
             </a:r>
             <a:endParaRPr lang="en-US" sz="820" dirty="0"/>
           </a:p>
@@ -3799,7 +3488,7 @@
       </p:sp>
       <p:sp>
         <p:nvSpPr>
-          <p:cNvPr id="86" name="Text 73"/>
+          <p:cNvPr id="75" name="Text 62"/>
           <p:cNvSpPr/>
           <p:nvPr/>
         </p:nvSpPr>

</xml_diff>

<commit_message>
Way-forward page restructure: four-level hierarchy plus companion page
Page 1 now carries only the core idea: Combat Mindset banner,
Performance Under Pressure (Prepare, Perform, Recover), the Army
Combat Mindset Framework, and a full-width five-phase Framework
Development Programme pathway (0 Define and govern through 4 Endorse
and implement). Governance & Assurance and Current Delivery System
move to a new second page, Current System, Governance and Delivery,
at full size. Paper embed updated to the new page 1.

Co-Authored-By: Claude Fable 5 <noreply@anthropic.com>
Claude-Session: https://claude.ai/code/session_01YLo1WfwUDkbwfJEF3ZNVbB
</commit_message>
<xml_diff>
--- a/output/combat-mindset-onepager-portrait.pptx
+++ b/output/combat-mindset-onepager-portrait.pptx
@@ -6,9 +6,10 @@
   </p:sldMasterIdLst>
   <p:sldIdLst>
     <p:sldId id="256" r:id="rId2"/>
+    <p:sldId id="257" r:id="rId3"/>
   </p:sldIdLst>
   <p:notesMasterIdLst>
-    <p:notesMasterId r:id="rId3"/>
+    <p:notesMasterId r:id="rId4"/>
   </p:notesMasterIdLst>
   <p:sldSz cx="7562088" cy="10689336"/>
   <p:notesSz cx="10689336" cy="7562088"/>
@@ -526,6 +527,94 @@
             <a:fld id="{F7021451-1387-4CA6-816F-3879F97B5CBC}" type="slidenum">
               <a:rPr lang="en-US"/>
               <a:t>1</a:t>
+            </a:fld>
+            <a:endParaRPr lang="en-US"/>
+          </a:p>
+        </p:txBody>
+      </p:sp>
+    </p:spTree>
+    <p:extLst>
+      <p:ext uri="{BB962C8B-B14F-4D97-AF65-F5344CB8AC3E}">
+        <p14:creationId xmlns:p14="http://schemas.microsoft.com/office/powerpoint/2010/main" val="1024086991"/>
+      </p:ext>
+    </p:extLst>
+  </p:cSld>
+  <p:clrMapOvr>
+    <a:masterClrMapping/>
+  </p:clrMapOvr>
+</p:notes>
+</file>
+
+<file path=ppt/notesSlides/notesSlide2.xml><?xml version="1.0" encoding="utf-8"?>
+<p:notes xmlns:a="http://schemas.openxmlformats.org/drawingml/2006/main" xmlns:r="http://schemas.openxmlformats.org/officeDocument/2006/relationships" xmlns:p="http://schemas.openxmlformats.org/presentationml/2006/main">
+  <p:cSld>
+    <p:spTree>
+      <p:nvGrpSpPr>
+        <p:cNvPr id="1" name=""/>
+        <p:cNvGrpSpPr/>
+        <p:nvPr/>
+      </p:nvGrpSpPr>
+      <p:grpSpPr>
+        <a:xfrm>
+          <a:off x="0" y="0"/>
+          <a:ext cx="0" cy="0"/>
+          <a:chOff x="0" y="0"/>
+          <a:chExt cx="0" cy="0"/>
+        </a:xfrm>
+      </p:grpSpPr>
+      <p:sp>
+        <p:nvSpPr>
+          <p:cNvPr id="2" name="Slide Image Placeholder 1"/>
+          <p:cNvSpPr>
+            <a:spLocks noGrp="1" noRot="1" noChangeAspect="1"/>
+          </p:cNvSpPr>
+          <p:nvPr>
+            <p:ph type="sldImg"/>
+          </p:nvPr>
+        </p:nvSpPr>
+        <p:spPr/>
+      </p:sp>
+      <p:sp>
+        <p:nvSpPr>
+          <p:cNvPr id="3" name="Notes Placeholder 2"/>
+          <p:cNvSpPr>
+            <a:spLocks noGrp="1"/>
+          </p:cNvSpPr>
+          <p:nvPr>
+            <p:ph type="body" idx="1"/>
+          </p:nvPr>
+        </p:nvSpPr>
+        <p:spPr/>
+        <p:txBody>
+          <a:bodyPr/>
+          <a:lstStyle/>
+          <a:p>
+            <a:r>
+              <a:rPr lang="en-US" dirty="0"/>
+              <a:t/>
+            </a:r>
+            <a:endParaRPr lang="en-US" dirty="0"/>
+          </a:p>
+        </p:txBody>
+      </p:sp>
+      <p:sp>
+        <p:nvSpPr>
+          <p:cNvPr id="4" name="Slide Number Placeholder 3"/>
+          <p:cNvSpPr>
+            <a:spLocks noGrp="1"/>
+          </p:cNvSpPr>
+          <p:nvPr>
+            <p:ph type="sldNum" sz="quarter" idx="10"/>
+          </p:nvPr>
+        </p:nvSpPr>
+        <p:spPr/>
+        <p:txBody>
+          <a:bodyPr/>
+          <a:lstStyle/>
+          <a:p>
+            <a:fld id="{F7021451-1387-4CA6-816F-3879F97B5CBC}" type="slidenum">
+              <a:rPr lang="en-US"/>
+              <a:t>2</a:t>
             </a:fld>
             <a:endParaRPr lang="en-US"/>
           </a:p>
@@ -875,87 +964,9 @@
           <a:chExt cx="0" cy="0"/>
         </a:xfrm>
       </p:grpSpPr>
-      <p:sp>
-        <p:nvSpPr>
-          <p:cNvPr id="2" name="Text 0"/>
-          <p:cNvSpPr/>
-          <p:nvPr/>
-        </p:nvSpPr>
-        <p:spPr>
-          <a:xfrm>
-            <a:off x="457200" y="10469880"/>
-            <a:ext cx="2377440" cy="164592"/>
-          </a:xfrm>
-          <a:prstGeom prst="rect">
-            <a:avLst/>
-          </a:prstGeom>
-          <a:noFill/>
-          <a:ln/>
-        </p:spPr>
-        <p:txBody>
-          <a:bodyPr wrap="square" lIns="0" tIns="0" rIns="0" bIns="0" rtlCol="0" anchor="ctr"/>
-          <a:lstStyle/>
-          <a:p>
-            <a:pPr algn="l" indent="0" marL="0">
-              <a:buNone/>
-            </a:pPr>
-            <a:r>
-              <a:rPr lang="en-US" sz="600" dirty="0">
-                <a:solidFill>
-                  <a:srgbClr val="000000"/>
-                </a:solidFill>
-                <a:latin typeface="Arial" pitchFamily="34" charset="0"/>
-                <a:ea typeface="Arial" pitchFamily="34" charset="-122"/>
-                <a:cs typeface="Arial" pitchFamily="34" charset="-120"/>
-              </a:rPr>
-              <a:t>Army Command School  ·  ACS 2026</a:t>
-            </a:r>
-            <a:endParaRPr lang="en-US" sz="600" dirty="0"/>
-          </a:p>
-        </p:txBody>
-      </p:sp>
-      <p:sp>
-        <p:nvSpPr>
-          <p:cNvPr id="3" name="Text 1"/>
-          <p:cNvSpPr/>
-          <p:nvPr/>
-        </p:nvSpPr>
-        <p:spPr>
-          <a:xfrm>
-            <a:off x="5212080" y="10469880"/>
-            <a:ext cx="1892808" cy="164592"/>
-          </a:xfrm>
-          <a:prstGeom prst="rect">
-            <a:avLst/>
-          </a:prstGeom>
-          <a:noFill/>
-          <a:ln/>
-        </p:spPr>
-        <p:txBody>
-          <a:bodyPr wrap="square" lIns="0" tIns="0" rIns="0" bIns="0" rtlCol="0" anchor="ctr"/>
-          <a:lstStyle/>
-          <a:p>
-            <a:pPr algn="r" indent="0" marL="0">
-              <a:buNone/>
-            </a:pPr>
-            <a:r>
-              <a:rPr lang="en-US" sz="600" dirty="0">
-                <a:solidFill>
-                  <a:srgbClr val="000000"/>
-                </a:solidFill>
-                <a:latin typeface="Arial" pitchFamily="34" charset="0"/>
-                <a:ea typeface="Arial" pitchFamily="34" charset="-122"/>
-                <a:cs typeface="Arial" pitchFamily="34" charset="-120"/>
-              </a:rPr>
-              <a:t>Draft v0.8  ·  July 2026</a:t>
-            </a:r>
-            <a:endParaRPr lang="en-US" sz="600" dirty="0"/>
-          </a:p>
-        </p:txBody>
-      </p:sp>
       <p:pic>
         <p:nvPicPr>
-          <p:cNvPr id="4" name="Image 0" descr="/tmp/claude-0/-home-user-PUP/2d4cec0e-a52e-5368-bb54-803c6f37698d/scratchpad/logo-trimmed.png">    </p:cNvPr>
+          <p:cNvPr id="2" name="Image 0" descr="/tmp/claude-0/-home-user-PUP/2d4cec0e-a52e-5368-bb54-803c6f37698d/scratchpad/logo-trimmed.png">    </p:cNvPr>
           <p:cNvPicPr>
             <a:picLocks noChangeAspect="1"/>
           </p:cNvPicPr>
@@ -979,7 +990,7 @@
       </p:pic>
       <p:sp>
         <p:nvSpPr>
-          <p:cNvPr id="5" name="Text 2"/>
+          <p:cNvPr id="3" name="Text 0"/>
           <p:cNvSpPr/>
           <p:nvPr/>
         </p:nvSpPr>
@@ -1018,14 +1029,92 @@
       </p:sp>
       <p:sp>
         <p:nvSpPr>
+          <p:cNvPr id="4" name="Text 1"/>
+          <p:cNvSpPr/>
+          <p:nvPr/>
+        </p:nvSpPr>
+        <p:spPr>
+          <a:xfrm>
+            <a:off x="457200" y="10469880"/>
+            <a:ext cx="2377440" cy="164592"/>
+          </a:xfrm>
+          <a:prstGeom prst="rect">
+            <a:avLst/>
+          </a:prstGeom>
+          <a:noFill/>
+          <a:ln/>
+        </p:spPr>
+        <p:txBody>
+          <a:bodyPr wrap="square" lIns="0" tIns="0" rIns="0" bIns="0" rtlCol="0" anchor="ctr"/>
+          <a:lstStyle/>
+          <a:p>
+            <a:pPr algn="l" indent="0" marL="0">
+              <a:buNone/>
+            </a:pPr>
+            <a:r>
+              <a:rPr lang="en-US" sz="600" dirty="0">
+                <a:solidFill>
+                  <a:srgbClr val="000000"/>
+                </a:solidFill>
+                <a:latin typeface="Arial" pitchFamily="34" charset="0"/>
+                <a:ea typeface="Arial" pitchFamily="34" charset="-122"/>
+                <a:cs typeface="Arial" pitchFamily="34" charset="-120"/>
+              </a:rPr>
+              <a:t>Army Command School  ·  ACS 2026</a:t>
+            </a:r>
+            <a:endParaRPr lang="en-US" sz="600" dirty="0"/>
+          </a:p>
+        </p:txBody>
+      </p:sp>
+      <p:sp>
+        <p:nvSpPr>
+          <p:cNvPr id="5" name="Text 2"/>
+          <p:cNvSpPr/>
+          <p:nvPr/>
+        </p:nvSpPr>
+        <p:spPr>
+          <a:xfrm>
+            <a:off x="5212080" y="10469880"/>
+            <a:ext cx="1892808" cy="164592"/>
+          </a:xfrm>
+          <a:prstGeom prst="rect">
+            <a:avLst/>
+          </a:prstGeom>
+          <a:noFill/>
+          <a:ln/>
+        </p:spPr>
+        <p:txBody>
+          <a:bodyPr wrap="square" lIns="0" tIns="0" rIns="0" bIns="0" rtlCol="0" anchor="ctr"/>
+          <a:lstStyle/>
+          <a:p>
+            <a:pPr algn="r" indent="0" marL="0">
+              <a:buNone/>
+            </a:pPr>
+            <a:r>
+              <a:rPr lang="en-US" sz="600" dirty="0">
+                <a:solidFill>
+                  <a:srgbClr val="000000"/>
+                </a:solidFill>
+                <a:latin typeface="Arial" pitchFamily="34" charset="0"/>
+                <a:ea typeface="Arial" pitchFamily="34" charset="-122"/>
+                <a:cs typeface="Arial" pitchFamily="34" charset="-120"/>
+              </a:rPr>
+              <a:t>Draft v0.8  ·  July 2026</a:t>
+            </a:r>
+            <a:endParaRPr lang="en-US" sz="600" dirty="0"/>
+          </a:p>
+        </p:txBody>
+      </p:sp>
+      <p:sp>
+        <p:nvSpPr>
           <p:cNvPr id="6" name="Shape 3"/>
           <p:cNvSpPr/>
           <p:nvPr/>
         </p:nvSpPr>
         <p:spPr>
           <a:xfrm>
-            <a:off x="457200" y="1024128"/>
-            <a:ext cx="6647688" cy="1188720"/>
+            <a:off x="457200" y="1042416"/>
+            <a:ext cx="6647688" cy="1426464"/>
           </a:xfrm>
           <a:prstGeom prst="rect">
             <a:avLst/>
@@ -1044,7 +1133,7 @@
         </p:nvSpPr>
         <p:spPr>
           <a:xfrm>
-            <a:off x="2683764" y="914400"/>
+            <a:off x="2683764" y="932688"/>
             <a:ext cx="2194560" cy="219456"/>
           </a:xfrm>
           <a:prstGeom prst="roundRect">
@@ -1071,7 +1160,7 @@
         </p:nvSpPr>
         <p:spPr>
           <a:xfrm>
-            <a:off x="2683764" y="914400"/>
+            <a:off x="2683764" y="932688"/>
             <a:ext cx="2194560" cy="219456"/>
           </a:xfrm>
           <a:prstGeom prst="rect">
@@ -1120,8 +1209,8 @@
         </p:blipFill>
         <p:spPr>
           <a:xfrm>
-            <a:off x="713232" y="1335024"/>
-            <a:ext cx="603504" cy="603504"/>
+            <a:off x="731520" y="1389888"/>
+            <a:ext cx="731520" cy="731520"/>
           </a:xfrm>
           <a:prstGeom prst="rect">
             <a:avLst/>
@@ -1136,8 +1225,8 @@
         </p:nvSpPr>
         <p:spPr>
           <a:xfrm>
-            <a:off x="457200" y="1316736"/>
-            <a:ext cx="6647688" cy="502920"/>
+            <a:off x="457200" y="1389888"/>
+            <a:ext cx="6647688" cy="566928"/>
           </a:xfrm>
           <a:prstGeom prst="rect">
             <a:avLst/>
@@ -1153,7 +1242,7 @@
               <a:buNone/>
             </a:pPr>
             <a:r>
-              <a:rPr lang="en-US" sz="3300" b="1" dirty="0">
+              <a:rPr lang="en-US" sz="3700" b="1" dirty="0">
                 <a:solidFill>
                   <a:srgbClr val="FFFFFF"/>
                 </a:solidFill>
@@ -1163,7 +1252,7 @@
               </a:rPr>
               <a:t>COMBAT MINDSET</a:t>
             </a:r>
-            <a:endParaRPr lang="en-US" sz="3300" dirty="0"/>
+            <a:endParaRPr lang="en-US" sz="3700" dirty="0"/>
           </a:p>
         </p:txBody>
       </p:sp>
@@ -1175,8 +1264,8 @@
         </p:nvSpPr>
         <p:spPr>
           <a:xfrm>
-            <a:off x="457200" y="1847088"/>
-            <a:ext cx="6647688" cy="237744"/>
+            <a:off x="457200" y="2011680"/>
+            <a:ext cx="6647688" cy="274320"/>
           </a:xfrm>
           <a:prstGeom prst="rect">
             <a:avLst/>
@@ -1192,7 +1281,7 @@
               <a:buNone/>
             </a:pPr>
             <a:r>
-              <a:rPr lang="en-US" sz="1300" b="1" dirty="0">
+              <a:rPr lang="en-US" sz="1400" b="1" dirty="0">
                 <a:solidFill>
                   <a:srgbClr val="C62026"/>
                 </a:solidFill>
@@ -1202,7 +1291,7 @@
               </a:rPr>
               <a:t>Remain effective. Act decisively. Harder to kill.</a:t>
             </a:r>
-            <a:endParaRPr lang="en-US" sz="1300" dirty="0"/>
+            <a:endParaRPr lang="en-US" sz="1400" dirty="0"/>
           </a:p>
         </p:txBody>
       </p:sp>
@@ -1214,7 +1303,7 @@
         </p:nvSpPr>
         <p:spPr>
           <a:xfrm rot="10800000">
-            <a:off x="3717036" y="2286000"/>
+            <a:off x="3717036" y="2596896"/>
             <a:ext cx="128016" cy="100584"/>
           </a:xfrm>
           <a:prstGeom prst="triangle">
@@ -1234,7 +1323,7 @@
         </p:nvSpPr>
         <p:spPr>
           <a:xfrm>
-            <a:off x="2043684" y="2404872"/>
+            <a:off x="2043684" y="2715768"/>
             <a:ext cx="3474720" cy="146304"/>
           </a:xfrm>
           <a:prstGeom prst="rect">
@@ -1273,8 +1362,8 @@
         </p:nvSpPr>
         <p:spPr>
           <a:xfrm>
-            <a:off x="457200" y="2834640"/>
-            <a:ext cx="6647688" cy="969264"/>
+            <a:off x="457200" y="3127248"/>
+            <a:ext cx="6647688" cy="1133856"/>
           </a:xfrm>
           <a:prstGeom prst="rect">
             <a:avLst/>
@@ -1293,7 +1382,7 @@
         </p:nvSpPr>
         <p:spPr>
           <a:xfrm>
-            <a:off x="1952244" y="2724912"/>
+            <a:off x="1952244" y="3017520"/>
             <a:ext cx="3657600" cy="219456"/>
           </a:xfrm>
           <a:prstGeom prst="roundRect">
@@ -1320,7 +1409,7 @@
         </p:nvSpPr>
         <p:spPr>
           <a:xfrm>
-            <a:off x="1952244" y="2724912"/>
+            <a:off x="1952244" y="3017520"/>
             <a:ext cx="3657600" cy="219456"/>
           </a:xfrm>
           <a:prstGeom prst="rect">
@@ -1367,8 +1456,8 @@
         </p:blipFill>
         <p:spPr>
           <a:xfrm>
-            <a:off x="676656" y="3127248"/>
-            <a:ext cx="457200" cy="457200"/>
+            <a:off x="658368" y="3474720"/>
+            <a:ext cx="438912" cy="438912"/>
           </a:xfrm>
           <a:prstGeom prst="rect">
             <a:avLst/>
@@ -1383,8 +1472,8 @@
         </p:nvSpPr>
         <p:spPr>
           <a:xfrm>
-            <a:off x="457200" y="3035808"/>
-            <a:ext cx="6647688" cy="384048"/>
+            <a:off x="457200" y="3383280"/>
+            <a:ext cx="6647688" cy="420624"/>
           </a:xfrm>
           <a:prstGeom prst="rect">
             <a:avLst/>
@@ -1400,7 +1489,7 @@
               <a:buNone/>
             </a:pPr>
             <a:r>
-              <a:rPr lang="en-US" sz="2300" b="1" dirty="0">
+              <a:rPr lang="en-US" sz="2250" b="1" dirty="0">
                 <a:solidFill>
                   <a:srgbClr val="FFFFFF"/>
                 </a:solidFill>
@@ -1410,7 +1499,7 @@
               </a:rPr>
               <a:t>PERFORMANCE UNDER PRESSURE</a:t>
             </a:r>
-            <a:endParaRPr lang="en-US" sz="2300" dirty="0"/>
+            <a:endParaRPr lang="en-US" sz="2250" dirty="0"/>
           </a:p>
         </p:txBody>
       </p:sp>
@@ -1422,8 +1511,8 @@
         </p:nvSpPr>
         <p:spPr>
           <a:xfrm>
-            <a:off x="457200" y="3465576"/>
-            <a:ext cx="6647688" cy="182880"/>
+            <a:off x="457200" y="3840480"/>
+            <a:ext cx="6647688" cy="237744"/>
           </a:xfrm>
           <a:prstGeom prst="rect">
             <a:avLst/>
@@ -1439,7 +1528,7 @@
               <a:buNone/>
             </a:pPr>
             <a:r>
-              <a:rPr lang="en-US" sz="1050" b="1" dirty="0">
+              <a:rPr lang="en-US" sz="1200" b="1" dirty="0">
                 <a:solidFill>
                   <a:srgbClr val="FFFFFF"/>
                 </a:solidFill>
@@ -1449,7 +1538,7 @@
               </a:rPr>
               <a:t>Prepare   •   Perform   •   Recover</a:t>
             </a:r>
-            <a:endParaRPr lang="en-US" sz="1050" dirty="0"/>
+            <a:endParaRPr lang="en-US" sz="1200" dirty="0"/>
           </a:p>
         </p:txBody>
       </p:sp>
@@ -1461,7 +1550,7 @@
         </p:nvSpPr>
         <p:spPr>
           <a:xfrm rot="10800000">
-            <a:off x="3717036" y="3877056"/>
+            <a:off x="3717036" y="4389120"/>
             <a:ext cx="128016" cy="100584"/>
           </a:xfrm>
           <a:prstGeom prst="triangle">
@@ -1481,7 +1570,7 @@
         </p:nvSpPr>
         <p:spPr>
           <a:xfrm>
-            <a:off x="2043684" y="3995928"/>
+            <a:off x="2043684" y="4507992"/>
             <a:ext cx="3474720" cy="146304"/>
           </a:xfrm>
           <a:prstGeom prst="rect">
@@ -1520,8 +1609,8 @@
         </p:nvSpPr>
         <p:spPr>
           <a:xfrm>
-            <a:off x="457200" y="4425696"/>
-            <a:ext cx="6647688" cy="841248"/>
+            <a:off x="457200" y="4919472"/>
+            <a:ext cx="6647688" cy="1042416"/>
           </a:xfrm>
           <a:prstGeom prst="rect">
             <a:avLst/>
@@ -1540,7 +1629,7 @@
         </p:nvSpPr>
         <p:spPr>
           <a:xfrm>
-            <a:off x="2820924" y="4315968"/>
+            <a:off x="2820924" y="4809744"/>
             <a:ext cx="1920240" cy="219456"/>
           </a:xfrm>
           <a:prstGeom prst="roundRect">
@@ -1567,7 +1656,7 @@
         </p:nvSpPr>
         <p:spPr>
           <a:xfrm>
-            <a:off x="2820924" y="4315968"/>
+            <a:off x="2820924" y="4809744"/>
             <a:ext cx="1920240" cy="219456"/>
           </a:xfrm>
           <a:prstGeom prst="rect">
@@ -1614,8 +1703,8 @@
         </p:blipFill>
         <p:spPr>
           <a:xfrm>
-            <a:off x="676656" y="4626864"/>
-            <a:ext cx="420624" cy="420624"/>
+            <a:off x="658368" y="5230368"/>
+            <a:ext cx="402336" cy="402336"/>
           </a:xfrm>
           <a:prstGeom prst="rect">
             <a:avLst/>
@@ -1630,8 +1719,8 @@
         </p:nvSpPr>
         <p:spPr>
           <a:xfrm>
-            <a:off x="457200" y="4553712"/>
-            <a:ext cx="6647688" cy="329184"/>
+            <a:off x="457200" y="5120640"/>
+            <a:ext cx="6647688" cy="365760"/>
           </a:xfrm>
           <a:prstGeom prst="rect">
             <a:avLst/>
@@ -1647,7 +1736,7 @@
               <a:buNone/>
             </a:pPr>
             <a:r>
-              <a:rPr lang="en-US" sz="1900" b="1" dirty="0">
+              <a:rPr lang="en-US" sz="1750" b="1" dirty="0">
                 <a:solidFill>
                   <a:srgbClr val="FFFFFF"/>
                 </a:solidFill>
@@ -1657,7 +1746,7 @@
               </a:rPr>
               <a:t>THE ARMY COMBAT MINDSET FRAMEWORK</a:t>
             </a:r>
-            <a:endParaRPr lang="en-US" sz="1900" dirty="0"/>
+            <a:endParaRPr lang="en-US" sz="1750" dirty="0"/>
           </a:p>
         </p:txBody>
       </p:sp>
@@ -1669,8 +1758,8 @@
         </p:nvSpPr>
         <p:spPr>
           <a:xfrm>
-            <a:off x="457200" y="4910328"/>
-            <a:ext cx="6647688" cy="182880"/>
+            <a:off x="457200" y="5522976"/>
+            <a:ext cx="6647688" cy="219456"/>
           </a:xfrm>
           <a:prstGeom prst="rect">
             <a:avLst/>
@@ -1686,7 +1775,7 @@
               <a:buNone/>
             </a:pPr>
             <a:r>
-              <a:rPr lang="en-US" sz="900" dirty="0">
+              <a:rPr lang="en-US" sz="950" dirty="0">
                 <a:solidFill>
                   <a:srgbClr val="FFFFFF"/>
                 </a:solidFill>
@@ -1696,7 +1785,7 @@
               </a:rPr>
               <a:t>The Army system through which Combat Mindset is governed, developed, delivered and assured.</a:t>
             </a:r>
-            <a:endParaRPr lang="en-US" sz="900" dirty="0"/>
+            <a:endParaRPr lang="en-US" sz="950" dirty="0"/>
           </a:p>
         </p:txBody>
       </p:sp>
@@ -1707,11 +1796,11 @@
           <p:nvPr/>
         </p:nvSpPr>
         <p:spPr>
-          <a:xfrm>
-            <a:off x="457200" y="5413248"/>
-            <a:ext cx="2142744" cy="329184"/>
-          </a:xfrm>
-          <a:prstGeom prst="rect">
+          <a:xfrm rot="10800000">
+            <a:off x="3717036" y="6089904"/>
+            <a:ext cx="128016" cy="100584"/>
+          </a:xfrm>
+          <a:prstGeom prst="triangle">
             <a:avLst/>
           </a:prstGeom>
           <a:solidFill>
@@ -1720,24 +1809,1072 @@
           <a:ln/>
         </p:spPr>
       </p:sp>
+      <p:sp>
+        <p:nvSpPr>
+          <p:cNvPr id="29" name="Text 23"/>
+          <p:cNvSpPr/>
+          <p:nvPr/>
+        </p:nvSpPr>
+        <p:spPr>
+          <a:xfrm>
+            <a:off x="2043684" y="6208776"/>
+            <a:ext cx="3474720" cy="146304"/>
+          </a:xfrm>
+          <a:prstGeom prst="rect">
+            <a:avLst/>
+          </a:prstGeom>
+          <a:noFill/>
+          <a:ln/>
+        </p:spPr>
+        <p:txBody>
+          <a:bodyPr wrap="square" lIns="0" tIns="0" rIns="0" bIns="0" rtlCol="0" anchor="ctr"/>
+          <a:lstStyle/>
+          <a:p>
+            <a:pPr algn="ctr" indent="0" marL="0">
+              <a:buNone/>
+            </a:pPr>
+            <a:r>
+              <a:rPr lang="en-US" sz="850" i="1" dirty="0">
+                <a:solidFill>
+                  <a:srgbClr val="000000"/>
+                </a:solidFill>
+                <a:latin typeface="Arial" pitchFamily="34" charset="0"/>
+                <a:ea typeface="Arial" pitchFamily="34" charset="-122"/>
+                <a:cs typeface="Arial" pitchFamily="34" charset="-120"/>
+              </a:rPr>
+              <a:t>achieved through</a:t>
+            </a:r>
+            <a:endParaRPr lang="en-US" sz="850" dirty="0"/>
+          </a:p>
+        </p:txBody>
+      </p:sp>
+      <p:sp>
+        <p:nvSpPr>
+          <p:cNvPr id="30" name="Shape 24"/>
+          <p:cNvSpPr/>
+          <p:nvPr/>
+        </p:nvSpPr>
+        <p:spPr>
+          <a:xfrm>
+            <a:off x="457200" y="6729984"/>
+            <a:ext cx="6647688" cy="2606040"/>
+          </a:xfrm>
+          <a:prstGeom prst="rect">
+            <a:avLst/>
+          </a:prstGeom>
+          <a:solidFill>
+            <a:srgbClr val="CDD2B7">
+              <a:alpha val="28000"/>
+            </a:srgbClr>
+          </a:solidFill>
+          <a:ln/>
+        </p:spPr>
+      </p:sp>
+      <p:sp>
+        <p:nvSpPr>
+          <p:cNvPr id="31" name="Shape 25"/>
+          <p:cNvSpPr/>
+          <p:nvPr/>
+        </p:nvSpPr>
+        <p:spPr>
+          <a:xfrm>
+            <a:off x="2089404" y="6620256"/>
+            <a:ext cx="3383280" cy="219456"/>
+          </a:xfrm>
+          <a:prstGeom prst="roundRect">
+            <a:avLst>
+              <a:gd name="adj" fmla="val 50000"/>
+            </a:avLst>
+          </a:prstGeom>
+          <a:solidFill>
+            <a:srgbClr val="002516"/>
+          </a:solidFill>
+          <a:ln w="12700">
+            <a:solidFill>
+              <a:srgbClr val="FFFFFF"/>
+            </a:solidFill>
+            <a:prstDash val="solid"/>
+          </a:ln>
+        </p:spPr>
+      </p:sp>
+      <p:sp>
+        <p:nvSpPr>
+          <p:cNvPr id="32" name="Text 26"/>
+          <p:cNvSpPr/>
+          <p:nvPr/>
+        </p:nvSpPr>
+        <p:spPr>
+          <a:xfrm>
+            <a:off x="2089404" y="6620256"/>
+            <a:ext cx="3383280" cy="219456"/>
+          </a:xfrm>
+          <a:prstGeom prst="rect">
+            <a:avLst/>
+          </a:prstGeom>
+          <a:noFill/>
+          <a:ln/>
+        </p:spPr>
+        <p:txBody>
+          <a:bodyPr wrap="square" lIns="0" tIns="0" rIns="0" bIns="0" rtlCol="0" anchor="ctr"/>
+          <a:lstStyle/>
+          <a:p>
+            <a:pPr algn="ctr" indent="0" marL="0">
+              <a:buNone/>
+            </a:pPr>
+            <a:r>
+              <a:rPr lang="en-US" sz="780" b="1" spc="120" kern="0" dirty="0">
+                <a:solidFill>
+                  <a:srgbClr val="FFFFFF"/>
+                </a:solidFill>
+                <a:latin typeface="Arial" pitchFamily="34" charset="0"/>
+                <a:ea typeface="Arial" pitchFamily="34" charset="-122"/>
+                <a:cs typeface="Arial" pitchFamily="34" charset="-120"/>
+              </a:rPr>
+              <a:t>4)  FRAMEWORK DEVELOPMENT PROGRAMME</a:t>
+            </a:r>
+            <a:endParaRPr lang="en-US" sz="780" dirty="0"/>
+          </a:p>
+        </p:txBody>
+      </p:sp>
+      <p:sp>
+        <p:nvSpPr>
+          <p:cNvPr id="33" name="Shape 27"/>
+          <p:cNvSpPr/>
+          <p:nvPr/>
+        </p:nvSpPr>
+        <p:spPr>
+          <a:xfrm>
+            <a:off x="1121969" y="7699248"/>
+            <a:ext cx="5318150" cy="0"/>
+          </a:xfrm>
+          <a:prstGeom prst="line">
+            <a:avLst/>
+          </a:prstGeom>
+          <a:noFill/>
+          <a:ln w="19050">
+            <a:solidFill>
+              <a:srgbClr val="002516"/>
+            </a:solidFill>
+            <a:prstDash val="solid"/>
+          </a:ln>
+        </p:spPr>
+      </p:sp>
+      <p:sp>
+        <p:nvSpPr>
+          <p:cNvPr id="34" name="Text 28"/>
+          <p:cNvSpPr/>
+          <p:nvPr/>
+        </p:nvSpPr>
+        <p:spPr>
+          <a:xfrm>
+            <a:off x="1567282" y="7552944"/>
+            <a:ext cx="438912" cy="292608"/>
+          </a:xfrm>
+          <a:prstGeom prst="rect">
+            <a:avLst/>
+          </a:prstGeom>
+          <a:noFill/>
+          <a:ln/>
+        </p:spPr>
+        <p:txBody>
+          <a:bodyPr wrap="square" lIns="0" tIns="0" rIns="0" bIns="0" rtlCol="0" anchor="ctr"/>
+          <a:lstStyle/>
+          <a:p>
+            <a:pPr algn="ctr" indent="0" marL="0">
+              <a:buNone/>
+            </a:pPr>
+            <a:r>
+              <a:rPr lang="en-US" sz="1100" b="1" dirty="0">
+                <a:solidFill>
+                  <a:srgbClr val="C62026"/>
+                </a:solidFill>
+                <a:latin typeface="Arial" pitchFamily="34" charset="0"/>
+                <a:ea typeface="Arial" pitchFamily="34" charset="-122"/>
+                <a:cs typeface="Arial" pitchFamily="34" charset="-120"/>
+              </a:rPr>
+              <a:t>►</a:t>
+            </a:r>
+            <a:endParaRPr lang="en-US" sz="1100" dirty="0"/>
+          </a:p>
+        </p:txBody>
+      </p:sp>
+      <p:sp>
+        <p:nvSpPr>
+          <p:cNvPr id="35" name="Shape 29"/>
+          <p:cNvSpPr/>
+          <p:nvPr/>
+        </p:nvSpPr>
+        <p:spPr>
+          <a:xfrm>
+            <a:off x="884225" y="7461504"/>
+            <a:ext cx="475488" cy="475488"/>
+          </a:xfrm>
+          <a:prstGeom prst="ellipse">
+            <a:avLst/>
+          </a:prstGeom>
+          <a:solidFill>
+            <a:srgbClr val="002516"/>
+          </a:solidFill>
+          <a:ln w="19050">
+            <a:solidFill>
+              <a:srgbClr val="FFFFFF"/>
+            </a:solidFill>
+            <a:prstDash val="solid"/>
+          </a:ln>
+        </p:spPr>
+      </p:sp>
+      <p:sp>
+        <p:nvSpPr>
+          <p:cNvPr id="36" name="Text 30"/>
+          <p:cNvSpPr/>
+          <p:nvPr/>
+        </p:nvSpPr>
+        <p:spPr>
+          <a:xfrm>
+            <a:off x="884225" y="7461504"/>
+            <a:ext cx="475488" cy="475488"/>
+          </a:xfrm>
+          <a:prstGeom prst="rect">
+            <a:avLst/>
+          </a:prstGeom>
+          <a:noFill/>
+          <a:ln/>
+        </p:spPr>
+        <p:txBody>
+          <a:bodyPr wrap="square" lIns="0" tIns="0" rIns="0" bIns="0" rtlCol="0" anchor="ctr"/>
+          <a:lstStyle/>
+          <a:p>
+            <a:pPr algn="ctr" indent="0" marL="0">
+              <a:buNone/>
+            </a:pPr>
+            <a:r>
+              <a:rPr lang="en-US" sz="1500" b="1" dirty="0">
+                <a:solidFill>
+                  <a:srgbClr val="FFFFFF"/>
+                </a:solidFill>
+                <a:latin typeface="Arial" pitchFamily="34" charset="0"/>
+                <a:ea typeface="Arial" pitchFamily="34" charset="-122"/>
+                <a:cs typeface="Arial" pitchFamily="34" charset="-120"/>
+              </a:rPr>
+              <a:t>0</a:t>
+            </a:r>
+            <a:endParaRPr lang="en-US" sz="1500" dirty="0"/>
+          </a:p>
+        </p:txBody>
+      </p:sp>
+      <p:sp>
+        <p:nvSpPr>
+          <p:cNvPr id="37" name="Text 31"/>
+          <p:cNvSpPr/>
+          <p:nvPr/>
+        </p:nvSpPr>
+        <p:spPr>
+          <a:xfrm>
+            <a:off x="512064" y="8065008"/>
+            <a:ext cx="1219810" cy="384048"/>
+          </a:xfrm>
+          <a:prstGeom prst="rect">
+            <a:avLst/>
+          </a:prstGeom>
+          <a:noFill/>
+          <a:ln/>
+        </p:spPr>
+        <p:txBody>
+          <a:bodyPr wrap="square" lIns="0" tIns="0" rIns="0" bIns="0" rtlCol="0" anchor="t"/>
+          <a:lstStyle/>
+          <a:p>
+            <a:pPr algn="ctr" indent="0" marL="0">
+              <a:buNone/>
+            </a:pPr>
+            <a:r>
+              <a:rPr lang="en-US" sz="950" b="1" dirty="0">
+                <a:solidFill>
+                  <a:srgbClr val="002516"/>
+                </a:solidFill>
+                <a:latin typeface="Arial" pitchFamily="34" charset="0"/>
+                <a:ea typeface="Arial" pitchFamily="34" charset="-122"/>
+                <a:cs typeface="Arial" pitchFamily="34" charset="-120"/>
+              </a:rPr>
+              <a:t>Define and govern</a:t>
+            </a:r>
+            <a:endParaRPr lang="en-US" sz="950" dirty="0"/>
+          </a:p>
+        </p:txBody>
+      </p:sp>
+      <p:sp>
+        <p:nvSpPr>
+          <p:cNvPr id="38" name="Text 32"/>
+          <p:cNvSpPr/>
+          <p:nvPr/>
+        </p:nvSpPr>
+        <p:spPr>
+          <a:xfrm>
+            <a:off x="548640" y="8485632"/>
+            <a:ext cx="1146658" cy="1280160"/>
+          </a:xfrm>
+          <a:prstGeom prst="rect">
+            <a:avLst/>
+          </a:prstGeom>
+          <a:noFill/>
+          <a:ln/>
+        </p:spPr>
+        <p:txBody>
+          <a:bodyPr wrap="square" lIns="0" tIns="0" rIns="0" bIns="0" rtlCol="0" anchor="t"/>
+          <a:lstStyle/>
+          <a:p>
+            <a:pPr algn="ctr" indent="0" marL="0">
+              <a:buNone/>
+            </a:pPr>
+            <a:r>
+              <a:rPr lang="en-US" sz="760" dirty="0">
+                <a:solidFill>
+                  <a:srgbClr val="000000"/>
+                </a:solidFill>
+                <a:latin typeface="Arial" pitchFamily="34" charset="0"/>
+                <a:ea typeface="Arial" pitchFamily="34" charset="-122"/>
+                <a:cs typeface="Arial" pitchFamily="34" charset="-120"/>
+              </a:rPr>
+              <a:t>Confirm terminology, sponsorship, ownership and interim governance.</a:t>
+            </a:r>
+            <a:endParaRPr lang="en-US" sz="760" dirty="0"/>
+          </a:p>
+        </p:txBody>
+      </p:sp>
+      <p:sp>
+        <p:nvSpPr>
+          <p:cNvPr id="39" name="Text 33"/>
+          <p:cNvSpPr/>
+          <p:nvPr/>
+        </p:nvSpPr>
+        <p:spPr>
+          <a:xfrm>
+            <a:off x="2896819" y="7552944"/>
+            <a:ext cx="438912" cy="292608"/>
+          </a:xfrm>
+          <a:prstGeom prst="rect">
+            <a:avLst/>
+          </a:prstGeom>
+          <a:noFill/>
+          <a:ln/>
+        </p:spPr>
+        <p:txBody>
+          <a:bodyPr wrap="square" lIns="0" tIns="0" rIns="0" bIns="0" rtlCol="0" anchor="ctr"/>
+          <a:lstStyle/>
+          <a:p>
+            <a:pPr algn="ctr" indent="0" marL="0">
+              <a:buNone/>
+            </a:pPr>
+            <a:r>
+              <a:rPr lang="en-US" sz="1100" b="1" dirty="0">
+                <a:solidFill>
+                  <a:srgbClr val="C62026"/>
+                </a:solidFill>
+                <a:latin typeface="Arial" pitchFamily="34" charset="0"/>
+                <a:ea typeface="Arial" pitchFamily="34" charset="-122"/>
+                <a:cs typeface="Arial" pitchFamily="34" charset="-120"/>
+              </a:rPr>
+              <a:t>►</a:t>
+            </a:r>
+            <a:endParaRPr lang="en-US" sz="1100" dirty="0"/>
+          </a:p>
+        </p:txBody>
+      </p:sp>
+      <p:sp>
+        <p:nvSpPr>
+          <p:cNvPr id="40" name="Shape 34"/>
+          <p:cNvSpPr/>
+          <p:nvPr/>
+        </p:nvSpPr>
+        <p:spPr>
+          <a:xfrm>
+            <a:off x="2213762" y="7461504"/>
+            <a:ext cx="475488" cy="475488"/>
+          </a:xfrm>
+          <a:prstGeom prst="ellipse">
+            <a:avLst/>
+          </a:prstGeom>
+          <a:solidFill>
+            <a:srgbClr val="002516"/>
+          </a:solidFill>
+          <a:ln w="19050">
+            <a:solidFill>
+              <a:srgbClr val="FFFFFF"/>
+            </a:solidFill>
+            <a:prstDash val="solid"/>
+          </a:ln>
+        </p:spPr>
+      </p:sp>
+      <p:sp>
+        <p:nvSpPr>
+          <p:cNvPr id="41" name="Text 35"/>
+          <p:cNvSpPr/>
+          <p:nvPr/>
+        </p:nvSpPr>
+        <p:spPr>
+          <a:xfrm>
+            <a:off x="2213762" y="7461504"/>
+            <a:ext cx="475488" cy="475488"/>
+          </a:xfrm>
+          <a:prstGeom prst="rect">
+            <a:avLst/>
+          </a:prstGeom>
+          <a:noFill/>
+          <a:ln/>
+        </p:spPr>
+        <p:txBody>
+          <a:bodyPr wrap="square" lIns="0" tIns="0" rIns="0" bIns="0" rtlCol="0" anchor="ctr"/>
+          <a:lstStyle/>
+          <a:p>
+            <a:pPr algn="ctr" indent="0" marL="0">
+              <a:buNone/>
+            </a:pPr>
+            <a:r>
+              <a:rPr lang="en-US" sz="1500" b="1" dirty="0">
+                <a:solidFill>
+                  <a:srgbClr val="FFFFFF"/>
+                </a:solidFill>
+                <a:latin typeface="Arial" pitchFamily="34" charset="0"/>
+                <a:ea typeface="Arial" pitchFamily="34" charset="-122"/>
+                <a:cs typeface="Arial" pitchFamily="34" charset="-120"/>
+              </a:rPr>
+              <a:t>1</a:t>
+            </a:r>
+            <a:endParaRPr lang="en-US" sz="1500" dirty="0"/>
+          </a:p>
+        </p:txBody>
+      </p:sp>
+      <p:sp>
+        <p:nvSpPr>
+          <p:cNvPr id="42" name="Text 36"/>
+          <p:cNvSpPr/>
+          <p:nvPr/>
+        </p:nvSpPr>
+        <p:spPr>
+          <a:xfrm>
+            <a:off x="1841602" y="8065008"/>
+            <a:ext cx="1219810" cy="384048"/>
+          </a:xfrm>
+          <a:prstGeom prst="rect">
+            <a:avLst/>
+          </a:prstGeom>
+          <a:noFill/>
+          <a:ln/>
+        </p:spPr>
+        <p:txBody>
+          <a:bodyPr wrap="square" lIns="0" tIns="0" rIns="0" bIns="0" rtlCol="0" anchor="t"/>
+          <a:lstStyle/>
+          <a:p>
+            <a:pPr algn="ctr" indent="0" marL="0">
+              <a:buNone/>
+            </a:pPr>
+            <a:r>
+              <a:rPr lang="en-US" sz="950" b="1" dirty="0">
+                <a:solidFill>
+                  <a:srgbClr val="002516"/>
+                </a:solidFill>
+                <a:latin typeface="Arial" pitchFamily="34" charset="0"/>
+                <a:ea typeface="Arial" pitchFamily="34" charset="-122"/>
+                <a:cs typeface="Arial" pitchFamily="34" charset="-120"/>
+              </a:rPr>
+              <a:t>Understand</a:t>
+            </a:r>
+            <a:endParaRPr lang="en-US" sz="950" dirty="0"/>
+          </a:p>
+        </p:txBody>
+      </p:sp>
+      <p:sp>
+        <p:nvSpPr>
+          <p:cNvPr id="43" name="Text 37"/>
+          <p:cNvSpPr/>
+          <p:nvPr/>
+        </p:nvSpPr>
+        <p:spPr>
+          <a:xfrm>
+            <a:off x="1878178" y="8485632"/>
+            <a:ext cx="1146658" cy="1280160"/>
+          </a:xfrm>
+          <a:prstGeom prst="rect">
+            <a:avLst/>
+          </a:prstGeom>
+          <a:noFill/>
+          <a:ln/>
+        </p:spPr>
+        <p:txBody>
+          <a:bodyPr wrap="square" lIns="0" tIns="0" rIns="0" bIns="0" rtlCol="0" anchor="t"/>
+          <a:lstStyle/>
+          <a:p>
+            <a:pPr algn="ctr" indent="0" marL="0">
+              <a:buNone/>
+            </a:pPr>
+            <a:r>
+              <a:rPr lang="en-US" sz="760" dirty="0">
+                <a:solidFill>
+                  <a:srgbClr val="000000"/>
+                </a:solidFill>
+                <a:latin typeface="Arial" pitchFamily="34" charset="0"/>
+                <a:ea typeface="Arial" pitchFamily="34" charset="-122"/>
+                <a:cs typeface="Arial" pitchFamily="34" charset="-120"/>
+              </a:rPr>
+              <a:t>Stocktake existing doctrine, products, delivery, evidence, ownership and assurance.</a:t>
+            </a:r>
+            <a:endParaRPr lang="en-US" sz="760" dirty="0"/>
+          </a:p>
+        </p:txBody>
+      </p:sp>
+      <p:sp>
+        <p:nvSpPr>
+          <p:cNvPr id="44" name="Text 38"/>
+          <p:cNvSpPr/>
+          <p:nvPr/>
+        </p:nvSpPr>
+        <p:spPr>
+          <a:xfrm>
+            <a:off x="4226357" y="7552944"/>
+            <a:ext cx="438912" cy="292608"/>
+          </a:xfrm>
+          <a:prstGeom prst="rect">
+            <a:avLst/>
+          </a:prstGeom>
+          <a:noFill/>
+          <a:ln/>
+        </p:spPr>
+        <p:txBody>
+          <a:bodyPr wrap="square" lIns="0" tIns="0" rIns="0" bIns="0" rtlCol="0" anchor="ctr"/>
+          <a:lstStyle/>
+          <a:p>
+            <a:pPr algn="ctr" indent="0" marL="0">
+              <a:buNone/>
+            </a:pPr>
+            <a:r>
+              <a:rPr lang="en-US" sz="1100" b="1" dirty="0">
+                <a:solidFill>
+                  <a:srgbClr val="C62026"/>
+                </a:solidFill>
+                <a:latin typeface="Arial" pitchFamily="34" charset="0"/>
+                <a:ea typeface="Arial" pitchFamily="34" charset="-122"/>
+                <a:cs typeface="Arial" pitchFamily="34" charset="-120"/>
+              </a:rPr>
+              <a:t>►</a:t>
+            </a:r>
+            <a:endParaRPr lang="en-US" sz="1100" dirty="0"/>
+          </a:p>
+        </p:txBody>
+      </p:sp>
+      <p:sp>
+        <p:nvSpPr>
+          <p:cNvPr id="45" name="Shape 39"/>
+          <p:cNvSpPr/>
+          <p:nvPr/>
+        </p:nvSpPr>
+        <p:spPr>
+          <a:xfrm>
+            <a:off x="3543300" y="7461504"/>
+            <a:ext cx="475488" cy="475488"/>
+          </a:xfrm>
+          <a:prstGeom prst="ellipse">
+            <a:avLst/>
+          </a:prstGeom>
+          <a:solidFill>
+            <a:srgbClr val="002516"/>
+          </a:solidFill>
+          <a:ln w="19050">
+            <a:solidFill>
+              <a:srgbClr val="FFFFFF"/>
+            </a:solidFill>
+            <a:prstDash val="solid"/>
+          </a:ln>
+        </p:spPr>
+      </p:sp>
+      <p:sp>
+        <p:nvSpPr>
+          <p:cNvPr id="46" name="Text 40"/>
+          <p:cNvSpPr/>
+          <p:nvPr/>
+        </p:nvSpPr>
+        <p:spPr>
+          <a:xfrm>
+            <a:off x="3543300" y="7461504"/>
+            <a:ext cx="475488" cy="475488"/>
+          </a:xfrm>
+          <a:prstGeom prst="rect">
+            <a:avLst/>
+          </a:prstGeom>
+          <a:noFill/>
+          <a:ln/>
+        </p:spPr>
+        <p:txBody>
+          <a:bodyPr wrap="square" lIns="0" tIns="0" rIns="0" bIns="0" rtlCol="0" anchor="ctr"/>
+          <a:lstStyle/>
+          <a:p>
+            <a:pPr algn="ctr" indent="0" marL="0">
+              <a:buNone/>
+            </a:pPr>
+            <a:r>
+              <a:rPr lang="en-US" sz="1500" b="1" dirty="0">
+                <a:solidFill>
+                  <a:srgbClr val="FFFFFF"/>
+                </a:solidFill>
+                <a:latin typeface="Arial" pitchFamily="34" charset="0"/>
+                <a:ea typeface="Arial" pitchFamily="34" charset="-122"/>
+                <a:cs typeface="Arial" pitchFamily="34" charset="-120"/>
+              </a:rPr>
+              <a:t>2</a:t>
+            </a:r>
+            <a:endParaRPr lang="en-US" sz="1500" dirty="0"/>
+          </a:p>
+        </p:txBody>
+      </p:sp>
+      <p:sp>
+        <p:nvSpPr>
+          <p:cNvPr id="47" name="Text 41"/>
+          <p:cNvSpPr/>
+          <p:nvPr/>
+        </p:nvSpPr>
+        <p:spPr>
+          <a:xfrm>
+            <a:off x="3171139" y="8065008"/>
+            <a:ext cx="1219810" cy="384048"/>
+          </a:xfrm>
+          <a:prstGeom prst="rect">
+            <a:avLst/>
+          </a:prstGeom>
+          <a:noFill/>
+          <a:ln/>
+        </p:spPr>
+        <p:txBody>
+          <a:bodyPr wrap="square" lIns="0" tIns="0" rIns="0" bIns="0" rtlCol="0" anchor="t"/>
+          <a:lstStyle/>
+          <a:p>
+            <a:pPr algn="ctr" indent="0" marL="0">
+              <a:buNone/>
+            </a:pPr>
+            <a:r>
+              <a:rPr lang="en-US" sz="950" b="1" dirty="0">
+                <a:solidFill>
+                  <a:srgbClr val="002516"/>
+                </a:solidFill>
+                <a:latin typeface="Arial" pitchFamily="34" charset="0"/>
+                <a:ea typeface="Arial" pitchFamily="34" charset="-122"/>
+                <a:cs typeface="Arial" pitchFamily="34" charset="-120"/>
+              </a:rPr>
+              <a:t>Design</a:t>
+            </a:r>
+            <a:endParaRPr lang="en-US" sz="950" dirty="0"/>
+          </a:p>
+        </p:txBody>
+      </p:sp>
+      <p:sp>
+        <p:nvSpPr>
+          <p:cNvPr id="48" name="Text 42"/>
+          <p:cNvSpPr/>
+          <p:nvPr/>
+        </p:nvSpPr>
+        <p:spPr>
+          <a:xfrm>
+            <a:off x="3207715" y="8485632"/>
+            <a:ext cx="1146658" cy="1280160"/>
+          </a:xfrm>
+          <a:prstGeom prst="rect">
+            <a:avLst/>
+          </a:prstGeom>
+          <a:noFill/>
+          <a:ln/>
+        </p:spPr>
+        <p:txBody>
+          <a:bodyPr wrap="square" lIns="0" tIns="0" rIns="0" bIns="0" rtlCol="0" anchor="t"/>
+          <a:lstStyle/>
+          <a:p>
+            <a:pPr algn="ctr" indent="0" marL="0">
+              <a:buNone/>
+            </a:pPr>
+            <a:r>
+              <a:rPr lang="en-US" sz="760" dirty="0">
+                <a:solidFill>
+                  <a:srgbClr val="000000"/>
+                </a:solidFill>
+                <a:latin typeface="Arial" pitchFamily="34" charset="0"/>
+                <a:ea typeface="Arial" pitchFamily="34" charset="-122"/>
+                <a:cs typeface="Arial" pitchFamily="34" charset="-120"/>
+              </a:rPr>
+              <a:t>Develop the framework, delivery architecture, outcomes and product-recognition criteria.</a:t>
+            </a:r>
+            <a:endParaRPr lang="en-US" sz="760" dirty="0"/>
+          </a:p>
+        </p:txBody>
+      </p:sp>
+      <p:sp>
+        <p:nvSpPr>
+          <p:cNvPr id="49" name="Text 43"/>
+          <p:cNvSpPr/>
+          <p:nvPr/>
+        </p:nvSpPr>
+        <p:spPr>
+          <a:xfrm>
+            <a:off x="5555894" y="7552944"/>
+            <a:ext cx="438912" cy="292608"/>
+          </a:xfrm>
+          <a:prstGeom prst="rect">
+            <a:avLst/>
+          </a:prstGeom>
+          <a:noFill/>
+          <a:ln/>
+        </p:spPr>
+        <p:txBody>
+          <a:bodyPr wrap="square" lIns="0" tIns="0" rIns="0" bIns="0" rtlCol="0" anchor="ctr"/>
+          <a:lstStyle/>
+          <a:p>
+            <a:pPr algn="ctr" indent="0" marL="0">
+              <a:buNone/>
+            </a:pPr>
+            <a:r>
+              <a:rPr lang="en-US" sz="1100" b="1" dirty="0">
+                <a:solidFill>
+                  <a:srgbClr val="C62026"/>
+                </a:solidFill>
+                <a:latin typeface="Arial" pitchFamily="34" charset="0"/>
+                <a:ea typeface="Arial" pitchFamily="34" charset="-122"/>
+                <a:cs typeface="Arial" pitchFamily="34" charset="-120"/>
+              </a:rPr>
+              <a:t>►</a:t>
+            </a:r>
+            <a:endParaRPr lang="en-US" sz="1100" dirty="0"/>
+          </a:p>
+        </p:txBody>
+      </p:sp>
+      <p:sp>
+        <p:nvSpPr>
+          <p:cNvPr id="50" name="Shape 44"/>
+          <p:cNvSpPr/>
+          <p:nvPr/>
+        </p:nvSpPr>
+        <p:spPr>
+          <a:xfrm>
+            <a:off x="4872838" y="7461504"/>
+            <a:ext cx="475488" cy="475488"/>
+          </a:xfrm>
+          <a:prstGeom prst="ellipse">
+            <a:avLst/>
+          </a:prstGeom>
+          <a:solidFill>
+            <a:srgbClr val="002516"/>
+          </a:solidFill>
+          <a:ln w="19050">
+            <a:solidFill>
+              <a:srgbClr val="FFFFFF"/>
+            </a:solidFill>
+            <a:prstDash val="solid"/>
+          </a:ln>
+        </p:spPr>
+      </p:sp>
+      <p:sp>
+        <p:nvSpPr>
+          <p:cNvPr id="51" name="Text 45"/>
+          <p:cNvSpPr/>
+          <p:nvPr/>
+        </p:nvSpPr>
+        <p:spPr>
+          <a:xfrm>
+            <a:off x="4872838" y="7461504"/>
+            <a:ext cx="475488" cy="475488"/>
+          </a:xfrm>
+          <a:prstGeom prst="rect">
+            <a:avLst/>
+          </a:prstGeom>
+          <a:noFill/>
+          <a:ln/>
+        </p:spPr>
+        <p:txBody>
+          <a:bodyPr wrap="square" lIns="0" tIns="0" rIns="0" bIns="0" rtlCol="0" anchor="ctr"/>
+          <a:lstStyle/>
+          <a:p>
+            <a:pPr algn="ctr" indent="0" marL="0">
+              <a:buNone/>
+            </a:pPr>
+            <a:r>
+              <a:rPr lang="en-US" sz="1500" b="1" dirty="0">
+                <a:solidFill>
+                  <a:srgbClr val="FFFFFF"/>
+                </a:solidFill>
+                <a:latin typeface="Arial" pitchFamily="34" charset="0"/>
+                <a:ea typeface="Arial" pitchFamily="34" charset="-122"/>
+                <a:cs typeface="Arial" pitchFamily="34" charset="-120"/>
+              </a:rPr>
+              <a:t>3</a:t>
+            </a:r>
+            <a:endParaRPr lang="en-US" sz="1500" dirty="0"/>
+          </a:p>
+        </p:txBody>
+      </p:sp>
+      <p:sp>
+        <p:nvSpPr>
+          <p:cNvPr id="52" name="Text 46"/>
+          <p:cNvSpPr/>
+          <p:nvPr/>
+        </p:nvSpPr>
+        <p:spPr>
+          <a:xfrm>
+            <a:off x="4500677" y="8065008"/>
+            <a:ext cx="1219810" cy="384048"/>
+          </a:xfrm>
+          <a:prstGeom prst="rect">
+            <a:avLst/>
+          </a:prstGeom>
+          <a:noFill/>
+          <a:ln/>
+        </p:spPr>
+        <p:txBody>
+          <a:bodyPr wrap="square" lIns="0" tIns="0" rIns="0" bIns="0" rtlCol="0" anchor="t"/>
+          <a:lstStyle/>
+          <a:p>
+            <a:pPr algn="ctr" indent="0" marL="0">
+              <a:buNone/>
+            </a:pPr>
+            <a:r>
+              <a:rPr lang="en-US" sz="950" b="1" dirty="0">
+                <a:solidFill>
+                  <a:srgbClr val="002516"/>
+                </a:solidFill>
+                <a:latin typeface="Arial" pitchFamily="34" charset="0"/>
+                <a:ea typeface="Arial" pitchFamily="34" charset="-122"/>
+                <a:cs typeface="Arial" pitchFamily="34" charset="-120"/>
+              </a:rPr>
+              <a:t>Validate</a:t>
+            </a:r>
+            <a:endParaRPr lang="en-US" sz="950" dirty="0"/>
+          </a:p>
+        </p:txBody>
+      </p:sp>
+      <p:sp>
+        <p:nvSpPr>
+          <p:cNvPr id="53" name="Text 47"/>
+          <p:cNvSpPr/>
+          <p:nvPr/>
+        </p:nvSpPr>
+        <p:spPr>
+          <a:xfrm>
+            <a:off x="4537253" y="8485632"/>
+            <a:ext cx="1146658" cy="1280160"/>
+          </a:xfrm>
+          <a:prstGeom prst="rect">
+            <a:avLst/>
+          </a:prstGeom>
+          <a:noFill/>
+          <a:ln/>
+        </p:spPr>
+        <p:txBody>
+          <a:bodyPr wrap="square" lIns="0" tIns="0" rIns="0" bIns="0" rtlCol="0" anchor="t"/>
+          <a:lstStyle/>
+          <a:p>
+            <a:pPr algn="ctr" indent="0" marL="0">
+              <a:buNone/>
+            </a:pPr>
+            <a:r>
+              <a:rPr lang="en-US" sz="760" dirty="0">
+                <a:solidFill>
+                  <a:srgbClr val="000000"/>
+                </a:solidFill>
+                <a:latin typeface="Arial" pitchFamily="34" charset="0"/>
+                <a:ea typeface="Arial" pitchFamily="34" charset="-122"/>
+                <a:cs typeface="Arial" pitchFamily="34" charset="-120"/>
+              </a:rPr>
+              <a:t>Refine the framework with stakeholders, training establishments and units.</a:t>
+            </a:r>
+            <a:endParaRPr lang="en-US" sz="760" dirty="0"/>
+          </a:p>
+        </p:txBody>
+      </p:sp>
+      <p:sp>
+        <p:nvSpPr>
+          <p:cNvPr id="54" name="Shape 48"/>
+          <p:cNvSpPr/>
+          <p:nvPr/>
+        </p:nvSpPr>
+        <p:spPr>
+          <a:xfrm>
+            <a:off x="6202375" y="7461504"/>
+            <a:ext cx="475488" cy="475488"/>
+          </a:xfrm>
+          <a:prstGeom prst="ellipse">
+            <a:avLst/>
+          </a:prstGeom>
+          <a:solidFill>
+            <a:srgbClr val="002516"/>
+          </a:solidFill>
+          <a:ln w="19050">
+            <a:solidFill>
+              <a:srgbClr val="FFFFFF"/>
+            </a:solidFill>
+            <a:prstDash val="solid"/>
+          </a:ln>
+        </p:spPr>
+      </p:sp>
+      <p:sp>
+        <p:nvSpPr>
+          <p:cNvPr id="55" name="Text 49"/>
+          <p:cNvSpPr/>
+          <p:nvPr/>
+        </p:nvSpPr>
+        <p:spPr>
+          <a:xfrm>
+            <a:off x="6202375" y="7461504"/>
+            <a:ext cx="475488" cy="475488"/>
+          </a:xfrm>
+          <a:prstGeom prst="rect">
+            <a:avLst/>
+          </a:prstGeom>
+          <a:noFill/>
+          <a:ln/>
+        </p:spPr>
+        <p:txBody>
+          <a:bodyPr wrap="square" lIns="0" tIns="0" rIns="0" bIns="0" rtlCol="0" anchor="ctr"/>
+          <a:lstStyle/>
+          <a:p>
+            <a:pPr algn="ctr" indent="0" marL="0">
+              <a:buNone/>
+            </a:pPr>
+            <a:r>
+              <a:rPr lang="en-US" sz="1500" b="1" dirty="0">
+                <a:solidFill>
+                  <a:srgbClr val="FFFFFF"/>
+                </a:solidFill>
+                <a:latin typeface="Arial" pitchFamily="34" charset="0"/>
+                <a:ea typeface="Arial" pitchFamily="34" charset="-122"/>
+                <a:cs typeface="Arial" pitchFamily="34" charset="-120"/>
+              </a:rPr>
+              <a:t>4</a:t>
+            </a:r>
+            <a:endParaRPr lang="en-US" sz="1500" dirty="0"/>
+          </a:p>
+        </p:txBody>
+      </p:sp>
+      <p:sp>
+        <p:nvSpPr>
+          <p:cNvPr id="56" name="Text 50"/>
+          <p:cNvSpPr/>
+          <p:nvPr/>
+        </p:nvSpPr>
+        <p:spPr>
+          <a:xfrm>
+            <a:off x="5830214" y="8065008"/>
+            <a:ext cx="1219810" cy="384048"/>
+          </a:xfrm>
+          <a:prstGeom prst="rect">
+            <a:avLst/>
+          </a:prstGeom>
+          <a:noFill/>
+          <a:ln/>
+        </p:spPr>
+        <p:txBody>
+          <a:bodyPr wrap="square" lIns="0" tIns="0" rIns="0" bIns="0" rtlCol="0" anchor="t"/>
+          <a:lstStyle/>
+          <a:p>
+            <a:pPr algn="ctr" indent="0" marL="0">
+              <a:buNone/>
+            </a:pPr>
+            <a:r>
+              <a:rPr lang="en-US" sz="950" b="1" dirty="0">
+                <a:solidFill>
+                  <a:srgbClr val="002516"/>
+                </a:solidFill>
+                <a:latin typeface="Arial" pitchFamily="34" charset="0"/>
+                <a:ea typeface="Arial" pitchFamily="34" charset="-122"/>
+                <a:cs typeface="Arial" pitchFamily="34" charset="-120"/>
+              </a:rPr>
+              <a:t>Endorse and implement</a:t>
+            </a:r>
+            <a:endParaRPr lang="en-US" sz="950" dirty="0"/>
+          </a:p>
+        </p:txBody>
+      </p:sp>
+      <p:sp>
+        <p:nvSpPr>
+          <p:cNvPr id="57" name="Text 51"/>
+          <p:cNvSpPr/>
+          <p:nvPr/>
+        </p:nvSpPr>
+        <p:spPr>
+          <a:xfrm>
+            <a:off x="5866790" y="8485632"/>
+            <a:ext cx="1146658" cy="1280160"/>
+          </a:xfrm>
+          <a:prstGeom prst="rect">
+            <a:avLst/>
+          </a:prstGeom>
+          <a:noFill/>
+          <a:ln/>
+        </p:spPr>
+        <p:txBody>
+          <a:bodyPr wrap="square" lIns="0" tIns="0" rIns="0" bIns="0" rtlCol="0" anchor="t"/>
+          <a:lstStyle/>
+          <a:p>
+            <a:pPr algn="ctr" indent="0" marL="0">
+              <a:buNone/>
+            </a:pPr>
+            <a:r>
+              <a:rPr lang="en-US" sz="760" dirty="0">
+                <a:solidFill>
+                  <a:srgbClr val="000000"/>
+                </a:solidFill>
+                <a:latin typeface="Arial" pitchFamily="34" charset="0"/>
+                <a:ea typeface="Arial" pitchFamily="34" charset="-122"/>
+                <a:cs typeface="Arial" pitchFamily="34" charset="-120"/>
+              </a:rPr>
+              <a:t>Deliver Framework v1.0 and a prioritised implementation plan.</a:t>
+            </a:r>
+            <a:endParaRPr lang="en-US" sz="760" dirty="0"/>
+          </a:p>
+        </p:txBody>
+      </p:sp>
+    </p:spTree>
+  </p:cSld>
+  <p:clrMapOvr>
+    <a:masterClrMapping/>
+  </p:clrMapOvr>
+</p:sld>
+</file>
+
+<file path=ppt/slides/slide2.xml><?xml version="1.0" encoding="utf-8"?>
+<p:sld xmlns:a="http://schemas.openxmlformats.org/drawingml/2006/main" xmlns:r="http://schemas.openxmlformats.org/officeDocument/2006/relationships" xmlns:p="http://schemas.openxmlformats.org/presentationml/2006/main">
+  <p:cSld name="Slide 2">
+    <p:bg>
+      <p:bgPr>
+        <a:solidFill>
+          <a:srgbClr val="FFFFFF"/>
+        </a:solidFill>
+      </p:bgPr>
+    </p:bg>
+    <p:spTree>
+      <p:nvGrpSpPr>
+        <p:cNvPr id="1" name=""/>
+        <p:cNvGrpSpPr/>
+        <p:nvPr/>
+      </p:nvGrpSpPr>
+      <p:grpSpPr>
+        <a:xfrm>
+          <a:off x="0" y="0"/>
+          <a:ext cx="0" cy="0"/>
+          <a:chOff x="0" y="0"/>
+          <a:chExt cx="0" cy="0"/>
+        </a:xfrm>
+      </p:grpSpPr>
       <p:pic>
         <p:nvPicPr>
-          <p:cNvPr id="29" name="Image 4" descr="preencoded.png">    </p:cNvPr>
+          <p:cNvPr id="2" name="Image 0" descr="/tmp/claude-0/-home-user-PUP/2d4cec0e-a52e-5368-bb54-803c6f37698d/scratchpad/logo-trimmed.png">    </p:cNvPr>
           <p:cNvPicPr>
             <a:picLocks noChangeAspect="1"/>
           </p:cNvPicPr>
           <p:nvPr/>
         </p:nvPicPr>
         <p:blipFill>
-          <a:blip r:embed="rId5"/>
+          <a:blip r:embed="rId1"/>
           <a:stretch>
             <a:fillRect/>
           </a:stretch>
         </p:blipFill>
         <p:spPr>
           <a:xfrm>
-            <a:off x="530352" y="5486400"/>
-            <a:ext cx="182880" cy="182880"/>
+            <a:off x="457200" y="457200"/>
+            <a:ext cx="1005840" cy="243230"/>
           </a:xfrm>
           <a:prstGeom prst="rect">
             <a:avLst/>
@@ -1746,14 +2883,14 @@
       </p:pic>
       <p:sp>
         <p:nvSpPr>
-          <p:cNvPr id="30" name="Text 23"/>
-          <p:cNvSpPr/>
-          <p:nvPr/>
-        </p:nvSpPr>
-        <p:spPr>
-          <a:xfrm>
-            <a:off x="768096" y="5413248"/>
-            <a:ext cx="1776984" cy="329184"/>
+          <p:cNvPr id="3" name="Text 0"/>
+          <p:cNvSpPr/>
+          <p:nvPr/>
+        </p:nvSpPr>
+        <p:spPr>
+          <a:xfrm>
+            <a:off x="1691640" y="429768"/>
+            <a:ext cx="5413248" cy="292608"/>
           </a:xfrm>
           <a:prstGeom prst="rect">
             <a:avLst/>
@@ -1769,7 +2906,168 @@
               <a:buNone/>
             </a:pPr>
             <a:r>
-              <a:rPr lang="en-US" sz="760" b="1" dirty="0">
+              <a:rPr lang="en-US" sz="1550" b="1" dirty="0">
+                <a:solidFill>
+                  <a:srgbClr val="000000"/>
+                </a:solidFill>
+                <a:latin typeface="Arial" pitchFamily="34" charset="0"/>
+                <a:ea typeface="Arial" pitchFamily="34" charset="-122"/>
+                <a:cs typeface="Arial" pitchFamily="34" charset="-120"/>
+              </a:rPr>
+              <a:t>CURRENT SYSTEM, GOVERNANCE AND DELIVERY</a:t>
+            </a:r>
+            <a:endParaRPr lang="en-US" sz="1550" dirty="0"/>
+          </a:p>
+        </p:txBody>
+      </p:sp>
+      <p:sp>
+        <p:nvSpPr>
+          <p:cNvPr id="4" name="Text 1"/>
+          <p:cNvSpPr/>
+          <p:nvPr/>
+        </p:nvSpPr>
+        <p:spPr>
+          <a:xfrm>
+            <a:off x="457200" y="10469880"/>
+            <a:ext cx="2377440" cy="164592"/>
+          </a:xfrm>
+          <a:prstGeom prst="rect">
+            <a:avLst/>
+          </a:prstGeom>
+          <a:noFill/>
+          <a:ln/>
+        </p:spPr>
+        <p:txBody>
+          <a:bodyPr wrap="square" lIns="0" tIns="0" rIns="0" bIns="0" rtlCol="0" anchor="ctr"/>
+          <a:lstStyle/>
+          <a:p>
+            <a:pPr algn="l" indent="0" marL="0">
+              <a:buNone/>
+            </a:pPr>
+            <a:r>
+              <a:rPr lang="en-US" sz="600" dirty="0">
+                <a:solidFill>
+                  <a:srgbClr val="000000"/>
+                </a:solidFill>
+                <a:latin typeface="Arial" pitchFamily="34" charset="0"/>
+                <a:ea typeface="Arial" pitchFamily="34" charset="-122"/>
+                <a:cs typeface="Arial" pitchFamily="34" charset="-120"/>
+              </a:rPr>
+              <a:t>Army Command School  ·  ACS 2026</a:t>
+            </a:r>
+            <a:endParaRPr lang="en-US" sz="600" dirty="0"/>
+          </a:p>
+        </p:txBody>
+      </p:sp>
+      <p:sp>
+        <p:nvSpPr>
+          <p:cNvPr id="5" name="Text 2"/>
+          <p:cNvSpPr/>
+          <p:nvPr/>
+        </p:nvSpPr>
+        <p:spPr>
+          <a:xfrm>
+            <a:off x="5212080" y="10469880"/>
+            <a:ext cx="1892808" cy="164592"/>
+          </a:xfrm>
+          <a:prstGeom prst="rect">
+            <a:avLst/>
+          </a:prstGeom>
+          <a:noFill/>
+          <a:ln/>
+        </p:spPr>
+        <p:txBody>
+          <a:bodyPr wrap="square" lIns="0" tIns="0" rIns="0" bIns="0" rtlCol="0" anchor="ctr"/>
+          <a:lstStyle/>
+          <a:p>
+            <a:pPr algn="r" indent="0" marL="0">
+              <a:buNone/>
+            </a:pPr>
+            <a:r>
+              <a:rPr lang="en-US" sz="600" dirty="0">
+                <a:solidFill>
+                  <a:srgbClr val="000000"/>
+                </a:solidFill>
+                <a:latin typeface="Arial" pitchFamily="34" charset="0"/>
+                <a:ea typeface="Arial" pitchFamily="34" charset="-122"/>
+                <a:cs typeface="Arial" pitchFamily="34" charset="-120"/>
+              </a:rPr>
+              <a:t>Draft v0.8  ·  July 2026</a:t>
+            </a:r>
+            <a:endParaRPr lang="en-US" sz="600" dirty="0"/>
+          </a:p>
+        </p:txBody>
+      </p:sp>
+      <p:sp>
+        <p:nvSpPr>
+          <p:cNvPr id="6" name="Shape 3"/>
+          <p:cNvSpPr/>
+          <p:nvPr/>
+        </p:nvSpPr>
+        <p:spPr>
+          <a:xfrm>
+            <a:off x="457200" y="1042416"/>
+            <a:ext cx="3232404" cy="365760"/>
+          </a:xfrm>
+          <a:prstGeom prst="rect">
+            <a:avLst/>
+          </a:prstGeom>
+          <a:solidFill>
+            <a:srgbClr val="002516"/>
+          </a:solidFill>
+          <a:ln/>
+        </p:spPr>
+      </p:sp>
+      <p:pic>
+        <p:nvPicPr>
+          <p:cNvPr id="7" name="Image 1" descr="preencoded.png">    </p:cNvPr>
+          <p:cNvPicPr>
+            <a:picLocks noChangeAspect="1"/>
+          </p:cNvPicPr>
+          <p:nvPr/>
+        </p:nvPicPr>
+        <p:blipFill>
+          <a:blip r:embed="rId2"/>
+          <a:stretch>
+            <a:fillRect/>
+          </a:stretch>
+        </p:blipFill>
+        <p:spPr>
+          <a:xfrm>
+            <a:off x="566928" y="1124712"/>
+            <a:ext cx="201168" cy="201168"/>
+          </a:xfrm>
+          <a:prstGeom prst="rect">
+            <a:avLst/>
+          </a:prstGeom>
+        </p:spPr>
+      </p:pic>
+      <p:sp>
+        <p:nvSpPr>
+          <p:cNvPr id="8" name="Text 4"/>
+          <p:cNvSpPr/>
+          <p:nvPr/>
+        </p:nvSpPr>
+        <p:spPr>
+          <a:xfrm>
+            <a:off x="841248" y="1042416"/>
+            <a:ext cx="2775204" cy="365760"/>
+          </a:xfrm>
+          <a:prstGeom prst="rect">
+            <a:avLst/>
+          </a:prstGeom>
+          <a:noFill/>
+          <a:ln/>
+        </p:spPr>
+        <p:txBody>
+          <a:bodyPr wrap="square" lIns="0" tIns="0" rIns="0" bIns="0" rtlCol="0" anchor="ctr"/>
+          <a:lstStyle/>
+          <a:p>
+            <a:pPr algn="l" indent="0" marL="0">
+              <a:buNone/>
+            </a:pPr>
+            <a:r>
+              <a:rPr lang="en-US" sz="950" b="1" spc="100" kern="0" dirty="0">
                 <a:solidFill>
                   <a:srgbClr val="FFFFFF"/>
                 </a:solidFill>
@@ -1777,22 +3075,22 @@
                 <a:ea typeface="Arial" pitchFamily="34" charset="-122"/>
                 <a:cs typeface="Arial" pitchFamily="34" charset="-120"/>
               </a:rPr>
-              <a:t>1. GOVERNANCE &amp; ASSURANCE</a:t>
-            </a:r>
-            <a:endParaRPr lang="en-US" sz="760" dirty="0"/>
-          </a:p>
-        </p:txBody>
-      </p:sp>
-      <p:sp>
-        <p:nvSpPr>
-          <p:cNvPr id="31" name="Shape 24"/>
-          <p:cNvSpPr/>
-          <p:nvPr/>
-        </p:nvSpPr>
-        <p:spPr>
-          <a:xfrm>
-            <a:off x="457200" y="5742432"/>
-            <a:ext cx="2142744" cy="4407408"/>
+              <a:t>GOVERNANCE &amp; ASSURANCE</a:t>
+            </a:r>
+            <a:endParaRPr lang="en-US" sz="950" dirty="0"/>
+          </a:p>
+        </p:txBody>
+      </p:sp>
+      <p:sp>
+        <p:nvSpPr>
+          <p:cNvPr id="9" name="Shape 5"/>
+          <p:cNvSpPr/>
+          <p:nvPr/>
+        </p:nvSpPr>
+        <p:spPr>
+          <a:xfrm>
+            <a:off x="457200" y="1408176"/>
+            <a:ext cx="3232404" cy="6675120"/>
           </a:xfrm>
           <a:prstGeom prst="rect">
             <a:avLst/>
@@ -1810,14 +3108,162 @@
       </p:sp>
       <p:sp>
         <p:nvSpPr>
-          <p:cNvPr id="32" name="Shape 25"/>
-          <p:cNvSpPr/>
-          <p:nvPr/>
-        </p:nvSpPr>
-        <p:spPr>
-          <a:xfrm>
-            <a:off x="2709672" y="5413248"/>
-            <a:ext cx="2142744" cy="329184"/>
+          <p:cNvPr id="10" name="Text 6"/>
+          <p:cNvSpPr/>
+          <p:nvPr/>
+        </p:nvSpPr>
+        <p:spPr>
+          <a:xfrm>
+            <a:off x="640080" y="1682496"/>
+            <a:ext cx="2866644" cy="6126480"/>
+          </a:xfrm>
+          <a:prstGeom prst="rect">
+            <a:avLst/>
+          </a:prstGeom>
+          <a:noFill/>
+          <a:ln/>
+        </p:spPr>
+        <p:txBody>
+          <a:bodyPr wrap="square" lIns="0" tIns="0" rIns="0" bIns="0" rtlCol="0" anchor="t"/>
+          <a:lstStyle/>
+          <a:p>
+            <a:pPr algn="l" marL="152400" indent="-152400">
+              <a:spcAft>
+                <a:spcPts val="2400"/>
+              </a:spcAft>
+              <a:buSzPct val="100000"/>
+              <a:buChar char="•"/>
+            </a:pPr>
+            <a:r>
+              <a:rPr lang="en-US" sz="950" dirty="0">
+                <a:solidFill>
+                  <a:srgbClr val="000000"/>
+                </a:solidFill>
+                <a:latin typeface="Arial" pitchFamily="34" charset="0"/>
+                <a:ea typeface="Arial" pitchFamily="34" charset="-122"/>
+                <a:cs typeface="Arial" pitchFamily="34" charset="-120"/>
+              </a:rPr>
+              <a:t>Strategic sponsorship and policy direction</a:t>
+            </a:r>
+            <a:endParaRPr lang="en-US" sz="950" dirty="0"/>
+          </a:p>
+          <a:p>
+            <a:pPr algn="l" marL="152400" indent="-152400">
+              <a:spcAft>
+                <a:spcPts val="2400"/>
+              </a:spcAft>
+              <a:buSzPct val="100000"/>
+              <a:buChar char="•"/>
+            </a:pPr>
+            <a:r>
+              <a:rPr lang="en-US" sz="950" dirty="0">
+                <a:solidFill>
+                  <a:srgbClr val="000000"/>
+                </a:solidFill>
+                <a:latin typeface="Arial" pitchFamily="34" charset="0"/>
+                <a:ea typeface="Arial" pitchFamily="34" charset="-122"/>
+                <a:cs typeface="Arial" pitchFamily="34" charset="-120"/>
+              </a:rPr>
+              <a:t>Capability integration</a:t>
+            </a:r>
+            <a:endParaRPr lang="en-US" sz="950" dirty="0"/>
+          </a:p>
+          <a:p>
+            <a:pPr algn="l" marL="152400" indent="-152400">
+              <a:spcAft>
+                <a:spcPts val="2400"/>
+              </a:spcAft>
+              <a:buSzPct val="100000"/>
+              <a:buChar char="•"/>
+            </a:pPr>
+            <a:r>
+              <a:rPr lang="en-US" sz="950" dirty="0">
+                <a:solidFill>
+                  <a:srgbClr val="000000"/>
+                </a:solidFill>
+                <a:latin typeface="Arial" pitchFamily="34" charset="0"/>
+                <a:ea typeface="Arial" pitchFamily="34" charset="-122"/>
+                <a:cs typeface="Arial" pitchFamily="34" charset="-120"/>
+              </a:rPr>
+              <a:t>Technical and professional authorities</a:t>
+            </a:r>
+            <a:endParaRPr lang="en-US" sz="950" dirty="0"/>
+          </a:p>
+          <a:p>
+            <a:pPr algn="l" marL="152400" indent="-152400">
+              <a:spcAft>
+                <a:spcPts val="2400"/>
+              </a:spcAft>
+              <a:buSzPct val="100000"/>
+              <a:buChar char="•"/>
+            </a:pPr>
+            <a:r>
+              <a:rPr lang="en-US" sz="950" dirty="0">
+                <a:solidFill>
+                  <a:srgbClr val="000000"/>
+                </a:solidFill>
+                <a:latin typeface="Arial" pitchFamily="34" charset="0"/>
+                <a:ea typeface="Arial" pitchFamily="34" charset="-122"/>
+                <a:cs typeface="Arial" pitchFamily="34" charset="-120"/>
+              </a:rPr>
+              <a:t>Product recognition and evidence requirements</a:t>
+            </a:r>
+            <a:endParaRPr lang="en-US" sz="950" dirty="0"/>
+          </a:p>
+          <a:p>
+            <a:pPr algn="l" marL="152400" indent="-152400">
+              <a:spcAft>
+                <a:spcPts val="2400"/>
+              </a:spcAft>
+              <a:buSzPct val="100000"/>
+              <a:buChar char="•"/>
+            </a:pPr>
+            <a:r>
+              <a:rPr lang="en-US" sz="950" dirty="0">
+                <a:solidFill>
+                  <a:srgbClr val="000000"/>
+                </a:solidFill>
+                <a:latin typeface="Arial" pitchFamily="34" charset="0"/>
+                <a:ea typeface="Arial" pitchFamily="34" charset="-122"/>
+                <a:cs typeface="Arial" pitchFamily="34" charset="-120"/>
+              </a:rPr>
+              <a:t>Delivery standards</a:t>
+            </a:r>
+            <a:endParaRPr lang="en-US" sz="950" dirty="0"/>
+          </a:p>
+          <a:p>
+            <a:pPr algn="l" marL="152400" indent="-152400">
+              <a:spcAft>
+                <a:spcPts val="2400"/>
+              </a:spcAft>
+              <a:buSzPct val="100000"/>
+              <a:buChar char="•"/>
+            </a:pPr>
+            <a:r>
+              <a:rPr lang="en-US" sz="950" dirty="0">
+                <a:solidFill>
+                  <a:srgbClr val="000000"/>
+                </a:solidFill>
+                <a:latin typeface="Arial" pitchFamily="34" charset="0"/>
+                <a:ea typeface="Arial" pitchFamily="34" charset="-122"/>
+                <a:cs typeface="Arial" pitchFamily="34" charset="-120"/>
+              </a:rPr>
+              <a:t>Evaluation and assurance</a:t>
+            </a:r>
+            <a:endParaRPr lang="en-US" sz="950" dirty="0"/>
+          </a:p>
+        </p:txBody>
+      </p:sp>
+      <p:sp>
+        <p:nvSpPr>
+          <p:cNvPr id="11" name="Shape 7"/>
+          <p:cNvSpPr/>
+          <p:nvPr/>
+        </p:nvSpPr>
+        <p:spPr>
+          <a:xfrm>
+            <a:off x="3872484" y="1042416"/>
+            <a:ext cx="3232404" cy="365760"/>
           </a:xfrm>
           <a:prstGeom prst="rect">
             <a:avLst/>
@@ -1830,22 +3276,22 @@
       </p:sp>
       <p:pic>
         <p:nvPicPr>
-          <p:cNvPr id="33" name="Image 5" descr="preencoded.png">    </p:cNvPr>
+          <p:cNvPr id="12" name="Image 2" descr="preencoded.png">    </p:cNvPr>
           <p:cNvPicPr>
             <a:picLocks noChangeAspect="1"/>
           </p:cNvPicPr>
           <p:nvPr/>
         </p:nvPicPr>
         <p:blipFill>
-          <a:blip r:embed="rId6"/>
+          <a:blip r:embed="rId3"/>
           <a:stretch>
             <a:fillRect/>
           </a:stretch>
         </p:blipFill>
         <p:spPr>
           <a:xfrm>
-            <a:off x="2782824" y="5486400"/>
-            <a:ext cx="182880" cy="182880"/>
+            <a:off x="3982212" y="1124712"/>
+            <a:ext cx="201168" cy="201168"/>
           </a:xfrm>
           <a:prstGeom prst="rect">
             <a:avLst/>
@@ -1854,14 +3300,14 @@
       </p:pic>
       <p:sp>
         <p:nvSpPr>
-          <p:cNvPr id="34" name="Text 26"/>
-          <p:cNvSpPr/>
-          <p:nvPr/>
-        </p:nvSpPr>
-        <p:spPr>
-          <a:xfrm>
-            <a:off x="3020568" y="5413248"/>
-            <a:ext cx="1776984" cy="329184"/>
+          <p:cNvPr id="13" name="Text 8"/>
+          <p:cNvSpPr/>
+          <p:nvPr/>
+        </p:nvSpPr>
+        <p:spPr>
+          <a:xfrm>
+            <a:off x="4256532" y="1042416"/>
+            <a:ext cx="2775204" cy="365760"/>
           </a:xfrm>
           <a:prstGeom prst="rect">
             <a:avLst/>
@@ -1877,7 +3323,7 @@
               <a:buNone/>
             </a:pPr>
             <a:r>
-              <a:rPr lang="en-US" sz="760" b="1" dirty="0">
+              <a:rPr lang="en-US" sz="950" b="1" spc="100" kern="0" dirty="0">
                 <a:solidFill>
                   <a:srgbClr val="FFFFFF"/>
                 </a:solidFill>
@@ -1885,22 +3331,22 @@
                 <a:ea typeface="Arial" pitchFamily="34" charset="-122"/>
                 <a:cs typeface="Arial" pitchFamily="34" charset="-120"/>
               </a:rPr>
-              <a:t>2. CURRENT DELIVERY SYSTEM</a:t>
-            </a:r>
-            <a:endParaRPr lang="en-US" sz="760" dirty="0"/>
-          </a:p>
-        </p:txBody>
-      </p:sp>
-      <p:sp>
-        <p:nvSpPr>
-          <p:cNvPr id="35" name="Shape 27"/>
-          <p:cNvSpPr/>
-          <p:nvPr/>
-        </p:nvSpPr>
-        <p:spPr>
-          <a:xfrm>
-            <a:off x="2709672" y="5742432"/>
-            <a:ext cx="2142744" cy="4407408"/>
+              <a:t>CURRENT DELIVERY SYSTEM</a:t>
+            </a:r>
+            <a:endParaRPr lang="en-US" sz="950" dirty="0"/>
+          </a:p>
+        </p:txBody>
+      </p:sp>
+      <p:sp>
+        <p:nvSpPr>
+          <p:cNvPr id="14" name="Shape 9"/>
+          <p:cNvSpPr/>
+          <p:nvPr/>
+        </p:nvSpPr>
+        <p:spPr>
+          <a:xfrm>
+            <a:off x="3872484" y="1408176"/>
+            <a:ext cx="3232404" cy="6675120"/>
           </a:xfrm>
           <a:prstGeom prst="rect">
             <a:avLst/>
@@ -1916,44 +3362,24 @@
           </a:ln>
         </p:spPr>
       </p:sp>
-      <p:sp>
-        <p:nvSpPr>
-          <p:cNvPr id="36" name="Shape 28"/>
-          <p:cNvSpPr/>
-          <p:nvPr/>
-        </p:nvSpPr>
-        <p:spPr>
-          <a:xfrm>
-            <a:off x="4962144" y="5413248"/>
-            <a:ext cx="2142744" cy="329184"/>
-          </a:xfrm>
-          <a:prstGeom prst="rect">
-            <a:avLst/>
-          </a:prstGeom>
-          <a:solidFill>
-            <a:srgbClr val="002516"/>
-          </a:solidFill>
-          <a:ln/>
-        </p:spPr>
-      </p:sp>
       <p:pic>
         <p:nvPicPr>
-          <p:cNvPr id="37" name="Image 6" descr="preencoded.png">    </p:cNvPr>
+          <p:cNvPr id="15" name="Image 3" descr="preencoded.png">    </p:cNvPr>
           <p:cNvPicPr>
             <a:picLocks noChangeAspect="1"/>
           </p:cNvPicPr>
           <p:nvPr/>
         </p:nvPicPr>
         <p:blipFill>
-          <a:blip r:embed="rId7"/>
+          <a:blip r:embed="rId4"/>
           <a:stretch>
             <a:fillRect/>
           </a:stretch>
         </p:blipFill>
         <p:spPr>
           <a:xfrm>
-            <a:off x="5035296" y="5486400"/>
-            <a:ext cx="182880" cy="182880"/>
+            <a:off x="4018788" y="1691640"/>
+            <a:ext cx="256032" cy="256032"/>
           </a:xfrm>
           <a:prstGeom prst="rect">
             <a:avLst/>
@@ -1962,14 +3388,14 @@
       </p:pic>
       <p:sp>
         <p:nvSpPr>
-          <p:cNvPr id="38" name="Text 29"/>
-          <p:cNvSpPr/>
-          <p:nvPr/>
-        </p:nvSpPr>
-        <p:spPr>
-          <a:xfrm>
-            <a:off x="5273040" y="5413248"/>
-            <a:ext cx="1776984" cy="329184"/>
+          <p:cNvPr id="16" name="Text 10"/>
+          <p:cNvSpPr/>
+          <p:nvPr/>
+        </p:nvSpPr>
+        <p:spPr>
+          <a:xfrm>
+            <a:off x="4366260" y="1682496"/>
+            <a:ext cx="2592324" cy="274320"/>
           </a:xfrm>
           <a:prstGeom prst="rect">
             <a:avLst/>
@@ -1985,55 +3411,30 @@
               <a:buNone/>
             </a:pPr>
             <a:r>
-              <a:rPr lang="en-US" sz="760" b="1" dirty="0">
-                <a:solidFill>
-                  <a:srgbClr val="FFFFFF"/>
-                </a:solidFill>
-                <a:latin typeface="Arial" pitchFamily="34" charset="0"/>
-                <a:ea typeface="Arial" pitchFamily="34" charset="-122"/>
-                <a:cs typeface="Arial" pitchFamily="34" charset="-120"/>
-              </a:rPr>
-              <a:t>3. FRAMEWORK DEVELOPMENT PROGRAMME</a:t>
-            </a:r>
-            <a:endParaRPr lang="en-US" sz="760" dirty="0"/>
-          </a:p>
-        </p:txBody>
-      </p:sp>
-      <p:sp>
-        <p:nvSpPr>
-          <p:cNvPr id="39" name="Shape 30"/>
-          <p:cNvSpPr/>
-          <p:nvPr/>
-        </p:nvSpPr>
-        <p:spPr>
-          <a:xfrm>
-            <a:off x="4962144" y="5742432"/>
-            <a:ext cx="2142744" cy="4407408"/>
-          </a:xfrm>
-          <a:prstGeom prst="rect">
-            <a:avLst/>
-          </a:prstGeom>
-          <a:solidFill>
-            <a:srgbClr val="FFFFFF"/>
-          </a:solidFill>
-          <a:ln w="9525">
-            <a:solidFill>
-              <a:srgbClr val="A89662"/>
-            </a:solidFill>
-            <a:prstDash val="solid"/>
-          </a:ln>
-        </p:spPr>
-      </p:sp>
-      <p:sp>
-        <p:nvSpPr>
-          <p:cNvPr id="40" name="Text 31"/>
-          <p:cNvSpPr/>
-          <p:nvPr/>
-        </p:nvSpPr>
-        <p:spPr>
-          <a:xfrm>
-            <a:off x="585216" y="5907024"/>
-            <a:ext cx="1905000" cy="4078224"/>
+              <a:rPr lang="en-US" sz="950" b="1" dirty="0">
+                <a:solidFill>
+                  <a:srgbClr val="002516"/>
+                </a:solidFill>
+                <a:latin typeface="Arial" pitchFamily="34" charset="0"/>
+                <a:ea typeface="Arial" pitchFamily="34" charset="-122"/>
+                <a:cs typeface="Arial" pitchFamily="34" charset="-120"/>
+              </a:rPr>
+              <a:t>NZALC</a:t>
+            </a:r>
+            <a:endParaRPr lang="en-US" sz="950" dirty="0"/>
+          </a:p>
+        </p:txBody>
+      </p:sp>
+      <p:sp>
+        <p:nvSpPr>
+          <p:cNvPr id="17" name="Text 11"/>
+          <p:cNvSpPr/>
+          <p:nvPr/>
+        </p:nvSpPr>
+        <p:spPr>
+          <a:xfrm>
+            <a:off x="4366260" y="1993392"/>
+            <a:ext cx="2592324" cy="1463040"/>
           </a:xfrm>
           <a:prstGeom prst="rect">
             <a:avLst/>
@@ -2047,13 +3448,13 @@
           <a:p>
             <a:pPr algn="l" marL="127000" indent="-127000">
               <a:spcAft>
-                <a:spcPts val="1200"/>
+                <a:spcPts val="500"/>
               </a:spcAft>
               <a:buSzPct val="100000"/>
               <a:buChar char="•"/>
             </a:pPr>
             <a:r>
-              <a:rPr lang="en-US" sz="820" dirty="0">
+              <a:rPr lang="en-US" sz="850" dirty="0">
                 <a:solidFill>
                   <a:srgbClr val="000000"/>
                 </a:solidFill>
@@ -2061,20 +3462,20 @@
                 <a:ea typeface="Arial" pitchFamily="34" charset="-122"/>
                 <a:cs typeface="Arial" pitchFamily="34" charset="-120"/>
               </a:rPr>
-              <a:t>Strategic sponsorship and policy direction</a:t>
-            </a:r>
-            <a:endParaRPr lang="en-US" sz="820" dirty="0"/>
+              <a:t>ELDA Lead Leaders</a:t>
+            </a:r>
+            <a:endParaRPr lang="en-US" sz="850" dirty="0"/>
           </a:p>
           <a:p>
             <a:pPr algn="l" marL="127000" indent="-127000">
               <a:spcAft>
-                <a:spcPts val="1200"/>
+                <a:spcPts val="500"/>
               </a:spcAft>
               <a:buSzPct val="100000"/>
               <a:buChar char="•"/>
             </a:pPr>
             <a:r>
-              <a:rPr lang="en-US" sz="820" dirty="0">
+              <a:rPr lang="en-US" sz="850" dirty="0">
                 <a:solidFill>
                   <a:srgbClr val="000000"/>
                 </a:solidFill>
@@ -2082,20 +3483,20 @@
                 <a:ea typeface="Arial" pitchFamily="34" charset="-122"/>
                 <a:cs typeface="Arial" pitchFamily="34" charset="-120"/>
               </a:rPr>
-              <a:t>Capability integration</a:t>
-            </a:r>
-            <a:endParaRPr lang="en-US" sz="820" dirty="0"/>
+              <a:t>ELDA Lead Systems</a:t>
+            </a:r>
+            <a:endParaRPr lang="en-US" sz="850" dirty="0"/>
           </a:p>
           <a:p>
             <a:pPr algn="l" marL="127000" indent="-127000">
               <a:spcAft>
-                <a:spcPts val="1200"/>
+                <a:spcPts val="500"/>
               </a:spcAft>
               <a:buSzPct val="100000"/>
               <a:buChar char="•"/>
             </a:pPr>
             <a:r>
-              <a:rPr lang="en-US" sz="820" dirty="0">
+              <a:rPr lang="en-US" sz="850" dirty="0">
                 <a:solidFill>
                   <a:srgbClr val="000000"/>
                 </a:solidFill>
@@ -2103,20 +3504,20 @@
                 <a:ea typeface="Arial" pitchFamily="34" charset="-122"/>
                 <a:cs typeface="Arial" pitchFamily="34" charset="-120"/>
               </a:rPr>
-              <a:t>Technical and professional authorities</a:t>
-            </a:r>
-            <a:endParaRPr lang="en-US" sz="820" dirty="0"/>
+              <a:t>ELDA Resilience</a:t>
+            </a:r>
+            <a:endParaRPr lang="en-US" sz="850" dirty="0"/>
           </a:p>
           <a:p>
             <a:pPr algn="l" marL="127000" indent="-127000">
               <a:spcAft>
-                <a:spcPts val="1200"/>
+                <a:spcPts val="500"/>
               </a:spcAft>
               <a:buSzPct val="100000"/>
               <a:buChar char="•"/>
             </a:pPr>
             <a:r>
-              <a:rPr lang="en-US" sz="820" dirty="0">
+              <a:rPr lang="en-US" sz="850" dirty="0">
                 <a:solidFill>
                   <a:srgbClr val="000000"/>
                 </a:solidFill>
@@ -2124,20 +3525,20 @@
                 <a:ea typeface="Arial" pitchFamily="34" charset="-122"/>
                 <a:cs typeface="Arial" pitchFamily="34" charset="-120"/>
               </a:rPr>
-              <a:t>Product recognition and evidence requirements</a:t>
-            </a:r>
-            <a:endParaRPr lang="en-US" sz="820" dirty="0"/>
+              <a:t>Performance Under Pressure (Lead Self)</a:t>
+            </a:r>
+            <a:endParaRPr lang="en-US" sz="850" dirty="0"/>
           </a:p>
           <a:p>
             <a:pPr algn="l" marL="127000" indent="-127000">
               <a:spcAft>
-                <a:spcPts val="1200"/>
+                <a:spcPts val="500"/>
               </a:spcAft>
               <a:buSzPct val="100000"/>
               <a:buChar char="•"/>
             </a:pPr>
             <a:r>
-              <a:rPr lang="en-US" sz="820" dirty="0">
+              <a:rPr lang="en-US" sz="850" dirty="0">
                 <a:solidFill>
                   <a:srgbClr val="000000"/>
                 </a:solidFill>
@@ -2145,233 +3546,22 @@
                 <a:ea typeface="Arial" pitchFamily="34" charset="-122"/>
                 <a:cs typeface="Arial" pitchFamily="34" charset="-120"/>
               </a:rPr>
-              <a:t>Delivery standards</a:t>
-            </a:r>
-            <a:endParaRPr lang="en-US" sz="820" dirty="0"/>
-          </a:p>
-          <a:p>
-            <a:pPr algn="l" marL="127000" indent="-127000">
-              <a:spcAft>
-                <a:spcPts val="1200"/>
-              </a:spcAft>
-              <a:buSzPct val="100000"/>
-              <a:buChar char="•"/>
-            </a:pPr>
-            <a:r>
-              <a:rPr lang="en-US" sz="820" dirty="0">
-                <a:solidFill>
-                  <a:srgbClr val="000000"/>
-                </a:solidFill>
-                <a:latin typeface="Arial" pitchFamily="34" charset="0"/>
-                <a:ea typeface="Arial" pitchFamily="34" charset="-122"/>
-                <a:cs typeface="Arial" pitchFamily="34" charset="-120"/>
-              </a:rPr>
-              <a:t>Evaluation and assurance</a:t>
-            </a:r>
-            <a:endParaRPr lang="en-US" sz="820" dirty="0"/>
-          </a:p>
-        </p:txBody>
-      </p:sp>
-      <p:pic>
-        <p:nvPicPr>
-          <p:cNvPr id="41" name="Image 7" descr="preencoded.png">    </p:cNvPr>
-          <p:cNvPicPr>
-            <a:picLocks noChangeAspect="1"/>
-          </p:cNvPicPr>
-          <p:nvPr/>
-        </p:nvPicPr>
-        <p:blipFill>
-          <a:blip r:embed="rId8"/>
-          <a:stretch>
-            <a:fillRect/>
-          </a:stretch>
-        </p:blipFill>
-        <p:spPr>
-          <a:xfrm>
-            <a:off x="2819400" y="5879592"/>
-            <a:ext cx="219456" cy="219456"/>
-          </a:xfrm>
-          <a:prstGeom prst="rect">
-            <a:avLst/>
-          </a:prstGeom>
-        </p:spPr>
-      </p:pic>
-      <p:sp>
-        <p:nvSpPr>
-          <p:cNvPr id="42" name="Text 32"/>
-          <p:cNvSpPr/>
-          <p:nvPr/>
-        </p:nvSpPr>
-        <p:spPr>
-          <a:xfrm>
-            <a:off x="3112008" y="5870448"/>
-            <a:ext cx="1630680" cy="237744"/>
-          </a:xfrm>
-          <a:prstGeom prst="rect">
-            <a:avLst/>
-          </a:prstGeom>
-          <a:noFill/>
-          <a:ln/>
-        </p:spPr>
-        <p:txBody>
-          <a:bodyPr wrap="square" lIns="0" tIns="0" rIns="0" bIns="0" rtlCol="0" anchor="ctr"/>
-          <a:lstStyle/>
-          <a:p>
-            <a:pPr algn="l" indent="0" marL="0">
-              <a:buNone/>
-            </a:pPr>
-            <a:r>
-              <a:rPr lang="en-US" sz="830" b="1" dirty="0">
-                <a:solidFill>
-                  <a:srgbClr val="002516"/>
-                </a:solidFill>
-                <a:latin typeface="Arial" pitchFamily="34" charset="0"/>
-                <a:ea typeface="Arial" pitchFamily="34" charset="-122"/>
-                <a:cs typeface="Arial" pitchFamily="34" charset="-120"/>
-              </a:rPr>
-              <a:t>NZALC</a:t>
-            </a:r>
-            <a:endParaRPr lang="en-US" sz="830" dirty="0"/>
-          </a:p>
-        </p:txBody>
-      </p:sp>
-      <p:sp>
-        <p:nvSpPr>
-          <p:cNvPr id="43" name="Text 33"/>
-          <p:cNvSpPr/>
-          <p:nvPr/>
-        </p:nvSpPr>
-        <p:spPr>
-          <a:xfrm>
-            <a:off x="3112008" y="6117336"/>
-            <a:ext cx="1630680" cy="1188720"/>
-          </a:xfrm>
-          <a:prstGeom prst="rect">
-            <a:avLst/>
-          </a:prstGeom>
-          <a:noFill/>
-          <a:ln/>
-        </p:spPr>
-        <p:txBody>
-          <a:bodyPr wrap="square" lIns="0" tIns="0" rIns="0" bIns="0" rtlCol="0" anchor="t"/>
-          <a:lstStyle/>
-          <a:p>
-            <a:pPr algn="l" marL="101600" indent="-101600">
-              <a:spcAft>
-                <a:spcPts val="300"/>
-              </a:spcAft>
-              <a:buSzPct val="100000"/>
-              <a:buChar char="•"/>
-            </a:pPr>
-            <a:r>
-              <a:rPr lang="en-US" sz="730" dirty="0">
-                <a:solidFill>
-                  <a:srgbClr val="000000"/>
-                </a:solidFill>
-                <a:latin typeface="Arial" pitchFamily="34" charset="0"/>
-                <a:ea typeface="Arial" pitchFamily="34" charset="-122"/>
-                <a:cs typeface="Arial" pitchFamily="34" charset="-120"/>
-              </a:rPr>
-              <a:t>ELDA Lead Leaders</a:t>
-            </a:r>
-            <a:endParaRPr lang="en-US" sz="730" dirty="0"/>
-          </a:p>
-          <a:p>
-            <a:pPr algn="l" marL="101600" indent="-101600">
-              <a:spcAft>
-                <a:spcPts val="300"/>
-              </a:spcAft>
-              <a:buSzPct val="100000"/>
-              <a:buChar char="•"/>
-            </a:pPr>
-            <a:r>
-              <a:rPr lang="en-US" sz="730" dirty="0">
-                <a:solidFill>
-                  <a:srgbClr val="000000"/>
-                </a:solidFill>
-                <a:latin typeface="Arial" pitchFamily="34" charset="0"/>
-                <a:ea typeface="Arial" pitchFamily="34" charset="-122"/>
-                <a:cs typeface="Arial" pitchFamily="34" charset="-120"/>
-              </a:rPr>
-              <a:t>ELDA Lead Systems</a:t>
-            </a:r>
-            <a:endParaRPr lang="en-US" sz="730" dirty="0"/>
-          </a:p>
-          <a:p>
-            <a:pPr algn="l" marL="101600" indent="-101600">
-              <a:spcAft>
-                <a:spcPts val="300"/>
-              </a:spcAft>
-              <a:buSzPct val="100000"/>
-              <a:buChar char="•"/>
-            </a:pPr>
-            <a:r>
-              <a:rPr lang="en-US" sz="730" dirty="0">
-                <a:solidFill>
-                  <a:srgbClr val="000000"/>
-                </a:solidFill>
-                <a:latin typeface="Arial" pitchFamily="34" charset="0"/>
-                <a:ea typeface="Arial" pitchFamily="34" charset="-122"/>
-                <a:cs typeface="Arial" pitchFamily="34" charset="-120"/>
-              </a:rPr>
-              <a:t>ELDA Resilience</a:t>
-            </a:r>
-            <a:endParaRPr lang="en-US" sz="730" dirty="0"/>
-          </a:p>
-          <a:p>
-            <a:pPr algn="l" marL="101600" indent="-101600">
-              <a:spcAft>
-                <a:spcPts val="300"/>
-              </a:spcAft>
-              <a:buSzPct val="100000"/>
-              <a:buChar char="•"/>
-            </a:pPr>
-            <a:r>
-              <a:rPr lang="en-US" sz="730" dirty="0">
-                <a:solidFill>
-                  <a:srgbClr val="000000"/>
-                </a:solidFill>
-                <a:latin typeface="Arial" pitchFamily="34" charset="0"/>
-                <a:ea typeface="Arial" pitchFamily="34" charset="-122"/>
-                <a:cs typeface="Arial" pitchFamily="34" charset="-120"/>
-              </a:rPr>
-              <a:t>Performance Under Pressure (Lead Self)</a:t>
-            </a:r>
-            <a:endParaRPr lang="en-US" sz="730" dirty="0"/>
-          </a:p>
-          <a:p>
-            <a:pPr algn="l" marL="101600" indent="-101600">
-              <a:spcAft>
-                <a:spcPts val="300"/>
-              </a:spcAft>
-              <a:buSzPct val="100000"/>
-              <a:buChar char="•"/>
-            </a:pPr>
-            <a:r>
-              <a:rPr lang="en-US" sz="730" dirty="0">
-                <a:solidFill>
-                  <a:srgbClr val="000000"/>
-                </a:solidFill>
-                <a:latin typeface="Arial" pitchFamily="34" charset="0"/>
-                <a:ea typeface="Arial" pitchFamily="34" charset="-122"/>
-                <a:cs typeface="Arial" pitchFamily="34" charset="-120"/>
-              </a:rPr>
               <a:t>Performance Under Pressure (Lead Teams)</a:t>
             </a:r>
-            <a:endParaRPr lang="en-US" sz="730" dirty="0"/>
-          </a:p>
-        </p:txBody>
-      </p:sp>
-      <p:sp>
-        <p:nvSpPr>
-          <p:cNvPr id="44" name="Shape 34"/>
-          <p:cNvSpPr/>
-          <p:nvPr/>
-        </p:nvSpPr>
-        <p:spPr>
-          <a:xfrm>
-            <a:off x="2819400" y="7315200"/>
-            <a:ext cx="1923288" cy="0"/>
+            <a:endParaRPr lang="en-US" sz="850" dirty="0"/>
+          </a:p>
+        </p:txBody>
+      </p:sp>
+      <p:sp>
+        <p:nvSpPr>
+          <p:cNvPr id="18" name="Shape 12"/>
+          <p:cNvSpPr/>
+          <p:nvPr/>
+        </p:nvSpPr>
+        <p:spPr>
+          <a:xfrm>
+            <a:off x="4018788" y="3694176"/>
+            <a:ext cx="2939796" cy="0"/>
           </a:xfrm>
           <a:prstGeom prst="line">
             <a:avLst/>
@@ -2387,22 +3577,22 @@
       </p:sp>
       <p:pic>
         <p:nvPicPr>
-          <p:cNvPr id="45" name="Image 8" descr="preencoded.png">    </p:cNvPr>
+          <p:cNvPr id="19" name="Image 4" descr="preencoded.png">    </p:cNvPr>
           <p:cNvPicPr>
             <a:picLocks noChangeAspect="1"/>
           </p:cNvPicPr>
           <p:nvPr/>
         </p:nvPicPr>
         <p:blipFill>
-          <a:blip r:embed="rId9"/>
+          <a:blip r:embed="rId5"/>
           <a:stretch>
             <a:fillRect/>
           </a:stretch>
         </p:blipFill>
         <p:spPr>
           <a:xfrm>
-            <a:off x="2819400" y="7434072"/>
-            <a:ext cx="219456" cy="219456"/>
+            <a:off x="4018788" y="3886200"/>
+            <a:ext cx="256032" cy="256032"/>
           </a:xfrm>
           <a:prstGeom prst="rect">
             <a:avLst/>
@@ -2411,14 +3601,14 @@
       </p:pic>
       <p:sp>
         <p:nvSpPr>
-          <p:cNvPr id="46" name="Text 35"/>
-          <p:cNvSpPr/>
-          <p:nvPr/>
-        </p:nvSpPr>
-        <p:spPr>
-          <a:xfrm>
-            <a:off x="3112008" y="7424928"/>
-            <a:ext cx="1630680" cy="237744"/>
+          <p:cNvPr id="20" name="Text 13"/>
+          <p:cNvSpPr/>
+          <p:nvPr/>
+        </p:nvSpPr>
+        <p:spPr>
+          <a:xfrm>
+            <a:off x="4366260" y="3877056"/>
+            <a:ext cx="2592324" cy="274320"/>
           </a:xfrm>
           <a:prstGeom prst="rect">
             <a:avLst/>
@@ -2434,7 +3624,7 @@
               <a:buNone/>
             </a:pPr>
             <a:r>
-              <a:rPr lang="en-US" sz="830" b="1" dirty="0">
+              <a:rPr lang="en-US" sz="950" b="1" dirty="0">
                 <a:solidFill>
                   <a:srgbClr val="002516"/>
                 </a:solidFill>
@@ -2444,20 +3634,20 @@
               </a:rPr>
               <a:t>HUMAN PERFORMANCE CELL</a:t>
             </a:r>
-            <a:endParaRPr lang="en-US" sz="830" dirty="0"/>
-          </a:p>
-        </p:txBody>
-      </p:sp>
-      <p:sp>
-        <p:nvSpPr>
-          <p:cNvPr id="47" name="Text 36"/>
-          <p:cNvSpPr/>
-          <p:nvPr/>
-        </p:nvSpPr>
-        <p:spPr>
-          <a:xfrm>
-            <a:off x="3112008" y="7671816"/>
-            <a:ext cx="1630680" cy="1188720"/>
+            <a:endParaRPr lang="en-US" sz="950" dirty="0"/>
+          </a:p>
+        </p:txBody>
+      </p:sp>
+      <p:sp>
+        <p:nvSpPr>
+          <p:cNvPr id="21" name="Text 14"/>
+          <p:cNvSpPr/>
+          <p:nvPr/>
+        </p:nvSpPr>
+        <p:spPr>
+          <a:xfrm>
+            <a:off x="4366260" y="4187952"/>
+            <a:ext cx="2592324" cy="1463040"/>
           </a:xfrm>
           <a:prstGeom prst="rect">
             <a:avLst/>
@@ -2469,15 +3659,15 @@
           <a:bodyPr wrap="square" lIns="0" tIns="0" rIns="0" bIns="0" rtlCol="0" anchor="t"/>
           <a:lstStyle/>
           <a:p>
-            <a:pPr algn="l" marL="101600" indent="-101600">
+            <a:pPr algn="l" marL="127000" indent="-127000">
               <a:spcAft>
-                <a:spcPts val="300"/>
+                <a:spcPts val="500"/>
               </a:spcAft>
               <a:buSzPct val="100000"/>
               <a:buChar char="•"/>
             </a:pPr>
             <a:r>
-              <a:rPr lang="en-US" sz="730" dirty="0">
+              <a:rPr lang="en-US" sz="850" dirty="0">
                 <a:solidFill>
                   <a:srgbClr val="000000"/>
                 </a:solidFill>
@@ -2487,18 +3677,18 @@
               </a:rPr>
               <a:t>COGCON</a:t>
             </a:r>
-            <a:endParaRPr lang="en-US" sz="730" dirty="0"/>
-          </a:p>
-          <a:p>
-            <a:pPr algn="l" marL="101600" indent="-101600">
+            <a:endParaRPr lang="en-US" sz="850" dirty="0"/>
+          </a:p>
+          <a:p>
+            <a:pPr algn="l" marL="127000" indent="-127000">
               <a:spcAft>
-                <a:spcPts val="300"/>
+                <a:spcPts val="500"/>
               </a:spcAft>
               <a:buSzPct val="100000"/>
               <a:buChar char="•"/>
             </a:pPr>
             <a:r>
-              <a:rPr lang="en-US" sz="730" dirty="0">
+              <a:rPr lang="en-US" sz="850" dirty="0">
                 <a:solidFill>
                   <a:srgbClr val="000000"/>
                 </a:solidFill>
@@ -2508,20 +3698,20 @@
               </a:rPr>
               <a:t>Performance conditioning</a:t>
             </a:r>
-            <a:endParaRPr lang="en-US" sz="730" dirty="0"/>
-          </a:p>
-        </p:txBody>
-      </p:sp>
-      <p:sp>
-        <p:nvSpPr>
-          <p:cNvPr id="48" name="Shape 37"/>
-          <p:cNvSpPr/>
-          <p:nvPr/>
-        </p:nvSpPr>
-        <p:spPr>
-          <a:xfrm>
-            <a:off x="2819400" y="8138160"/>
-            <a:ext cx="1923288" cy="0"/>
+            <a:endParaRPr lang="en-US" sz="850" dirty="0"/>
+          </a:p>
+        </p:txBody>
+      </p:sp>
+      <p:sp>
+        <p:nvSpPr>
+          <p:cNvPr id="22" name="Shape 15"/>
+          <p:cNvSpPr/>
+          <p:nvPr/>
+        </p:nvSpPr>
+        <p:spPr>
+          <a:xfrm>
+            <a:off x="4018788" y="4974336"/>
+            <a:ext cx="2939796" cy="0"/>
           </a:xfrm>
           <a:prstGeom prst="line">
             <a:avLst/>
@@ -2537,22 +3727,22 @@
       </p:sp>
       <p:pic>
         <p:nvPicPr>
-          <p:cNvPr id="49" name="Image 9" descr="preencoded.png">    </p:cNvPr>
+          <p:cNvPr id="23" name="Image 5" descr="preencoded.png">    </p:cNvPr>
           <p:cNvPicPr>
             <a:picLocks noChangeAspect="1"/>
           </p:cNvPicPr>
           <p:nvPr/>
         </p:nvPicPr>
         <p:blipFill>
-          <a:blip r:embed="rId10"/>
+          <a:blip r:embed="rId6"/>
           <a:stretch>
             <a:fillRect/>
           </a:stretch>
         </p:blipFill>
         <p:spPr>
           <a:xfrm>
-            <a:off x="2819400" y="8257032"/>
-            <a:ext cx="219456" cy="219456"/>
+            <a:off x="4018788" y="5166360"/>
+            <a:ext cx="256032" cy="256032"/>
           </a:xfrm>
           <a:prstGeom prst="rect">
             <a:avLst/>
@@ -2561,14 +3751,14 @@
       </p:pic>
       <p:sp>
         <p:nvSpPr>
-          <p:cNvPr id="50" name="Text 38"/>
-          <p:cNvSpPr/>
-          <p:nvPr/>
-        </p:nvSpPr>
-        <p:spPr>
-          <a:xfrm>
-            <a:off x="3112008" y="8229600"/>
-            <a:ext cx="1630680" cy="310896"/>
+          <p:cNvPr id="24" name="Text 16"/>
+          <p:cNvSpPr/>
+          <p:nvPr/>
+        </p:nvSpPr>
+        <p:spPr>
+          <a:xfrm>
+            <a:off x="4366260" y="5157216"/>
+            <a:ext cx="2592324" cy="274320"/>
           </a:xfrm>
           <a:prstGeom prst="rect">
             <a:avLst/>
@@ -2584,7 +3774,7 @@
               <a:buNone/>
             </a:pPr>
             <a:r>
-              <a:rPr lang="en-US" sz="830" b="1" dirty="0">
+              <a:rPr lang="en-US" sz="950" b="1" dirty="0">
                 <a:solidFill>
                   <a:srgbClr val="002516"/>
                 </a:solidFill>
@@ -2594,20 +3784,20 @@
               </a:rPr>
               <a:t>UNITS AND TRAINING ESTABLISHMENTS</a:t>
             </a:r>
-            <a:endParaRPr lang="en-US" sz="830" dirty="0"/>
-          </a:p>
-        </p:txBody>
-      </p:sp>
-      <p:sp>
-        <p:nvSpPr>
-          <p:cNvPr id="51" name="Text 39"/>
-          <p:cNvSpPr/>
-          <p:nvPr/>
-        </p:nvSpPr>
-        <p:spPr>
-          <a:xfrm>
-            <a:off x="3112008" y="8558784"/>
-            <a:ext cx="1630680" cy="685800"/>
+            <a:endParaRPr lang="en-US" sz="950" dirty="0"/>
+          </a:p>
+        </p:txBody>
+      </p:sp>
+      <p:sp>
+        <p:nvSpPr>
+          <p:cNvPr id="25" name="Text 17"/>
+          <p:cNvSpPr/>
+          <p:nvPr/>
+        </p:nvSpPr>
+        <p:spPr>
+          <a:xfrm>
+            <a:off x="4366260" y="5468112"/>
+            <a:ext cx="2592324" cy="1463040"/>
           </a:xfrm>
           <a:prstGeom prst="rect">
             <a:avLst/>
@@ -2619,15 +3809,15 @@
           <a:bodyPr wrap="square" lIns="0" tIns="0" rIns="0" bIns="0" rtlCol="0" anchor="t"/>
           <a:lstStyle/>
           <a:p>
-            <a:pPr algn="l" marL="101600" indent="-101600">
+            <a:pPr algn="l" marL="127000" indent="-127000">
               <a:spcAft>
-                <a:spcPts val="300"/>
+                <a:spcPts val="500"/>
               </a:spcAft>
               <a:buSzPct val="100000"/>
               <a:buChar char="•"/>
             </a:pPr>
             <a:r>
-              <a:rPr lang="en-US" sz="730" dirty="0">
+              <a:rPr lang="en-US" sz="850" dirty="0">
                 <a:solidFill>
                   <a:srgbClr val="000000"/>
                 </a:solidFill>
@@ -2637,18 +3827,18 @@
               </a:rPr>
               <a:t>Training</a:t>
             </a:r>
-            <a:endParaRPr lang="en-US" sz="730" dirty="0"/>
-          </a:p>
-          <a:p>
-            <a:pPr algn="l" marL="101600" indent="-101600">
+            <a:endParaRPr lang="en-US" sz="850" dirty="0"/>
+          </a:p>
+          <a:p>
+            <a:pPr algn="l" marL="127000" indent="-127000">
               <a:spcAft>
-                <a:spcPts val="300"/>
+                <a:spcPts val="500"/>
               </a:spcAft>
               <a:buSzPct val="100000"/>
               <a:buChar char="•"/>
             </a:pPr>
             <a:r>
-              <a:rPr lang="en-US" sz="730" dirty="0">
+              <a:rPr lang="en-US" sz="850" dirty="0">
                 <a:solidFill>
                   <a:srgbClr val="000000"/>
                 </a:solidFill>
@@ -2658,18 +3848,18 @@
               </a:rPr>
               <a:t>Exercises</a:t>
             </a:r>
-            <a:endParaRPr lang="en-US" sz="730" dirty="0"/>
-          </a:p>
-          <a:p>
-            <a:pPr algn="l" marL="101600" indent="-101600">
+            <a:endParaRPr lang="en-US" sz="850" dirty="0"/>
+          </a:p>
+          <a:p>
+            <a:pPr algn="l" marL="127000" indent="-127000">
               <a:spcAft>
-                <a:spcPts val="300"/>
+                <a:spcPts val="500"/>
               </a:spcAft>
               <a:buSzPct val="100000"/>
               <a:buChar char="•"/>
             </a:pPr>
             <a:r>
-              <a:rPr lang="en-US" sz="730" dirty="0">
+              <a:rPr lang="en-US" sz="850" dirty="0">
                 <a:solidFill>
                   <a:srgbClr val="000000"/>
                 </a:solidFill>
@@ -2679,18 +3869,18 @@
               </a:rPr>
               <a:t>Mission rehearsal</a:t>
             </a:r>
-            <a:endParaRPr lang="en-US" sz="730" dirty="0"/>
-          </a:p>
-          <a:p>
-            <a:pPr algn="l" marL="101600" indent="-101600">
+            <a:endParaRPr lang="en-US" sz="850" dirty="0"/>
+          </a:p>
+          <a:p>
+            <a:pPr algn="l" marL="127000" indent="-127000">
               <a:spcAft>
-                <a:spcPts val="300"/>
+                <a:spcPts val="500"/>
               </a:spcAft>
               <a:buSzPct val="100000"/>
               <a:buChar char="•"/>
             </a:pPr>
             <a:r>
-              <a:rPr lang="en-US" sz="730" dirty="0">
+              <a:rPr lang="en-US" sz="850" dirty="0">
                 <a:solidFill>
                   <a:srgbClr val="000000"/>
                 </a:solidFill>
@@ -2700,20 +3890,20 @@
               </a:rPr>
               <a:t>Field activity</a:t>
             </a:r>
-            <a:endParaRPr lang="en-US" sz="730" dirty="0"/>
-          </a:p>
-        </p:txBody>
-      </p:sp>
-      <p:sp>
-        <p:nvSpPr>
-          <p:cNvPr id="52" name="Shape 40"/>
-          <p:cNvSpPr/>
-          <p:nvPr/>
-        </p:nvSpPr>
-        <p:spPr>
-          <a:xfrm>
-            <a:off x="2819400" y="9381744"/>
-            <a:ext cx="1923288" cy="658368"/>
+            <a:endParaRPr lang="en-US" sz="850" dirty="0"/>
+          </a:p>
+        </p:txBody>
+      </p:sp>
+      <p:sp>
+        <p:nvSpPr>
+          <p:cNvPr id="26" name="Shape 18"/>
+          <p:cNvSpPr/>
+          <p:nvPr/>
+        </p:nvSpPr>
+        <p:spPr>
+          <a:xfrm>
+            <a:off x="4018788" y="6803136"/>
+            <a:ext cx="2939796" cy="822960"/>
           </a:xfrm>
           <a:prstGeom prst="rect">
             <a:avLst/>
@@ -2731,22 +3921,22 @@
       </p:sp>
       <p:pic>
         <p:nvPicPr>
-          <p:cNvPr id="53" name="Image 10" descr="preencoded.png">    </p:cNvPr>
+          <p:cNvPr id="27" name="Image 6" descr="preencoded.png">    </p:cNvPr>
           <p:cNvPicPr>
             <a:picLocks noChangeAspect="1"/>
           </p:cNvPicPr>
           <p:nvPr/>
         </p:nvPicPr>
         <p:blipFill>
-          <a:blip r:embed="rId11"/>
+          <a:blip r:embed="rId7"/>
           <a:stretch>
             <a:fillRect/>
           </a:stretch>
         </p:blipFill>
         <p:spPr>
           <a:xfrm>
-            <a:off x="2892552" y="9601200"/>
-            <a:ext cx="219456" cy="219456"/>
+            <a:off x="4128516" y="7077456"/>
+            <a:ext cx="274320" cy="274320"/>
           </a:xfrm>
           <a:prstGeom prst="rect">
             <a:avLst/>
@@ -2755,14 +3945,14 @@
       </p:pic>
       <p:sp>
         <p:nvSpPr>
-          <p:cNvPr id="54" name="Text 41"/>
-          <p:cNvSpPr/>
-          <p:nvPr/>
-        </p:nvSpPr>
-        <p:spPr>
-          <a:xfrm>
-            <a:off x="3166872" y="9418320"/>
-            <a:ext cx="1484376" cy="585216"/>
+          <p:cNvPr id="28" name="Text 19"/>
+          <p:cNvSpPr/>
+          <p:nvPr/>
+        </p:nvSpPr>
+        <p:spPr>
+          <a:xfrm>
+            <a:off x="4494276" y="6858000"/>
+            <a:ext cx="2372868" cy="713232"/>
           </a:xfrm>
           <a:prstGeom prst="rect">
             <a:avLst/>
@@ -2778,7 +3968,7 @@
               <a:buNone/>
             </a:pPr>
             <a:r>
-              <a:rPr lang="en-US" sz="720" i="1" dirty="0">
+              <a:rPr lang="en-US" sz="850" i="1" dirty="0">
                 <a:solidFill>
                   <a:srgbClr val="000000"/>
                 </a:solidFill>
@@ -2788,740 +3978,7 @@
               </a:rPr>
               <a:t>Units contextualise and express Combat Mindset under realistic warfighting conditions.</a:t>
             </a:r>
-            <a:endParaRPr lang="en-US" sz="720" dirty="0"/>
-          </a:p>
-        </p:txBody>
-      </p:sp>
-      <p:sp>
-        <p:nvSpPr>
-          <p:cNvPr id="55" name="Shape 42"/>
-          <p:cNvSpPr/>
-          <p:nvPr/>
-        </p:nvSpPr>
-        <p:spPr>
-          <a:xfrm>
-            <a:off x="5227320" y="6044184"/>
-            <a:ext cx="0" cy="3364992"/>
-          </a:xfrm>
-          <a:prstGeom prst="line">
-            <a:avLst/>
-          </a:prstGeom>
-          <a:noFill/>
-          <a:ln w="15875">
-            <a:solidFill>
-              <a:srgbClr val="002516"/>
-            </a:solidFill>
-            <a:prstDash val="solid"/>
-          </a:ln>
-        </p:spPr>
-      </p:sp>
-      <p:sp>
-        <p:nvSpPr>
-          <p:cNvPr id="56" name="Shape 43"/>
-          <p:cNvSpPr/>
-          <p:nvPr/>
-        </p:nvSpPr>
-        <p:spPr>
-          <a:xfrm>
-            <a:off x="5090160" y="5907024"/>
-            <a:ext cx="274320" cy="274320"/>
-          </a:xfrm>
-          <a:prstGeom prst="ellipse">
-            <a:avLst/>
-          </a:prstGeom>
-          <a:solidFill>
-            <a:srgbClr val="002516"/>
-          </a:solidFill>
-          <a:ln w="12700">
-            <a:solidFill>
-              <a:srgbClr val="FFFFFF"/>
-            </a:solidFill>
-            <a:prstDash val="solid"/>
-          </a:ln>
-        </p:spPr>
-      </p:sp>
-      <p:sp>
-        <p:nvSpPr>
-          <p:cNvPr id="57" name="Text 44"/>
-          <p:cNvSpPr/>
-          <p:nvPr/>
-        </p:nvSpPr>
-        <p:spPr>
-          <a:xfrm>
-            <a:off x="5090160" y="5907024"/>
-            <a:ext cx="274320" cy="274320"/>
-          </a:xfrm>
-          <a:prstGeom prst="rect">
-            <a:avLst/>
-          </a:prstGeom>
-          <a:noFill/>
-          <a:ln/>
-        </p:spPr>
-        <p:txBody>
-          <a:bodyPr wrap="square" lIns="0" tIns="0" rIns="0" bIns="0" rtlCol="0" anchor="ctr"/>
-          <a:lstStyle/>
-          <a:p>
-            <a:pPr algn="ctr" indent="0" marL="0">
-              <a:buNone/>
-            </a:pPr>
-            <a:r>
-              <a:rPr lang="en-US" sz="1000" b="1" dirty="0">
-                <a:solidFill>
-                  <a:srgbClr val="FFFFFF"/>
-                </a:solidFill>
-                <a:latin typeface="Arial" pitchFamily="34" charset="0"/>
-                <a:ea typeface="Arial" pitchFamily="34" charset="-122"/>
-                <a:cs typeface="Arial" pitchFamily="34" charset="-120"/>
-              </a:rPr>
-              <a:t>0</a:t>
-            </a:r>
-            <a:endParaRPr lang="en-US" sz="1000" dirty="0"/>
-          </a:p>
-        </p:txBody>
-      </p:sp>
-      <p:sp>
-        <p:nvSpPr>
-          <p:cNvPr id="58" name="Text 45"/>
-          <p:cNvSpPr/>
-          <p:nvPr/>
-        </p:nvSpPr>
-        <p:spPr>
-          <a:xfrm>
-            <a:off x="5455920" y="5888736"/>
-            <a:ext cx="1539240" cy="310896"/>
-          </a:xfrm>
-          <a:prstGeom prst="rect">
-            <a:avLst/>
-          </a:prstGeom>
-          <a:noFill/>
-          <a:ln/>
-        </p:spPr>
-        <p:txBody>
-          <a:bodyPr wrap="square" lIns="0" tIns="0" rIns="0" bIns="0" rtlCol="0" anchor="t"/>
-          <a:lstStyle/>
-          <a:p>
-            <a:pPr algn="l" indent="0" marL="0">
-              <a:buNone/>
-            </a:pPr>
-            <a:r>
-              <a:rPr lang="en-US" sz="820" b="1" dirty="0">
-                <a:solidFill>
-                  <a:srgbClr val="002516"/>
-                </a:solidFill>
-                <a:latin typeface="Arial" pitchFamily="34" charset="0"/>
-                <a:ea typeface="Arial" pitchFamily="34" charset="-122"/>
-                <a:cs typeface="Arial" pitchFamily="34" charset="-120"/>
-              </a:rPr>
-              <a:t>Phase 0: Define and govern</a:t>
-            </a:r>
-            <a:endParaRPr lang="en-US" sz="820" dirty="0"/>
-          </a:p>
-        </p:txBody>
-      </p:sp>
-      <p:sp>
-        <p:nvSpPr>
-          <p:cNvPr id="59" name="Text 46"/>
-          <p:cNvSpPr/>
-          <p:nvPr/>
-        </p:nvSpPr>
-        <p:spPr>
-          <a:xfrm>
-            <a:off x="5455920" y="6181344"/>
-            <a:ext cx="1539240" cy="512064"/>
-          </a:xfrm>
-          <a:prstGeom prst="rect">
-            <a:avLst/>
-          </a:prstGeom>
-          <a:noFill/>
-          <a:ln/>
-        </p:spPr>
-        <p:txBody>
-          <a:bodyPr wrap="square" lIns="0" tIns="0" rIns="0" bIns="0" rtlCol="0" anchor="t"/>
-          <a:lstStyle/>
-          <a:p>
-            <a:pPr algn="l" indent="0" marL="0">
-              <a:buNone/>
-            </a:pPr>
-            <a:r>
-              <a:rPr lang="en-US" sz="720" dirty="0">
-                <a:solidFill>
-                  <a:srgbClr val="000000"/>
-                </a:solidFill>
-                <a:latin typeface="Arial" pitchFamily="34" charset="0"/>
-                <a:ea typeface="Arial" pitchFamily="34" charset="-122"/>
-                <a:cs typeface="Arial" pitchFamily="34" charset="-120"/>
-              </a:rPr>
-              <a:t>Confirm terminology, sponsorship, ownership and interim governance.</a:t>
-            </a:r>
-            <a:endParaRPr lang="en-US" sz="720" dirty="0"/>
-          </a:p>
-        </p:txBody>
-      </p:sp>
-      <p:sp>
-        <p:nvSpPr>
-          <p:cNvPr id="60" name="Shape 47"/>
-          <p:cNvSpPr/>
-          <p:nvPr/>
-        </p:nvSpPr>
-        <p:spPr>
-          <a:xfrm>
-            <a:off x="5090160" y="6748272"/>
-            <a:ext cx="274320" cy="274320"/>
-          </a:xfrm>
-          <a:prstGeom prst="ellipse">
-            <a:avLst/>
-          </a:prstGeom>
-          <a:solidFill>
-            <a:srgbClr val="002516"/>
-          </a:solidFill>
-          <a:ln w="12700">
-            <a:solidFill>
-              <a:srgbClr val="FFFFFF"/>
-            </a:solidFill>
-            <a:prstDash val="solid"/>
-          </a:ln>
-        </p:spPr>
-      </p:sp>
-      <p:sp>
-        <p:nvSpPr>
-          <p:cNvPr id="61" name="Text 48"/>
-          <p:cNvSpPr/>
-          <p:nvPr/>
-        </p:nvSpPr>
-        <p:spPr>
-          <a:xfrm>
-            <a:off x="5090160" y="6748272"/>
-            <a:ext cx="274320" cy="274320"/>
-          </a:xfrm>
-          <a:prstGeom prst="rect">
-            <a:avLst/>
-          </a:prstGeom>
-          <a:noFill/>
-          <a:ln/>
-        </p:spPr>
-        <p:txBody>
-          <a:bodyPr wrap="square" lIns="0" tIns="0" rIns="0" bIns="0" rtlCol="0" anchor="ctr"/>
-          <a:lstStyle/>
-          <a:p>
-            <a:pPr algn="ctr" indent="0" marL="0">
-              <a:buNone/>
-            </a:pPr>
-            <a:r>
-              <a:rPr lang="en-US" sz="1000" b="1" dirty="0">
-                <a:solidFill>
-                  <a:srgbClr val="FFFFFF"/>
-                </a:solidFill>
-                <a:latin typeface="Arial" pitchFamily="34" charset="0"/>
-                <a:ea typeface="Arial" pitchFamily="34" charset="-122"/>
-                <a:cs typeface="Arial" pitchFamily="34" charset="-120"/>
-              </a:rPr>
-              <a:t>1</a:t>
-            </a:r>
-            <a:endParaRPr lang="en-US" sz="1000" dirty="0"/>
-          </a:p>
-        </p:txBody>
-      </p:sp>
-      <p:sp>
-        <p:nvSpPr>
-          <p:cNvPr id="62" name="Text 49"/>
-          <p:cNvSpPr/>
-          <p:nvPr/>
-        </p:nvSpPr>
-        <p:spPr>
-          <a:xfrm>
-            <a:off x="5455920" y="6729984"/>
-            <a:ext cx="1539240" cy="310896"/>
-          </a:xfrm>
-          <a:prstGeom prst="rect">
-            <a:avLst/>
-          </a:prstGeom>
-          <a:noFill/>
-          <a:ln/>
-        </p:spPr>
-        <p:txBody>
-          <a:bodyPr wrap="square" lIns="0" tIns="0" rIns="0" bIns="0" rtlCol="0" anchor="t"/>
-          <a:lstStyle/>
-          <a:p>
-            <a:pPr algn="l" indent="0" marL="0">
-              <a:buNone/>
-            </a:pPr>
-            <a:r>
-              <a:rPr lang="en-US" sz="820" b="1" dirty="0">
-                <a:solidFill>
-                  <a:srgbClr val="002516"/>
-                </a:solidFill>
-                <a:latin typeface="Arial" pitchFamily="34" charset="0"/>
-                <a:ea typeface="Arial" pitchFamily="34" charset="-122"/>
-                <a:cs typeface="Arial" pitchFamily="34" charset="-120"/>
-              </a:rPr>
-              <a:t>Phase 1: Understand</a:t>
-            </a:r>
-            <a:endParaRPr lang="en-US" sz="820" dirty="0"/>
-          </a:p>
-        </p:txBody>
-      </p:sp>
-      <p:sp>
-        <p:nvSpPr>
-          <p:cNvPr id="63" name="Text 50"/>
-          <p:cNvSpPr/>
-          <p:nvPr/>
-        </p:nvSpPr>
-        <p:spPr>
-          <a:xfrm>
-            <a:off x="5455920" y="7022592"/>
-            <a:ext cx="1539240" cy="512064"/>
-          </a:xfrm>
-          <a:prstGeom prst="rect">
-            <a:avLst/>
-          </a:prstGeom>
-          <a:noFill/>
-          <a:ln/>
-        </p:spPr>
-        <p:txBody>
-          <a:bodyPr wrap="square" lIns="0" tIns="0" rIns="0" bIns="0" rtlCol="0" anchor="t"/>
-          <a:lstStyle/>
-          <a:p>
-            <a:pPr algn="l" indent="0" marL="0">
-              <a:buNone/>
-            </a:pPr>
-            <a:r>
-              <a:rPr lang="en-US" sz="720" dirty="0">
-                <a:solidFill>
-                  <a:srgbClr val="000000"/>
-                </a:solidFill>
-                <a:latin typeface="Arial" pitchFamily="34" charset="0"/>
-                <a:ea typeface="Arial" pitchFamily="34" charset="-122"/>
-                <a:cs typeface="Arial" pitchFamily="34" charset="-120"/>
-              </a:rPr>
-              <a:t>Stocktake existing doctrine, products, delivery, evidence, ownership and assurance.</a:t>
-            </a:r>
-            <a:endParaRPr lang="en-US" sz="720" dirty="0"/>
-          </a:p>
-        </p:txBody>
-      </p:sp>
-      <p:sp>
-        <p:nvSpPr>
-          <p:cNvPr id="64" name="Shape 51"/>
-          <p:cNvSpPr/>
-          <p:nvPr/>
-        </p:nvSpPr>
-        <p:spPr>
-          <a:xfrm>
-            <a:off x="5090160" y="7589520"/>
-            <a:ext cx="274320" cy="274320"/>
-          </a:xfrm>
-          <a:prstGeom prst="ellipse">
-            <a:avLst/>
-          </a:prstGeom>
-          <a:solidFill>
-            <a:srgbClr val="002516"/>
-          </a:solidFill>
-          <a:ln w="12700">
-            <a:solidFill>
-              <a:srgbClr val="FFFFFF"/>
-            </a:solidFill>
-            <a:prstDash val="solid"/>
-          </a:ln>
-        </p:spPr>
-      </p:sp>
-      <p:sp>
-        <p:nvSpPr>
-          <p:cNvPr id="65" name="Text 52"/>
-          <p:cNvSpPr/>
-          <p:nvPr/>
-        </p:nvSpPr>
-        <p:spPr>
-          <a:xfrm>
-            <a:off x="5090160" y="7589520"/>
-            <a:ext cx="274320" cy="274320"/>
-          </a:xfrm>
-          <a:prstGeom prst="rect">
-            <a:avLst/>
-          </a:prstGeom>
-          <a:noFill/>
-          <a:ln/>
-        </p:spPr>
-        <p:txBody>
-          <a:bodyPr wrap="square" lIns="0" tIns="0" rIns="0" bIns="0" rtlCol="0" anchor="ctr"/>
-          <a:lstStyle/>
-          <a:p>
-            <a:pPr algn="ctr" indent="0" marL="0">
-              <a:buNone/>
-            </a:pPr>
-            <a:r>
-              <a:rPr lang="en-US" sz="1000" b="1" dirty="0">
-                <a:solidFill>
-                  <a:srgbClr val="FFFFFF"/>
-                </a:solidFill>
-                <a:latin typeface="Arial" pitchFamily="34" charset="0"/>
-                <a:ea typeface="Arial" pitchFamily="34" charset="-122"/>
-                <a:cs typeface="Arial" pitchFamily="34" charset="-120"/>
-              </a:rPr>
-              <a:t>2</a:t>
-            </a:r>
-            <a:endParaRPr lang="en-US" sz="1000" dirty="0"/>
-          </a:p>
-        </p:txBody>
-      </p:sp>
-      <p:sp>
-        <p:nvSpPr>
-          <p:cNvPr id="66" name="Text 53"/>
-          <p:cNvSpPr/>
-          <p:nvPr/>
-        </p:nvSpPr>
-        <p:spPr>
-          <a:xfrm>
-            <a:off x="5455920" y="7571232"/>
-            <a:ext cx="1539240" cy="310896"/>
-          </a:xfrm>
-          <a:prstGeom prst="rect">
-            <a:avLst/>
-          </a:prstGeom>
-          <a:noFill/>
-          <a:ln/>
-        </p:spPr>
-        <p:txBody>
-          <a:bodyPr wrap="square" lIns="0" tIns="0" rIns="0" bIns="0" rtlCol="0" anchor="t"/>
-          <a:lstStyle/>
-          <a:p>
-            <a:pPr algn="l" indent="0" marL="0">
-              <a:buNone/>
-            </a:pPr>
-            <a:r>
-              <a:rPr lang="en-US" sz="820" b="1" dirty="0">
-                <a:solidFill>
-                  <a:srgbClr val="002516"/>
-                </a:solidFill>
-                <a:latin typeface="Arial" pitchFamily="34" charset="0"/>
-                <a:ea typeface="Arial" pitchFamily="34" charset="-122"/>
-                <a:cs typeface="Arial" pitchFamily="34" charset="-120"/>
-              </a:rPr>
-              <a:t>Phase 2: Design</a:t>
-            </a:r>
-            <a:endParaRPr lang="en-US" sz="820" dirty="0"/>
-          </a:p>
-        </p:txBody>
-      </p:sp>
-      <p:sp>
-        <p:nvSpPr>
-          <p:cNvPr id="67" name="Text 54"/>
-          <p:cNvSpPr/>
-          <p:nvPr/>
-        </p:nvSpPr>
-        <p:spPr>
-          <a:xfrm>
-            <a:off x="5455920" y="7863840"/>
-            <a:ext cx="1539240" cy="512064"/>
-          </a:xfrm>
-          <a:prstGeom prst="rect">
-            <a:avLst/>
-          </a:prstGeom>
-          <a:noFill/>
-          <a:ln/>
-        </p:spPr>
-        <p:txBody>
-          <a:bodyPr wrap="square" lIns="0" tIns="0" rIns="0" bIns="0" rtlCol="0" anchor="t"/>
-          <a:lstStyle/>
-          <a:p>
-            <a:pPr algn="l" indent="0" marL="0">
-              <a:buNone/>
-            </a:pPr>
-            <a:r>
-              <a:rPr lang="en-US" sz="720" dirty="0">
-                <a:solidFill>
-                  <a:srgbClr val="000000"/>
-                </a:solidFill>
-                <a:latin typeface="Arial" pitchFamily="34" charset="0"/>
-                <a:ea typeface="Arial" pitchFamily="34" charset="-122"/>
-                <a:cs typeface="Arial" pitchFamily="34" charset="-120"/>
-              </a:rPr>
-              <a:t>Develop the framework, delivery architecture, outcomes and product-recognition criteria.</a:t>
-            </a:r>
-            <a:endParaRPr lang="en-US" sz="720" dirty="0"/>
-          </a:p>
-        </p:txBody>
-      </p:sp>
-      <p:sp>
-        <p:nvSpPr>
-          <p:cNvPr id="68" name="Shape 55"/>
-          <p:cNvSpPr/>
-          <p:nvPr/>
-        </p:nvSpPr>
-        <p:spPr>
-          <a:xfrm>
-            <a:off x="5090160" y="8430768"/>
-            <a:ext cx="274320" cy="274320"/>
-          </a:xfrm>
-          <a:prstGeom prst="ellipse">
-            <a:avLst/>
-          </a:prstGeom>
-          <a:solidFill>
-            <a:srgbClr val="002516"/>
-          </a:solidFill>
-          <a:ln w="12700">
-            <a:solidFill>
-              <a:srgbClr val="FFFFFF"/>
-            </a:solidFill>
-            <a:prstDash val="solid"/>
-          </a:ln>
-        </p:spPr>
-      </p:sp>
-      <p:sp>
-        <p:nvSpPr>
-          <p:cNvPr id="69" name="Text 56"/>
-          <p:cNvSpPr/>
-          <p:nvPr/>
-        </p:nvSpPr>
-        <p:spPr>
-          <a:xfrm>
-            <a:off x="5090160" y="8430768"/>
-            <a:ext cx="274320" cy="274320"/>
-          </a:xfrm>
-          <a:prstGeom prst="rect">
-            <a:avLst/>
-          </a:prstGeom>
-          <a:noFill/>
-          <a:ln/>
-        </p:spPr>
-        <p:txBody>
-          <a:bodyPr wrap="square" lIns="0" tIns="0" rIns="0" bIns="0" rtlCol="0" anchor="ctr"/>
-          <a:lstStyle/>
-          <a:p>
-            <a:pPr algn="ctr" indent="0" marL="0">
-              <a:buNone/>
-            </a:pPr>
-            <a:r>
-              <a:rPr lang="en-US" sz="1000" b="1" dirty="0">
-                <a:solidFill>
-                  <a:srgbClr val="FFFFFF"/>
-                </a:solidFill>
-                <a:latin typeface="Arial" pitchFamily="34" charset="0"/>
-                <a:ea typeface="Arial" pitchFamily="34" charset="-122"/>
-                <a:cs typeface="Arial" pitchFamily="34" charset="-120"/>
-              </a:rPr>
-              <a:t>3</a:t>
-            </a:r>
-            <a:endParaRPr lang="en-US" sz="1000" dirty="0"/>
-          </a:p>
-        </p:txBody>
-      </p:sp>
-      <p:sp>
-        <p:nvSpPr>
-          <p:cNvPr id="70" name="Text 57"/>
-          <p:cNvSpPr/>
-          <p:nvPr/>
-        </p:nvSpPr>
-        <p:spPr>
-          <a:xfrm>
-            <a:off x="5455920" y="8412480"/>
-            <a:ext cx="1539240" cy="310896"/>
-          </a:xfrm>
-          <a:prstGeom prst="rect">
-            <a:avLst/>
-          </a:prstGeom>
-          <a:noFill/>
-          <a:ln/>
-        </p:spPr>
-        <p:txBody>
-          <a:bodyPr wrap="square" lIns="0" tIns="0" rIns="0" bIns="0" rtlCol="0" anchor="t"/>
-          <a:lstStyle/>
-          <a:p>
-            <a:pPr algn="l" indent="0" marL="0">
-              <a:buNone/>
-            </a:pPr>
-            <a:r>
-              <a:rPr lang="en-US" sz="820" b="1" dirty="0">
-                <a:solidFill>
-                  <a:srgbClr val="002516"/>
-                </a:solidFill>
-                <a:latin typeface="Arial" pitchFamily="34" charset="0"/>
-                <a:ea typeface="Arial" pitchFamily="34" charset="-122"/>
-                <a:cs typeface="Arial" pitchFamily="34" charset="-120"/>
-              </a:rPr>
-              <a:t>Phase 3: Validate</a:t>
-            </a:r>
-            <a:endParaRPr lang="en-US" sz="820" dirty="0"/>
-          </a:p>
-        </p:txBody>
-      </p:sp>
-      <p:sp>
-        <p:nvSpPr>
-          <p:cNvPr id="71" name="Text 58"/>
-          <p:cNvSpPr/>
-          <p:nvPr/>
-        </p:nvSpPr>
-        <p:spPr>
-          <a:xfrm>
-            <a:off x="5455920" y="8705088"/>
-            <a:ext cx="1539240" cy="512064"/>
-          </a:xfrm>
-          <a:prstGeom prst="rect">
-            <a:avLst/>
-          </a:prstGeom>
-          <a:noFill/>
-          <a:ln/>
-        </p:spPr>
-        <p:txBody>
-          <a:bodyPr wrap="square" lIns="0" tIns="0" rIns="0" bIns="0" rtlCol="0" anchor="t"/>
-          <a:lstStyle/>
-          <a:p>
-            <a:pPr algn="l" indent="0" marL="0">
-              <a:buNone/>
-            </a:pPr>
-            <a:r>
-              <a:rPr lang="en-US" sz="720" dirty="0">
-                <a:solidFill>
-                  <a:srgbClr val="000000"/>
-                </a:solidFill>
-                <a:latin typeface="Arial" pitchFamily="34" charset="0"/>
-                <a:ea typeface="Arial" pitchFamily="34" charset="-122"/>
-                <a:cs typeface="Arial" pitchFamily="34" charset="-120"/>
-              </a:rPr>
-              <a:t>Refine the framework with stakeholders, training establishments and units.</a:t>
-            </a:r>
-            <a:endParaRPr lang="en-US" sz="720" dirty="0"/>
-          </a:p>
-        </p:txBody>
-      </p:sp>
-      <p:sp>
-        <p:nvSpPr>
-          <p:cNvPr id="72" name="Shape 59"/>
-          <p:cNvSpPr/>
-          <p:nvPr/>
-        </p:nvSpPr>
-        <p:spPr>
-          <a:xfrm>
-            <a:off x="5090160" y="9272016"/>
-            <a:ext cx="274320" cy="274320"/>
-          </a:xfrm>
-          <a:prstGeom prst="ellipse">
-            <a:avLst/>
-          </a:prstGeom>
-          <a:solidFill>
-            <a:srgbClr val="002516"/>
-          </a:solidFill>
-          <a:ln w="12700">
-            <a:solidFill>
-              <a:srgbClr val="FFFFFF"/>
-            </a:solidFill>
-            <a:prstDash val="solid"/>
-          </a:ln>
-        </p:spPr>
-      </p:sp>
-      <p:sp>
-        <p:nvSpPr>
-          <p:cNvPr id="73" name="Text 60"/>
-          <p:cNvSpPr/>
-          <p:nvPr/>
-        </p:nvSpPr>
-        <p:spPr>
-          <a:xfrm>
-            <a:off x="5090160" y="9272016"/>
-            <a:ext cx="274320" cy="274320"/>
-          </a:xfrm>
-          <a:prstGeom prst="rect">
-            <a:avLst/>
-          </a:prstGeom>
-          <a:noFill/>
-          <a:ln/>
-        </p:spPr>
-        <p:txBody>
-          <a:bodyPr wrap="square" lIns="0" tIns="0" rIns="0" bIns="0" rtlCol="0" anchor="ctr"/>
-          <a:lstStyle/>
-          <a:p>
-            <a:pPr algn="ctr" indent="0" marL="0">
-              <a:buNone/>
-            </a:pPr>
-            <a:r>
-              <a:rPr lang="en-US" sz="1000" b="1" dirty="0">
-                <a:solidFill>
-                  <a:srgbClr val="FFFFFF"/>
-                </a:solidFill>
-                <a:latin typeface="Arial" pitchFamily="34" charset="0"/>
-                <a:ea typeface="Arial" pitchFamily="34" charset="-122"/>
-                <a:cs typeface="Arial" pitchFamily="34" charset="-120"/>
-              </a:rPr>
-              <a:t>4</a:t>
-            </a:r>
-            <a:endParaRPr lang="en-US" sz="1000" dirty="0"/>
-          </a:p>
-        </p:txBody>
-      </p:sp>
-      <p:sp>
-        <p:nvSpPr>
-          <p:cNvPr id="74" name="Text 61"/>
-          <p:cNvSpPr/>
-          <p:nvPr/>
-        </p:nvSpPr>
-        <p:spPr>
-          <a:xfrm>
-            <a:off x="5455920" y="9253728"/>
-            <a:ext cx="1539240" cy="310896"/>
-          </a:xfrm>
-          <a:prstGeom prst="rect">
-            <a:avLst/>
-          </a:prstGeom>
-          <a:noFill/>
-          <a:ln/>
-        </p:spPr>
-        <p:txBody>
-          <a:bodyPr wrap="square" lIns="0" tIns="0" rIns="0" bIns="0" rtlCol="0" anchor="t"/>
-          <a:lstStyle/>
-          <a:p>
-            <a:pPr algn="l" indent="0" marL="0">
-              <a:buNone/>
-            </a:pPr>
-            <a:r>
-              <a:rPr lang="en-US" sz="820" b="1" dirty="0">
-                <a:solidFill>
-                  <a:srgbClr val="002516"/>
-                </a:solidFill>
-                <a:latin typeface="Arial" pitchFamily="34" charset="0"/>
-                <a:ea typeface="Arial" pitchFamily="34" charset="-122"/>
-                <a:cs typeface="Arial" pitchFamily="34" charset="-120"/>
-              </a:rPr>
-              <a:t>Phase 4: Endorse and implement</a:t>
-            </a:r>
-            <a:endParaRPr lang="en-US" sz="820" dirty="0"/>
-          </a:p>
-        </p:txBody>
-      </p:sp>
-      <p:sp>
-        <p:nvSpPr>
-          <p:cNvPr id="75" name="Text 62"/>
-          <p:cNvSpPr/>
-          <p:nvPr/>
-        </p:nvSpPr>
-        <p:spPr>
-          <a:xfrm>
-            <a:off x="5455920" y="9546336"/>
-            <a:ext cx="1539240" cy="512064"/>
-          </a:xfrm>
-          <a:prstGeom prst="rect">
-            <a:avLst/>
-          </a:prstGeom>
-          <a:noFill/>
-          <a:ln/>
-        </p:spPr>
-        <p:txBody>
-          <a:bodyPr wrap="square" lIns="0" tIns="0" rIns="0" bIns="0" rtlCol="0" anchor="t"/>
-          <a:lstStyle/>
-          <a:p>
-            <a:pPr algn="l" indent="0" marL="0">
-              <a:buNone/>
-            </a:pPr>
-            <a:r>
-              <a:rPr lang="en-US" sz="720" dirty="0">
-                <a:solidFill>
-                  <a:srgbClr val="000000"/>
-                </a:solidFill>
-                <a:latin typeface="Arial" pitchFamily="34" charset="0"/>
-                <a:ea typeface="Arial" pitchFamily="34" charset="-122"/>
-                <a:cs typeface="Arial" pitchFamily="34" charset="-120"/>
-              </a:rPr>
-              <a:t>Deliver Framework v1.0 and a prioritised implementation plan.</a:t>
-            </a:r>
-            <a:endParaRPr lang="en-US" sz="720" dirty="0"/>
+            <a:endParaRPr lang="en-US" sz="850" dirty="0"/>
           </a:p>
         </p:txBody>
       </p:sp>

</xml_diff>

<commit_message>
Programme phases tightened to single clear outcomes
Define and govern: confirm terminology, governance, roles and
responsibilities. Understand: assess existing doctrine, products,
delivery and governance. Design: develop the Combat Mindset Framework,
delivery architecture and outcomes. Validate: refine with key
stakeholders and conduct bounded pilots. Endorse and implement:
deliver the framework for approval and implementation. Paper embed
regenerated.

Co-Authored-By: Claude Fable 5 <noreply@anthropic.com>
Claude-Session: https://claude.ai/code/session_01YLo1WfwUDkbwfJEF3ZNVbB
</commit_message>
<xml_diff>
--- a/output/combat-mindset-onepager-portrait.pptx
+++ b/output/combat-mindset-onepager-portrait.pptx
@@ -2006,7 +2006,7 @@
                 <a:ea typeface="Arial" pitchFamily="34" charset="-122"/>
                 <a:cs typeface="Arial" pitchFamily="34" charset="-120"/>
               </a:rPr>
-              <a:t>Confirm terminology, sponsorship, ownership and interim governance.</a:t>
+              <a:t>Confirm terminology, governance, roles and responsibilities.</a:t>
             </a:r>
             <a:endParaRPr lang="en-US" sz="850" dirty="0"/>
           </a:p>
@@ -2148,7 +2148,7 @@
                 <a:ea typeface="Arial" pitchFamily="34" charset="-122"/>
                 <a:cs typeface="Arial" pitchFamily="34" charset="-120"/>
               </a:rPr>
-              <a:t>Stocktake existing doctrine, products, delivery, evidence, ownership and assurance.</a:t>
+              <a:t>Assess existing doctrine, products, delivery and governance.</a:t>
             </a:r>
             <a:endParaRPr lang="en-US" sz="850" dirty="0"/>
           </a:p>
@@ -2290,7 +2290,7 @@
                 <a:ea typeface="Arial" pitchFamily="34" charset="-122"/>
                 <a:cs typeface="Arial" pitchFamily="34" charset="-120"/>
               </a:rPr>
-              <a:t>Develop the framework, delivery architecture, outcomes and product-recognition criteria.</a:t>
+              <a:t>Develop the Combat Mindset Framework, delivery architecture and outcomes.</a:t>
             </a:r>
             <a:endParaRPr lang="en-US" sz="850" dirty="0"/>
           </a:p>
@@ -2432,7 +2432,7 @@
                 <a:ea typeface="Arial" pitchFamily="34" charset="-122"/>
                 <a:cs typeface="Arial" pitchFamily="34" charset="-120"/>
               </a:rPr>
-              <a:t>Refine the framework with stakeholders, training establishments and units.</a:t>
+              <a:t>Refine the framework with key stakeholders and conduct bounded pilots.</a:t>
             </a:r>
             <a:endParaRPr lang="en-US" sz="850" dirty="0"/>
           </a:p>
@@ -2574,7 +2574,7 @@
                 <a:ea typeface="Arial" pitchFamily="34" charset="-122"/>
                 <a:cs typeface="Arial" pitchFamily="34" charset="-120"/>
               </a:rPr>
-              <a:t>Deliver Framework v1.0 and a prioritised implementation plan.</a:t>
+              <a:t>Deliver the framework for approval and implementation.</a:t>
             </a:r>
             <a:endParaRPr lang="en-US" sz="850" dirty="0"/>
           </a:p>

</xml_diff>

<commit_message>
Pathway phases: single-word uppercase titles in tabular layout
DEFINE / UNDERSTAND / DESIGN / VALIDATE / IMPLEMENT as a letterspaced
title column beside the numbered line, descriptions in an aligned
right-hand column. Paper embed regenerated.

Co-Authored-By: Claude Fable 5 <noreply@anthropic.com>
Claude-Session: https://claude.ai/code/session_01YLo1WfwUDkbwfJEF3ZNVbB
</commit_message>
<xml_diff>
--- a/output/combat-mindset-onepager-portrait.pptx
+++ b/output/combat-mindset-onepager-portrait.pptx
@@ -1942,8 +1942,8 @@
         </p:nvSpPr>
         <p:spPr>
           <a:xfrm>
-            <a:off x="1389888" y="7059168"/>
-            <a:ext cx="5532120" cy="219456"/>
+            <a:off x="1408176" y="7114032"/>
+            <a:ext cx="1691640" cy="365760"/>
           </a:xfrm>
           <a:prstGeom prst="rect">
             <a:avLst/>
@@ -1959,7 +1959,7 @@
               <a:buNone/>
             </a:pPr>
             <a:r>
-              <a:rPr lang="en-US" sz="1100" b="1" dirty="0">
+              <a:rPr lang="en-US" sz="1150" b="1" spc="150" kern="0" dirty="0">
                 <a:solidFill>
                   <a:srgbClr val="002516"/>
                 </a:solidFill>
@@ -1967,9 +1967,9 @@
                 <a:ea typeface="Arial" pitchFamily="34" charset="-122"/>
                 <a:cs typeface="Arial" pitchFamily="34" charset="-120"/>
               </a:rPr>
-              <a:t>Define and govern</a:t>
-            </a:r>
-            <a:endParaRPr lang="en-US" sz="1100" dirty="0"/>
+              <a:t>DEFINE</a:t>
+            </a:r>
+            <a:endParaRPr lang="en-US" sz="1150" dirty="0"/>
           </a:p>
         </p:txBody>
       </p:sp>
@@ -1981,8 +1981,8 @@
         </p:nvSpPr>
         <p:spPr>
           <a:xfrm>
-            <a:off x="1389888" y="7287768"/>
-            <a:ext cx="5532120" cy="219456"/>
+            <a:off x="3145536" y="7077456"/>
+            <a:ext cx="3776472" cy="438912"/>
           </a:xfrm>
           <a:prstGeom prst="rect">
             <a:avLst/>
@@ -1998,7 +1998,7 @@
               <a:buNone/>
             </a:pPr>
             <a:r>
-              <a:rPr lang="en-US" sz="850" dirty="0">
+              <a:rPr lang="en-US" sz="860" dirty="0">
                 <a:solidFill>
                   <a:srgbClr val="000000"/>
                 </a:solidFill>
@@ -2008,7 +2008,7 @@
               </a:rPr>
               <a:t>Confirm terminology, governance, roles and responsibilities.</a:t>
             </a:r>
-            <a:endParaRPr lang="en-US" sz="850" dirty="0"/>
+            <a:endParaRPr lang="en-US" sz="860" dirty="0"/>
           </a:p>
         </p:txBody>
       </p:sp>
@@ -2084,8 +2084,8 @@
         </p:nvSpPr>
         <p:spPr>
           <a:xfrm>
-            <a:off x="1389888" y="7662672"/>
-            <a:ext cx="5532120" cy="219456"/>
+            <a:off x="1408176" y="7717536"/>
+            <a:ext cx="1691640" cy="365760"/>
           </a:xfrm>
           <a:prstGeom prst="rect">
             <a:avLst/>
@@ -2101,7 +2101,7 @@
               <a:buNone/>
             </a:pPr>
             <a:r>
-              <a:rPr lang="en-US" sz="1100" b="1" dirty="0">
+              <a:rPr lang="en-US" sz="1150" b="1" spc="150" kern="0" dirty="0">
                 <a:solidFill>
                   <a:srgbClr val="002516"/>
                 </a:solidFill>
@@ -2109,9 +2109,9 @@
                 <a:ea typeface="Arial" pitchFamily="34" charset="-122"/>
                 <a:cs typeface="Arial" pitchFamily="34" charset="-120"/>
               </a:rPr>
-              <a:t>Understand</a:t>
-            </a:r>
-            <a:endParaRPr lang="en-US" sz="1100" dirty="0"/>
+              <a:t>UNDERSTAND</a:t>
+            </a:r>
+            <a:endParaRPr lang="en-US" sz="1150" dirty="0"/>
           </a:p>
         </p:txBody>
       </p:sp>
@@ -2123,8 +2123,8 @@
         </p:nvSpPr>
         <p:spPr>
           <a:xfrm>
-            <a:off x="1389888" y="7891272"/>
-            <a:ext cx="5532120" cy="219456"/>
+            <a:off x="3145536" y="7680960"/>
+            <a:ext cx="3776472" cy="438912"/>
           </a:xfrm>
           <a:prstGeom prst="rect">
             <a:avLst/>
@@ -2140,7 +2140,7 @@
               <a:buNone/>
             </a:pPr>
             <a:r>
-              <a:rPr lang="en-US" sz="850" dirty="0">
+              <a:rPr lang="en-US" sz="860" dirty="0">
                 <a:solidFill>
                   <a:srgbClr val="000000"/>
                 </a:solidFill>
@@ -2150,7 +2150,7 @@
               </a:rPr>
               <a:t>Assess existing doctrine, products, delivery and governance.</a:t>
             </a:r>
-            <a:endParaRPr lang="en-US" sz="850" dirty="0"/>
+            <a:endParaRPr lang="en-US" sz="860" dirty="0"/>
           </a:p>
         </p:txBody>
       </p:sp>
@@ -2226,8 +2226,8 @@
         </p:nvSpPr>
         <p:spPr>
           <a:xfrm>
-            <a:off x="1389888" y="8266176"/>
-            <a:ext cx="5532120" cy="219456"/>
+            <a:off x="1408176" y="8321040"/>
+            <a:ext cx="1691640" cy="365760"/>
           </a:xfrm>
           <a:prstGeom prst="rect">
             <a:avLst/>
@@ -2243,7 +2243,7 @@
               <a:buNone/>
             </a:pPr>
             <a:r>
-              <a:rPr lang="en-US" sz="1100" b="1" dirty="0">
+              <a:rPr lang="en-US" sz="1150" b="1" spc="150" kern="0" dirty="0">
                 <a:solidFill>
                   <a:srgbClr val="002516"/>
                 </a:solidFill>
@@ -2251,9 +2251,9 @@
                 <a:ea typeface="Arial" pitchFamily="34" charset="-122"/>
                 <a:cs typeface="Arial" pitchFamily="34" charset="-120"/>
               </a:rPr>
-              <a:t>Design</a:t>
-            </a:r>
-            <a:endParaRPr lang="en-US" sz="1100" dirty="0"/>
+              <a:t>DESIGN</a:t>
+            </a:r>
+            <a:endParaRPr lang="en-US" sz="1150" dirty="0"/>
           </a:p>
         </p:txBody>
       </p:sp>
@@ -2265,8 +2265,8 @@
         </p:nvSpPr>
         <p:spPr>
           <a:xfrm>
-            <a:off x="1389888" y="8494776"/>
-            <a:ext cx="5532120" cy="219456"/>
+            <a:off x="3145536" y="8284464"/>
+            <a:ext cx="3776472" cy="438912"/>
           </a:xfrm>
           <a:prstGeom prst="rect">
             <a:avLst/>
@@ -2282,7 +2282,7 @@
               <a:buNone/>
             </a:pPr>
             <a:r>
-              <a:rPr lang="en-US" sz="850" dirty="0">
+              <a:rPr lang="en-US" sz="860" dirty="0">
                 <a:solidFill>
                   <a:srgbClr val="000000"/>
                 </a:solidFill>
@@ -2292,7 +2292,7 @@
               </a:rPr>
               <a:t>Develop the Combat Mindset Framework, delivery architecture and outcomes.</a:t>
             </a:r>
-            <a:endParaRPr lang="en-US" sz="850" dirty="0"/>
+            <a:endParaRPr lang="en-US" sz="860" dirty="0"/>
           </a:p>
         </p:txBody>
       </p:sp>
@@ -2368,8 +2368,8 @@
         </p:nvSpPr>
         <p:spPr>
           <a:xfrm>
-            <a:off x="1389888" y="8869680"/>
-            <a:ext cx="5532120" cy="219456"/>
+            <a:off x="1408176" y="8924544"/>
+            <a:ext cx="1691640" cy="365760"/>
           </a:xfrm>
           <a:prstGeom prst="rect">
             <a:avLst/>
@@ -2385,7 +2385,7 @@
               <a:buNone/>
             </a:pPr>
             <a:r>
-              <a:rPr lang="en-US" sz="1100" b="1" dirty="0">
+              <a:rPr lang="en-US" sz="1150" b="1" spc="150" kern="0" dirty="0">
                 <a:solidFill>
                   <a:srgbClr val="002516"/>
                 </a:solidFill>
@@ -2393,9 +2393,9 @@
                 <a:ea typeface="Arial" pitchFamily="34" charset="-122"/>
                 <a:cs typeface="Arial" pitchFamily="34" charset="-120"/>
               </a:rPr>
-              <a:t>Validate</a:t>
-            </a:r>
-            <a:endParaRPr lang="en-US" sz="1100" dirty="0"/>
+              <a:t>VALIDATE</a:t>
+            </a:r>
+            <a:endParaRPr lang="en-US" sz="1150" dirty="0"/>
           </a:p>
         </p:txBody>
       </p:sp>
@@ -2407,8 +2407,8 @@
         </p:nvSpPr>
         <p:spPr>
           <a:xfrm>
-            <a:off x="1389888" y="9098280"/>
-            <a:ext cx="5532120" cy="219456"/>
+            <a:off x="3145536" y="8887968"/>
+            <a:ext cx="3776472" cy="438912"/>
           </a:xfrm>
           <a:prstGeom prst="rect">
             <a:avLst/>
@@ -2424,7 +2424,7 @@
               <a:buNone/>
             </a:pPr>
             <a:r>
-              <a:rPr lang="en-US" sz="850" dirty="0">
+              <a:rPr lang="en-US" sz="860" dirty="0">
                 <a:solidFill>
                   <a:srgbClr val="000000"/>
                 </a:solidFill>
@@ -2434,7 +2434,7 @@
               </a:rPr>
               <a:t>Refine the framework with key stakeholders and conduct bounded pilots.</a:t>
             </a:r>
-            <a:endParaRPr lang="en-US" sz="850" dirty="0"/>
+            <a:endParaRPr lang="en-US" sz="860" dirty="0"/>
           </a:p>
         </p:txBody>
       </p:sp>
@@ -2510,8 +2510,8 @@
         </p:nvSpPr>
         <p:spPr>
           <a:xfrm>
-            <a:off x="1389888" y="9473184"/>
-            <a:ext cx="5532120" cy="219456"/>
+            <a:off x="1408176" y="9528048"/>
+            <a:ext cx="1691640" cy="365760"/>
           </a:xfrm>
           <a:prstGeom prst="rect">
             <a:avLst/>
@@ -2527,7 +2527,7 @@
               <a:buNone/>
             </a:pPr>
             <a:r>
-              <a:rPr lang="en-US" sz="1100" b="1" dirty="0">
+              <a:rPr lang="en-US" sz="1150" b="1" spc="150" kern="0" dirty="0">
                 <a:solidFill>
                   <a:srgbClr val="002516"/>
                 </a:solidFill>
@@ -2535,9 +2535,9 @@
                 <a:ea typeface="Arial" pitchFamily="34" charset="-122"/>
                 <a:cs typeface="Arial" pitchFamily="34" charset="-120"/>
               </a:rPr>
-              <a:t>Endorse and implement</a:t>
-            </a:r>
-            <a:endParaRPr lang="en-US" sz="1100" dirty="0"/>
+              <a:t>IMPLEMENT</a:t>
+            </a:r>
+            <a:endParaRPr lang="en-US" sz="1150" dirty="0"/>
           </a:p>
         </p:txBody>
       </p:sp>
@@ -2549,8 +2549,8 @@
         </p:nvSpPr>
         <p:spPr>
           <a:xfrm>
-            <a:off x="1389888" y="9701784"/>
-            <a:ext cx="5532120" cy="219456"/>
+            <a:off x="3145536" y="9491472"/>
+            <a:ext cx="3776472" cy="438912"/>
           </a:xfrm>
           <a:prstGeom prst="rect">
             <a:avLst/>
@@ -2566,7 +2566,7 @@
               <a:buNone/>
             </a:pPr>
             <a:r>
-              <a:rPr lang="en-US" sz="850" dirty="0">
+              <a:rPr lang="en-US" sz="860" dirty="0">
                 <a:solidFill>
                   <a:srgbClr val="000000"/>
                 </a:solidFill>
@@ -2576,7 +2576,7 @@
               </a:rPr>
               <a:t>Deliver the framework for approval and implementation.</a:t>
             </a:r>
-            <a:endParaRPr lang="en-US" sz="850" dirty="0"/>
+            <a:endParaRPr lang="en-US" sz="860" dirty="0"/>
           </a:p>
         </p:txBody>
       </p:sp>

</xml_diff>

<commit_message>
Executive presentation pass: title, brand mark, metadata, footer
Retitled COMBAT MINDSET FRAMEWORK PROPOSAL with stacked header (larger
brand mark, title, Army Command School). Version and draft markings
removed from the page; version control moved to document properties.
Footer simplified to Army Command School / August 2026. Pathway given
more room (wider title column, taller pitch). Paper embed regenerated.

Co-Authored-By: Claude Fable 5 <noreply@anthropic.com>
Claude-Session: https://claude.ai/code/session_01YLo1WfwUDkbwfJEF3ZNVbB
</commit_message>
<xml_diff>
--- a/output/combat-mindset-onepager-portrait.pptx
+++ b/output/combat-mindset-onepager-portrait.pptx
@@ -891,8 +891,8 @@
         </p:blipFill>
         <p:spPr>
           <a:xfrm>
-            <a:off x="457200" y="457200"/>
-            <a:ext cx="1005840" cy="243230"/>
+            <a:off x="457200" y="365760"/>
+            <a:ext cx="1261872" cy="305410"/>
           </a:xfrm>
           <a:prstGeom prst="rect">
             <a:avLst/>
@@ -907,8 +907,8 @@
         </p:nvSpPr>
         <p:spPr>
           <a:xfrm>
-            <a:off x="1691640" y="429768"/>
-            <a:ext cx="5413248" cy="292608"/>
+            <a:off x="457200" y="786384"/>
+            <a:ext cx="6647688" cy="310896"/>
           </a:xfrm>
           <a:prstGeom prst="rect">
             <a:avLst/>
@@ -924,7 +924,7 @@
               <a:buNone/>
             </a:pPr>
             <a:r>
-              <a:rPr lang="en-US" sz="1550" b="1" dirty="0">
+              <a:rPr lang="en-US" sz="1700" b="1" dirty="0">
                 <a:solidFill>
                   <a:srgbClr val="000000"/>
                 </a:solidFill>
@@ -932,9 +932,9 @@
                 <a:ea typeface="Arial" pitchFamily="34" charset="-122"/>
                 <a:cs typeface="Arial" pitchFamily="34" charset="-120"/>
               </a:rPr>
-              <a:t>COMBAT MINDSET THE WAY FORWARD</a:t>
-            </a:r>
-            <a:endParaRPr lang="en-US" sz="1550" dirty="0"/>
+              <a:t>COMBAT MINDSET FRAMEWORK PROPOSAL</a:t>
+            </a:r>
+            <a:endParaRPr lang="en-US" sz="1700" dirty="0"/>
           </a:p>
         </p:txBody>
       </p:sp>
@@ -946,8 +946,8 @@
         </p:nvSpPr>
         <p:spPr>
           <a:xfrm>
-            <a:off x="457200" y="10469880"/>
-            <a:ext cx="2377440" cy="164592"/>
+            <a:off x="457200" y="1097280"/>
+            <a:ext cx="6647688" cy="182880"/>
           </a:xfrm>
           <a:prstGeom prst="rect">
             <a:avLst/>
@@ -963,7 +963,46 @@
               <a:buNone/>
             </a:pPr>
             <a:r>
-              <a:rPr lang="en-US" sz="600" dirty="0">
+              <a:rPr lang="en-US" sz="900" i="1" dirty="0">
+                <a:solidFill>
+                  <a:srgbClr val="002516"/>
+                </a:solidFill>
+                <a:latin typeface="Arial" pitchFamily="34" charset="0"/>
+                <a:ea typeface="Arial" pitchFamily="34" charset="-122"/>
+                <a:cs typeface="Arial" pitchFamily="34" charset="-120"/>
+              </a:rPr>
+              <a:t>Army Command School</a:t>
+            </a:r>
+            <a:endParaRPr lang="en-US" sz="900" dirty="0"/>
+          </a:p>
+        </p:txBody>
+      </p:sp>
+      <p:sp>
+        <p:nvSpPr>
+          <p:cNvPr id="5" name="Text 2"/>
+          <p:cNvSpPr/>
+          <p:nvPr/>
+        </p:nvSpPr>
+        <p:spPr>
+          <a:xfrm>
+            <a:off x="457200" y="10442448"/>
+            <a:ext cx="2743200" cy="164592"/>
+          </a:xfrm>
+          <a:prstGeom prst="rect">
+            <a:avLst/>
+          </a:prstGeom>
+          <a:noFill/>
+          <a:ln/>
+        </p:spPr>
+        <p:txBody>
+          <a:bodyPr wrap="square" lIns="0" tIns="0" rIns="0" bIns="0" rtlCol="0" anchor="ctr"/>
+          <a:lstStyle/>
+          <a:p>
+            <a:pPr algn="l" indent="0" marL="0">
+              <a:buNone/>
+            </a:pPr>
+            <a:r>
+              <a:rPr lang="en-US" sz="650" dirty="0">
                 <a:solidFill>
                   <a:srgbClr val="000000"/>
                 </a:solidFill>
@@ -971,22 +1010,22 @@
                 <a:ea typeface="Arial" pitchFamily="34" charset="-122"/>
                 <a:cs typeface="Arial" pitchFamily="34" charset="-120"/>
               </a:rPr>
-              <a:t>Army Command School  ·  ACS 2026</a:t>
-            </a:r>
-            <a:endParaRPr lang="en-US" sz="600" dirty="0"/>
-          </a:p>
-        </p:txBody>
-      </p:sp>
-      <p:sp>
-        <p:nvSpPr>
-          <p:cNvPr id="5" name="Text 2"/>
-          <p:cNvSpPr/>
-          <p:nvPr/>
-        </p:nvSpPr>
-        <p:spPr>
-          <a:xfrm>
-            <a:off x="5212080" y="10469880"/>
-            <a:ext cx="1892808" cy="164592"/>
+              <a:t>Army Command School</a:t>
+            </a:r>
+            <a:endParaRPr lang="en-US" sz="650" dirty="0"/>
+          </a:p>
+        </p:txBody>
+      </p:sp>
+      <p:sp>
+        <p:nvSpPr>
+          <p:cNvPr id="6" name="Text 3"/>
+          <p:cNvSpPr/>
+          <p:nvPr/>
+        </p:nvSpPr>
+        <p:spPr>
+          <a:xfrm>
+            <a:off x="4361688" y="10442448"/>
+            <a:ext cx="2743200" cy="164592"/>
           </a:xfrm>
           <a:prstGeom prst="rect">
             <a:avLst/>
@@ -1002,7 +1041,7 @@
               <a:buNone/>
             </a:pPr>
             <a:r>
-              <a:rPr lang="en-US" sz="600" dirty="0">
+              <a:rPr lang="en-US" sz="650" dirty="0">
                 <a:solidFill>
                   <a:srgbClr val="000000"/>
                 </a:solidFill>
@@ -1010,22 +1049,22 @@
                 <a:ea typeface="Arial" pitchFamily="34" charset="-122"/>
                 <a:cs typeface="Arial" pitchFamily="34" charset="-120"/>
               </a:rPr>
-              <a:t>Draft v0.8  ·  July 2026</a:t>
-            </a:r>
-            <a:endParaRPr lang="en-US" sz="600" dirty="0"/>
-          </a:p>
-        </p:txBody>
-      </p:sp>
-      <p:sp>
-        <p:nvSpPr>
-          <p:cNvPr id="6" name="Shape 3"/>
-          <p:cNvSpPr/>
-          <p:nvPr/>
-        </p:nvSpPr>
-        <p:spPr>
-          <a:xfrm>
-            <a:off x="457200" y="1042416"/>
-            <a:ext cx="6647688" cy="1426464"/>
+              <a:t>August 2026</a:t>
+            </a:r>
+            <a:endParaRPr lang="en-US" sz="650" dirty="0"/>
+          </a:p>
+        </p:txBody>
+      </p:sp>
+      <p:sp>
+        <p:nvSpPr>
+          <p:cNvPr id="7" name="Shape 4"/>
+          <p:cNvSpPr/>
+          <p:nvPr/>
+        </p:nvSpPr>
+        <p:spPr>
+          <a:xfrm>
+            <a:off x="457200" y="1481328"/>
+            <a:ext cx="6647688" cy="1371600"/>
           </a:xfrm>
           <a:prstGeom prst="rect">
             <a:avLst/>
@@ -1038,13 +1077,13 @@
       </p:sp>
       <p:sp>
         <p:nvSpPr>
-          <p:cNvPr id="7" name="Shape 4"/>
-          <p:cNvSpPr/>
-          <p:nvPr/>
-        </p:nvSpPr>
-        <p:spPr>
-          <a:xfrm>
-            <a:off x="2683764" y="932688"/>
+          <p:cNvPr id="8" name="Shape 5"/>
+          <p:cNvSpPr/>
+          <p:nvPr/>
+        </p:nvSpPr>
+        <p:spPr>
+          <a:xfrm>
+            <a:off x="2683764" y="1371600"/>
             <a:ext cx="2194560" cy="219456"/>
           </a:xfrm>
           <a:prstGeom prst="roundRect">
@@ -1065,13 +1104,13 @@
       </p:sp>
       <p:sp>
         <p:nvSpPr>
-          <p:cNvPr id="8" name="Text 5"/>
-          <p:cNvSpPr/>
-          <p:nvPr/>
-        </p:nvSpPr>
-        <p:spPr>
-          <a:xfrm>
-            <a:off x="2683764" y="932688"/>
+          <p:cNvPr id="9" name="Text 6"/>
+          <p:cNvSpPr/>
+          <p:nvPr/>
+        </p:nvSpPr>
+        <p:spPr>
+          <a:xfrm>
+            <a:off x="2683764" y="1371600"/>
             <a:ext cx="2194560" cy="219456"/>
           </a:xfrm>
           <a:prstGeom prst="rect">
@@ -1104,7 +1143,7 @@
       </p:sp>
       <p:pic>
         <p:nvPicPr>
-          <p:cNvPr id="9" name="Image 1" descr="preencoded.png">    </p:cNvPr>
+          <p:cNvPr id="10" name="Image 1" descr="preencoded.png">    </p:cNvPr>
           <p:cNvPicPr>
             <a:picLocks noChangeAspect="1"/>
           </p:cNvPicPr>
@@ -1120,8 +1159,8 @@
         </p:blipFill>
         <p:spPr>
           <a:xfrm>
-            <a:off x="731520" y="1389888"/>
-            <a:ext cx="731520" cy="731520"/>
+            <a:off x="731520" y="1810512"/>
+            <a:ext cx="713232" cy="713232"/>
           </a:xfrm>
           <a:prstGeom prst="rect">
             <a:avLst/>
@@ -1130,14 +1169,14 @@
       </p:pic>
       <p:sp>
         <p:nvSpPr>
-          <p:cNvPr id="10" name="Text 6"/>
-          <p:cNvSpPr/>
-          <p:nvPr/>
-        </p:nvSpPr>
-        <p:spPr>
-          <a:xfrm>
-            <a:off x="457200" y="1389888"/>
-            <a:ext cx="6647688" cy="566928"/>
+          <p:cNvPr id="11" name="Text 7"/>
+          <p:cNvSpPr/>
+          <p:nvPr/>
+        </p:nvSpPr>
+        <p:spPr>
+          <a:xfrm>
+            <a:off x="457200" y="1810512"/>
+            <a:ext cx="6647688" cy="548640"/>
           </a:xfrm>
           <a:prstGeom prst="rect">
             <a:avLst/>
@@ -1153,7 +1192,7 @@
               <a:buNone/>
             </a:pPr>
             <a:r>
-              <a:rPr lang="en-US" sz="3700" b="1" dirty="0">
+              <a:rPr lang="en-US" sz="3600" b="1" dirty="0">
                 <a:solidFill>
                   <a:srgbClr val="FFFFFF"/>
                 </a:solidFill>
@@ -1163,19 +1202,19 @@
               </a:rPr>
               <a:t>COMBAT MINDSET</a:t>
             </a:r>
-            <a:endParaRPr lang="en-US" sz="3700" dirty="0"/>
-          </a:p>
-        </p:txBody>
-      </p:sp>
-      <p:sp>
-        <p:nvSpPr>
-          <p:cNvPr id="11" name="Text 7"/>
-          <p:cNvSpPr/>
-          <p:nvPr/>
-        </p:nvSpPr>
-        <p:spPr>
-          <a:xfrm>
-            <a:off x="457200" y="2011680"/>
+            <a:endParaRPr lang="en-US" sz="3600" dirty="0"/>
+          </a:p>
+        </p:txBody>
+      </p:sp>
+      <p:sp>
+        <p:nvSpPr>
+          <p:cNvPr id="12" name="Text 8"/>
+          <p:cNvSpPr/>
+          <p:nvPr/>
+        </p:nvSpPr>
+        <p:spPr>
+          <a:xfrm>
+            <a:off x="457200" y="2395728"/>
             <a:ext cx="6647688" cy="274320"/>
           </a:xfrm>
           <a:prstGeom prst="rect">
@@ -1208,13 +1247,13 @@
       </p:sp>
       <p:sp>
         <p:nvSpPr>
-          <p:cNvPr id="12" name="Shape 8"/>
+          <p:cNvPr id="13" name="Shape 9"/>
           <p:cNvSpPr/>
           <p:nvPr/>
         </p:nvSpPr>
         <p:spPr>
           <a:xfrm rot="10800000">
-            <a:off x="3717036" y="2596896"/>
+            <a:off x="3717036" y="2962656"/>
             <a:ext cx="128016" cy="100584"/>
           </a:xfrm>
           <a:prstGeom prst="triangle">
@@ -1228,13 +1267,13 @@
       </p:sp>
       <p:sp>
         <p:nvSpPr>
-          <p:cNvPr id="13" name="Text 9"/>
-          <p:cNvSpPr/>
-          <p:nvPr/>
-        </p:nvSpPr>
-        <p:spPr>
-          <a:xfrm>
-            <a:off x="2043684" y="2715768"/>
+          <p:cNvPr id="14" name="Text 10"/>
+          <p:cNvSpPr/>
+          <p:nvPr/>
+        </p:nvSpPr>
+        <p:spPr>
+          <a:xfrm>
+            <a:off x="2043684" y="3081528"/>
             <a:ext cx="3474720" cy="146304"/>
           </a:xfrm>
           <a:prstGeom prst="rect">
@@ -1267,14 +1306,14 @@
       </p:sp>
       <p:sp>
         <p:nvSpPr>
-          <p:cNvPr id="14" name="Shape 10"/>
-          <p:cNvSpPr/>
-          <p:nvPr/>
-        </p:nvSpPr>
-        <p:spPr>
-          <a:xfrm>
-            <a:off x="457200" y="3127248"/>
-            <a:ext cx="6647688" cy="1133856"/>
+          <p:cNvPr id="15" name="Shape 11"/>
+          <p:cNvSpPr/>
+          <p:nvPr/>
+        </p:nvSpPr>
+        <p:spPr>
+          <a:xfrm>
+            <a:off x="457200" y="3474720"/>
+            <a:ext cx="6647688" cy="1097280"/>
           </a:xfrm>
           <a:prstGeom prst="rect">
             <a:avLst/>
@@ -1287,13 +1326,13 @@
       </p:sp>
       <p:sp>
         <p:nvSpPr>
-          <p:cNvPr id="15" name="Shape 11"/>
-          <p:cNvSpPr/>
-          <p:nvPr/>
-        </p:nvSpPr>
-        <p:spPr>
-          <a:xfrm>
-            <a:off x="1952244" y="3017520"/>
+          <p:cNvPr id="16" name="Shape 12"/>
+          <p:cNvSpPr/>
+          <p:nvPr/>
+        </p:nvSpPr>
+        <p:spPr>
+          <a:xfrm>
+            <a:off x="1952244" y="3364992"/>
             <a:ext cx="3657600" cy="219456"/>
           </a:xfrm>
           <a:prstGeom prst="roundRect">
@@ -1314,13 +1353,13 @@
       </p:sp>
       <p:sp>
         <p:nvSpPr>
-          <p:cNvPr id="16" name="Text 12"/>
-          <p:cNvSpPr/>
-          <p:nvPr/>
-        </p:nvSpPr>
-        <p:spPr>
-          <a:xfrm>
-            <a:off x="1952244" y="3017520"/>
+          <p:cNvPr id="17" name="Text 13"/>
+          <p:cNvSpPr/>
+          <p:nvPr/>
+        </p:nvSpPr>
+        <p:spPr>
+          <a:xfrm>
+            <a:off x="1952244" y="3364992"/>
             <a:ext cx="3657600" cy="219456"/>
           </a:xfrm>
           <a:prstGeom prst="rect">
@@ -1353,7 +1392,7 @@
       </p:sp>
       <p:pic>
         <p:nvPicPr>
-          <p:cNvPr id="17" name="Image 2" descr="preencoded.png">    </p:cNvPr>
+          <p:cNvPr id="18" name="Image 2" descr="preencoded.png">    </p:cNvPr>
           <p:cNvPicPr>
             <a:picLocks noChangeAspect="1"/>
           </p:cNvPicPr>
@@ -1367,7 +1406,7 @@
         </p:blipFill>
         <p:spPr>
           <a:xfrm>
-            <a:off x="658368" y="3474720"/>
+            <a:off x="658368" y="3803904"/>
             <a:ext cx="438912" cy="438912"/>
           </a:xfrm>
           <a:prstGeom prst="rect">
@@ -1377,13 +1416,13 @@
       </p:pic>
       <p:sp>
         <p:nvSpPr>
-          <p:cNvPr id="18" name="Text 13"/>
-          <p:cNvSpPr/>
-          <p:nvPr/>
-        </p:nvSpPr>
-        <p:spPr>
-          <a:xfrm>
-            <a:off x="457200" y="3383280"/>
+          <p:cNvPr id="19" name="Text 14"/>
+          <p:cNvSpPr/>
+          <p:nvPr/>
+        </p:nvSpPr>
+        <p:spPr>
+          <a:xfrm>
+            <a:off x="457200" y="3712464"/>
             <a:ext cx="6647688" cy="420624"/>
           </a:xfrm>
           <a:prstGeom prst="rect">
@@ -1416,13 +1455,13 @@
       </p:sp>
       <p:sp>
         <p:nvSpPr>
-          <p:cNvPr id="19" name="Text 14"/>
-          <p:cNvSpPr/>
-          <p:nvPr/>
-        </p:nvSpPr>
-        <p:spPr>
-          <a:xfrm>
-            <a:off x="457200" y="3840480"/>
+          <p:cNvPr id="20" name="Text 15"/>
+          <p:cNvSpPr/>
+          <p:nvPr/>
+        </p:nvSpPr>
+        <p:spPr>
+          <a:xfrm>
+            <a:off x="457200" y="4169664"/>
             <a:ext cx="6647688" cy="237744"/>
           </a:xfrm>
           <a:prstGeom prst="rect">
@@ -1455,13 +1494,13 @@
       </p:sp>
       <p:sp>
         <p:nvSpPr>
-          <p:cNvPr id="20" name="Shape 15"/>
+          <p:cNvPr id="21" name="Shape 16"/>
           <p:cNvSpPr/>
           <p:nvPr/>
         </p:nvSpPr>
         <p:spPr>
           <a:xfrm rot="10800000">
-            <a:off x="3717036" y="4389120"/>
+            <a:off x="3717036" y="4681728"/>
             <a:ext cx="128016" cy="100584"/>
           </a:xfrm>
           <a:prstGeom prst="triangle">
@@ -1475,13 +1514,13 @@
       </p:sp>
       <p:sp>
         <p:nvSpPr>
-          <p:cNvPr id="21" name="Text 16"/>
-          <p:cNvSpPr/>
-          <p:nvPr/>
-        </p:nvSpPr>
-        <p:spPr>
-          <a:xfrm>
-            <a:off x="2043684" y="4507992"/>
+          <p:cNvPr id="22" name="Text 17"/>
+          <p:cNvSpPr/>
+          <p:nvPr/>
+        </p:nvSpPr>
+        <p:spPr>
+          <a:xfrm>
+            <a:off x="2043684" y="4800600"/>
             <a:ext cx="3474720" cy="146304"/>
           </a:xfrm>
           <a:prstGeom prst="rect">
@@ -1514,14 +1553,14 @@
       </p:sp>
       <p:sp>
         <p:nvSpPr>
-          <p:cNvPr id="22" name="Shape 17"/>
-          <p:cNvSpPr/>
-          <p:nvPr/>
-        </p:nvSpPr>
-        <p:spPr>
-          <a:xfrm>
-            <a:off x="457200" y="4919472"/>
-            <a:ext cx="6647688" cy="1042416"/>
+          <p:cNvPr id="23" name="Shape 18"/>
+          <p:cNvSpPr/>
+          <p:nvPr/>
+        </p:nvSpPr>
+        <p:spPr>
+          <a:xfrm>
+            <a:off x="457200" y="5193792"/>
+            <a:ext cx="6647688" cy="1024128"/>
           </a:xfrm>
           <a:prstGeom prst="rect">
             <a:avLst/>
@@ -1534,13 +1573,13 @@
       </p:sp>
       <p:sp>
         <p:nvSpPr>
-          <p:cNvPr id="23" name="Shape 18"/>
-          <p:cNvSpPr/>
-          <p:nvPr/>
-        </p:nvSpPr>
-        <p:spPr>
-          <a:xfrm>
-            <a:off x="2820924" y="4809744"/>
+          <p:cNvPr id="24" name="Shape 19"/>
+          <p:cNvSpPr/>
+          <p:nvPr/>
+        </p:nvSpPr>
+        <p:spPr>
+          <a:xfrm>
+            <a:off x="2820924" y="5084064"/>
             <a:ext cx="1920240" cy="219456"/>
           </a:xfrm>
           <a:prstGeom prst="roundRect">
@@ -1561,13 +1600,13 @@
       </p:sp>
       <p:sp>
         <p:nvSpPr>
-          <p:cNvPr id="24" name="Text 19"/>
-          <p:cNvSpPr/>
-          <p:nvPr/>
-        </p:nvSpPr>
-        <p:spPr>
-          <a:xfrm>
-            <a:off x="2820924" y="4809744"/>
+          <p:cNvPr id="25" name="Text 20"/>
+          <p:cNvSpPr/>
+          <p:nvPr/>
+        </p:nvSpPr>
+        <p:spPr>
+          <a:xfrm>
+            <a:off x="2820924" y="5084064"/>
             <a:ext cx="1920240" cy="219456"/>
           </a:xfrm>
           <a:prstGeom prst="rect">
@@ -1600,7 +1639,7 @@
       </p:sp>
       <p:pic>
         <p:nvPicPr>
-          <p:cNvPr id="25" name="Image 3" descr="preencoded.png">    </p:cNvPr>
+          <p:cNvPr id="26" name="Image 3" descr="preencoded.png">    </p:cNvPr>
           <p:cNvPicPr>
             <a:picLocks noChangeAspect="1"/>
           </p:cNvPicPr>
@@ -1614,7 +1653,7 @@
         </p:blipFill>
         <p:spPr>
           <a:xfrm>
-            <a:off x="658368" y="5230368"/>
+            <a:off x="658368" y="5486400"/>
             <a:ext cx="402336" cy="402336"/>
           </a:xfrm>
           <a:prstGeom prst="rect">
@@ -1624,13 +1663,13 @@
       </p:pic>
       <p:sp>
         <p:nvSpPr>
-          <p:cNvPr id="26" name="Text 20"/>
-          <p:cNvSpPr/>
-          <p:nvPr/>
-        </p:nvSpPr>
-        <p:spPr>
-          <a:xfrm>
-            <a:off x="457200" y="5120640"/>
+          <p:cNvPr id="27" name="Text 21"/>
+          <p:cNvSpPr/>
+          <p:nvPr/>
+        </p:nvSpPr>
+        <p:spPr>
+          <a:xfrm>
+            <a:off x="457200" y="5394960"/>
             <a:ext cx="6647688" cy="365760"/>
           </a:xfrm>
           <a:prstGeom prst="rect">
@@ -1663,13 +1702,13 @@
       </p:sp>
       <p:sp>
         <p:nvSpPr>
-          <p:cNvPr id="27" name="Text 21"/>
-          <p:cNvSpPr/>
-          <p:nvPr/>
-        </p:nvSpPr>
-        <p:spPr>
-          <a:xfrm>
-            <a:off x="457200" y="5522976"/>
+          <p:cNvPr id="28" name="Text 22"/>
+          <p:cNvSpPr/>
+          <p:nvPr/>
+        </p:nvSpPr>
+        <p:spPr>
+          <a:xfrm>
+            <a:off x="457200" y="5788152"/>
             <a:ext cx="6647688" cy="219456"/>
           </a:xfrm>
           <a:prstGeom prst="rect">
@@ -1702,13 +1741,13 @@
       </p:sp>
       <p:sp>
         <p:nvSpPr>
-          <p:cNvPr id="28" name="Shape 22"/>
+          <p:cNvPr id="29" name="Shape 23"/>
           <p:cNvSpPr/>
           <p:nvPr/>
         </p:nvSpPr>
         <p:spPr>
           <a:xfrm rot="10800000">
-            <a:off x="3717036" y="6089904"/>
+            <a:off x="3717036" y="6327648"/>
             <a:ext cx="128016" cy="100584"/>
           </a:xfrm>
           <a:prstGeom prst="triangle">
@@ -1722,13 +1761,13 @@
       </p:sp>
       <p:sp>
         <p:nvSpPr>
-          <p:cNvPr id="29" name="Text 23"/>
-          <p:cNvSpPr/>
-          <p:nvPr/>
-        </p:nvSpPr>
-        <p:spPr>
-          <a:xfrm>
-            <a:off x="2043684" y="6208776"/>
+          <p:cNvPr id="30" name="Text 24"/>
+          <p:cNvSpPr/>
+          <p:nvPr/>
+        </p:nvSpPr>
+        <p:spPr>
+          <a:xfrm>
+            <a:off x="2043684" y="6446520"/>
             <a:ext cx="3474720" cy="146304"/>
           </a:xfrm>
           <a:prstGeom prst="rect">
@@ -1761,14 +1800,14 @@
       </p:sp>
       <p:sp>
         <p:nvSpPr>
-          <p:cNvPr id="30" name="Shape 24"/>
-          <p:cNvSpPr/>
-          <p:nvPr/>
-        </p:nvSpPr>
-        <p:spPr>
-          <a:xfrm>
-            <a:off x="457200" y="6729984"/>
-            <a:ext cx="6647688" cy="3401568"/>
+          <p:cNvPr id="31" name="Shape 25"/>
+          <p:cNvSpPr/>
+          <p:nvPr/>
+        </p:nvSpPr>
+        <p:spPr>
+          <a:xfrm>
+            <a:off x="457200" y="6839712"/>
+            <a:ext cx="6647688" cy="3438144"/>
           </a:xfrm>
           <a:prstGeom prst="rect">
             <a:avLst/>
@@ -1783,13 +1822,13 @@
       </p:sp>
       <p:sp>
         <p:nvSpPr>
-          <p:cNvPr id="31" name="Shape 25"/>
-          <p:cNvSpPr/>
-          <p:nvPr/>
-        </p:nvSpPr>
-        <p:spPr>
-          <a:xfrm>
-            <a:off x="2089404" y="6620256"/>
+          <p:cNvPr id="32" name="Shape 26"/>
+          <p:cNvSpPr/>
+          <p:nvPr/>
+        </p:nvSpPr>
+        <p:spPr>
+          <a:xfrm>
+            <a:off x="2089404" y="6729984"/>
             <a:ext cx="3383280" cy="219456"/>
           </a:xfrm>
           <a:prstGeom prst="roundRect">
@@ -1810,13 +1849,13 @@
       </p:sp>
       <p:sp>
         <p:nvSpPr>
-          <p:cNvPr id="32" name="Text 26"/>
-          <p:cNvSpPr/>
-          <p:nvPr/>
-        </p:nvSpPr>
-        <p:spPr>
-          <a:xfrm>
-            <a:off x="2089404" y="6620256"/>
+          <p:cNvPr id="33" name="Text 27"/>
+          <p:cNvSpPr/>
+          <p:nvPr/>
+        </p:nvSpPr>
+        <p:spPr>
+          <a:xfrm>
+            <a:off x="2089404" y="6729984"/>
             <a:ext cx="3383280" cy="219456"/>
           </a:xfrm>
           <a:prstGeom prst="rect">
@@ -1849,14 +1888,14 @@
       </p:sp>
       <p:sp>
         <p:nvSpPr>
-          <p:cNvPr id="33" name="Shape 27"/>
-          <p:cNvSpPr/>
-          <p:nvPr/>
-        </p:nvSpPr>
-        <p:spPr>
-          <a:xfrm>
-            <a:off x="1024128" y="7296912"/>
-            <a:ext cx="0" cy="2414016"/>
+          <p:cNvPr id="34" name="Shape 28"/>
+          <p:cNvSpPr/>
+          <p:nvPr/>
+        </p:nvSpPr>
+        <p:spPr>
+          <a:xfrm>
+            <a:off x="987552" y="7406640"/>
+            <a:ext cx="0" cy="2596896"/>
           </a:xfrm>
           <a:prstGeom prst="line">
             <a:avLst/>
@@ -1872,13 +1911,13 @@
       </p:sp>
       <p:sp>
         <p:nvSpPr>
-          <p:cNvPr id="34" name="Shape 28"/>
-          <p:cNvSpPr/>
-          <p:nvPr/>
-        </p:nvSpPr>
-        <p:spPr>
-          <a:xfrm>
-            <a:off x="832104" y="7104888"/>
+          <p:cNvPr id="35" name="Shape 29"/>
+          <p:cNvSpPr/>
+          <p:nvPr/>
+        </p:nvSpPr>
+        <p:spPr>
+          <a:xfrm>
+            <a:off x="795528" y="7214616"/>
             <a:ext cx="384048" cy="384048"/>
           </a:xfrm>
           <a:prstGeom prst="ellipse">
@@ -1897,13 +1936,13 @@
       </p:sp>
       <p:sp>
         <p:nvSpPr>
-          <p:cNvPr id="35" name="Text 29"/>
-          <p:cNvSpPr/>
-          <p:nvPr/>
-        </p:nvSpPr>
-        <p:spPr>
-          <a:xfrm>
-            <a:off x="832104" y="7104888"/>
+          <p:cNvPr id="36" name="Text 30"/>
+          <p:cNvSpPr/>
+          <p:nvPr/>
+        </p:nvSpPr>
+        <p:spPr>
+          <a:xfrm>
+            <a:off x="795528" y="7214616"/>
             <a:ext cx="384048" cy="384048"/>
           </a:xfrm>
           <a:prstGeom prst="rect">
@@ -1936,14 +1975,14 @@
       </p:sp>
       <p:sp>
         <p:nvSpPr>
-          <p:cNvPr id="36" name="Text 30"/>
-          <p:cNvSpPr/>
-          <p:nvPr/>
-        </p:nvSpPr>
-        <p:spPr>
-          <a:xfrm>
-            <a:off x="1408176" y="7114032"/>
-            <a:ext cx="1691640" cy="365760"/>
+          <p:cNvPr id="37" name="Text 31"/>
+          <p:cNvSpPr/>
+          <p:nvPr/>
+        </p:nvSpPr>
+        <p:spPr>
+          <a:xfrm>
+            <a:off x="1353312" y="7223760"/>
+            <a:ext cx="1783080" cy="365760"/>
           </a:xfrm>
           <a:prstGeom prst="rect">
             <a:avLst/>
@@ -1959,7 +1998,7 @@
               <a:buNone/>
             </a:pPr>
             <a:r>
-              <a:rPr lang="en-US" sz="1150" b="1" spc="150" kern="0" dirty="0">
+              <a:rPr lang="en-US" sz="1150" b="1" spc="120" kern="0" dirty="0">
                 <a:solidFill>
                   <a:srgbClr val="002516"/>
                 </a:solidFill>
@@ -1975,14 +2014,14 @@
       </p:sp>
       <p:sp>
         <p:nvSpPr>
-          <p:cNvPr id="37" name="Text 31"/>
-          <p:cNvSpPr/>
-          <p:nvPr/>
-        </p:nvSpPr>
-        <p:spPr>
-          <a:xfrm>
-            <a:off x="3145536" y="7077456"/>
-            <a:ext cx="3776472" cy="438912"/>
+          <p:cNvPr id="38" name="Text 32"/>
+          <p:cNvSpPr/>
+          <p:nvPr/>
+        </p:nvSpPr>
+        <p:spPr>
+          <a:xfrm>
+            <a:off x="3182112" y="7187184"/>
+            <a:ext cx="3758184" cy="438912"/>
           </a:xfrm>
           <a:prstGeom prst="rect">
             <a:avLst/>
@@ -2014,13 +2053,13 @@
       </p:sp>
       <p:sp>
         <p:nvSpPr>
-          <p:cNvPr id="38" name="Shape 32"/>
-          <p:cNvSpPr/>
-          <p:nvPr/>
-        </p:nvSpPr>
-        <p:spPr>
-          <a:xfrm>
-            <a:off x="832104" y="7708392"/>
+          <p:cNvPr id="39" name="Shape 33"/>
+          <p:cNvSpPr/>
+          <p:nvPr/>
+        </p:nvSpPr>
+        <p:spPr>
+          <a:xfrm>
+            <a:off x="795528" y="7863840"/>
             <a:ext cx="384048" cy="384048"/>
           </a:xfrm>
           <a:prstGeom prst="ellipse">
@@ -2039,13 +2078,13 @@
       </p:sp>
       <p:sp>
         <p:nvSpPr>
-          <p:cNvPr id="39" name="Text 33"/>
-          <p:cNvSpPr/>
-          <p:nvPr/>
-        </p:nvSpPr>
-        <p:spPr>
-          <a:xfrm>
-            <a:off x="832104" y="7708392"/>
+          <p:cNvPr id="40" name="Text 34"/>
+          <p:cNvSpPr/>
+          <p:nvPr/>
+        </p:nvSpPr>
+        <p:spPr>
+          <a:xfrm>
+            <a:off x="795528" y="7863840"/>
             <a:ext cx="384048" cy="384048"/>
           </a:xfrm>
           <a:prstGeom prst="rect">
@@ -2078,14 +2117,14 @@
       </p:sp>
       <p:sp>
         <p:nvSpPr>
-          <p:cNvPr id="40" name="Text 34"/>
-          <p:cNvSpPr/>
-          <p:nvPr/>
-        </p:nvSpPr>
-        <p:spPr>
-          <a:xfrm>
-            <a:off x="1408176" y="7717536"/>
-            <a:ext cx="1691640" cy="365760"/>
+          <p:cNvPr id="41" name="Text 35"/>
+          <p:cNvSpPr/>
+          <p:nvPr/>
+        </p:nvSpPr>
+        <p:spPr>
+          <a:xfrm>
+            <a:off x="1353312" y="7872984"/>
+            <a:ext cx="1783080" cy="365760"/>
           </a:xfrm>
           <a:prstGeom prst="rect">
             <a:avLst/>
@@ -2101,7 +2140,7 @@
               <a:buNone/>
             </a:pPr>
             <a:r>
-              <a:rPr lang="en-US" sz="1150" b="1" spc="150" kern="0" dirty="0">
+              <a:rPr lang="en-US" sz="1150" b="1" spc="120" kern="0" dirty="0">
                 <a:solidFill>
                   <a:srgbClr val="002516"/>
                 </a:solidFill>
@@ -2117,14 +2156,14 @@
       </p:sp>
       <p:sp>
         <p:nvSpPr>
-          <p:cNvPr id="41" name="Text 35"/>
-          <p:cNvSpPr/>
-          <p:nvPr/>
-        </p:nvSpPr>
-        <p:spPr>
-          <a:xfrm>
-            <a:off x="3145536" y="7680960"/>
-            <a:ext cx="3776472" cy="438912"/>
+          <p:cNvPr id="42" name="Text 36"/>
+          <p:cNvSpPr/>
+          <p:nvPr/>
+        </p:nvSpPr>
+        <p:spPr>
+          <a:xfrm>
+            <a:off x="3182112" y="7836408"/>
+            <a:ext cx="3758184" cy="438912"/>
           </a:xfrm>
           <a:prstGeom prst="rect">
             <a:avLst/>
@@ -2156,13 +2195,13 @@
       </p:sp>
       <p:sp>
         <p:nvSpPr>
-          <p:cNvPr id="42" name="Shape 36"/>
-          <p:cNvSpPr/>
-          <p:nvPr/>
-        </p:nvSpPr>
-        <p:spPr>
-          <a:xfrm>
-            <a:off x="832104" y="8311896"/>
+          <p:cNvPr id="43" name="Shape 37"/>
+          <p:cNvSpPr/>
+          <p:nvPr/>
+        </p:nvSpPr>
+        <p:spPr>
+          <a:xfrm>
+            <a:off x="795528" y="8513064"/>
             <a:ext cx="384048" cy="384048"/>
           </a:xfrm>
           <a:prstGeom prst="ellipse">
@@ -2181,13 +2220,13 @@
       </p:sp>
       <p:sp>
         <p:nvSpPr>
-          <p:cNvPr id="43" name="Text 37"/>
-          <p:cNvSpPr/>
-          <p:nvPr/>
-        </p:nvSpPr>
-        <p:spPr>
-          <a:xfrm>
-            <a:off x="832104" y="8311896"/>
+          <p:cNvPr id="44" name="Text 38"/>
+          <p:cNvSpPr/>
+          <p:nvPr/>
+        </p:nvSpPr>
+        <p:spPr>
+          <a:xfrm>
+            <a:off x="795528" y="8513064"/>
             <a:ext cx="384048" cy="384048"/>
           </a:xfrm>
           <a:prstGeom prst="rect">
@@ -2220,14 +2259,14 @@
       </p:sp>
       <p:sp>
         <p:nvSpPr>
-          <p:cNvPr id="44" name="Text 38"/>
-          <p:cNvSpPr/>
-          <p:nvPr/>
-        </p:nvSpPr>
-        <p:spPr>
-          <a:xfrm>
-            <a:off x="1408176" y="8321040"/>
-            <a:ext cx="1691640" cy="365760"/>
+          <p:cNvPr id="45" name="Text 39"/>
+          <p:cNvSpPr/>
+          <p:nvPr/>
+        </p:nvSpPr>
+        <p:spPr>
+          <a:xfrm>
+            <a:off x="1353312" y="8522208"/>
+            <a:ext cx="1783080" cy="365760"/>
           </a:xfrm>
           <a:prstGeom prst="rect">
             <a:avLst/>
@@ -2243,7 +2282,7 @@
               <a:buNone/>
             </a:pPr>
             <a:r>
-              <a:rPr lang="en-US" sz="1150" b="1" spc="150" kern="0" dirty="0">
+              <a:rPr lang="en-US" sz="1150" b="1" spc="120" kern="0" dirty="0">
                 <a:solidFill>
                   <a:srgbClr val="002516"/>
                 </a:solidFill>
@@ -2259,14 +2298,14 @@
       </p:sp>
       <p:sp>
         <p:nvSpPr>
-          <p:cNvPr id="45" name="Text 39"/>
-          <p:cNvSpPr/>
-          <p:nvPr/>
-        </p:nvSpPr>
-        <p:spPr>
-          <a:xfrm>
-            <a:off x="3145536" y="8284464"/>
-            <a:ext cx="3776472" cy="438912"/>
+          <p:cNvPr id="46" name="Text 40"/>
+          <p:cNvSpPr/>
+          <p:nvPr/>
+        </p:nvSpPr>
+        <p:spPr>
+          <a:xfrm>
+            <a:off x="3182112" y="8485632"/>
+            <a:ext cx="3758184" cy="438912"/>
           </a:xfrm>
           <a:prstGeom prst="rect">
             <a:avLst/>
@@ -2298,13 +2337,13 @@
       </p:sp>
       <p:sp>
         <p:nvSpPr>
-          <p:cNvPr id="46" name="Shape 40"/>
-          <p:cNvSpPr/>
-          <p:nvPr/>
-        </p:nvSpPr>
-        <p:spPr>
-          <a:xfrm>
-            <a:off x="832104" y="8915400"/>
+          <p:cNvPr id="47" name="Shape 41"/>
+          <p:cNvSpPr/>
+          <p:nvPr/>
+        </p:nvSpPr>
+        <p:spPr>
+          <a:xfrm>
+            <a:off x="795528" y="9162288"/>
             <a:ext cx="384048" cy="384048"/>
           </a:xfrm>
           <a:prstGeom prst="ellipse">
@@ -2323,13 +2362,13 @@
       </p:sp>
       <p:sp>
         <p:nvSpPr>
-          <p:cNvPr id="47" name="Text 41"/>
-          <p:cNvSpPr/>
-          <p:nvPr/>
-        </p:nvSpPr>
-        <p:spPr>
-          <a:xfrm>
-            <a:off x="832104" y="8915400"/>
+          <p:cNvPr id="48" name="Text 42"/>
+          <p:cNvSpPr/>
+          <p:nvPr/>
+        </p:nvSpPr>
+        <p:spPr>
+          <a:xfrm>
+            <a:off x="795528" y="9162288"/>
             <a:ext cx="384048" cy="384048"/>
           </a:xfrm>
           <a:prstGeom prst="rect">
@@ -2362,14 +2401,14 @@
       </p:sp>
       <p:sp>
         <p:nvSpPr>
-          <p:cNvPr id="48" name="Text 42"/>
-          <p:cNvSpPr/>
-          <p:nvPr/>
-        </p:nvSpPr>
-        <p:spPr>
-          <a:xfrm>
-            <a:off x="1408176" y="8924544"/>
-            <a:ext cx="1691640" cy="365760"/>
+          <p:cNvPr id="49" name="Text 43"/>
+          <p:cNvSpPr/>
+          <p:nvPr/>
+        </p:nvSpPr>
+        <p:spPr>
+          <a:xfrm>
+            <a:off x="1353312" y="9171432"/>
+            <a:ext cx="1783080" cy="365760"/>
           </a:xfrm>
           <a:prstGeom prst="rect">
             <a:avLst/>
@@ -2385,7 +2424,7 @@
               <a:buNone/>
             </a:pPr>
             <a:r>
-              <a:rPr lang="en-US" sz="1150" b="1" spc="150" kern="0" dirty="0">
+              <a:rPr lang="en-US" sz="1150" b="1" spc="120" kern="0" dirty="0">
                 <a:solidFill>
                   <a:srgbClr val="002516"/>
                 </a:solidFill>
@@ -2401,14 +2440,14 @@
       </p:sp>
       <p:sp>
         <p:nvSpPr>
-          <p:cNvPr id="49" name="Text 43"/>
-          <p:cNvSpPr/>
-          <p:nvPr/>
-        </p:nvSpPr>
-        <p:spPr>
-          <a:xfrm>
-            <a:off x="3145536" y="8887968"/>
-            <a:ext cx="3776472" cy="438912"/>
+          <p:cNvPr id="50" name="Text 44"/>
+          <p:cNvSpPr/>
+          <p:nvPr/>
+        </p:nvSpPr>
+        <p:spPr>
+          <a:xfrm>
+            <a:off x="3182112" y="9134856"/>
+            <a:ext cx="3758184" cy="438912"/>
           </a:xfrm>
           <a:prstGeom prst="rect">
             <a:avLst/>
@@ -2440,13 +2479,13 @@
       </p:sp>
       <p:sp>
         <p:nvSpPr>
-          <p:cNvPr id="50" name="Shape 44"/>
-          <p:cNvSpPr/>
-          <p:nvPr/>
-        </p:nvSpPr>
-        <p:spPr>
-          <a:xfrm>
-            <a:off x="832104" y="9518904"/>
+          <p:cNvPr id="51" name="Shape 45"/>
+          <p:cNvSpPr/>
+          <p:nvPr/>
+        </p:nvSpPr>
+        <p:spPr>
+          <a:xfrm>
+            <a:off x="795528" y="9811512"/>
             <a:ext cx="384048" cy="384048"/>
           </a:xfrm>
           <a:prstGeom prst="ellipse">
@@ -2465,13 +2504,13 @@
       </p:sp>
       <p:sp>
         <p:nvSpPr>
-          <p:cNvPr id="51" name="Text 45"/>
-          <p:cNvSpPr/>
-          <p:nvPr/>
-        </p:nvSpPr>
-        <p:spPr>
-          <a:xfrm>
-            <a:off x="832104" y="9518904"/>
+          <p:cNvPr id="52" name="Text 46"/>
+          <p:cNvSpPr/>
+          <p:nvPr/>
+        </p:nvSpPr>
+        <p:spPr>
+          <a:xfrm>
+            <a:off x="795528" y="9811512"/>
             <a:ext cx="384048" cy="384048"/>
           </a:xfrm>
           <a:prstGeom prst="rect">
@@ -2504,14 +2543,14 @@
       </p:sp>
       <p:sp>
         <p:nvSpPr>
-          <p:cNvPr id="52" name="Text 46"/>
-          <p:cNvSpPr/>
-          <p:nvPr/>
-        </p:nvSpPr>
-        <p:spPr>
-          <a:xfrm>
-            <a:off x="1408176" y="9528048"/>
-            <a:ext cx="1691640" cy="365760"/>
+          <p:cNvPr id="53" name="Text 47"/>
+          <p:cNvSpPr/>
+          <p:nvPr/>
+        </p:nvSpPr>
+        <p:spPr>
+          <a:xfrm>
+            <a:off x="1353312" y="9820656"/>
+            <a:ext cx="1783080" cy="365760"/>
           </a:xfrm>
           <a:prstGeom prst="rect">
             <a:avLst/>
@@ -2527,7 +2566,7 @@
               <a:buNone/>
             </a:pPr>
             <a:r>
-              <a:rPr lang="en-US" sz="1150" b="1" spc="150" kern="0" dirty="0">
+              <a:rPr lang="en-US" sz="1150" b="1" spc="120" kern="0" dirty="0">
                 <a:solidFill>
                   <a:srgbClr val="002516"/>
                 </a:solidFill>
@@ -2543,14 +2582,14 @@
       </p:sp>
       <p:sp>
         <p:nvSpPr>
-          <p:cNvPr id="53" name="Text 47"/>
-          <p:cNvSpPr/>
-          <p:nvPr/>
-        </p:nvSpPr>
-        <p:spPr>
-          <a:xfrm>
-            <a:off x="3145536" y="9491472"/>
-            <a:ext cx="3776472" cy="438912"/>
+          <p:cNvPr id="54" name="Text 48"/>
+          <p:cNvSpPr/>
+          <p:nvPr/>
+        </p:nvSpPr>
+        <p:spPr>
+          <a:xfrm>
+            <a:off x="3182112" y="9784080"/>
+            <a:ext cx="3758184" cy="438912"/>
           </a:xfrm>
           <a:prstGeom prst="rect">
             <a:avLst/>

</xml_diff>

<commit_message>
Final executive refinements to the framework proposal page
Brand mark enlarged again to balance the title; footer reduced to
August 2026 bottom-right only; organising system retitled NZ ARMY
COMBAT MINDSET FRAMEWORK; phase 3 now reads delivery system rather
than delivery architecture; section connectors lightened (grey labels,
softened arrows) so the four primary headings carry the page. Paper
embed regenerated.

Co-Authored-By: Claude Fable 5 <noreply@anthropic.com>
Claude-Session: https://claude.ai/code/session_01YLo1WfwUDkbwfJEF3ZNVbB
</commit_message>
<xml_diff>
--- a/output/combat-mindset-onepager-portrait.pptx
+++ b/output/combat-mindset-onepager-portrait.pptx
@@ -891,8 +891,8 @@
         </p:blipFill>
         <p:spPr>
           <a:xfrm>
-            <a:off x="457200" y="365760"/>
-            <a:ext cx="1261872" cy="305410"/>
+            <a:off x="457200" y="329184"/>
+            <a:ext cx="1572768" cy="380390"/>
           </a:xfrm>
           <a:prstGeom prst="rect">
             <a:avLst/>
@@ -907,7 +907,7 @@
         </p:nvSpPr>
         <p:spPr>
           <a:xfrm>
-            <a:off x="457200" y="786384"/>
+            <a:off x="457200" y="822960"/>
             <a:ext cx="6647688" cy="310896"/>
           </a:xfrm>
           <a:prstGeom prst="rect">
@@ -946,8 +946,8 @@
         </p:nvSpPr>
         <p:spPr>
           <a:xfrm>
-            <a:off x="457200" y="1097280"/>
-            <a:ext cx="6647688" cy="182880"/>
+            <a:off x="457200" y="1133856"/>
+            <a:ext cx="6647688" cy="164592"/>
           </a:xfrm>
           <a:prstGeom prst="rect">
             <a:avLst/>
@@ -980,45 +980,6 @@
       <p:sp>
         <p:nvSpPr>
           <p:cNvPr id="5" name="Text 2"/>
-          <p:cNvSpPr/>
-          <p:nvPr/>
-        </p:nvSpPr>
-        <p:spPr>
-          <a:xfrm>
-            <a:off x="457200" y="10442448"/>
-            <a:ext cx="2743200" cy="164592"/>
-          </a:xfrm>
-          <a:prstGeom prst="rect">
-            <a:avLst/>
-          </a:prstGeom>
-          <a:noFill/>
-          <a:ln/>
-        </p:spPr>
-        <p:txBody>
-          <a:bodyPr wrap="square" lIns="0" tIns="0" rIns="0" bIns="0" rtlCol="0" anchor="ctr"/>
-          <a:lstStyle/>
-          <a:p>
-            <a:pPr algn="l" indent="0" marL="0">
-              <a:buNone/>
-            </a:pPr>
-            <a:r>
-              <a:rPr lang="en-US" sz="650" dirty="0">
-                <a:solidFill>
-                  <a:srgbClr val="000000"/>
-                </a:solidFill>
-                <a:latin typeface="Arial" pitchFamily="34" charset="0"/>
-                <a:ea typeface="Arial" pitchFamily="34" charset="-122"/>
-                <a:cs typeface="Arial" pitchFamily="34" charset="-120"/>
-              </a:rPr>
-              <a:t>Army Command School</a:t>
-            </a:r>
-            <a:endParaRPr lang="en-US" sz="650" dirty="0"/>
-          </a:p>
-        </p:txBody>
-      </p:sp>
-      <p:sp>
-        <p:nvSpPr>
-          <p:cNvPr id="6" name="Text 3"/>
           <p:cNvSpPr/>
           <p:nvPr/>
         </p:nvSpPr>
@@ -1057,7 +1018,7 @@
       </p:sp>
       <p:sp>
         <p:nvSpPr>
-          <p:cNvPr id="7" name="Shape 4"/>
+          <p:cNvPr id="6" name="Shape 3"/>
           <p:cNvSpPr/>
           <p:nvPr/>
         </p:nvSpPr>
@@ -1077,7 +1038,7 @@
       </p:sp>
       <p:sp>
         <p:nvSpPr>
-          <p:cNvPr id="8" name="Shape 5"/>
+          <p:cNvPr id="7" name="Shape 4"/>
           <p:cNvSpPr/>
           <p:nvPr/>
         </p:nvSpPr>
@@ -1104,7 +1065,7 @@
       </p:sp>
       <p:sp>
         <p:nvSpPr>
-          <p:cNvPr id="9" name="Text 6"/>
+          <p:cNvPr id="8" name="Text 5"/>
           <p:cNvSpPr/>
           <p:nvPr/>
         </p:nvSpPr>
@@ -1143,7 +1104,7 @@
       </p:sp>
       <p:pic>
         <p:nvPicPr>
-          <p:cNvPr id="10" name="Image 1" descr="preencoded.png">    </p:cNvPr>
+          <p:cNvPr id="9" name="Image 1" descr="preencoded.png">    </p:cNvPr>
           <p:cNvPicPr>
             <a:picLocks noChangeAspect="1"/>
           </p:cNvPicPr>
@@ -1169,7 +1130,7 @@
       </p:pic>
       <p:sp>
         <p:nvSpPr>
-          <p:cNvPr id="11" name="Text 7"/>
+          <p:cNvPr id="10" name="Text 6"/>
           <p:cNvSpPr/>
           <p:nvPr/>
         </p:nvSpPr>
@@ -1208,7 +1169,7 @@
       </p:sp>
       <p:sp>
         <p:nvSpPr>
-          <p:cNvPr id="12" name="Text 8"/>
+          <p:cNvPr id="11" name="Text 7"/>
           <p:cNvSpPr/>
           <p:nvPr/>
         </p:nvSpPr>
@@ -1247,7 +1208,7 @@
       </p:sp>
       <p:sp>
         <p:nvSpPr>
-          <p:cNvPr id="13" name="Shape 9"/>
+          <p:cNvPr id="12" name="Shape 8"/>
           <p:cNvSpPr/>
           <p:nvPr/>
         </p:nvSpPr>
@@ -1260,14 +1221,16 @@
             <a:avLst/>
           </a:prstGeom>
           <a:solidFill>
-            <a:srgbClr val="002516"/>
-          </a:solidFill>
-          <a:ln/>
-        </p:spPr>
-      </p:sp>
-      <p:sp>
-        <p:nvSpPr>
-          <p:cNvPr id="14" name="Text 10"/>
+            <a:srgbClr val="002516">
+              <a:alpha val="55000"/>
+            </a:srgbClr>
+          </a:solidFill>
+          <a:ln/>
+        </p:spPr>
+      </p:sp>
+      <p:sp>
+        <p:nvSpPr>
+          <p:cNvPr id="13" name="Text 9"/>
           <p:cNvSpPr/>
           <p:nvPr/>
         </p:nvSpPr>
@@ -1290,9 +1253,9 @@
               <a:buNone/>
             </a:pPr>
             <a:r>
-              <a:rPr lang="en-US" sz="850" i="1" dirty="0">
-                <a:solidFill>
-                  <a:srgbClr val="000000"/>
+              <a:rPr lang="en-US" sz="800" i="1" dirty="0">
+                <a:solidFill>
+                  <a:srgbClr val="7F7F7F"/>
                 </a:solidFill>
                 <a:latin typeface="Arial" pitchFamily="34" charset="0"/>
                 <a:ea typeface="Arial" pitchFamily="34" charset="-122"/>
@@ -1300,13 +1263,13 @@
               </a:rPr>
               <a:t>enabled by</a:t>
             </a:r>
-            <a:endParaRPr lang="en-US" sz="850" dirty="0"/>
-          </a:p>
-        </p:txBody>
-      </p:sp>
-      <p:sp>
-        <p:nvSpPr>
-          <p:cNvPr id="15" name="Shape 11"/>
+            <a:endParaRPr lang="en-US" sz="800" dirty="0"/>
+          </a:p>
+        </p:txBody>
+      </p:sp>
+      <p:sp>
+        <p:nvSpPr>
+          <p:cNvPr id="14" name="Shape 10"/>
           <p:cNvSpPr/>
           <p:nvPr/>
         </p:nvSpPr>
@@ -1326,7 +1289,7 @@
       </p:sp>
       <p:sp>
         <p:nvSpPr>
-          <p:cNvPr id="16" name="Shape 12"/>
+          <p:cNvPr id="15" name="Shape 11"/>
           <p:cNvSpPr/>
           <p:nvPr/>
         </p:nvSpPr>
@@ -1353,7 +1316,7 @@
       </p:sp>
       <p:sp>
         <p:nvSpPr>
-          <p:cNvPr id="17" name="Text 13"/>
+          <p:cNvPr id="16" name="Text 12"/>
           <p:cNvSpPr/>
           <p:nvPr/>
         </p:nvSpPr>
@@ -1392,7 +1355,7 @@
       </p:sp>
       <p:pic>
         <p:nvPicPr>
-          <p:cNvPr id="18" name="Image 2" descr="preencoded.png">    </p:cNvPr>
+          <p:cNvPr id="17" name="Image 2" descr="preencoded.png">    </p:cNvPr>
           <p:cNvPicPr>
             <a:picLocks noChangeAspect="1"/>
           </p:cNvPicPr>
@@ -1416,7 +1379,7 @@
       </p:pic>
       <p:sp>
         <p:nvSpPr>
-          <p:cNvPr id="19" name="Text 14"/>
+          <p:cNvPr id="18" name="Text 13"/>
           <p:cNvSpPr/>
           <p:nvPr/>
         </p:nvSpPr>
@@ -1455,7 +1418,7 @@
       </p:sp>
       <p:sp>
         <p:nvSpPr>
-          <p:cNvPr id="20" name="Text 15"/>
+          <p:cNvPr id="19" name="Text 14"/>
           <p:cNvSpPr/>
           <p:nvPr/>
         </p:nvSpPr>
@@ -1494,7 +1457,7 @@
       </p:sp>
       <p:sp>
         <p:nvSpPr>
-          <p:cNvPr id="21" name="Shape 16"/>
+          <p:cNvPr id="20" name="Shape 15"/>
           <p:cNvSpPr/>
           <p:nvPr/>
         </p:nvSpPr>
@@ -1507,14 +1470,16 @@
             <a:avLst/>
           </a:prstGeom>
           <a:solidFill>
-            <a:srgbClr val="002516"/>
-          </a:solidFill>
-          <a:ln/>
-        </p:spPr>
-      </p:sp>
-      <p:sp>
-        <p:nvSpPr>
-          <p:cNvPr id="22" name="Text 17"/>
+            <a:srgbClr val="002516">
+              <a:alpha val="55000"/>
+            </a:srgbClr>
+          </a:solidFill>
+          <a:ln/>
+        </p:spPr>
+      </p:sp>
+      <p:sp>
+        <p:nvSpPr>
+          <p:cNvPr id="21" name="Text 16"/>
           <p:cNvSpPr/>
           <p:nvPr/>
         </p:nvSpPr>
@@ -1537,9 +1502,9 @@
               <a:buNone/>
             </a:pPr>
             <a:r>
-              <a:rPr lang="en-US" sz="850" i="1" dirty="0">
-                <a:solidFill>
-                  <a:srgbClr val="000000"/>
+              <a:rPr lang="en-US" sz="800" i="1" dirty="0">
+                <a:solidFill>
+                  <a:srgbClr val="7F7F7F"/>
                 </a:solidFill>
                 <a:latin typeface="Arial" pitchFamily="34" charset="0"/>
                 <a:ea typeface="Arial" pitchFamily="34" charset="-122"/>
@@ -1547,13 +1512,13 @@
               </a:rPr>
               <a:t>developed, organised and assured through</a:t>
             </a:r>
-            <a:endParaRPr lang="en-US" sz="850" dirty="0"/>
-          </a:p>
-        </p:txBody>
-      </p:sp>
-      <p:sp>
-        <p:nvSpPr>
-          <p:cNvPr id="23" name="Shape 18"/>
+            <a:endParaRPr lang="en-US" sz="800" dirty="0"/>
+          </a:p>
+        </p:txBody>
+      </p:sp>
+      <p:sp>
+        <p:nvSpPr>
+          <p:cNvPr id="22" name="Shape 17"/>
           <p:cNvSpPr/>
           <p:nvPr/>
         </p:nvSpPr>
@@ -1573,7 +1538,7 @@
       </p:sp>
       <p:sp>
         <p:nvSpPr>
-          <p:cNvPr id="24" name="Shape 19"/>
+          <p:cNvPr id="23" name="Shape 18"/>
           <p:cNvSpPr/>
           <p:nvPr/>
         </p:nvSpPr>
@@ -1600,7 +1565,7 @@
       </p:sp>
       <p:sp>
         <p:nvSpPr>
-          <p:cNvPr id="25" name="Text 20"/>
+          <p:cNvPr id="24" name="Text 19"/>
           <p:cNvSpPr/>
           <p:nvPr/>
         </p:nvSpPr>
@@ -1639,7 +1604,7 @@
       </p:sp>
       <p:pic>
         <p:nvPicPr>
-          <p:cNvPr id="26" name="Image 3" descr="preencoded.png">    </p:cNvPr>
+          <p:cNvPr id="25" name="Image 3" descr="preencoded.png">    </p:cNvPr>
           <p:cNvPicPr>
             <a:picLocks noChangeAspect="1"/>
           </p:cNvPicPr>
@@ -1663,7 +1628,7 @@
       </p:pic>
       <p:sp>
         <p:nvSpPr>
-          <p:cNvPr id="27" name="Text 21"/>
+          <p:cNvPr id="26" name="Text 20"/>
           <p:cNvSpPr/>
           <p:nvPr/>
         </p:nvSpPr>
@@ -1694,7 +1659,7 @@
                 <a:ea typeface="Arial" pitchFamily="34" charset="-122"/>
                 <a:cs typeface="Arial" pitchFamily="34" charset="-120"/>
               </a:rPr>
-              <a:t>THE ARMY COMBAT MINDSET FRAMEWORK</a:t>
+              <a:t>NZ ARMY COMBAT MINDSET FRAMEWORK</a:t>
             </a:r>
             <a:endParaRPr lang="en-US" sz="1750" dirty="0"/>
           </a:p>
@@ -1702,7 +1667,7 @@
       </p:sp>
       <p:sp>
         <p:nvSpPr>
-          <p:cNvPr id="28" name="Text 22"/>
+          <p:cNvPr id="27" name="Text 21"/>
           <p:cNvSpPr/>
           <p:nvPr/>
         </p:nvSpPr>
@@ -1741,7 +1706,7 @@
       </p:sp>
       <p:sp>
         <p:nvSpPr>
-          <p:cNvPr id="29" name="Shape 23"/>
+          <p:cNvPr id="28" name="Shape 22"/>
           <p:cNvSpPr/>
           <p:nvPr/>
         </p:nvSpPr>
@@ -1754,14 +1719,16 @@
             <a:avLst/>
           </a:prstGeom>
           <a:solidFill>
-            <a:srgbClr val="002516"/>
-          </a:solidFill>
-          <a:ln/>
-        </p:spPr>
-      </p:sp>
-      <p:sp>
-        <p:nvSpPr>
-          <p:cNvPr id="30" name="Text 24"/>
+            <a:srgbClr val="002516">
+              <a:alpha val="55000"/>
+            </a:srgbClr>
+          </a:solidFill>
+          <a:ln/>
+        </p:spPr>
+      </p:sp>
+      <p:sp>
+        <p:nvSpPr>
+          <p:cNvPr id="29" name="Text 23"/>
           <p:cNvSpPr/>
           <p:nvPr/>
         </p:nvSpPr>
@@ -1784,9 +1751,9 @@
               <a:buNone/>
             </a:pPr>
             <a:r>
-              <a:rPr lang="en-US" sz="850" i="1" dirty="0">
-                <a:solidFill>
-                  <a:srgbClr val="000000"/>
+              <a:rPr lang="en-US" sz="800" i="1" dirty="0">
+                <a:solidFill>
+                  <a:srgbClr val="7F7F7F"/>
                 </a:solidFill>
                 <a:latin typeface="Arial" pitchFamily="34" charset="0"/>
                 <a:ea typeface="Arial" pitchFamily="34" charset="-122"/>
@@ -1794,13 +1761,13 @@
               </a:rPr>
               <a:t>achieved through</a:t>
             </a:r>
-            <a:endParaRPr lang="en-US" sz="850" dirty="0"/>
-          </a:p>
-        </p:txBody>
-      </p:sp>
-      <p:sp>
-        <p:nvSpPr>
-          <p:cNvPr id="31" name="Shape 25"/>
+            <a:endParaRPr lang="en-US" sz="800" dirty="0"/>
+          </a:p>
+        </p:txBody>
+      </p:sp>
+      <p:sp>
+        <p:nvSpPr>
+          <p:cNvPr id="30" name="Shape 24"/>
           <p:cNvSpPr/>
           <p:nvPr/>
         </p:nvSpPr>
@@ -1822,7 +1789,7 @@
       </p:sp>
       <p:sp>
         <p:nvSpPr>
-          <p:cNvPr id="32" name="Shape 26"/>
+          <p:cNvPr id="31" name="Shape 25"/>
           <p:cNvSpPr/>
           <p:nvPr/>
         </p:nvSpPr>
@@ -1849,7 +1816,7 @@
       </p:sp>
       <p:sp>
         <p:nvSpPr>
-          <p:cNvPr id="33" name="Text 27"/>
+          <p:cNvPr id="32" name="Text 26"/>
           <p:cNvSpPr/>
           <p:nvPr/>
         </p:nvSpPr>
@@ -1888,7 +1855,7 @@
       </p:sp>
       <p:sp>
         <p:nvSpPr>
-          <p:cNvPr id="34" name="Shape 28"/>
+          <p:cNvPr id="33" name="Shape 27"/>
           <p:cNvSpPr/>
           <p:nvPr/>
         </p:nvSpPr>
@@ -1911,7 +1878,7 @@
       </p:sp>
       <p:sp>
         <p:nvSpPr>
-          <p:cNvPr id="35" name="Shape 29"/>
+          <p:cNvPr id="34" name="Shape 28"/>
           <p:cNvSpPr/>
           <p:nvPr/>
         </p:nvSpPr>
@@ -1936,7 +1903,7 @@
       </p:sp>
       <p:sp>
         <p:nvSpPr>
-          <p:cNvPr id="36" name="Text 30"/>
+          <p:cNvPr id="35" name="Text 29"/>
           <p:cNvSpPr/>
           <p:nvPr/>
         </p:nvSpPr>
@@ -1975,7 +1942,7 @@
       </p:sp>
       <p:sp>
         <p:nvSpPr>
-          <p:cNvPr id="37" name="Text 31"/>
+          <p:cNvPr id="36" name="Text 30"/>
           <p:cNvSpPr/>
           <p:nvPr/>
         </p:nvSpPr>
@@ -2014,7 +1981,7 @@
       </p:sp>
       <p:sp>
         <p:nvSpPr>
-          <p:cNvPr id="38" name="Text 32"/>
+          <p:cNvPr id="37" name="Text 31"/>
           <p:cNvSpPr/>
           <p:nvPr/>
         </p:nvSpPr>
@@ -2053,7 +2020,7 @@
       </p:sp>
       <p:sp>
         <p:nvSpPr>
-          <p:cNvPr id="39" name="Shape 33"/>
+          <p:cNvPr id="38" name="Shape 32"/>
           <p:cNvSpPr/>
           <p:nvPr/>
         </p:nvSpPr>
@@ -2078,7 +2045,7 @@
       </p:sp>
       <p:sp>
         <p:nvSpPr>
-          <p:cNvPr id="40" name="Text 34"/>
+          <p:cNvPr id="39" name="Text 33"/>
           <p:cNvSpPr/>
           <p:nvPr/>
         </p:nvSpPr>
@@ -2117,7 +2084,7 @@
       </p:sp>
       <p:sp>
         <p:nvSpPr>
-          <p:cNvPr id="41" name="Text 35"/>
+          <p:cNvPr id="40" name="Text 34"/>
           <p:cNvSpPr/>
           <p:nvPr/>
         </p:nvSpPr>
@@ -2156,7 +2123,7 @@
       </p:sp>
       <p:sp>
         <p:nvSpPr>
-          <p:cNvPr id="42" name="Text 36"/>
+          <p:cNvPr id="41" name="Text 35"/>
           <p:cNvSpPr/>
           <p:nvPr/>
         </p:nvSpPr>
@@ -2195,7 +2162,7 @@
       </p:sp>
       <p:sp>
         <p:nvSpPr>
-          <p:cNvPr id="43" name="Shape 37"/>
+          <p:cNvPr id="42" name="Shape 36"/>
           <p:cNvSpPr/>
           <p:nvPr/>
         </p:nvSpPr>
@@ -2220,7 +2187,7 @@
       </p:sp>
       <p:sp>
         <p:nvSpPr>
-          <p:cNvPr id="44" name="Text 38"/>
+          <p:cNvPr id="43" name="Text 37"/>
           <p:cNvSpPr/>
           <p:nvPr/>
         </p:nvSpPr>
@@ -2259,7 +2226,7 @@
       </p:sp>
       <p:sp>
         <p:nvSpPr>
-          <p:cNvPr id="45" name="Text 39"/>
+          <p:cNvPr id="44" name="Text 38"/>
           <p:cNvSpPr/>
           <p:nvPr/>
         </p:nvSpPr>
@@ -2298,7 +2265,7 @@
       </p:sp>
       <p:sp>
         <p:nvSpPr>
-          <p:cNvPr id="46" name="Text 40"/>
+          <p:cNvPr id="45" name="Text 39"/>
           <p:cNvSpPr/>
           <p:nvPr/>
         </p:nvSpPr>
@@ -2329,7 +2296,7 @@
                 <a:ea typeface="Arial" pitchFamily="34" charset="-122"/>
                 <a:cs typeface="Arial" pitchFamily="34" charset="-120"/>
               </a:rPr>
-              <a:t>Develop the Combat Mindset Framework, delivery architecture and outcomes.</a:t>
+              <a:t>Develop the Combat Mindset Framework, delivery system and outcomes.</a:t>
             </a:r>
             <a:endParaRPr lang="en-US" sz="860" dirty="0"/>
           </a:p>
@@ -2337,7 +2304,7 @@
       </p:sp>
       <p:sp>
         <p:nvSpPr>
-          <p:cNvPr id="47" name="Shape 41"/>
+          <p:cNvPr id="46" name="Shape 40"/>
           <p:cNvSpPr/>
           <p:nvPr/>
         </p:nvSpPr>
@@ -2362,7 +2329,7 @@
       </p:sp>
       <p:sp>
         <p:nvSpPr>
-          <p:cNvPr id="48" name="Text 42"/>
+          <p:cNvPr id="47" name="Text 41"/>
           <p:cNvSpPr/>
           <p:nvPr/>
         </p:nvSpPr>
@@ -2401,7 +2368,7 @@
       </p:sp>
       <p:sp>
         <p:nvSpPr>
-          <p:cNvPr id="49" name="Text 43"/>
+          <p:cNvPr id="48" name="Text 42"/>
           <p:cNvSpPr/>
           <p:nvPr/>
         </p:nvSpPr>
@@ -2440,7 +2407,7 @@
       </p:sp>
       <p:sp>
         <p:nvSpPr>
-          <p:cNvPr id="50" name="Text 44"/>
+          <p:cNvPr id="49" name="Text 43"/>
           <p:cNvSpPr/>
           <p:nvPr/>
         </p:nvSpPr>
@@ -2479,7 +2446,7 @@
       </p:sp>
       <p:sp>
         <p:nvSpPr>
-          <p:cNvPr id="51" name="Shape 45"/>
+          <p:cNvPr id="50" name="Shape 44"/>
           <p:cNvSpPr/>
           <p:nvPr/>
         </p:nvSpPr>
@@ -2504,7 +2471,7 @@
       </p:sp>
       <p:sp>
         <p:nvSpPr>
-          <p:cNvPr id="52" name="Text 46"/>
+          <p:cNvPr id="51" name="Text 45"/>
           <p:cNvSpPr/>
           <p:nvPr/>
         </p:nvSpPr>
@@ -2543,7 +2510,7 @@
       </p:sp>
       <p:sp>
         <p:nvSpPr>
-          <p:cNvPr id="53" name="Text 47"/>
+          <p:cNvPr id="52" name="Text 46"/>
           <p:cNvSpPr/>
           <p:nvPr/>
         </p:nvSpPr>
@@ -2582,7 +2549,7 @@
       </p:sp>
       <p:sp>
         <p:nvSpPr>
-          <p:cNvPr id="54" name="Text 48"/>
+          <p:cNvPr id="53" name="Text 47"/>
           <p:cNvSpPr/>
           <p:nvPr/>
         </p:nvSpPr>

</xml_diff>

<commit_message>
Two-word connectors and layered tagline emphasis
Connector 2 shortened to "organised through" (all connectors now two
words). Combat Mindset card tagline split across two lines: "Remain
effective. Act decisively." in regular white, "Harder to kill." in
bold Army Red - capability, action, outcome. Paper embed regenerated.

Co-Authored-By: Claude Fable 5 <noreply@anthropic.com>
Claude-Session: https://claude.ai/code/session_01YLo1WfwUDkbwfJEF3ZNVbB
</commit_message>
<xml_diff>
--- a/output/combat-mindset-onepager-portrait.pptx
+++ b/output/combat-mindset-onepager-portrait.pptx
@@ -1120,7 +1120,7 @@
         </p:blipFill>
         <p:spPr>
           <a:xfrm>
-            <a:off x="731520" y="1810512"/>
+            <a:off x="731520" y="1773936"/>
             <a:ext cx="713232" cy="713232"/>
           </a:xfrm>
           <a:prstGeom prst="rect">
@@ -1136,8 +1136,8 @@
         </p:nvSpPr>
         <p:spPr>
           <a:xfrm>
-            <a:off x="457200" y="1810512"/>
-            <a:ext cx="6647688" cy="548640"/>
+            <a:off x="457200" y="1755648"/>
+            <a:ext cx="6647688" cy="530352"/>
           </a:xfrm>
           <a:prstGeom prst="rect">
             <a:avLst/>
@@ -1175,8 +1175,8 @@
         </p:nvSpPr>
         <p:spPr>
           <a:xfrm>
-            <a:off x="457200" y="2395728"/>
-            <a:ext cx="6647688" cy="274320"/>
+            <a:off x="457200" y="2304288"/>
+            <a:ext cx="6647688" cy="219456"/>
           </a:xfrm>
           <a:prstGeom prst="rect">
             <a:avLst/>
@@ -1192,7 +1192,46 @@
               <a:buNone/>
             </a:pPr>
             <a:r>
-              <a:rPr lang="en-US" sz="1400" b="1" dirty="0">
+              <a:rPr lang="en-US" sz="1350" dirty="0">
+                <a:solidFill>
+                  <a:srgbClr val="FFFFFF"/>
+                </a:solidFill>
+                <a:latin typeface="Arial" pitchFamily="34" charset="0"/>
+                <a:ea typeface="Arial" pitchFamily="34" charset="-122"/>
+                <a:cs typeface="Arial" pitchFamily="34" charset="-120"/>
+              </a:rPr>
+              <a:t>Remain effective. Act decisively.</a:t>
+            </a:r>
+            <a:endParaRPr lang="en-US" sz="1350" dirty="0"/>
+          </a:p>
+        </p:txBody>
+      </p:sp>
+      <p:sp>
+        <p:nvSpPr>
+          <p:cNvPr id="12" name="Text 8"/>
+          <p:cNvSpPr/>
+          <p:nvPr/>
+        </p:nvSpPr>
+        <p:spPr>
+          <a:xfrm>
+            <a:off x="457200" y="2523744"/>
+            <a:ext cx="6647688" cy="256032"/>
+          </a:xfrm>
+          <a:prstGeom prst="rect">
+            <a:avLst/>
+          </a:prstGeom>
+          <a:noFill/>
+          <a:ln/>
+        </p:spPr>
+        <p:txBody>
+          <a:bodyPr wrap="square" lIns="0" tIns="0" rIns="0" bIns="0" rtlCol="0" anchor="ctr"/>
+          <a:lstStyle/>
+          <a:p>
+            <a:pPr algn="ctr" indent="0" marL="0">
+              <a:buNone/>
+            </a:pPr>
+            <a:r>
+              <a:rPr lang="en-US" sz="1350" b="1" dirty="0">
                 <a:solidFill>
                   <a:srgbClr val="C62026"/>
                 </a:solidFill>
@@ -1200,15 +1239,15 @@
                 <a:ea typeface="Arial" pitchFamily="34" charset="-122"/>
                 <a:cs typeface="Arial" pitchFamily="34" charset="-120"/>
               </a:rPr>
-              <a:t>Remain effective. Act decisively. Harder to kill.</a:t>
-            </a:r>
-            <a:endParaRPr lang="en-US" sz="1400" dirty="0"/>
-          </a:p>
-        </p:txBody>
-      </p:sp>
-      <p:sp>
-        <p:nvSpPr>
-          <p:cNvPr id="12" name="Shape 8"/>
+              <a:t>Harder to kill.</a:t>
+            </a:r>
+            <a:endParaRPr lang="en-US" sz="1350" dirty="0"/>
+          </a:p>
+        </p:txBody>
+      </p:sp>
+      <p:sp>
+        <p:nvSpPr>
+          <p:cNvPr id="13" name="Shape 9"/>
           <p:cNvSpPr/>
           <p:nvPr/>
         </p:nvSpPr>
@@ -1230,7 +1269,7 @@
       </p:sp>
       <p:sp>
         <p:nvSpPr>
-          <p:cNvPr id="13" name="Text 9"/>
+          <p:cNvPr id="14" name="Text 10"/>
           <p:cNvSpPr/>
           <p:nvPr/>
         </p:nvSpPr>
@@ -1269,7 +1308,7 @@
       </p:sp>
       <p:sp>
         <p:nvSpPr>
-          <p:cNvPr id="14" name="Shape 10"/>
+          <p:cNvPr id="15" name="Shape 11"/>
           <p:cNvSpPr/>
           <p:nvPr/>
         </p:nvSpPr>
@@ -1289,7 +1328,7 @@
       </p:sp>
       <p:sp>
         <p:nvSpPr>
-          <p:cNvPr id="15" name="Shape 11"/>
+          <p:cNvPr id="16" name="Shape 12"/>
           <p:cNvSpPr/>
           <p:nvPr/>
         </p:nvSpPr>
@@ -1316,7 +1355,7 @@
       </p:sp>
       <p:sp>
         <p:nvSpPr>
-          <p:cNvPr id="16" name="Text 12"/>
+          <p:cNvPr id="17" name="Text 13"/>
           <p:cNvSpPr/>
           <p:nvPr/>
         </p:nvSpPr>
@@ -1355,7 +1394,7 @@
       </p:sp>
       <p:pic>
         <p:nvPicPr>
-          <p:cNvPr id="17" name="Image 2" descr="preencoded.png">    </p:cNvPr>
+          <p:cNvPr id="18" name="Image 2" descr="preencoded.png">    </p:cNvPr>
           <p:cNvPicPr>
             <a:picLocks noChangeAspect="1"/>
           </p:cNvPicPr>
@@ -1379,7 +1418,7 @@
       </p:pic>
       <p:sp>
         <p:nvSpPr>
-          <p:cNvPr id="18" name="Text 13"/>
+          <p:cNvPr id="19" name="Text 14"/>
           <p:cNvSpPr/>
           <p:nvPr/>
         </p:nvSpPr>
@@ -1418,7 +1457,7 @@
       </p:sp>
       <p:sp>
         <p:nvSpPr>
-          <p:cNvPr id="19" name="Text 14"/>
+          <p:cNvPr id="20" name="Text 15"/>
           <p:cNvSpPr/>
           <p:nvPr/>
         </p:nvSpPr>
@@ -1457,7 +1496,7 @@
       </p:sp>
       <p:sp>
         <p:nvSpPr>
-          <p:cNvPr id="20" name="Shape 15"/>
+          <p:cNvPr id="21" name="Shape 16"/>
           <p:cNvSpPr/>
           <p:nvPr/>
         </p:nvSpPr>
@@ -1479,7 +1518,7 @@
       </p:sp>
       <p:sp>
         <p:nvSpPr>
-          <p:cNvPr id="21" name="Text 16"/>
+          <p:cNvPr id="22" name="Text 17"/>
           <p:cNvSpPr/>
           <p:nvPr/>
         </p:nvSpPr>
@@ -1510,7 +1549,7 @@
                 <a:ea typeface="Arial" pitchFamily="34" charset="-122"/>
                 <a:cs typeface="Arial" pitchFamily="34" charset="-120"/>
               </a:rPr>
-              <a:t>developed, organised and assured through</a:t>
+              <a:t>organised through</a:t>
             </a:r>
             <a:endParaRPr lang="en-US" sz="800" dirty="0"/>
           </a:p>
@@ -1518,7 +1557,7 @@
       </p:sp>
       <p:sp>
         <p:nvSpPr>
-          <p:cNvPr id="22" name="Shape 17"/>
+          <p:cNvPr id="23" name="Shape 18"/>
           <p:cNvSpPr/>
           <p:nvPr/>
         </p:nvSpPr>
@@ -1538,7 +1577,7 @@
       </p:sp>
       <p:sp>
         <p:nvSpPr>
-          <p:cNvPr id="23" name="Shape 18"/>
+          <p:cNvPr id="24" name="Shape 19"/>
           <p:cNvSpPr/>
           <p:nvPr/>
         </p:nvSpPr>
@@ -1565,7 +1604,7 @@
       </p:sp>
       <p:sp>
         <p:nvSpPr>
-          <p:cNvPr id="24" name="Text 19"/>
+          <p:cNvPr id="25" name="Text 20"/>
           <p:cNvSpPr/>
           <p:nvPr/>
         </p:nvSpPr>
@@ -1604,7 +1643,7 @@
       </p:sp>
       <p:pic>
         <p:nvPicPr>
-          <p:cNvPr id="25" name="Image 3" descr="preencoded.png">    </p:cNvPr>
+          <p:cNvPr id="26" name="Image 3" descr="preencoded.png">    </p:cNvPr>
           <p:cNvPicPr>
             <a:picLocks noChangeAspect="1"/>
           </p:cNvPicPr>
@@ -1628,7 +1667,7 @@
       </p:pic>
       <p:sp>
         <p:nvSpPr>
-          <p:cNvPr id="26" name="Text 20"/>
+          <p:cNvPr id="27" name="Text 21"/>
           <p:cNvSpPr/>
           <p:nvPr/>
         </p:nvSpPr>
@@ -1667,7 +1706,7 @@
       </p:sp>
       <p:sp>
         <p:nvSpPr>
-          <p:cNvPr id="27" name="Text 21"/>
+          <p:cNvPr id="28" name="Text 22"/>
           <p:cNvSpPr/>
           <p:nvPr/>
         </p:nvSpPr>
@@ -1706,7 +1745,7 @@
       </p:sp>
       <p:sp>
         <p:nvSpPr>
-          <p:cNvPr id="28" name="Shape 22"/>
+          <p:cNvPr id="29" name="Shape 23"/>
           <p:cNvSpPr/>
           <p:nvPr/>
         </p:nvSpPr>
@@ -1728,7 +1767,7 @@
       </p:sp>
       <p:sp>
         <p:nvSpPr>
-          <p:cNvPr id="29" name="Text 23"/>
+          <p:cNvPr id="30" name="Text 24"/>
           <p:cNvSpPr/>
           <p:nvPr/>
         </p:nvSpPr>
@@ -1767,7 +1806,7 @@
       </p:sp>
       <p:sp>
         <p:nvSpPr>
-          <p:cNvPr id="30" name="Shape 24"/>
+          <p:cNvPr id="31" name="Shape 25"/>
           <p:cNvSpPr/>
           <p:nvPr/>
         </p:nvSpPr>
@@ -1789,7 +1828,7 @@
       </p:sp>
       <p:sp>
         <p:nvSpPr>
-          <p:cNvPr id="31" name="Shape 25"/>
+          <p:cNvPr id="32" name="Shape 26"/>
           <p:cNvSpPr/>
           <p:nvPr/>
         </p:nvSpPr>
@@ -1816,7 +1855,7 @@
       </p:sp>
       <p:sp>
         <p:nvSpPr>
-          <p:cNvPr id="32" name="Text 26"/>
+          <p:cNvPr id="33" name="Text 27"/>
           <p:cNvSpPr/>
           <p:nvPr/>
         </p:nvSpPr>
@@ -1855,7 +1894,7 @@
       </p:sp>
       <p:sp>
         <p:nvSpPr>
-          <p:cNvPr id="33" name="Shape 27"/>
+          <p:cNvPr id="34" name="Shape 28"/>
           <p:cNvSpPr/>
           <p:nvPr/>
         </p:nvSpPr>
@@ -1878,7 +1917,7 @@
       </p:sp>
       <p:sp>
         <p:nvSpPr>
-          <p:cNvPr id="34" name="Shape 28"/>
+          <p:cNvPr id="35" name="Shape 29"/>
           <p:cNvSpPr/>
           <p:nvPr/>
         </p:nvSpPr>
@@ -1903,7 +1942,7 @@
       </p:sp>
       <p:sp>
         <p:nvSpPr>
-          <p:cNvPr id="35" name="Text 29"/>
+          <p:cNvPr id="36" name="Text 30"/>
           <p:cNvSpPr/>
           <p:nvPr/>
         </p:nvSpPr>
@@ -1942,7 +1981,7 @@
       </p:sp>
       <p:sp>
         <p:nvSpPr>
-          <p:cNvPr id="36" name="Text 30"/>
+          <p:cNvPr id="37" name="Text 31"/>
           <p:cNvSpPr/>
           <p:nvPr/>
         </p:nvSpPr>
@@ -1981,7 +2020,7 @@
       </p:sp>
       <p:sp>
         <p:nvSpPr>
-          <p:cNvPr id="37" name="Text 31"/>
+          <p:cNvPr id="38" name="Text 32"/>
           <p:cNvSpPr/>
           <p:nvPr/>
         </p:nvSpPr>
@@ -2020,7 +2059,7 @@
       </p:sp>
       <p:sp>
         <p:nvSpPr>
-          <p:cNvPr id="38" name="Shape 32"/>
+          <p:cNvPr id="39" name="Shape 33"/>
           <p:cNvSpPr/>
           <p:nvPr/>
         </p:nvSpPr>
@@ -2045,7 +2084,7 @@
       </p:sp>
       <p:sp>
         <p:nvSpPr>
-          <p:cNvPr id="39" name="Text 33"/>
+          <p:cNvPr id="40" name="Text 34"/>
           <p:cNvSpPr/>
           <p:nvPr/>
         </p:nvSpPr>
@@ -2084,7 +2123,7 @@
       </p:sp>
       <p:sp>
         <p:nvSpPr>
-          <p:cNvPr id="40" name="Text 34"/>
+          <p:cNvPr id="41" name="Text 35"/>
           <p:cNvSpPr/>
           <p:nvPr/>
         </p:nvSpPr>
@@ -2123,7 +2162,7 @@
       </p:sp>
       <p:sp>
         <p:nvSpPr>
-          <p:cNvPr id="41" name="Text 35"/>
+          <p:cNvPr id="42" name="Text 36"/>
           <p:cNvSpPr/>
           <p:nvPr/>
         </p:nvSpPr>
@@ -2162,7 +2201,7 @@
       </p:sp>
       <p:sp>
         <p:nvSpPr>
-          <p:cNvPr id="42" name="Shape 36"/>
+          <p:cNvPr id="43" name="Shape 37"/>
           <p:cNvSpPr/>
           <p:nvPr/>
         </p:nvSpPr>
@@ -2187,7 +2226,7 @@
       </p:sp>
       <p:sp>
         <p:nvSpPr>
-          <p:cNvPr id="43" name="Text 37"/>
+          <p:cNvPr id="44" name="Text 38"/>
           <p:cNvSpPr/>
           <p:nvPr/>
         </p:nvSpPr>
@@ -2226,7 +2265,7 @@
       </p:sp>
       <p:sp>
         <p:nvSpPr>
-          <p:cNvPr id="44" name="Text 38"/>
+          <p:cNvPr id="45" name="Text 39"/>
           <p:cNvSpPr/>
           <p:nvPr/>
         </p:nvSpPr>
@@ -2265,7 +2304,7 @@
       </p:sp>
       <p:sp>
         <p:nvSpPr>
-          <p:cNvPr id="45" name="Text 39"/>
+          <p:cNvPr id="46" name="Text 40"/>
           <p:cNvSpPr/>
           <p:nvPr/>
         </p:nvSpPr>
@@ -2304,7 +2343,7 @@
       </p:sp>
       <p:sp>
         <p:nvSpPr>
-          <p:cNvPr id="46" name="Shape 40"/>
+          <p:cNvPr id="47" name="Shape 41"/>
           <p:cNvSpPr/>
           <p:nvPr/>
         </p:nvSpPr>
@@ -2329,7 +2368,7 @@
       </p:sp>
       <p:sp>
         <p:nvSpPr>
-          <p:cNvPr id="47" name="Text 41"/>
+          <p:cNvPr id="48" name="Text 42"/>
           <p:cNvSpPr/>
           <p:nvPr/>
         </p:nvSpPr>
@@ -2368,7 +2407,7 @@
       </p:sp>
       <p:sp>
         <p:nvSpPr>
-          <p:cNvPr id="48" name="Text 42"/>
+          <p:cNvPr id="49" name="Text 43"/>
           <p:cNvSpPr/>
           <p:nvPr/>
         </p:nvSpPr>
@@ -2407,7 +2446,7 @@
       </p:sp>
       <p:sp>
         <p:nvSpPr>
-          <p:cNvPr id="49" name="Text 43"/>
+          <p:cNvPr id="50" name="Text 44"/>
           <p:cNvSpPr/>
           <p:nvPr/>
         </p:nvSpPr>
@@ -2446,7 +2485,7 @@
       </p:sp>
       <p:sp>
         <p:nvSpPr>
-          <p:cNvPr id="50" name="Shape 44"/>
+          <p:cNvPr id="51" name="Shape 45"/>
           <p:cNvSpPr/>
           <p:nvPr/>
         </p:nvSpPr>
@@ -2471,7 +2510,7 @@
       </p:sp>
       <p:sp>
         <p:nvSpPr>
-          <p:cNvPr id="51" name="Text 45"/>
+          <p:cNvPr id="52" name="Text 46"/>
           <p:cNvSpPr/>
           <p:nvPr/>
         </p:nvSpPr>
@@ -2510,7 +2549,7 @@
       </p:sp>
       <p:sp>
         <p:nvSpPr>
-          <p:cNvPr id="52" name="Text 46"/>
+          <p:cNvPr id="53" name="Text 47"/>
           <p:cNvSpPr/>
           <p:nvPr/>
         </p:nvSpPr>
@@ -2549,7 +2588,7 @@
       </p:sp>
       <p:sp>
         <p:nvSpPr>
-          <p:cNvPr id="53" name="Text 47"/>
+          <p:cNvPr id="54" name="Text 48"/>
           <p:cNvSpPr/>
           <p:nvPr/>
         </p:nvSpPr>

</xml_diff>

<commit_message>
Apply shield emblem family to the framework proposal page
Shield family (family C) replaces the placeholder icons on all three
banners: ringed shield-and-chevron for Combat Mindset, shield within
the Prepare-Perform-Recover arcs for Performance Under Pressure, and
shield on the organising grid for the Framework. Emblems drawn as
parametric SVG in the builder. Paper embed regenerated.

Co-Authored-By: Claude Fable 5 <noreply@anthropic.com>
Claude-Session: https://claude.ai/code/session_01YLo1WfwUDkbwfJEF3ZNVbB
</commit_message>
<xml_diff>
--- a/output/combat-mindset-onepager-portrait.pptx
+++ b/output/combat-mindset-onepager-portrait.pptx
@@ -1111,9 +1111,7 @@
           <p:nvPr/>
         </p:nvPicPr>
         <p:blipFill>
-          <a:blip r:embed="rId2">
-            <a:alphaModFix amt="60000"/>
-          </a:blip>
+          <a:blip r:embed="rId2"/>
           <a:stretch>
             <a:fillRect/>
           </a:stretch>
@@ -1121,7 +1119,7 @@
         <p:spPr>
           <a:xfrm>
             <a:off x="731520" y="1773936"/>
-            <a:ext cx="713232" cy="713232"/>
+            <a:ext cx="749808" cy="749808"/>
           </a:xfrm>
           <a:prstGeom prst="rect">
             <a:avLst/>
@@ -1408,8 +1406,8 @@
         </p:blipFill>
         <p:spPr>
           <a:xfrm>
-            <a:off x="658368" y="3803904"/>
-            <a:ext cx="438912" cy="438912"/>
+            <a:off x="694944" y="3749040"/>
+            <a:ext cx="548640" cy="548640"/>
           </a:xfrm>
           <a:prstGeom prst="rect">
             <a:avLst/>
@@ -1657,8 +1655,8 @@
         </p:blipFill>
         <p:spPr>
           <a:xfrm>
-            <a:off x="658368" y="5486400"/>
-            <a:ext cx="402336" cy="402336"/>
+            <a:off x="694944" y="5431536"/>
+            <a:ext cx="530352" cy="530352"/>
           </a:xfrm>
           <a:prstGeom prst="rect">
             <a:avLst/>

</xml_diff>

<commit_message>
Soften main card corners (0.08in radius)
The four section cards now use gently rounded corners, matching the
capsule labels' language. Paper embed regenerated.

Co-Authored-By: Claude Fable 5 <noreply@anthropic.com>
Claude-Session: https://claude.ai/code/session_01YLo1WfwUDkbwfJEF3ZNVbB
</commit_message>
<xml_diff>
--- a/output/combat-mindset-onepager-portrait.pptx
+++ b/output/combat-mindset-onepager-portrait.pptx
@@ -1027,8 +1027,10 @@
             <a:off x="457200" y="1481328"/>
             <a:ext cx="6647688" cy="1371600"/>
           </a:xfrm>
-          <a:prstGeom prst="rect">
-            <a:avLst/>
+          <a:prstGeom prst="roundRect">
+            <a:avLst>
+              <a:gd name="adj" fmla="val 5333"/>
+            </a:avLst>
           </a:prstGeom>
           <a:solidFill>
             <a:srgbClr val="000000"/>
@@ -1315,8 +1317,10 @@
             <a:off x="457200" y="3474720"/>
             <a:ext cx="6647688" cy="1097280"/>
           </a:xfrm>
-          <a:prstGeom prst="rect">
-            <a:avLst/>
+          <a:prstGeom prst="roundRect">
+            <a:avLst>
+              <a:gd name="adj" fmla="val 6667"/>
+            </a:avLst>
           </a:prstGeom>
           <a:solidFill>
             <a:srgbClr val="002516"/>
@@ -1564,8 +1568,10 @@
             <a:off x="457200" y="5193792"/>
             <a:ext cx="6647688" cy="1024128"/>
           </a:xfrm>
-          <a:prstGeom prst="rect">
-            <a:avLst/>
+          <a:prstGeom prst="roundRect">
+            <a:avLst>
+              <a:gd name="adj" fmla="val 7143"/>
+            </a:avLst>
           </a:prstGeom>
           <a:solidFill>
             <a:srgbClr val="3A4B00"/>
@@ -1813,8 +1819,10 @@
             <a:off x="457200" y="6839712"/>
             <a:ext cx="6647688" cy="3438144"/>
           </a:xfrm>
-          <a:prstGeom prst="rect">
-            <a:avLst/>
+          <a:prstGeom prst="roundRect">
+            <a:avLst>
+              <a:gd name="adj" fmla="val 2128"/>
+            </a:avLst>
           </a:prstGeom>
           <a:solidFill>
             <a:srgbClr val="CDD2B7">

</xml_diff>

<commit_message>
Match card 2 and card 3 title sizes (22.5pt)
Combat Mindset Framework title raised from 17.5pt to match Performance
Under Pressure; the two enabling/organising cards now read as peers
beneath the Combat Mindset hero. Paper embed regenerated.

Co-Authored-By: Claude Fable 5 <noreply@anthropic.com>
Claude-Session: https://claude.ai/code/session_01YLo1WfwUDkbwfJEF3ZNVbB
</commit_message>
<xml_diff>
--- a/output/combat-mindset-onepager-portrait.pptx
+++ b/output/combat-mindset-onepager-portrait.pptx
@@ -1677,8 +1677,8 @@
         </p:nvSpPr>
         <p:spPr>
           <a:xfrm>
-            <a:off x="457200" y="5394960"/>
-            <a:ext cx="6647688" cy="365760"/>
+            <a:off x="457200" y="5358384"/>
+            <a:ext cx="6647688" cy="402336"/>
           </a:xfrm>
           <a:prstGeom prst="rect">
             <a:avLst/>
@@ -1694,7 +1694,7 @@
               <a:buNone/>
             </a:pPr>
             <a:r>
-              <a:rPr lang="en-US" sz="1750" b="1" dirty="0">
+              <a:rPr lang="en-US" sz="2250" b="1" dirty="0">
                 <a:solidFill>
                   <a:srgbClr val="FFFFFF"/>
                 </a:solidFill>
@@ -1704,7 +1704,7 @@
               </a:rPr>
               <a:t>COMBAT MINDSET FRAMEWORK</a:t>
             </a:r>
-            <a:endParaRPr lang="en-US" sz="1750" dirty="0"/>
+            <a:endParaRPr lang="en-US" sz="2250" dirty="0"/>
           </a:p>
         </p:txBody>
       </p:sp>

</xml_diff>

<commit_message>
Card 2 capsule: ENABLING CAPABILITY
Co-Authored-By: Claude Fable 5 <noreply@anthropic.com>
Claude-Session: https://claude.ai/code/session_01YLo1WfwUDkbwfJEF3ZNVbB
</commit_message>
<xml_diff>
--- a/output/combat-mindset-onepager-portrait.pptx
+++ b/output/combat-mindset-onepager-portrait.pptx
@@ -1336,8 +1336,8 @@
         </p:nvSpPr>
         <p:spPr>
           <a:xfrm>
-            <a:off x="1952244" y="3364992"/>
-            <a:ext cx="3657600" cy="219456"/>
+            <a:off x="2706624" y="3364992"/>
+            <a:ext cx="2148840" cy="219456"/>
           </a:xfrm>
           <a:prstGeom prst="roundRect">
             <a:avLst>
@@ -1363,8 +1363,8 @@
         </p:nvSpPr>
         <p:spPr>
           <a:xfrm>
-            <a:off x="1952244" y="3364992"/>
-            <a:ext cx="3657600" cy="219456"/>
+            <a:off x="2706624" y="3364992"/>
+            <a:ext cx="2148840" cy="219456"/>
           </a:xfrm>
           <a:prstGeom prst="rect">
             <a:avLst/>
@@ -1388,7 +1388,7 @@
                 <a:ea typeface="Arial" pitchFamily="34" charset="-122"/>
                 <a:cs typeface="Arial" pitchFamily="34" charset="-120"/>
               </a:rPr>
-              <a:t>2)  ENABLING HUMAN-PERFORMANCE CAPABILITY</a:t>
+              <a:t>2)  ENABLING CAPABILITY</a:t>
             </a:r>
             <a:endParaRPr lang="en-US" sz="780" dirty="0"/>
           </a:p>

</xml_diff>

<commit_message>
Card 2 subordinate line sized to match card 3 (9.5pt)
Co-Authored-By: Claude Fable 5 <noreply@anthropic.com>
Claude-Session: https://claude.ai/code/session_01YLo1WfwUDkbwfJEF3ZNVbB
</commit_message>
<xml_diff>
--- a/output/combat-mindset-onepager-portrait.pptx
+++ b/output/combat-mindset-onepager-portrait.pptx
@@ -1482,7 +1482,7 @@
               <a:buNone/>
             </a:pPr>
             <a:r>
-              <a:rPr lang="en-US" sz="1200" b="1" dirty="0">
+              <a:rPr lang="en-US" sz="950" b="1" dirty="0">
                 <a:solidFill>
                   <a:srgbClr val="FFFFFF"/>
                 </a:solidFill>
@@ -1492,7 +1492,7 @@
               </a:rPr>
               <a:t>Prepare   •   Perform   •   Recover</a:t>
             </a:r>
-            <a:endParaRPr lang="en-US" sz="1200" dirty="0"/>
+            <a:endParaRPr lang="en-US" sz="950" dirty="0"/>
           </a:p>
         </p:txBody>
       </p:sp>

</xml_diff>

<commit_message>
Name the service on the model page and drop the card connectors
Title now reads NZ Army Combat Mindset Framework Proposal so the paper is
clearly a single-service body of work. Remove the enabled by, organised
through and achieved through connectors and their arrows, close the gaps
they left, and give the programme card the reclaimed height.

Co-Authored-By: Claude Fable 5 <noreply@anthropic.com>
Claude-Session: https://claude.ai/code/session_01YLo1WfwUDkbwfJEF3ZNVbB
</commit_message>
<xml_diff>
--- a/output/combat-mindset-onepager-portrait.pptx
+++ b/output/combat-mindset-onepager-portrait.pptx
@@ -924,7 +924,7 @@
               <a:buNone/>
             </a:pPr>
             <a:r>
-              <a:rPr lang="en-US" sz="1700" b="1" dirty="0">
+              <a:rPr lang="en-US" sz="1600" b="1" dirty="0">
                 <a:solidFill>
                   <a:srgbClr val="000000"/>
                 </a:solidFill>
@@ -932,9 +932,9 @@
                 <a:ea typeface="Arial" pitchFamily="34" charset="-122"/>
                 <a:cs typeface="Arial" pitchFamily="34" charset="-120"/>
               </a:rPr>
-              <a:t>COMBAT MINDSET FRAMEWORK PROPOSAL</a:t>
-            </a:r>
-            <a:endParaRPr lang="en-US" sz="1700" dirty="0"/>
+              <a:t>NZ ARMY COMBAT MINDSET FRAMEWORK PROPOSAL</a:t>
+            </a:r>
+            <a:endParaRPr lang="en-US" sz="1600" dirty="0"/>
           </a:p>
         </p:txBody>
       </p:sp>
@@ -1252,69 +1252,8 @@
           <p:nvPr/>
         </p:nvSpPr>
         <p:spPr>
-          <a:xfrm rot="10800000">
-            <a:off x="3717036" y="2962656"/>
-            <a:ext cx="128016" cy="100584"/>
-          </a:xfrm>
-          <a:prstGeom prst="triangle">
-            <a:avLst/>
-          </a:prstGeom>
-          <a:solidFill>
-            <a:srgbClr val="002516">
-              <a:alpha val="55000"/>
-            </a:srgbClr>
-          </a:solidFill>
-          <a:ln/>
-        </p:spPr>
-      </p:sp>
-      <p:sp>
-        <p:nvSpPr>
-          <p:cNvPr id="14" name="Text 10"/>
-          <p:cNvSpPr/>
-          <p:nvPr/>
-        </p:nvSpPr>
-        <p:spPr>
-          <a:xfrm>
-            <a:off x="2043684" y="3081528"/>
-            <a:ext cx="3474720" cy="146304"/>
-          </a:xfrm>
-          <a:prstGeom prst="rect">
-            <a:avLst/>
-          </a:prstGeom>
-          <a:noFill/>
-          <a:ln/>
-        </p:spPr>
-        <p:txBody>
-          <a:bodyPr wrap="square" lIns="0" tIns="0" rIns="0" bIns="0" rtlCol="0" anchor="ctr"/>
-          <a:lstStyle/>
-          <a:p>
-            <a:pPr algn="ctr" indent="0" marL="0">
-              <a:buNone/>
-            </a:pPr>
-            <a:r>
-              <a:rPr lang="en-US" sz="800" i="1" dirty="0">
-                <a:solidFill>
-                  <a:srgbClr val="7F7F7F"/>
-                </a:solidFill>
-                <a:latin typeface="Arial" pitchFamily="34" charset="0"/>
-                <a:ea typeface="Arial" pitchFamily="34" charset="-122"/>
-                <a:cs typeface="Arial" pitchFamily="34" charset="-120"/>
-              </a:rPr>
-              <a:t>enabled by</a:t>
-            </a:r>
-            <a:endParaRPr lang="en-US" sz="800" dirty="0"/>
-          </a:p>
-        </p:txBody>
-      </p:sp>
-      <p:sp>
-        <p:nvSpPr>
-          <p:cNvPr id="15" name="Shape 11"/>
-          <p:cNvSpPr/>
-          <p:nvPr/>
-        </p:nvSpPr>
-        <p:spPr>
-          <a:xfrm>
-            <a:off x="457200" y="3474720"/>
+          <a:xfrm>
+            <a:off x="457200" y="3236976"/>
             <a:ext cx="6647688" cy="1097280"/>
           </a:xfrm>
           <a:prstGeom prst="roundRect">
@@ -1330,13 +1269,13 @@
       </p:sp>
       <p:sp>
         <p:nvSpPr>
-          <p:cNvPr id="16" name="Shape 12"/>
-          <p:cNvSpPr/>
-          <p:nvPr/>
-        </p:nvSpPr>
-        <p:spPr>
-          <a:xfrm>
-            <a:off x="2706624" y="3364992"/>
+          <p:cNvPr id="14" name="Shape 10"/>
+          <p:cNvSpPr/>
+          <p:nvPr/>
+        </p:nvSpPr>
+        <p:spPr>
+          <a:xfrm>
+            <a:off x="2706624" y="3127248"/>
             <a:ext cx="2148840" cy="219456"/>
           </a:xfrm>
           <a:prstGeom prst="roundRect">
@@ -1357,13 +1296,13 @@
       </p:sp>
       <p:sp>
         <p:nvSpPr>
-          <p:cNvPr id="17" name="Text 13"/>
-          <p:cNvSpPr/>
-          <p:nvPr/>
-        </p:nvSpPr>
-        <p:spPr>
-          <a:xfrm>
-            <a:off x="2706624" y="3364992"/>
+          <p:cNvPr id="15" name="Text 11"/>
+          <p:cNvSpPr/>
+          <p:nvPr/>
+        </p:nvSpPr>
+        <p:spPr>
+          <a:xfrm>
+            <a:off x="2706624" y="3127248"/>
             <a:ext cx="2148840" cy="219456"/>
           </a:xfrm>
           <a:prstGeom prst="rect">
@@ -1396,7 +1335,7 @@
       </p:sp>
       <p:pic>
         <p:nvPicPr>
-          <p:cNvPr id="18" name="Image 2" descr="preencoded.png">    </p:cNvPr>
+          <p:cNvPr id="16" name="Image 2" descr="preencoded.png">    </p:cNvPr>
           <p:cNvPicPr>
             <a:picLocks noChangeAspect="1"/>
           </p:cNvPicPr>
@@ -1410,7 +1349,7 @@
         </p:blipFill>
         <p:spPr>
           <a:xfrm>
-            <a:off x="694944" y="3749040"/>
+            <a:off x="694944" y="3511296"/>
             <a:ext cx="548640" cy="548640"/>
           </a:xfrm>
           <a:prstGeom prst="rect">
@@ -1420,13 +1359,13 @@
       </p:pic>
       <p:sp>
         <p:nvSpPr>
-          <p:cNvPr id="19" name="Text 14"/>
-          <p:cNvSpPr/>
-          <p:nvPr/>
-        </p:nvSpPr>
-        <p:spPr>
-          <a:xfrm>
-            <a:off x="457200" y="3712464"/>
+          <p:cNvPr id="17" name="Text 12"/>
+          <p:cNvSpPr/>
+          <p:nvPr/>
+        </p:nvSpPr>
+        <p:spPr>
+          <a:xfrm>
+            <a:off x="457200" y="3474720"/>
             <a:ext cx="6647688" cy="420624"/>
           </a:xfrm>
           <a:prstGeom prst="rect">
@@ -1459,13 +1398,13 @@
       </p:sp>
       <p:sp>
         <p:nvSpPr>
-          <p:cNvPr id="20" name="Text 15"/>
-          <p:cNvSpPr/>
-          <p:nvPr/>
-        </p:nvSpPr>
-        <p:spPr>
-          <a:xfrm>
-            <a:off x="457200" y="4169664"/>
+          <p:cNvPr id="18" name="Text 13"/>
+          <p:cNvSpPr/>
+          <p:nvPr/>
+        </p:nvSpPr>
+        <p:spPr>
+          <a:xfrm>
+            <a:off x="457200" y="3931920"/>
             <a:ext cx="6647688" cy="237744"/>
           </a:xfrm>
           <a:prstGeom prst="rect">
@@ -1498,74 +1437,13 @@
       </p:sp>
       <p:sp>
         <p:nvSpPr>
-          <p:cNvPr id="21" name="Shape 16"/>
-          <p:cNvSpPr/>
-          <p:nvPr/>
-        </p:nvSpPr>
-        <p:spPr>
-          <a:xfrm rot="10800000">
-            <a:off x="3717036" y="4681728"/>
-            <a:ext cx="128016" cy="100584"/>
-          </a:xfrm>
-          <a:prstGeom prst="triangle">
-            <a:avLst/>
-          </a:prstGeom>
-          <a:solidFill>
-            <a:srgbClr val="002516">
-              <a:alpha val="55000"/>
-            </a:srgbClr>
-          </a:solidFill>
-          <a:ln/>
-        </p:spPr>
-      </p:sp>
-      <p:sp>
-        <p:nvSpPr>
-          <p:cNvPr id="22" name="Text 17"/>
-          <p:cNvSpPr/>
-          <p:nvPr/>
-        </p:nvSpPr>
-        <p:spPr>
-          <a:xfrm>
-            <a:off x="2043684" y="4800600"/>
-            <a:ext cx="3474720" cy="146304"/>
-          </a:xfrm>
-          <a:prstGeom prst="rect">
-            <a:avLst/>
-          </a:prstGeom>
-          <a:noFill/>
-          <a:ln/>
-        </p:spPr>
-        <p:txBody>
-          <a:bodyPr wrap="square" lIns="0" tIns="0" rIns="0" bIns="0" rtlCol="0" anchor="ctr"/>
-          <a:lstStyle/>
-          <a:p>
-            <a:pPr algn="ctr" indent="0" marL="0">
-              <a:buNone/>
-            </a:pPr>
-            <a:r>
-              <a:rPr lang="en-US" sz="800" i="1" dirty="0">
-                <a:solidFill>
-                  <a:srgbClr val="7F7F7F"/>
-                </a:solidFill>
-                <a:latin typeface="Arial" pitchFamily="34" charset="0"/>
-                <a:ea typeface="Arial" pitchFamily="34" charset="-122"/>
-                <a:cs typeface="Arial" pitchFamily="34" charset="-120"/>
-              </a:rPr>
-              <a:t>organised through</a:t>
-            </a:r>
-            <a:endParaRPr lang="en-US" sz="800" dirty="0"/>
-          </a:p>
-        </p:txBody>
-      </p:sp>
-      <p:sp>
-        <p:nvSpPr>
-          <p:cNvPr id="23" name="Shape 18"/>
-          <p:cNvSpPr/>
-          <p:nvPr/>
-        </p:nvSpPr>
-        <p:spPr>
-          <a:xfrm>
-            <a:off x="457200" y="5193792"/>
+          <p:cNvPr id="19" name="Shape 14"/>
+          <p:cNvSpPr/>
+          <p:nvPr/>
+        </p:nvSpPr>
+        <p:spPr>
+          <a:xfrm>
+            <a:off x="457200" y="4718304"/>
             <a:ext cx="6647688" cy="1024128"/>
           </a:xfrm>
           <a:prstGeom prst="roundRect">
@@ -1581,13 +1459,13 @@
       </p:sp>
       <p:sp>
         <p:nvSpPr>
-          <p:cNvPr id="24" name="Shape 19"/>
-          <p:cNvSpPr/>
-          <p:nvPr/>
-        </p:nvSpPr>
-        <p:spPr>
-          <a:xfrm>
-            <a:off x="2820924" y="5084064"/>
+          <p:cNvPr id="20" name="Shape 15"/>
+          <p:cNvSpPr/>
+          <p:nvPr/>
+        </p:nvSpPr>
+        <p:spPr>
+          <a:xfrm>
+            <a:off x="2820924" y="4608576"/>
             <a:ext cx="1920240" cy="219456"/>
           </a:xfrm>
           <a:prstGeom prst="roundRect">
@@ -1608,13 +1486,13 @@
       </p:sp>
       <p:sp>
         <p:nvSpPr>
-          <p:cNvPr id="25" name="Text 20"/>
-          <p:cNvSpPr/>
-          <p:nvPr/>
-        </p:nvSpPr>
-        <p:spPr>
-          <a:xfrm>
-            <a:off x="2820924" y="5084064"/>
+          <p:cNvPr id="21" name="Text 16"/>
+          <p:cNvSpPr/>
+          <p:nvPr/>
+        </p:nvSpPr>
+        <p:spPr>
+          <a:xfrm>
+            <a:off x="2820924" y="4608576"/>
             <a:ext cx="1920240" cy="219456"/>
           </a:xfrm>
           <a:prstGeom prst="rect">
@@ -1647,7 +1525,7 @@
       </p:sp>
       <p:pic>
         <p:nvPicPr>
-          <p:cNvPr id="26" name="Image 3" descr="preencoded.png">    </p:cNvPr>
+          <p:cNvPr id="22" name="Image 3" descr="preencoded.png">    </p:cNvPr>
           <p:cNvPicPr>
             <a:picLocks noChangeAspect="1"/>
           </p:cNvPicPr>
@@ -1661,7 +1539,7 @@
         </p:blipFill>
         <p:spPr>
           <a:xfrm>
-            <a:off x="694944" y="5431536"/>
+            <a:off x="694944" y="4956048"/>
             <a:ext cx="530352" cy="530352"/>
           </a:xfrm>
           <a:prstGeom prst="rect">
@@ -1671,13 +1549,13 @@
       </p:pic>
       <p:sp>
         <p:nvSpPr>
-          <p:cNvPr id="27" name="Text 21"/>
-          <p:cNvSpPr/>
-          <p:nvPr/>
-        </p:nvSpPr>
-        <p:spPr>
-          <a:xfrm>
-            <a:off x="457200" y="5358384"/>
+          <p:cNvPr id="23" name="Text 17"/>
+          <p:cNvSpPr/>
+          <p:nvPr/>
+        </p:nvSpPr>
+        <p:spPr>
+          <a:xfrm>
+            <a:off x="457200" y="4882896"/>
             <a:ext cx="6647688" cy="402336"/>
           </a:xfrm>
           <a:prstGeom prst="rect">
@@ -1710,13 +1588,13 @@
       </p:sp>
       <p:sp>
         <p:nvSpPr>
-          <p:cNvPr id="28" name="Text 22"/>
-          <p:cNvSpPr/>
-          <p:nvPr/>
-        </p:nvSpPr>
-        <p:spPr>
-          <a:xfrm>
-            <a:off x="457200" y="5788152"/>
+          <p:cNvPr id="24" name="Text 18"/>
+          <p:cNvSpPr/>
+          <p:nvPr/>
+        </p:nvSpPr>
+        <p:spPr>
+          <a:xfrm>
+            <a:off x="457200" y="5312664"/>
             <a:ext cx="6647688" cy="219456"/>
           </a:xfrm>
           <a:prstGeom prst="rect">
@@ -1749,79 +1627,18 @@
       </p:sp>
       <p:sp>
         <p:nvSpPr>
-          <p:cNvPr id="29" name="Shape 23"/>
-          <p:cNvSpPr/>
-          <p:nvPr/>
-        </p:nvSpPr>
-        <p:spPr>
-          <a:xfrm rot="10800000">
-            <a:off x="3717036" y="6327648"/>
-            <a:ext cx="128016" cy="100584"/>
-          </a:xfrm>
-          <a:prstGeom prst="triangle">
-            <a:avLst/>
-          </a:prstGeom>
-          <a:solidFill>
-            <a:srgbClr val="002516">
-              <a:alpha val="55000"/>
-            </a:srgbClr>
-          </a:solidFill>
-          <a:ln/>
-        </p:spPr>
-      </p:sp>
-      <p:sp>
-        <p:nvSpPr>
-          <p:cNvPr id="30" name="Text 24"/>
-          <p:cNvSpPr/>
-          <p:nvPr/>
-        </p:nvSpPr>
-        <p:spPr>
-          <a:xfrm>
-            <a:off x="2043684" y="6446520"/>
-            <a:ext cx="3474720" cy="146304"/>
-          </a:xfrm>
-          <a:prstGeom prst="rect">
-            <a:avLst/>
-          </a:prstGeom>
-          <a:noFill/>
-          <a:ln/>
-        </p:spPr>
-        <p:txBody>
-          <a:bodyPr wrap="square" lIns="0" tIns="0" rIns="0" bIns="0" rtlCol="0" anchor="ctr"/>
-          <a:lstStyle/>
-          <a:p>
-            <a:pPr algn="ctr" indent="0" marL="0">
-              <a:buNone/>
-            </a:pPr>
-            <a:r>
-              <a:rPr lang="en-US" sz="800" i="1" dirty="0">
-                <a:solidFill>
-                  <a:srgbClr val="7F7F7F"/>
-                </a:solidFill>
-                <a:latin typeface="Arial" pitchFamily="34" charset="0"/>
-                <a:ea typeface="Arial" pitchFamily="34" charset="-122"/>
-                <a:cs typeface="Arial" pitchFamily="34" charset="-120"/>
-              </a:rPr>
-              <a:t>achieved through</a:t>
-            </a:r>
-            <a:endParaRPr lang="en-US" sz="800" dirty="0"/>
-          </a:p>
-        </p:txBody>
-      </p:sp>
-      <p:sp>
-        <p:nvSpPr>
-          <p:cNvPr id="31" name="Shape 25"/>
-          <p:cNvSpPr/>
-          <p:nvPr/>
-        </p:nvSpPr>
-        <p:spPr>
-          <a:xfrm>
-            <a:off x="457200" y="6839712"/>
-            <a:ext cx="6647688" cy="3438144"/>
+          <p:cNvPr id="25" name="Shape 19"/>
+          <p:cNvSpPr/>
+          <p:nvPr/>
+        </p:nvSpPr>
+        <p:spPr>
+          <a:xfrm>
+            <a:off x="457200" y="6126480"/>
+            <a:ext cx="6647688" cy="4151376"/>
           </a:xfrm>
           <a:prstGeom prst="roundRect">
             <a:avLst>
-              <a:gd name="adj" fmla="val 2128"/>
+              <a:gd name="adj" fmla="val 1762"/>
             </a:avLst>
           </a:prstGeom>
           <a:solidFill>
@@ -1834,13 +1651,13 @@
       </p:sp>
       <p:sp>
         <p:nvSpPr>
-          <p:cNvPr id="32" name="Shape 26"/>
-          <p:cNvSpPr/>
-          <p:nvPr/>
-        </p:nvSpPr>
-        <p:spPr>
-          <a:xfrm>
-            <a:off x="2089404" y="6729984"/>
+          <p:cNvPr id="26" name="Shape 20"/>
+          <p:cNvSpPr/>
+          <p:nvPr/>
+        </p:nvSpPr>
+        <p:spPr>
+          <a:xfrm>
+            <a:off x="2089404" y="6016752"/>
             <a:ext cx="3383280" cy="219456"/>
           </a:xfrm>
           <a:prstGeom prst="roundRect">
@@ -1861,13 +1678,13 @@
       </p:sp>
       <p:sp>
         <p:nvSpPr>
-          <p:cNvPr id="33" name="Text 27"/>
-          <p:cNvSpPr/>
-          <p:nvPr/>
-        </p:nvSpPr>
-        <p:spPr>
-          <a:xfrm>
-            <a:off x="2089404" y="6729984"/>
+          <p:cNvPr id="27" name="Text 21"/>
+          <p:cNvSpPr/>
+          <p:nvPr/>
+        </p:nvSpPr>
+        <p:spPr>
+          <a:xfrm>
+            <a:off x="2089404" y="6016752"/>
             <a:ext cx="3383280" cy="219456"/>
           </a:xfrm>
           <a:prstGeom prst="rect">
@@ -1900,14 +1717,14 @@
       </p:sp>
       <p:sp>
         <p:nvSpPr>
-          <p:cNvPr id="34" name="Shape 28"/>
-          <p:cNvSpPr/>
-          <p:nvPr/>
-        </p:nvSpPr>
-        <p:spPr>
-          <a:xfrm>
-            <a:off x="987552" y="7406640"/>
-            <a:ext cx="0" cy="2596896"/>
+          <p:cNvPr id="28" name="Shape 22"/>
+          <p:cNvSpPr/>
+          <p:nvPr/>
+        </p:nvSpPr>
+        <p:spPr>
+          <a:xfrm>
+            <a:off x="987552" y="6766560"/>
+            <a:ext cx="0" cy="2962656"/>
           </a:xfrm>
           <a:prstGeom prst="line">
             <a:avLst/>
@@ -1923,13 +1740,13 @@
       </p:sp>
       <p:sp>
         <p:nvSpPr>
-          <p:cNvPr id="35" name="Shape 29"/>
-          <p:cNvSpPr/>
-          <p:nvPr/>
-        </p:nvSpPr>
-        <p:spPr>
-          <a:xfrm>
-            <a:off x="795528" y="7214616"/>
+          <p:cNvPr id="29" name="Shape 23"/>
+          <p:cNvSpPr/>
+          <p:nvPr/>
+        </p:nvSpPr>
+        <p:spPr>
+          <a:xfrm>
+            <a:off x="795528" y="6574536"/>
             <a:ext cx="384048" cy="384048"/>
           </a:xfrm>
           <a:prstGeom prst="ellipse">
@@ -1948,13 +1765,13 @@
       </p:sp>
       <p:sp>
         <p:nvSpPr>
-          <p:cNvPr id="36" name="Text 30"/>
-          <p:cNvSpPr/>
-          <p:nvPr/>
-        </p:nvSpPr>
-        <p:spPr>
-          <a:xfrm>
-            <a:off x="795528" y="7214616"/>
+          <p:cNvPr id="30" name="Text 24"/>
+          <p:cNvSpPr/>
+          <p:nvPr/>
+        </p:nvSpPr>
+        <p:spPr>
+          <a:xfrm>
+            <a:off x="795528" y="6574536"/>
             <a:ext cx="384048" cy="384048"/>
           </a:xfrm>
           <a:prstGeom prst="rect">
@@ -1987,13 +1804,13 @@
       </p:sp>
       <p:sp>
         <p:nvSpPr>
-          <p:cNvPr id="37" name="Text 31"/>
-          <p:cNvSpPr/>
-          <p:nvPr/>
-        </p:nvSpPr>
-        <p:spPr>
-          <a:xfrm>
-            <a:off x="1353312" y="7223760"/>
+          <p:cNvPr id="31" name="Text 25"/>
+          <p:cNvSpPr/>
+          <p:nvPr/>
+        </p:nvSpPr>
+        <p:spPr>
+          <a:xfrm>
+            <a:off x="1353312" y="6583680"/>
             <a:ext cx="1783080" cy="365760"/>
           </a:xfrm>
           <a:prstGeom prst="rect">
@@ -2026,13 +1843,13 @@
       </p:sp>
       <p:sp>
         <p:nvSpPr>
-          <p:cNvPr id="38" name="Text 32"/>
-          <p:cNvSpPr/>
-          <p:nvPr/>
-        </p:nvSpPr>
-        <p:spPr>
-          <a:xfrm>
-            <a:off x="3182112" y="7187184"/>
+          <p:cNvPr id="32" name="Text 26"/>
+          <p:cNvSpPr/>
+          <p:nvPr/>
+        </p:nvSpPr>
+        <p:spPr>
+          <a:xfrm>
+            <a:off x="3182112" y="6547104"/>
             <a:ext cx="3758184" cy="438912"/>
           </a:xfrm>
           <a:prstGeom prst="rect">
@@ -2065,13 +1882,13 @@
       </p:sp>
       <p:sp>
         <p:nvSpPr>
-          <p:cNvPr id="39" name="Shape 33"/>
-          <p:cNvSpPr/>
-          <p:nvPr/>
-        </p:nvSpPr>
-        <p:spPr>
-          <a:xfrm>
-            <a:off x="795528" y="7863840"/>
+          <p:cNvPr id="33" name="Shape 27"/>
+          <p:cNvSpPr/>
+          <p:nvPr/>
+        </p:nvSpPr>
+        <p:spPr>
+          <a:xfrm>
+            <a:off x="795528" y="7315200"/>
             <a:ext cx="384048" cy="384048"/>
           </a:xfrm>
           <a:prstGeom prst="ellipse">
@@ -2090,13 +1907,13 @@
       </p:sp>
       <p:sp>
         <p:nvSpPr>
-          <p:cNvPr id="40" name="Text 34"/>
-          <p:cNvSpPr/>
-          <p:nvPr/>
-        </p:nvSpPr>
-        <p:spPr>
-          <a:xfrm>
-            <a:off x="795528" y="7863840"/>
+          <p:cNvPr id="34" name="Text 28"/>
+          <p:cNvSpPr/>
+          <p:nvPr/>
+        </p:nvSpPr>
+        <p:spPr>
+          <a:xfrm>
+            <a:off x="795528" y="7315200"/>
             <a:ext cx="384048" cy="384048"/>
           </a:xfrm>
           <a:prstGeom prst="rect">
@@ -2129,13 +1946,13 @@
       </p:sp>
       <p:sp>
         <p:nvSpPr>
-          <p:cNvPr id="41" name="Text 35"/>
-          <p:cNvSpPr/>
-          <p:nvPr/>
-        </p:nvSpPr>
-        <p:spPr>
-          <a:xfrm>
-            <a:off x="1353312" y="7872984"/>
+          <p:cNvPr id="35" name="Text 29"/>
+          <p:cNvSpPr/>
+          <p:nvPr/>
+        </p:nvSpPr>
+        <p:spPr>
+          <a:xfrm>
+            <a:off x="1353312" y="7324344"/>
             <a:ext cx="1783080" cy="365760"/>
           </a:xfrm>
           <a:prstGeom prst="rect">
@@ -2168,13 +1985,13 @@
       </p:sp>
       <p:sp>
         <p:nvSpPr>
-          <p:cNvPr id="42" name="Text 36"/>
-          <p:cNvSpPr/>
-          <p:nvPr/>
-        </p:nvSpPr>
-        <p:spPr>
-          <a:xfrm>
-            <a:off x="3182112" y="7836408"/>
+          <p:cNvPr id="36" name="Text 30"/>
+          <p:cNvSpPr/>
+          <p:nvPr/>
+        </p:nvSpPr>
+        <p:spPr>
+          <a:xfrm>
+            <a:off x="3182112" y="7287768"/>
             <a:ext cx="3758184" cy="438912"/>
           </a:xfrm>
           <a:prstGeom prst="rect">
@@ -2207,13 +2024,13 @@
       </p:sp>
       <p:sp>
         <p:nvSpPr>
-          <p:cNvPr id="43" name="Shape 37"/>
-          <p:cNvSpPr/>
-          <p:nvPr/>
-        </p:nvSpPr>
-        <p:spPr>
-          <a:xfrm>
-            <a:off x="795528" y="8513064"/>
+          <p:cNvPr id="37" name="Shape 31"/>
+          <p:cNvSpPr/>
+          <p:nvPr/>
+        </p:nvSpPr>
+        <p:spPr>
+          <a:xfrm>
+            <a:off x="795528" y="8055864"/>
             <a:ext cx="384048" cy="384048"/>
           </a:xfrm>
           <a:prstGeom prst="ellipse">
@@ -2232,13 +2049,13 @@
       </p:sp>
       <p:sp>
         <p:nvSpPr>
-          <p:cNvPr id="44" name="Text 38"/>
-          <p:cNvSpPr/>
-          <p:nvPr/>
-        </p:nvSpPr>
-        <p:spPr>
-          <a:xfrm>
-            <a:off x="795528" y="8513064"/>
+          <p:cNvPr id="38" name="Text 32"/>
+          <p:cNvSpPr/>
+          <p:nvPr/>
+        </p:nvSpPr>
+        <p:spPr>
+          <a:xfrm>
+            <a:off x="795528" y="8055864"/>
             <a:ext cx="384048" cy="384048"/>
           </a:xfrm>
           <a:prstGeom prst="rect">
@@ -2271,13 +2088,13 @@
       </p:sp>
       <p:sp>
         <p:nvSpPr>
-          <p:cNvPr id="45" name="Text 39"/>
-          <p:cNvSpPr/>
-          <p:nvPr/>
-        </p:nvSpPr>
-        <p:spPr>
-          <a:xfrm>
-            <a:off x="1353312" y="8522208"/>
+          <p:cNvPr id="39" name="Text 33"/>
+          <p:cNvSpPr/>
+          <p:nvPr/>
+        </p:nvSpPr>
+        <p:spPr>
+          <a:xfrm>
+            <a:off x="1353312" y="8065008"/>
             <a:ext cx="1783080" cy="365760"/>
           </a:xfrm>
           <a:prstGeom prst="rect">
@@ -2310,13 +2127,13 @@
       </p:sp>
       <p:sp>
         <p:nvSpPr>
-          <p:cNvPr id="46" name="Text 40"/>
-          <p:cNvSpPr/>
-          <p:nvPr/>
-        </p:nvSpPr>
-        <p:spPr>
-          <a:xfrm>
-            <a:off x="3182112" y="8485632"/>
+          <p:cNvPr id="40" name="Text 34"/>
+          <p:cNvSpPr/>
+          <p:nvPr/>
+        </p:nvSpPr>
+        <p:spPr>
+          <a:xfrm>
+            <a:off x="3182112" y="8028432"/>
             <a:ext cx="3758184" cy="438912"/>
           </a:xfrm>
           <a:prstGeom prst="rect">
@@ -2349,13 +2166,13 @@
       </p:sp>
       <p:sp>
         <p:nvSpPr>
-          <p:cNvPr id="47" name="Shape 41"/>
-          <p:cNvSpPr/>
-          <p:nvPr/>
-        </p:nvSpPr>
-        <p:spPr>
-          <a:xfrm>
-            <a:off x="795528" y="9162288"/>
+          <p:cNvPr id="41" name="Shape 35"/>
+          <p:cNvSpPr/>
+          <p:nvPr/>
+        </p:nvSpPr>
+        <p:spPr>
+          <a:xfrm>
+            <a:off x="795528" y="8796528"/>
             <a:ext cx="384048" cy="384048"/>
           </a:xfrm>
           <a:prstGeom prst="ellipse">
@@ -2374,13 +2191,13 @@
       </p:sp>
       <p:sp>
         <p:nvSpPr>
-          <p:cNvPr id="48" name="Text 42"/>
-          <p:cNvSpPr/>
-          <p:nvPr/>
-        </p:nvSpPr>
-        <p:spPr>
-          <a:xfrm>
-            <a:off x="795528" y="9162288"/>
+          <p:cNvPr id="42" name="Text 36"/>
+          <p:cNvSpPr/>
+          <p:nvPr/>
+        </p:nvSpPr>
+        <p:spPr>
+          <a:xfrm>
+            <a:off x="795528" y="8796528"/>
             <a:ext cx="384048" cy="384048"/>
           </a:xfrm>
           <a:prstGeom prst="rect">
@@ -2413,13 +2230,13 @@
       </p:sp>
       <p:sp>
         <p:nvSpPr>
-          <p:cNvPr id="49" name="Text 43"/>
-          <p:cNvSpPr/>
-          <p:nvPr/>
-        </p:nvSpPr>
-        <p:spPr>
-          <a:xfrm>
-            <a:off x="1353312" y="9171432"/>
+          <p:cNvPr id="43" name="Text 37"/>
+          <p:cNvSpPr/>
+          <p:nvPr/>
+        </p:nvSpPr>
+        <p:spPr>
+          <a:xfrm>
+            <a:off x="1353312" y="8805672"/>
             <a:ext cx="1783080" cy="365760"/>
           </a:xfrm>
           <a:prstGeom prst="rect">
@@ -2452,13 +2269,13 @@
       </p:sp>
       <p:sp>
         <p:nvSpPr>
-          <p:cNvPr id="50" name="Text 44"/>
-          <p:cNvSpPr/>
-          <p:nvPr/>
-        </p:nvSpPr>
-        <p:spPr>
-          <a:xfrm>
-            <a:off x="3182112" y="9134856"/>
+          <p:cNvPr id="44" name="Text 38"/>
+          <p:cNvSpPr/>
+          <p:nvPr/>
+        </p:nvSpPr>
+        <p:spPr>
+          <a:xfrm>
+            <a:off x="3182112" y="8769096"/>
             <a:ext cx="3758184" cy="438912"/>
           </a:xfrm>
           <a:prstGeom prst="rect">
@@ -2491,13 +2308,13 @@
       </p:sp>
       <p:sp>
         <p:nvSpPr>
-          <p:cNvPr id="51" name="Shape 45"/>
-          <p:cNvSpPr/>
-          <p:nvPr/>
-        </p:nvSpPr>
-        <p:spPr>
-          <a:xfrm>
-            <a:off x="795528" y="9811512"/>
+          <p:cNvPr id="45" name="Shape 39"/>
+          <p:cNvSpPr/>
+          <p:nvPr/>
+        </p:nvSpPr>
+        <p:spPr>
+          <a:xfrm>
+            <a:off x="795528" y="9537192"/>
             <a:ext cx="384048" cy="384048"/>
           </a:xfrm>
           <a:prstGeom prst="ellipse">
@@ -2516,13 +2333,13 @@
       </p:sp>
       <p:sp>
         <p:nvSpPr>
-          <p:cNvPr id="52" name="Text 46"/>
-          <p:cNvSpPr/>
-          <p:nvPr/>
-        </p:nvSpPr>
-        <p:spPr>
-          <a:xfrm>
-            <a:off x="795528" y="9811512"/>
+          <p:cNvPr id="46" name="Text 40"/>
+          <p:cNvSpPr/>
+          <p:nvPr/>
+        </p:nvSpPr>
+        <p:spPr>
+          <a:xfrm>
+            <a:off x="795528" y="9537192"/>
             <a:ext cx="384048" cy="384048"/>
           </a:xfrm>
           <a:prstGeom prst="rect">
@@ -2555,13 +2372,13 @@
       </p:sp>
       <p:sp>
         <p:nvSpPr>
-          <p:cNvPr id="53" name="Text 47"/>
-          <p:cNvSpPr/>
-          <p:nvPr/>
-        </p:nvSpPr>
-        <p:spPr>
-          <a:xfrm>
-            <a:off x="1353312" y="9820656"/>
+          <p:cNvPr id="47" name="Text 41"/>
+          <p:cNvSpPr/>
+          <p:nvPr/>
+        </p:nvSpPr>
+        <p:spPr>
+          <a:xfrm>
+            <a:off x="1353312" y="9546336"/>
             <a:ext cx="1783080" cy="365760"/>
           </a:xfrm>
           <a:prstGeom prst="rect">
@@ -2594,13 +2411,13 @@
       </p:sp>
       <p:sp>
         <p:nvSpPr>
-          <p:cNvPr id="54" name="Text 48"/>
-          <p:cNvSpPr/>
-          <p:nvPr/>
-        </p:nvSpPr>
-        <p:spPr>
-          <a:xfrm>
-            <a:off x="3182112" y="9784080"/>
+          <p:cNvPr id="48" name="Text 42"/>
+          <p:cNvSpPr/>
+          <p:nvPr/>
+        </p:nvSpPr>
+        <p:spPr>
+          <a:xfrm>
+            <a:off x="3182112" y="9509760"/>
             <a:ext cx="3758184" cy="438912"/>
           </a:xfrm>
           <a:prstGeom prst="rect">

</xml_diff>

<commit_message>
Apply the NZ Army brand guidelines to the framework proposal
Colour: replace the approximated palette with the published Army values,
Pantone 200 C red and the four secondary greens, across the paper and the
model page.

Type: body copy to Calibri and display headings to Arial Black, the
published PC substitutes for Neue Haas Grotesk. Sub-headings stay in
Calibri Bold. Leading tightened to hold the paper at eight pages.

Colour use: headings move from secondary green to black with red as the
single accent, matching every Army application example in the guidelines.
Fourth level headings take red, the way the guidelines label sub-sections.

Co-Authored-By: Claude Fable 5 <noreply@anthropic.com>
Claude-Session: https://claude.ai/code/session_01YLo1WfwUDkbwfJEF3ZNVbB
</commit_message>
<xml_diff>
--- a/output/combat-mindset-onepager-portrait.pptx
+++ b/output/combat-mindset-onepager-portrait.pptx
@@ -965,7 +965,7 @@
             <a:r>
               <a:rPr lang="en-US" sz="900" i="1" dirty="0">
                 <a:solidFill>
-                  <a:srgbClr val="002516"/>
+                  <a:srgbClr val="00261B"/>
                 </a:solidFill>
                 <a:latin typeface="Arial" pitchFamily="34" charset="0"/>
                 <a:ea typeface="Arial" pitchFamily="34" charset="-122"/>
@@ -1055,7 +1055,7 @@
             </a:avLst>
           </a:prstGeom>
           <a:solidFill>
-            <a:srgbClr val="C62026"/>
+            <a:srgbClr val="D31145"/>
           </a:solidFill>
           <a:ln w="12700">
             <a:solidFill>
@@ -1233,7 +1233,7 @@
             <a:r>
               <a:rPr lang="en-US" sz="1350" b="1" dirty="0">
                 <a:solidFill>
-                  <a:srgbClr val="C62026"/>
+                  <a:srgbClr val="D31145"/>
                 </a:solidFill>
                 <a:latin typeface="Arial" pitchFamily="34" charset="0"/>
                 <a:ea typeface="Arial" pitchFamily="34" charset="-122"/>
@@ -1262,7 +1262,7 @@
             </a:avLst>
           </a:prstGeom>
           <a:solidFill>
-            <a:srgbClr val="002516"/>
+            <a:srgbClr val="00261B"/>
           </a:solidFill>
           <a:ln/>
         </p:spPr>
@@ -1284,7 +1284,7 @@
             </a:avLst>
           </a:prstGeom>
           <a:solidFill>
-            <a:srgbClr val="002516"/>
+            <a:srgbClr val="00261B"/>
           </a:solidFill>
           <a:ln w="12700">
             <a:solidFill>
@@ -1452,7 +1452,7 @@
             </a:avLst>
           </a:prstGeom>
           <a:solidFill>
-            <a:srgbClr val="3A4B00"/>
+            <a:srgbClr val="444D06"/>
           </a:solidFill>
           <a:ln/>
         </p:spPr>
@@ -1474,7 +1474,7 @@
             </a:avLst>
           </a:prstGeom>
           <a:solidFill>
-            <a:srgbClr val="3A4B00"/>
+            <a:srgbClr val="444D06"/>
           </a:solidFill>
           <a:ln w="12700">
             <a:solidFill>
@@ -1642,7 +1642,7 @@
             </a:avLst>
           </a:prstGeom>
           <a:solidFill>
-            <a:srgbClr val="CDD2B7">
+            <a:srgbClr val="DFD8AD">
               <a:alpha val="28000"/>
             </a:srgbClr>
           </a:solidFill>
@@ -1666,7 +1666,7 @@
             </a:avLst>
           </a:prstGeom>
           <a:solidFill>
-            <a:srgbClr val="002516"/>
+            <a:srgbClr val="00261B"/>
           </a:solidFill>
           <a:ln w="12700">
             <a:solidFill>
@@ -1732,7 +1732,7 @@
           <a:noFill/>
           <a:ln w="19050">
             <a:solidFill>
-              <a:srgbClr val="002516"/>
+              <a:srgbClr val="00261B"/>
             </a:solidFill>
             <a:prstDash val="solid"/>
           </a:ln>
@@ -1753,7 +1753,7 @@
             <a:avLst/>
           </a:prstGeom>
           <a:solidFill>
-            <a:srgbClr val="002516"/>
+            <a:srgbClr val="00261B"/>
           </a:solidFill>
           <a:ln w="19050">
             <a:solidFill>
@@ -1829,7 +1829,7 @@
             <a:r>
               <a:rPr lang="en-US" sz="1150" b="1" spc="120" kern="0" dirty="0">
                 <a:solidFill>
-                  <a:srgbClr val="002516"/>
+                  <a:srgbClr val="00261B"/>
                 </a:solidFill>
                 <a:latin typeface="Arial" pitchFamily="34" charset="0"/>
                 <a:ea typeface="Arial" pitchFamily="34" charset="-122"/>
@@ -1895,7 +1895,7 @@
             <a:avLst/>
           </a:prstGeom>
           <a:solidFill>
-            <a:srgbClr val="002516"/>
+            <a:srgbClr val="00261B"/>
           </a:solidFill>
           <a:ln w="19050">
             <a:solidFill>
@@ -1971,7 +1971,7 @@
             <a:r>
               <a:rPr lang="en-US" sz="1150" b="1" spc="120" kern="0" dirty="0">
                 <a:solidFill>
-                  <a:srgbClr val="002516"/>
+                  <a:srgbClr val="00261B"/>
                 </a:solidFill>
                 <a:latin typeface="Arial" pitchFamily="34" charset="0"/>
                 <a:ea typeface="Arial" pitchFamily="34" charset="-122"/>
@@ -2037,7 +2037,7 @@
             <a:avLst/>
           </a:prstGeom>
           <a:solidFill>
-            <a:srgbClr val="002516"/>
+            <a:srgbClr val="00261B"/>
           </a:solidFill>
           <a:ln w="19050">
             <a:solidFill>
@@ -2113,7 +2113,7 @@
             <a:r>
               <a:rPr lang="en-US" sz="1150" b="1" spc="120" kern="0" dirty="0">
                 <a:solidFill>
-                  <a:srgbClr val="002516"/>
+                  <a:srgbClr val="00261B"/>
                 </a:solidFill>
                 <a:latin typeface="Arial" pitchFamily="34" charset="0"/>
                 <a:ea typeface="Arial" pitchFamily="34" charset="-122"/>
@@ -2179,7 +2179,7 @@
             <a:avLst/>
           </a:prstGeom>
           <a:solidFill>
-            <a:srgbClr val="002516"/>
+            <a:srgbClr val="00261B"/>
           </a:solidFill>
           <a:ln w="19050">
             <a:solidFill>
@@ -2255,7 +2255,7 @@
             <a:r>
               <a:rPr lang="en-US" sz="1150" b="1" spc="120" kern="0" dirty="0">
                 <a:solidFill>
-                  <a:srgbClr val="002516"/>
+                  <a:srgbClr val="00261B"/>
                 </a:solidFill>
                 <a:latin typeface="Arial" pitchFamily="34" charset="0"/>
                 <a:ea typeface="Arial" pitchFamily="34" charset="-122"/>
@@ -2321,7 +2321,7 @@
             <a:avLst/>
           </a:prstGeom>
           <a:solidFill>
-            <a:srgbClr val="002516"/>
+            <a:srgbClr val="00261B"/>
           </a:solidFill>
           <a:ln w="19050">
             <a:solidFill>
@@ -2397,7 +2397,7 @@
             <a:r>
               <a:rPr lang="en-US" sz="1150" b="1" spc="120" kern="0" dirty="0">
                 <a:solidFill>
-                  <a:srgbClr val="002516"/>
+                  <a:srgbClr val="00261B"/>
                 </a:solidFill>
                 <a:latin typeface="Arial" pitchFamily="34" charset="0"/>
                 <a:ea typeface="Arial" pitchFamily="34" charset="-122"/>

</xml_diff>

<commit_message>
Remove the emblem family from the model page
The identity system permits no freestanding brand mark, badge or symbol.
The three shield emblems inside the cards were the last of them, so they
go, along with the SVG generator and the now unused imports that served
only them. The cards carry their meaning through typography, hierarchy
and the published palette alone.

Co-Authored-By: Claude Fable 5 <noreply@anthropic.com>
Claude-Session: https://claude.ai/code/session_01YLo1WfwUDkbwfJEF3ZNVbB
</commit_message>
<xml_diff>
--- a/output/combat-mindset-onepager-portrait.pptx
+++ b/output/combat-mindset-onepager-portrait.pptx
@@ -1104,33 +1104,9 @@
           </a:p>
         </p:txBody>
       </p:sp>
-      <p:pic>
-        <p:nvPicPr>
-          <p:cNvPr id="9" name="Image 1" descr="preencoded.png">    </p:cNvPr>
-          <p:cNvPicPr>
-            <a:picLocks noChangeAspect="1"/>
-          </p:cNvPicPr>
-          <p:nvPr/>
-        </p:nvPicPr>
-        <p:blipFill>
-          <a:blip r:embed="rId2"/>
-          <a:stretch>
-            <a:fillRect/>
-          </a:stretch>
-        </p:blipFill>
-        <p:spPr>
-          <a:xfrm>
-            <a:off x="676656" y="1773936"/>
-            <a:ext cx="749808" cy="749808"/>
-          </a:xfrm>
-          <a:prstGeom prst="rect">
-            <a:avLst/>
-          </a:prstGeom>
-        </p:spPr>
-      </p:pic>
-      <p:sp>
-        <p:nvSpPr>
-          <p:cNvPr id="10" name="Text 6"/>
+      <p:sp>
+        <p:nvSpPr>
+          <p:cNvPr id="9" name="Text 6"/>
           <p:cNvSpPr/>
           <p:nvPr/>
         </p:nvSpPr>
@@ -1169,7 +1145,7 @@
       </p:sp>
       <p:sp>
         <p:nvSpPr>
-          <p:cNvPr id="11" name="Text 7"/>
+          <p:cNvPr id="10" name="Text 7"/>
           <p:cNvSpPr/>
           <p:nvPr/>
         </p:nvSpPr>
@@ -1208,7 +1184,7 @@
       </p:sp>
       <p:sp>
         <p:nvSpPr>
-          <p:cNvPr id="12" name="Text 8"/>
+          <p:cNvPr id="11" name="Text 8"/>
           <p:cNvSpPr/>
           <p:nvPr/>
         </p:nvSpPr>
@@ -1247,7 +1223,7 @@
       </p:sp>
       <p:sp>
         <p:nvSpPr>
-          <p:cNvPr id="13" name="Shape 9"/>
+          <p:cNvPr id="12" name="Shape 9"/>
           <p:cNvSpPr/>
           <p:nvPr/>
         </p:nvSpPr>
@@ -1269,7 +1245,7 @@
       </p:sp>
       <p:sp>
         <p:nvSpPr>
-          <p:cNvPr id="14" name="Shape 10"/>
+          <p:cNvPr id="13" name="Shape 10"/>
           <p:cNvSpPr/>
           <p:nvPr/>
         </p:nvSpPr>
@@ -1296,7 +1272,7 @@
       </p:sp>
       <p:sp>
         <p:nvSpPr>
-          <p:cNvPr id="15" name="Text 11"/>
+          <p:cNvPr id="14" name="Text 11"/>
           <p:cNvSpPr/>
           <p:nvPr/>
         </p:nvSpPr>
@@ -1333,33 +1309,9 @@
           </a:p>
         </p:txBody>
       </p:sp>
-      <p:pic>
-        <p:nvPicPr>
-          <p:cNvPr id="16" name="Image 2" descr="preencoded.png">    </p:cNvPr>
-          <p:cNvPicPr>
-            <a:picLocks noChangeAspect="1"/>
-          </p:cNvPicPr>
-          <p:nvPr/>
-        </p:nvPicPr>
-        <p:blipFill>
-          <a:blip r:embed="rId3"/>
-          <a:stretch>
-            <a:fillRect/>
-          </a:stretch>
-        </p:blipFill>
-        <p:spPr>
-          <a:xfrm>
-            <a:off x="694944" y="3511296"/>
-            <a:ext cx="548640" cy="548640"/>
-          </a:xfrm>
-          <a:prstGeom prst="rect">
-            <a:avLst/>
-          </a:prstGeom>
-        </p:spPr>
-      </p:pic>
-      <p:sp>
-        <p:nvSpPr>
-          <p:cNvPr id="17" name="Text 12"/>
+      <p:sp>
+        <p:nvSpPr>
+          <p:cNvPr id="15" name="Text 12"/>
           <p:cNvSpPr/>
           <p:nvPr/>
         </p:nvSpPr>
@@ -1398,7 +1350,7 @@
       </p:sp>
       <p:sp>
         <p:nvSpPr>
-          <p:cNvPr id="18" name="Text 13"/>
+          <p:cNvPr id="16" name="Text 13"/>
           <p:cNvSpPr/>
           <p:nvPr/>
         </p:nvSpPr>
@@ -1437,7 +1389,7 @@
       </p:sp>
       <p:sp>
         <p:nvSpPr>
-          <p:cNvPr id="19" name="Shape 14"/>
+          <p:cNvPr id="17" name="Shape 14"/>
           <p:cNvSpPr/>
           <p:nvPr/>
         </p:nvSpPr>
@@ -1459,7 +1411,7 @@
       </p:sp>
       <p:sp>
         <p:nvSpPr>
-          <p:cNvPr id="20" name="Shape 15"/>
+          <p:cNvPr id="18" name="Shape 15"/>
           <p:cNvSpPr/>
           <p:nvPr/>
         </p:nvSpPr>
@@ -1486,7 +1438,7 @@
       </p:sp>
       <p:sp>
         <p:nvSpPr>
-          <p:cNvPr id="21" name="Text 16"/>
+          <p:cNvPr id="19" name="Text 16"/>
           <p:cNvSpPr/>
           <p:nvPr/>
         </p:nvSpPr>
@@ -1523,33 +1475,9 @@
           </a:p>
         </p:txBody>
       </p:sp>
-      <p:pic>
-        <p:nvPicPr>
-          <p:cNvPr id="22" name="Image 3" descr="preencoded.png">    </p:cNvPr>
-          <p:cNvPicPr>
-            <a:picLocks noChangeAspect="1"/>
-          </p:cNvPicPr>
-          <p:nvPr/>
-        </p:nvPicPr>
-        <p:blipFill>
-          <a:blip r:embed="rId4"/>
-          <a:stretch>
-            <a:fillRect/>
-          </a:stretch>
-        </p:blipFill>
-        <p:spPr>
-          <a:xfrm>
-            <a:off x="694944" y="4956048"/>
-            <a:ext cx="530352" cy="530352"/>
-          </a:xfrm>
-          <a:prstGeom prst="rect">
-            <a:avLst/>
-          </a:prstGeom>
-        </p:spPr>
-      </p:pic>
-      <p:sp>
-        <p:nvSpPr>
-          <p:cNvPr id="23" name="Text 17"/>
+      <p:sp>
+        <p:nvSpPr>
+          <p:cNvPr id="20" name="Text 17"/>
           <p:cNvSpPr/>
           <p:nvPr/>
         </p:nvSpPr>
@@ -1588,7 +1516,7 @@
       </p:sp>
       <p:sp>
         <p:nvSpPr>
-          <p:cNvPr id="24" name="Text 18"/>
+          <p:cNvPr id="21" name="Text 18"/>
           <p:cNvSpPr/>
           <p:nvPr/>
         </p:nvSpPr>
@@ -1627,7 +1555,7 @@
       </p:sp>
       <p:sp>
         <p:nvSpPr>
-          <p:cNvPr id="25" name="Shape 19"/>
+          <p:cNvPr id="22" name="Shape 19"/>
           <p:cNvSpPr/>
           <p:nvPr/>
         </p:nvSpPr>
@@ -1651,7 +1579,7 @@
       </p:sp>
       <p:sp>
         <p:nvSpPr>
-          <p:cNvPr id="26" name="Shape 20"/>
+          <p:cNvPr id="23" name="Shape 20"/>
           <p:cNvSpPr/>
           <p:nvPr/>
         </p:nvSpPr>
@@ -1678,7 +1606,7 @@
       </p:sp>
       <p:sp>
         <p:nvSpPr>
-          <p:cNvPr id="27" name="Text 21"/>
+          <p:cNvPr id="24" name="Text 21"/>
           <p:cNvSpPr/>
           <p:nvPr/>
         </p:nvSpPr>
@@ -1717,7 +1645,7 @@
       </p:sp>
       <p:sp>
         <p:nvSpPr>
-          <p:cNvPr id="28" name="Shape 22"/>
+          <p:cNvPr id="25" name="Shape 22"/>
           <p:cNvSpPr/>
           <p:nvPr/>
         </p:nvSpPr>
@@ -1740,7 +1668,7 @@
       </p:sp>
       <p:sp>
         <p:nvSpPr>
-          <p:cNvPr id="29" name="Shape 23"/>
+          <p:cNvPr id="26" name="Shape 23"/>
           <p:cNvSpPr/>
           <p:nvPr/>
         </p:nvSpPr>
@@ -1765,7 +1693,7 @@
       </p:sp>
       <p:sp>
         <p:nvSpPr>
-          <p:cNvPr id="30" name="Text 24"/>
+          <p:cNvPr id="27" name="Text 24"/>
           <p:cNvSpPr/>
           <p:nvPr/>
         </p:nvSpPr>
@@ -1804,7 +1732,7 @@
       </p:sp>
       <p:sp>
         <p:nvSpPr>
-          <p:cNvPr id="31" name="Text 25"/>
+          <p:cNvPr id="28" name="Text 25"/>
           <p:cNvSpPr/>
           <p:nvPr/>
         </p:nvSpPr>
@@ -1843,7 +1771,7 @@
       </p:sp>
       <p:sp>
         <p:nvSpPr>
-          <p:cNvPr id="32" name="Text 26"/>
+          <p:cNvPr id="29" name="Text 26"/>
           <p:cNvSpPr/>
           <p:nvPr/>
         </p:nvSpPr>
@@ -1882,7 +1810,7 @@
       </p:sp>
       <p:sp>
         <p:nvSpPr>
-          <p:cNvPr id="33" name="Shape 27"/>
+          <p:cNvPr id="30" name="Shape 27"/>
           <p:cNvSpPr/>
           <p:nvPr/>
         </p:nvSpPr>
@@ -1907,7 +1835,7 @@
       </p:sp>
       <p:sp>
         <p:nvSpPr>
-          <p:cNvPr id="34" name="Text 28"/>
+          <p:cNvPr id="31" name="Text 28"/>
           <p:cNvSpPr/>
           <p:nvPr/>
         </p:nvSpPr>
@@ -1946,7 +1874,7 @@
       </p:sp>
       <p:sp>
         <p:nvSpPr>
-          <p:cNvPr id="35" name="Text 29"/>
+          <p:cNvPr id="32" name="Text 29"/>
           <p:cNvSpPr/>
           <p:nvPr/>
         </p:nvSpPr>
@@ -1985,7 +1913,7 @@
       </p:sp>
       <p:sp>
         <p:nvSpPr>
-          <p:cNvPr id="36" name="Text 30"/>
+          <p:cNvPr id="33" name="Text 30"/>
           <p:cNvSpPr/>
           <p:nvPr/>
         </p:nvSpPr>
@@ -2024,7 +1952,7 @@
       </p:sp>
       <p:sp>
         <p:nvSpPr>
-          <p:cNvPr id="37" name="Shape 31"/>
+          <p:cNvPr id="34" name="Shape 31"/>
           <p:cNvSpPr/>
           <p:nvPr/>
         </p:nvSpPr>
@@ -2049,7 +1977,7 @@
       </p:sp>
       <p:sp>
         <p:nvSpPr>
-          <p:cNvPr id="38" name="Text 32"/>
+          <p:cNvPr id="35" name="Text 32"/>
           <p:cNvSpPr/>
           <p:nvPr/>
         </p:nvSpPr>
@@ -2088,7 +2016,7 @@
       </p:sp>
       <p:sp>
         <p:nvSpPr>
-          <p:cNvPr id="39" name="Text 33"/>
+          <p:cNvPr id="36" name="Text 33"/>
           <p:cNvSpPr/>
           <p:nvPr/>
         </p:nvSpPr>
@@ -2127,7 +2055,7 @@
       </p:sp>
       <p:sp>
         <p:nvSpPr>
-          <p:cNvPr id="40" name="Text 34"/>
+          <p:cNvPr id="37" name="Text 34"/>
           <p:cNvSpPr/>
           <p:nvPr/>
         </p:nvSpPr>
@@ -2166,7 +2094,7 @@
       </p:sp>
       <p:sp>
         <p:nvSpPr>
-          <p:cNvPr id="41" name="Shape 35"/>
+          <p:cNvPr id="38" name="Shape 35"/>
           <p:cNvSpPr/>
           <p:nvPr/>
         </p:nvSpPr>
@@ -2191,7 +2119,7 @@
       </p:sp>
       <p:sp>
         <p:nvSpPr>
-          <p:cNvPr id="42" name="Text 36"/>
+          <p:cNvPr id="39" name="Text 36"/>
           <p:cNvSpPr/>
           <p:nvPr/>
         </p:nvSpPr>
@@ -2230,7 +2158,7 @@
       </p:sp>
       <p:sp>
         <p:nvSpPr>
-          <p:cNvPr id="43" name="Text 37"/>
+          <p:cNvPr id="40" name="Text 37"/>
           <p:cNvSpPr/>
           <p:nvPr/>
         </p:nvSpPr>
@@ -2269,7 +2197,7 @@
       </p:sp>
       <p:sp>
         <p:nvSpPr>
-          <p:cNvPr id="44" name="Text 38"/>
+          <p:cNvPr id="41" name="Text 38"/>
           <p:cNvSpPr/>
           <p:nvPr/>
         </p:nvSpPr>
@@ -2308,7 +2236,7 @@
       </p:sp>
       <p:sp>
         <p:nvSpPr>
-          <p:cNvPr id="45" name="Shape 39"/>
+          <p:cNvPr id="42" name="Shape 39"/>
           <p:cNvSpPr/>
           <p:nvPr/>
         </p:nvSpPr>
@@ -2333,7 +2261,7 @@
       </p:sp>
       <p:sp>
         <p:nvSpPr>
-          <p:cNvPr id="46" name="Text 40"/>
+          <p:cNvPr id="43" name="Text 40"/>
           <p:cNvSpPr/>
           <p:nvPr/>
         </p:nvSpPr>
@@ -2372,7 +2300,7 @@
       </p:sp>
       <p:sp>
         <p:nvSpPr>
-          <p:cNvPr id="47" name="Text 41"/>
+          <p:cNvPr id="44" name="Text 41"/>
           <p:cNvSpPr/>
           <p:nvPr/>
         </p:nvSpPr>
@@ -2411,7 +2339,7 @@
       </p:sp>
       <p:sp>
         <p:nvSpPr>
-          <p:cNvPr id="48" name="Text 42"/>
+          <p:cNvPr id="45" name="Text 42"/>
           <p:cNvSpPr/>
           <p:nvPr/>
         </p:nvSpPr>

</xml_diff>